<commit_message>
docs: restructure action plan & presentation into Previous -> Current -> Future BAU State model
</commit_message>
<xml_diff>
--- a/docs/ProcureFlow_Executive_Roadmap.pptx
+++ b/docs/ProcureFlow_Executive_Roadmap.pptx
@@ -3174,7 +3174,7 @@
               </a:defRPr>
             </a:pPr>
             <a:r>
-              <a:t>SOUTH PACIFIC LAUNDRY  |  EXECUTIVE WORKSHOP</a:t>
+              <a:t>SOUTH PACIFIC LAUNDRY  |  EXECUTIVE STRATEGIC REVIEW</a:t>
             </a:r>
           </a:p>
           <a:p>
@@ -3190,11 +3190,7 @@
               </a:defRPr>
             </a:pPr>
             <a:r>
-              <a:t>ProcureFlow Executive Governance</a:t>
-            </a:r>
-            <a:br/>
-            <a:r>
-              <a:t>&amp; Spend Management Roadmap</a:t>
+              <a:t>ProcureFlow: Journey to Seamless BAU Integration</a:t>
             </a:r>
           </a:p>
           <a:p>
@@ -3210,7 +3206,7 @@
               </a:defRPr>
             </a:pPr>
             <a:r>
-              <a:t>Point-of-Entry Governance  •  Approval Workflows &amp; DOA  •  Automated Escalations  •  EOM Budget Parity</a:t>
+              <a:t>Previous State Foundation  •  Current State Wins &amp; Challenges  •  Target Developed State &amp; Closed-Loop Governance</a:t>
             </a:r>
           </a:p>
         </p:txBody>
@@ -3249,7 +3245,7 @@
               </a:defRPr>
             </a:pPr>
             <a:r>
-              <a:t>EXECUTIVE GOVERNANCE COMMITTEE:</a:t>
+              <a:t>KEY GOVERNANCE STAKEHOLDERS:</a:t>
             </a:r>
           </a:p>
           <a:p>
@@ -3262,7 +3258,7 @@
               </a:defRPr>
             </a:pPr>
             <a:r>
-              <a:t>Ebrahim Mokhtari (Chief Operating Officer)   |   Ashish Chhabra (Procurement Lead)   |   Aaron Bell (Tech Lead)</a:t>
+              <a:t>Ebrahim Mokhtari (Chief Operating Officer)   |   Ashish Chhabra (Procurement Lead / Super User)   |   Aaron Bell (Tech Lead)</a:t>
             </a:r>
           </a:p>
         </p:txBody>
@@ -3319,7 +3315,7 @@
               </a:defRPr>
             </a:pPr>
             <a:r>
-              <a:t>EXECUTION &amp; SIGN-OFF</a:t>
+              <a:t>ACT 3: EXECUTION &amp; SIGN-OFF</a:t>
             </a:r>
           </a:p>
           <a:p>
@@ -3332,7 +3328,7 @@
               </a:defRPr>
             </a:pPr>
             <a:r>
-              <a:t>Thursday Executive Workshop Agenda &amp; Production Cutover</a:t>
+              <a:t>Thursday Executive Workshop Agenda &amp; Production Cutover Plan</a:t>
             </a:r>
           </a:p>
         </p:txBody>
@@ -3432,7 +3428,7 @@
               </a:defRPr>
             </a:pPr>
             <a:r>
-              <a:t>1. Point-of-Entry Input Governance</a:t>
+              <a:t>1. Point-of-Entry Governance</a:t>
             </a:r>
           </a:p>
           <a:p>
@@ -3917,7 +3913,7 @@
               </a:defRPr>
             </a:pPr>
             <a:r>
-              <a:t>STRATEGIC TRANSFORMATION</a:t>
+              <a:t>STRATEGIC TRANSFORMATION FRAMEWORK</a:t>
             </a:r>
           </a:p>
           <a:p>
@@ -3930,7 +3926,7 @@
               </a:defRPr>
             </a:pPr>
             <a:r>
-              <a:t>Executive Summary: The Transition to Closed-Loop Governance</a:t>
+              <a:t>Strategic Narrative: The Evolution of ProcureFlow in SPL</a:t>
             </a:r>
           </a:p>
         </p:txBody>
@@ -4008,13 +4004,29 @@
               </a:spcAft>
               <a:defRPr sz="900" b="1">
                 <a:solidFill>
-                  <a:srgbClr val="E11D48"/>
-                </a:solidFill>
-                <a:latin typeface="Segoe UI"/>
-              </a:defRPr>
-            </a:pPr>
-            <a:r>
-              <a:t>PREVIOUS STATE</a:t>
+                  <a:srgbClr val="0284C7"/>
+                </a:solidFill>
+                <a:latin typeface="Segoe UI"/>
+              </a:defRPr>
+            </a:pPr>
+            <a:r>
+              <a:t>STAGE 1: THE FOUNDATION</a:t>
+            </a:r>
+          </a:p>
+          <a:p>
+            <a:pPr>
+              <a:spcAft>
+                <a:spcPts val="200"/>
+              </a:spcAft>
+              <a:defRPr sz="1700" b="1">
+                <a:solidFill>
+                  <a:srgbClr val="0F172A"/>
+                </a:solidFill>
+                <a:latin typeface="Segoe UI"/>
+              </a:defRPr>
+            </a:pPr>
+            <a:r>
+              <a:t>Previous State</a:t>
             </a:r>
           </a:p>
           <a:p>
@@ -4022,15 +4034,40 @@
               <a:spcAft>
                 <a:spcPts val="1400"/>
               </a:spcAft>
-              <a:defRPr sz="1400" b="1">
+              <a:defRPr sz="1000" b="1">
+                <a:solidFill>
+                  <a:srgbClr val="64748B"/>
+                </a:solidFill>
+                <a:latin typeface="Segoe UI"/>
+              </a:defRPr>
+            </a:pPr>
+            <a:r>
+              <a:t>What ProcureFlow Provided the Business</a:t>
+            </a:r>
+          </a:p>
+          <a:p>
+            <a:pPr>
+              <a:spcAft>
+                <a:spcPts val="1000"/>
+              </a:spcAft>
+            </a:pPr>
+            <a:r>
+              <a:rPr sz="1050" b="1">
                 <a:solidFill>
                   <a:srgbClr val="0F172A"/>
                 </a:solidFill>
                 <a:latin typeface="Segoe UI"/>
-              </a:defRPr>
-            </a:pPr>
-            <a:r>
-              <a:t>1. The Operational Challenge</a:t>
+              </a:rPr>
+              <a:t>• Digitized Linen Requisitions:</a:t>
+            </a:r>
+            <a:r>
+              <a:rPr sz="1050">
+                <a:solidFill>
+                  <a:srgbClr val="475569"/>
+                </a:solidFill>
+                <a:latin typeface="Segoe UI"/>
+              </a:rPr>
+              <a:t> Replaced manual emails and paper forms with a structured ordering portal.</a:t>
             </a:r>
           </a:p>
           <a:p>
@@ -4046,7 +4083,7 @@
                 </a:solidFill>
                 <a:latin typeface="Segoe UI"/>
               </a:rPr>
-              <a:t>• Manual Excel Crunching:</a:t>
+              <a:t>• Multi-Site Management:</a:t>
             </a:r>
             <a:r>
               <a:rPr sz="1050">
@@ -4055,7 +4092,7 @@
                 </a:solidFill>
                 <a:latin typeface="Segoe UI"/>
               </a:rPr>
-              <a:t> Hours spent extracting and categorising Concur reports each month.</a:t>
+              <a:t> Enabled branch-specific catalog browsing and centralized delivery address routing.</a:t>
             </a:r>
           </a:p>
           <a:p>
@@ -4071,7 +4108,7 @@
                 </a:solidFill>
                 <a:latin typeface="Segoe UI"/>
               </a:rPr>
-              <a:t>• Uncontrolled Input Quantities:</a:t>
+              <a:t>• Baseline Approval Hierarchy:</a:t>
             </a:r>
             <a:r>
               <a:rPr sz="1050">
@@ -4080,7 +4117,7 @@
                 </a:solidFill>
                 <a:latin typeface="Segoe UI"/>
               </a:rPr>
-              <a:t> Orders placed with arbitrary numbers (e.g. 5,000 units instead of 240 carton sizes).</a:t>
+              <a:t> Created initial review gates for site managers and procurement.</a:t>
             </a:r>
           </a:p>
           <a:p>
@@ -4096,7 +4133,7 @@
                 </a:solidFill>
                 <a:latin typeface="Segoe UI"/>
               </a:rPr>
-              <a:t>• Contract Price Variances:</a:t>
+              <a:t>• Goods Receipting (GR) Logging:</a:t>
             </a:r>
             <a:r>
               <a:rPr sz="1050">
@@ -4105,32 +4142,7 @@
                 </a:solidFill>
                 <a:latin typeface="Segoe UI"/>
               </a:rPr>
-              <a:t> Accidental pricing typos (e.g. 61¢ vs 51¢) causing finance invoice delays.</a:t>
-            </a:r>
-          </a:p>
-          <a:p>
-            <a:pPr>
-              <a:spcAft>
-                <a:spcPts val="1000"/>
-              </a:spcAft>
-            </a:pPr>
-            <a:r>
-              <a:rPr sz="1050" b="1">
-                <a:solidFill>
-                  <a:srgbClr val="0F172A"/>
-                </a:solidFill>
-                <a:latin typeface="Segoe UI"/>
-              </a:rPr>
-              <a:t>• Missing ERP Linkage:</a:t>
-            </a:r>
-            <a:r>
-              <a:rPr sz="1050">
-                <a:solidFill>
-                  <a:srgbClr val="475569"/>
-                </a:solidFill>
-                <a:latin typeface="Segoe UI"/>
-              </a:rPr>
-              <a:t> Orders receipted in ProcureFlow without Concur PR numbers, breaking audit parity.</a:t>
+              <a:t> Established physical docket tracking on site for delivery confirmation.</a:t>
             </a:r>
           </a:p>
         </p:txBody>
@@ -4208,13 +4220,29 @@
               </a:spcAft>
               <a:defRPr sz="900" b="1">
                 <a:solidFill>
-                  <a:srgbClr val="0284C7"/>
-                </a:solidFill>
-                <a:latin typeface="Segoe UI"/>
-              </a:defRPr>
-            </a:pPr>
-            <a:r>
-              <a:t>UPGRADED CAPABILITIES</a:t>
+                  <a:srgbClr val="D97706"/>
+                </a:solidFill>
+                <a:latin typeface="Segoe UI"/>
+              </a:defRPr>
+            </a:pPr>
+            <a:r>
+              <a:t>STAGE 2: THE REALITY</a:t>
+            </a:r>
+          </a:p>
+          <a:p>
+            <a:pPr>
+              <a:spcAft>
+                <a:spcPts val="200"/>
+              </a:spcAft>
+              <a:defRPr sz="1700" b="1">
+                <a:solidFill>
+                  <a:srgbClr val="0F172A"/>
+                </a:solidFill>
+                <a:latin typeface="Segoe UI"/>
+              </a:defRPr>
+            </a:pPr>
+            <a:r>
+              <a:t>Current State</a:t>
             </a:r>
           </a:p>
           <a:p>
@@ -4222,15 +4250,40 @@
               <a:spcAft>
                 <a:spcPts val="1400"/>
               </a:spcAft>
-              <a:defRPr sz="1400" b="1">
+              <a:defRPr sz="1000" b="1">
+                <a:solidFill>
+                  <a:srgbClr val="64748B"/>
+                </a:solidFill>
+                <a:latin typeface="Segoe UI"/>
+              </a:defRPr>
+            </a:pPr>
+            <a:r>
+              <a:t>Wins, Challenges &amp; Operational Friction</a:t>
+            </a:r>
+          </a:p>
+          <a:p>
+            <a:pPr>
+              <a:spcAft>
+                <a:spcPts val="1000"/>
+              </a:spcAft>
+            </a:pPr>
+            <a:r>
+              <a:rPr sz="1050" b="1">
                 <a:solidFill>
                   <a:srgbClr val="0F172A"/>
                 </a:solidFill>
                 <a:latin typeface="Segoe UI"/>
-              </a:defRPr>
-            </a:pPr>
-            <a:r>
-              <a:t>2. ProcureFlow Engineered Solution</a:t>
+              </a:rPr>
+              <a:t>• Key Wins:</a:t>
+            </a:r>
+            <a:r>
+              <a:rPr sz="1050">
+                <a:solidFill>
+                  <a:srgbClr val="475569"/>
+                </a:solidFill>
+                <a:latin typeface="Segoe UI"/>
+              </a:rPr>
+              <a:t> 100% item code mapping achieved; centralized spend taxonomy (Depletion vs New Business).</a:t>
             </a:r>
           </a:p>
           <a:p>
@@ -4246,7 +4299,7 @@
                 </a:solidFill>
                 <a:latin typeface="Segoe UI"/>
               </a:rPr>
-              <a:t>• Point-of-Entry Validation:</a:t>
+              <a:t>• Operational Challenges:</a:t>
             </a:r>
             <a:r>
               <a:rPr sz="1050">
@@ -4255,7 +4308,7 @@
                 </a:solidFill>
                 <a:latin typeface="Segoe UI"/>
               </a:rPr>
-              <a:t> Hard blocking rules for carton multiples and contracted price master.</a:t>
+              <a:t> Manual EOM Excel crunching by super user; unrounded pack sizes; contract pricing typos; missing Concur ERP links.</a:t>
             </a:r>
           </a:p>
           <a:p>
@@ -4271,7 +4324,7 @@
                 </a:solidFill>
                 <a:latin typeface="Segoe UI"/>
               </a:rPr>
-              <a:t>• DOA Approval Routing:</a:t>
+              <a:t>• The Strategic Opportunity:</a:t>
             </a:r>
             <a:r>
               <a:rPr sz="1050">
@@ -4280,57 +4333,7 @@
                 </a:solidFill>
                 <a:latin typeface="Segoe UI"/>
               </a:rPr>
-              <a:t> Multi-tier approvals aligned with corporate delegation thresholds.</a:t>
-            </a:r>
-          </a:p>
-          <a:p>
-            <a:pPr>
-              <a:spcAft>
-                <a:spcPts val="1000"/>
-              </a:spcAft>
-            </a:pPr>
-            <a:r>
-              <a:rPr sz="1050" b="1">
-                <a:solidFill>
-                  <a:srgbClr val="0F172A"/>
-                </a:solidFill>
-                <a:latin typeface="Segoe UI"/>
-              </a:rPr>
-              <a:t>• Automated Nudges &amp; Escalation:</a:t>
-            </a:r>
-            <a:r>
-              <a:rPr sz="1050">
-                <a:solidFill>
-                  <a:srgbClr val="475569"/>
-                </a:solidFill>
-                <a:latin typeface="Segoe UI"/>
-              </a:rPr>
-              <a:t> Proactive notifications for 100% receipt closure &amp; &gt;14d overdue shipments.</a:t>
-            </a:r>
-          </a:p>
-          <a:p>
-            <a:pPr>
-              <a:spcAft>
-                <a:spcPts val="1000"/>
-              </a:spcAft>
-            </a:pPr>
-            <a:r>
-              <a:rPr sz="1050" b="1">
-                <a:solidFill>
-                  <a:srgbClr val="0F172A"/>
-                </a:solidFill>
-                <a:latin typeface="Segoe UI"/>
-              </a:rPr>
-              <a:t>• Automated EOM Reconciliation:</a:t>
-            </a:r>
-            <a:r>
-              <a:rPr sz="1050">
-                <a:solidFill>
-                  <a:srgbClr val="475569"/>
-                </a:solidFill>
-                <a:latin typeface="Segoe UI"/>
-              </a:rPr>
-              <a:t> Real-time 2D Pivot Table &amp; FY27 Budget burn rate tracking.</a:t>
+              <a:t> Transition from a passive recording tool to an active, self-governing platform.</a:t>
             </a:r>
           </a:p>
         </p:txBody>
@@ -4414,7 +4417,23 @@
               </a:defRPr>
             </a:pPr>
             <a:r>
-              <a:t>EXECUTIVE IMPACT</a:t>
+              <a:t>STAGE 3: THE VISION</a:t>
+            </a:r>
+          </a:p>
+          <a:p>
+            <a:pPr>
+              <a:spcAft>
+                <a:spcPts val="200"/>
+              </a:spcAft>
+              <a:defRPr sz="1700" b="1">
+                <a:solidFill>
+                  <a:srgbClr val="0F172A"/>
+                </a:solidFill>
+                <a:latin typeface="Segoe UI"/>
+              </a:defRPr>
+            </a:pPr>
+            <a:r>
+              <a:t>Future / Developed State</a:t>
             </a:r>
           </a:p>
           <a:p>
@@ -4422,15 +4441,40 @@
               <a:spcAft>
                 <a:spcPts val="1400"/>
               </a:spcAft>
-              <a:defRPr sz="1400" b="1">
+              <a:defRPr sz="1000" b="1">
+                <a:solidFill>
+                  <a:srgbClr val="64748B"/>
+                </a:solidFill>
+                <a:latin typeface="Segoe UI"/>
+              </a:defRPr>
+            </a:pPr>
+            <a:r>
+              <a:t>Frictionless BAU Integration &amp; User Engagement</a:t>
+            </a:r>
+          </a:p>
+          <a:p>
+            <a:pPr>
+              <a:spcAft>
+                <a:spcPts val="1000"/>
+              </a:spcAft>
+            </a:pPr>
+            <a:r>
+              <a:rPr sz="1050" b="1">
                 <a:solidFill>
                   <a:srgbClr val="0F172A"/>
                 </a:solidFill>
                 <a:latin typeface="Segoe UI"/>
-              </a:defRPr>
-            </a:pPr>
-            <a:r>
-              <a:t>3. Strategic Business Value</a:t>
+              </a:rPr>
+              <a:t>• Zero-Defect Input Governance:</a:t>
+            </a:r>
+            <a:r>
+              <a:rPr sz="1050">
+                <a:solidFill>
+                  <a:srgbClr val="475569"/>
+                </a:solidFill>
+                <a:latin typeface="Segoe UI"/>
+              </a:rPr>
+              <a:t> Automated carton multiple rounding and contract price master checks.</a:t>
             </a:r>
           </a:p>
           <a:p>
@@ -4446,7 +4490,7 @@
                 </a:solidFill>
                 <a:latin typeface="Segoe UI"/>
               </a:rPr>
-              <a:t>• Single Source of Truth:</a:t>
+              <a:t>• Closed-Loop ERP Parity:</a:t>
             </a:r>
             <a:r>
               <a:rPr sz="1050">
@@ -4455,7 +4499,7 @@
                 </a:solidFill>
                 <a:latin typeface="Segoe UI"/>
               </a:rPr>
-              <a:t> ProcureFlow natively matches SAP Concur financial figures 100%.</a:t>
+              <a:t> Mandatory Concur PR # rule and live Action Required homepage center.</a:t>
             </a:r>
           </a:p>
           <a:p>
@@ -4471,7 +4515,7 @@
                 </a:solidFill>
                 <a:latin typeface="Segoe UI"/>
               </a:rPr>
-              <a:t>• Zero-Rework Ordering:</a:t>
+              <a:t>• Executive Intelligence:</a:t>
             </a:r>
             <a:r>
               <a:rPr sz="1050">
@@ -4480,7 +4524,7 @@
                 </a:solidFill>
                 <a:latin typeface="Segoe UI"/>
               </a:rPr>
-              <a:t> Eliminates supplier rejections and manual procurement corrections.</a:t>
+              <a:t> Real-time 2D EOM Pivot Reconciliation and FY27 Budget burn rate tracking ($14.521M).</a:t>
             </a:r>
           </a:p>
           <a:p>
@@ -4496,7 +4540,7 @@
                 </a:solidFill>
                 <a:latin typeface="Segoe UI"/>
               </a:rPr>
-              <a:t>• Audit &amp; Compliance Assurance:</a:t>
+              <a:t>• Self-Sustaining User Engagement:</a:t>
             </a:r>
             <a:r>
               <a:rPr sz="1050">
@@ -4505,32 +4549,7 @@
                 </a:solidFill>
                 <a:latin typeface="Segoe UI"/>
               </a:rPr>
-              <a:t> Every requisition has full traceability, manager sign-off, and ERP linkage.</a:t>
-            </a:r>
-          </a:p>
-          <a:p>
-            <a:pPr>
-              <a:spcAft>
-                <a:spcPts val="1000"/>
-              </a:spcAft>
-            </a:pPr>
-            <a:r>
-              <a:rPr sz="1050" b="1">
-                <a:solidFill>
-                  <a:srgbClr val="0F172A"/>
-                </a:solidFill>
-                <a:latin typeface="Segoe UI"/>
-              </a:rPr>
-              <a:t>• Live SOH Transparency:</a:t>
-            </a:r>
-            <a:r>
-              <a:rPr sz="1050">
-                <a:solidFill>
-                  <a:srgbClr val="475569"/>
-                </a:solidFill>
-                <a:latin typeface="Segoe UI"/>
-              </a:rPr>
-              <a:t> Self-service supplier inventory visibility for all state operations managers.</a:t>
+              <a:t> Guardrails guide users naturally to achieve permanent compliance.</a:t>
             </a:r>
           </a:p>
         </p:txBody>
@@ -4587,7 +4606,7 @@
               </a:defRPr>
             </a:pPr>
             <a:r>
-              <a:t>LEADERSHIP ALIGNMENT</a:t>
+              <a:t>ACT 1: THE FOUNDATION</a:t>
             </a:r>
           </a:p>
           <a:p>
@@ -4600,7 +4619,7 @@
               </a:defRPr>
             </a:pPr>
             <a:r>
-              <a:t>Governance Committee: Roles, Responsibilities &amp; Authority</a:t>
+              <a:t>Previous State: What ProcureFlow Has Provided to South Pacific Laundry</a:t>
             </a:r>
           </a:p>
         </p:txBody>
@@ -4614,7 +4633,7 @@
         <p:spPr>
           <a:xfrm>
             <a:off x="731520" y="1463040"/>
-            <a:ext cx="3328416" cy="4754880"/>
+            <a:ext cx="5166360" cy="2240280"/>
           </a:xfrm>
           <a:prstGeom prst="roundRect">
             <a:avLst/>
@@ -4658,8 +4677,8 @@
         </p:nvSpPr>
         <p:spPr>
           <a:xfrm>
-            <a:off x="960120" y="1691640"/>
-            <a:ext cx="2871216" cy="4297680"/>
+            <a:off x="960120" y="1645920"/>
+            <a:ext cx="4709160" cy="1874520"/>
           </a:xfrm>
           <a:prstGeom prst="rect">
             <a:avLst/>
@@ -4674,113 +4693,33 @@
           <a:p>
             <a:pPr>
               <a:spcAft>
-                <a:spcPts val="200"/>
-              </a:spcAft>
-              <a:defRPr sz="1700" b="1">
-                <a:solidFill>
-                  <a:srgbClr val="9333EA"/>
-                </a:solidFill>
-                <a:latin typeface="Segoe UI"/>
-              </a:defRPr>
-            </a:pPr>
-            <a:r>
-              <a:t>Ebrahim Mokhtari</a:t>
-            </a:r>
-          </a:p>
-          <a:p>
-            <a:pPr>
-              <a:spcAft>
-                <a:spcPts val="400"/>
-              </a:spcAft>
-              <a:defRPr sz="1100" b="1">
-                <a:solidFill>
-                  <a:srgbClr val="0F172A"/>
-                </a:solidFill>
-                <a:latin typeface="Segoe UI"/>
-              </a:defRPr>
-            </a:pPr>
-            <a:r>
-              <a:t>Chief Operating Officer (COO)</a:t>
-            </a:r>
-          </a:p>
-          <a:p>
-            <a:pPr>
-              <a:spcAft>
-                <a:spcPts val="1400"/>
-              </a:spcAft>
-              <a:defRPr sz="850" b="1">
-                <a:solidFill>
-                  <a:srgbClr val="64748B"/>
-                </a:solidFill>
-                <a:latin typeface="Segoe UI"/>
-              </a:defRPr>
-            </a:pPr>
-            <a:r>
-              <a:t>EXECUTIVE OVERSIGHT &amp; COMMERCIAL GOVERNANCE</a:t>
-            </a:r>
-          </a:p>
-          <a:p>
-            <a:pPr>
-              <a:spcAft>
-                <a:spcPts val="1000"/>
-              </a:spcAft>
-              <a:defRPr sz="1050">
-                <a:solidFill>
-                  <a:srgbClr val="334155"/>
-                </a:solidFill>
-                <a:latin typeface="Segoe UI"/>
-              </a:defRPr>
-            </a:pPr>
-            <a:r>
-              <a:t>• Executive Sponsor &amp; final sign-off authority for production cutover.</a:t>
-            </a:r>
-          </a:p>
-          <a:p>
-            <a:pPr>
-              <a:spcAft>
-                <a:spcPts val="1000"/>
-              </a:spcAft>
-              <a:defRPr sz="1050">
-                <a:solidFill>
-                  <a:srgbClr val="334155"/>
-                </a:solidFill>
-                <a:latin typeface="Segoe UI"/>
-              </a:defRPr>
-            </a:pPr>
-            <a:r>
-              <a:t>• Reviews national FY27 budget burn rates ($14.521M operating budget).</a:t>
-            </a:r>
-          </a:p>
-          <a:p>
-            <a:pPr>
-              <a:spcAft>
-                <a:spcPts val="1000"/>
-              </a:spcAft>
-              <a:defRPr sz="1050">
-                <a:solidFill>
-                  <a:srgbClr val="334155"/>
-                </a:solidFill>
-                <a:latin typeface="Segoe UI"/>
-              </a:defRPr>
-            </a:pPr>
-            <a:r>
-              <a:t>• Tier 3 DOA Approver: Authorizes high-value orders (&gt;$50k), new customer injection capital, and budget exceptions.</a:t>
-            </a:r>
-          </a:p>
-          <a:p>
-            <a:pPr>
-              <a:spcAft>
-                <a:spcPts val="1000"/>
-              </a:spcAft>
-              <a:defRPr sz="1050">
-                <a:solidFill>
-                  <a:srgbClr val="334155"/>
-                </a:solidFill>
-                <a:latin typeface="Segoe UI"/>
-              </a:defRPr>
-            </a:pPr>
-            <a:r>
-              <a:t>• Enforces site manager compliance and financial accountability across all laundry branches.</a:t>
+                <a:spcPts val="800"/>
+              </a:spcAft>
+              <a:defRPr sz="1300" b="1">
+                <a:solidFill>
+                  <a:srgbClr val="0284C7"/>
+                </a:solidFill>
+                <a:latin typeface="Segoe UI"/>
+              </a:defRPr>
+            </a:pPr>
+            <a:r>
+              <a:t>01  |  DIGITIZED REQUISITIONING</a:t>
+            </a:r>
+          </a:p>
+          <a:p>
+            <a:pPr>
+              <a:spcAft>
+                <a:spcPts val="600"/>
+              </a:spcAft>
+              <a:defRPr sz="1100">
+                <a:solidFill>
+                  <a:srgbClr val="475569"/>
+                </a:solidFill>
+                <a:latin typeface="Segoe UI"/>
+              </a:defRPr>
+            </a:pPr>
+            <a:r>
+              <a:t>Replaced informal emails, phone orders, and physical paperwork with a single standardized online ordering portal for all laundry sites.</a:t>
             </a:r>
           </a:p>
         </p:txBody>
@@ -4793,8 +4732,8 @@
         </p:nvSpPr>
         <p:spPr>
           <a:xfrm>
-            <a:off x="4425696" y="1463040"/>
-            <a:ext cx="3328416" cy="4754880"/>
+            <a:off x="6263640" y="1463040"/>
+            <a:ext cx="5166360" cy="2240280"/>
           </a:xfrm>
           <a:prstGeom prst="roundRect">
             <a:avLst/>
@@ -4838,8 +4777,8 @@
         </p:nvSpPr>
         <p:spPr>
           <a:xfrm>
-            <a:off x="4654296" y="1691640"/>
-            <a:ext cx="2871216" cy="4297680"/>
+            <a:off x="6492240" y="1645920"/>
+            <a:ext cx="4709160" cy="1874520"/>
           </a:xfrm>
           <a:prstGeom prst="rect">
             <a:avLst/>
@@ -4854,113 +4793,33 @@
           <a:p>
             <a:pPr>
               <a:spcAft>
-                <a:spcPts val="200"/>
-              </a:spcAft>
-              <a:defRPr sz="1700" b="1">
-                <a:solidFill>
-                  <a:srgbClr val="0284C7"/>
-                </a:solidFill>
-                <a:latin typeface="Segoe UI"/>
-              </a:defRPr>
-            </a:pPr>
-            <a:r>
-              <a:t>Ashish Chhabra</a:t>
-            </a:r>
-          </a:p>
-          <a:p>
-            <a:pPr>
-              <a:spcAft>
-                <a:spcPts val="400"/>
-              </a:spcAft>
-              <a:defRPr sz="1100" b="1">
-                <a:solidFill>
-                  <a:srgbClr val="0F172A"/>
-                </a:solidFill>
-                <a:latin typeface="Segoe UI"/>
-              </a:defRPr>
-            </a:pPr>
-            <a:r>
-              <a:t>Procurement Lead &amp; Super User</a:t>
-            </a:r>
-          </a:p>
-          <a:p>
-            <a:pPr>
-              <a:spcAft>
-                <a:spcPts val="1400"/>
-              </a:spcAft>
-              <a:defRPr sz="850" b="1">
-                <a:solidFill>
-                  <a:srgbClr val="64748B"/>
-                </a:solidFill>
-                <a:latin typeface="Segoe UI"/>
-              </a:defRPr>
-            </a:pPr>
-            <a:r>
-              <a:t>PROCUREMENT INTEGRITY &amp; FINANCIAL RECONCILIATION</a:t>
-            </a:r>
-          </a:p>
-          <a:p>
-            <a:pPr>
-              <a:spcAft>
-                <a:spcPts val="1000"/>
-              </a:spcAft>
-              <a:defRPr sz="1050">
-                <a:solidFill>
-                  <a:srgbClr val="334155"/>
-                </a:solidFill>
-                <a:latin typeface="Segoe UI"/>
-              </a:defRPr>
-            </a:pPr>
-            <a:r>
-              <a:t>• Procurement Lead &amp; System Super User ensuring commercial data integrity.</a:t>
-            </a:r>
-          </a:p>
-          <a:p>
-            <a:pPr>
-              <a:spcAft>
-                <a:spcPts val="1000"/>
-              </a:spcAft>
-              <a:defRPr sz="1050">
-                <a:solidFill>
-                  <a:srgbClr val="334155"/>
-                </a:solidFill>
-                <a:latin typeface="Segoe UI"/>
-              </a:defRPr>
-            </a:pPr>
-            <a:r>
-              <a:t>• Tier 2 DOA Approver: Validates spend reason (Depletion vs New Business), packaging sizes, and contracted pricing.</a:t>
-            </a:r>
-          </a:p>
-          <a:p>
-            <a:pPr>
-              <a:spcAft>
-                <a:spcPts val="1000"/>
-              </a:spcAft>
-              <a:defRPr sz="1050">
-                <a:solidFill>
-                  <a:srgbClr val="334155"/>
-                </a:solidFill>
-                <a:latin typeface="Segoe UI"/>
-              </a:defRPr>
-            </a:pPr>
-            <a:r>
-              <a:t>• Reconciles monthly EOM spend against SAP Concur and validates strategic subcontracts (HSV, RHC).</a:t>
-            </a:r>
-          </a:p>
-          <a:p>
-            <a:pPr>
-              <a:spcAft>
-                <a:spcPts val="1000"/>
-              </a:spcAft>
-              <a:defRPr sz="1050">
-                <a:solidFill>
-                  <a:srgbClr val="334155"/>
-                </a:solidFill>
-                <a:latin typeface="Segoe UI"/>
-              </a:defRPr>
-            </a:pPr>
-            <a:r>
-              <a:t>• Manages order variance adjustments and supplier catalog master data.</a:t>
+                <a:spcPts val="800"/>
+              </a:spcAft>
+              <a:defRPr sz="1300" b="1">
+                <a:solidFill>
+                  <a:srgbClr val="9333EA"/>
+                </a:solidFill>
+                <a:latin typeface="Segoe UI"/>
+              </a:defRPr>
+            </a:pPr>
+            <a:r>
+              <a:t>02  |  MULTI-SITE GOVERNANCE</a:t>
+            </a:r>
+          </a:p>
+          <a:p>
+            <a:pPr>
+              <a:spcAft>
+                <a:spcPts val="600"/>
+              </a:spcAft>
+              <a:defRPr sz="1100">
+                <a:solidFill>
+                  <a:srgbClr val="475569"/>
+                </a:solidFill>
+                <a:latin typeface="Segoe UI"/>
+              </a:defRPr>
+            </a:pPr>
+            <a:r>
+              <a:t>Enabled site-specific product catalogs, delivery address routing, and local manager authorization across Melbourne, Sydney, Brisbane, Perth, Adelaide, Cairns, Mackay, and Albury.</a:t>
             </a:r>
           </a:p>
         </p:txBody>
@@ -4973,8 +4832,8 @@
         </p:nvSpPr>
         <p:spPr>
           <a:xfrm>
-            <a:off x="8119872" y="1463040"/>
-            <a:ext cx="3328416" cy="4754880"/>
+            <a:off x="731520" y="3977639"/>
+            <a:ext cx="5166360" cy="2240280"/>
           </a:xfrm>
           <a:prstGeom prst="roundRect">
             <a:avLst/>
@@ -5018,8 +4877,8 @@
         </p:nvSpPr>
         <p:spPr>
           <a:xfrm>
-            <a:off x="8348472" y="1691640"/>
-            <a:ext cx="2871216" cy="4297680"/>
+            <a:off x="960120" y="4160519"/>
+            <a:ext cx="4709160" cy="1874520"/>
           </a:xfrm>
           <a:prstGeom prst="rect">
             <a:avLst/>
@@ -5034,9 +4893,9 @@
           <a:p>
             <a:pPr>
               <a:spcAft>
-                <a:spcPts val="200"/>
-              </a:spcAft>
-              <a:defRPr sz="1700" b="1">
+                <a:spcPts val="800"/>
+              </a:spcAft>
+              <a:defRPr sz="1300" b="1">
                 <a:solidFill>
                   <a:srgbClr val="059669"/>
                 </a:solidFill>
@@ -5044,103 +4903,123 @@
               </a:defRPr>
             </a:pPr>
             <a:r>
-              <a:t>Aaron Bell</a:t>
-            </a:r>
-          </a:p>
-          <a:p>
-            <a:pPr>
-              <a:spcAft>
-                <a:spcPts val="400"/>
-              </a:spcAft>
-              <a:defRPr sz="1100" b="1">
-                <a:solidFill>
-                  <a:srgbClr val="0F172A"/>
-                </a:solidFill>
-                <a:latin typeface="Segoe UI"/>
-              </a:defRPr>
-            </a:pPr>
-            <a:r>
-              <a:t>Tech Lead &amp; ProcureFlow Developer</a:t>
-            </a:r>
-          </a:p>
-          <a:p>
-            <a:pPr>
-              <a:spcAft>
-                <a:spcPts val="1400"/>
-              </a:spcAft>
-              <a:defRPr sz="850" b="1">
-                <a:solidFill>
-                  <a:srgbClr val="64748B"/>
-                </a:solidFill>
-                <a:latin typeface="Segoe UI"/>
-              </a:defRPr>
-            </a:pPr>
-            <a:r>
-              <a:t>SYSTEM ARCHITECTURE, AUTOMATION &amp; GOVERNANCE RULES</a:t>
-            </a:r>
-          </a:p>
-          <a:p>
-            <a:pPr>
-              <a:spcAft>
-                <a:spcPts val="1000"/>
-              </a:spcAft>
-              <a:defRPr sz="1050">
-                <a:solidFill>
-                  <a:srgbClr val="334155"/>
-                </a:solidFill>
-                <a:latin typeface="Segoe UI"/>
-              </a:defRPr>
-            </a:pPr>
-            <a:r>
-              <a:t>• Architect and technical developer of ProcureFlow and backend data pipelines.</a:t>
-            </a:r>
-          </a:p>
-          <a:p>
-            <a:pPr>
-              <a:spcAft>
-                <a:spcPts val="1000"/>
-              </a:spcAft>
-              <a:defRPr sz="1050">
-                <a:solidFill>
-                  <a:srgbClr val="334155"/>
-                </a:solidFill>
-                <a:latin typeface="Segoe UI"/>
-              </a:defRPr>
-            </a:pPr>
-            <a:r>
-              <a:t>• Builds automated input blocking rules (carton rounding, price master checks).</a:t>
-            </a:r>
-          </a:p>
-          <a:p>
-            <a:pPr>
-              <a:spcAft>
-                <a:spcPts val="1000"/>
-              </a:spcAft>
-              <a:defRPr sz="1050">
-                <a:solidFill>
-                  <a:srgbClr val="334155"/>
-                </a:solidFill>
-                <a:latin typeface="Segoe UI"/>
-              </a:defRPr>
-            </a:pPr>
-            <a:r>
-              <a:t>• Engineered multi-channel notifications (In-App, Email, MS Teams) &amp; escalation hierarchies.</a:t>
-            </a:r>
-          </a:p>
-          <a:p>
-            <a:pPr>
-              <a:spcAft>
-                <a:spcPts val="1000"/>
-              </a:spcAft>
-              <a:defRPr sz="1050">
-                <a:solidFill>
-                  <a:srgbClr val="334155"/>
-                </a:solidFill>
-                <a:latin typeface="Segoe UI"/>
-              </a:defRPr>
-            </a:pPr>
-            <a:r>
-              <a:t>• Constructed automated 2D Pivot Reconciliation and Live SOH distribution engine.</a:t>
+              <a:t>03  |  GOODS RECEIPT (GR) TRACKING</a:t>
+            </a:r>
+          </a:p>
+          <a:p>
+            <a:pPr>
+              <a:spcAft>
+                <a:spcPts val="600"/>
+              </a:spcAft>
+              <a:defRPr sz="1100">
+                <a:solidFill>
+                  <a:srgbClr val="475569"/>
+                </a:solidFill>
+                <a:latin typeface="Segoe UI"/>
+              </a:defRPr>
+            </a:pPr>
+            <a:r>
+              <a:t>Established digital delivery logging on site, capturing dockets, received quantities, and initial partial delivery histories for audit visibility.</a:t>
+            </a:r>
+          </a:p>
+        </p:txBody>
+      </p:sp>
+      <p:sp>
+        <p:nvSpPr>
+          <p:cNvPr id="9" name="Rounded Rectangle 8"/>
+          <p:cNvSpPr/>
+          <p:nvPr/>
+        </p:nvSpPr>
+        <p:spPr>
+          <a:xfrm>
+            <a:off x="6263640" y="3977639"/>
+            <a:ext cx="5166360" cy="2240280"/>
+          </a:xfrm>
+          <a:prstGeom prst="roundRect">
+            <a:avLst/>
+          </a:prstGeom>
+          <a:solidFill>
+            <a:srgbClr val="FFFFFF"/>
+          </a:solidFill>
+          <a:ln w="15240">
+            <a:solidFill>
+              <a:srgbClr val="E2E8F0"/>
+            </a:solidFill>
+          </a:ln>
+        </p:spPr>
+        <p:style>
+          <a:lnRef idx="1">
+            <a:schemeClr val="accent1"/>
+          </a:lnRef>
+          <a:fillRef idx="3">
+            <a:schemeClr val="accent1"/>
+          </a:fillRef>
+          <a:effectRef idx="2">
+            <a:schemeClr val="accent1"/>
+          </a:effectRef>
+          <a:fontRef idx="minor">
+            <a:schemeClr val="lt1"/>
+          </a:fontRef>
+        </p:style>
+        <p:txBody>
+          <a:bodyPr rtlCol="0" anchor="ctr"/>
+          <a:lstStyle/>
+          <a:p>
+            <a:pPr algn="ctr"/>
+          </a:p>
+        </p:txBody>
+      </p:sp>
+      <p:sp>
+        <p:nvSpPr>
+          <p:cNvPr id="10" name="TextBox 9"/>
+          <p:cNvSpPr txBox="1"/>
+          <p:nvPr/>
+        </p:nvSpPr>
+        <p:spPr>
+          <a:xfrm>
+            <a:off x="6492240" y="4160519"/>
+            <a:ext cx="4709160" cy="1874520"/>
+          </a:xfrm>
+          <a:prstGeom prst="rect">
+            <a:avLst/>
+          </a:prstGeom>
+          <a:noFill/>
+        </p:spPr>
+        <p:txBody>
+          <a:bodyPr wrap="square">
+            <a:spAutoFit/>
+          </a:bodyPr>
+          <a:lstStyle/>
+          <a:p>
+            <a:pPr>
+              <a:spcAft>
+                <a:spcPts val="800"/>
+              </a:spcAft>
+              <a:defRPr sz="1300" b="1">
+                <a:solidFill>
+                  <a:srgbClr val="D97706"/>
+                </a:solidFill>
+                <a:latin typeface="Segoe UI"/>
+              </a:defRPr>
+            </a:pPr>
+            <a:r>
+              <a:t>04  |  FINANCIAL CATEGORISATION</a:t>
+            </a:r>
+          </a:p>
+          <a:p>
+            <a:pPr>
+              <a:spcAft>
+                <a:spcPts val="600"/>
+              </a:spcAft>
+              <a:defRPr sz="1100">
+                <a:solidFill>
+                  <a:srgbClr val="475569"/>
+                </a:solidFill>
+                <a:latin typeface="Segoe UI"/>
+              </a:defRPr>
+            </a:pPr>
+            <a:r>
+              <a:t>Introduced structured taxonomy for classifying spend reasons (Depletion vs New Customer Injection vs Other) to support management reporting.</a:t>
             </a:r>
           </a:p>
         </p:txBody>
@@ -5197,7 +5076,7 @@
               </a:defRPr>
             </a:pPr>
             <a:r>
-              <a:t>POINT-OF-ENTRY GOVERNANCE</a:t>
+              <a:t>ACT 2: OPERATIONAL WINS</a:t>
             </a:r>
           </a:p>
           <a:p>
@@ -5210,7 +5089,7 @@
               </a:defRPr>
             </a:pPr>
             <a:r>
-              <a:t>Pillar 1: Zero-Defect Requisitioning via Input Blocking Rules</a:t>
+              <a:t>Current State: Key Operational Wins &amp; Milestones Achieved</a:t>
             </a:r>
           </a:p>
         </p:txBody>
@@ -5224,7 +5103,7 @@
         <p:spPr>
           <a:xfrm>
             <a:off x="731520" y="1463040"/>
-            <a:ext cx="5166360" cy="4754880"/>
+            <a:ext cx="3328416" cy="4754880"/>
           </a:xfrm>
           <a:prstGeom prst="roundRect">
             <a:avLst/>
@@ -5269,7 +5148,7 @@
         <p:spPr>
           <a:xfrm>
             <a:off x="960120" y="1691640"/>
-            <a:ext cx="4709160" cy="4297680"/>
+            <a:ext cx="2871216" cy="4297680"/>
           </a:xfrm>
           <a:prstGeom prst="rect">
             <a:avLst/>
@@ -5284,17 +5163,17 @@
           <a:p>
             <a:pPr>
               <a:spcAft>
-                <a:spcPts val="1200"/>
-              </a:spcAft>
-              <a:defRPr sz="1600" b="1">
-                <a:solidFill>
-                  <a:srgbClr val="0284C7"/>
-                </a:solidFill>
-                <a:latin typeface="Segoe UI"/>
-              </a:defRPr>
-            </a:pPr>
-            <a:r>
-              <a:t>1. Carton / Pack Size Multiple Enforcement</a:t>
+                <a:spcPts val="400"/>
+              </a:spcAft>
+              <a:defRPr sz="900" b="1">
+                <a:solidFill>
+                  <a:srgbClr val="059669"/>
+                </a:solidFill>
+                <a:latin typeface="Segoe UI"/>
+              </a:defRPr>
+            </a:pPr>
+            <a:r>
+              <a:t>MASTER DATA MILESTONE</a:t>
             </a:r>
           </a:p>
           <a:p>
@@ -5302,23 +5181,7 @@
               <a:spcAft>
                 <a:spcPts val="1400"/>
               </a:spcAft>
-              <a:defRPr sz="1100">
-                <a:solidFill>
-                  <a:srgbClr val="475569"/>
-                </a:solidFill>
-                <a:latin typeface="Segoe UI"/>
-              </a:defRPr>
-            </a:pPr>
-            <a:r>
-              <a:t>The Problem: Staff frequently order arbitrary numbers (e.g. 5,000 units on a 240 carton size, or 90 units on a 100 pack), resulting in supplier order rejection, shipping delays, and manual correction.</a:t>
-            </a:r>
-          </a:p>
-          <a:p>
-            <a:pPr>
-              <a:spcAft>
-                <a:spcPts val="600"/>
-              </a:spcAft>
-              <a:defRPr sz="1150" b="1">
+              <a:defRPr sz="1500" b="1">
                 <a:solidFill>
                   <a:srgbClr val="0F172A"/>
                 </a:solidFill>
@@ -5326,71 +5189,55 @@
               </a:defRPr>
             </a:pPr>
             <a:r>
-              <a:t>The System Rule:</a:t>
-            </a:r>
-          </a:p>
-          <a:p>
-            <a:pPr>
-              <a:spcAft>
-                <a:spcPts val="600"/>
+              <a:t>1. 100% Item Code Mapping</a:t>
+            </a:r>
+          </a:p>
+          <a:p>
+            <a:pPr>
+              <a:spcAft>
+                <a:spcPts val="1000"/>
               </a:spcAft>
               <a:defRPr sz="1050">
                 <a:solidFill>
-                  <a:srgbClr val="059669"/>
-                </a:solidFill>
-                <a:latin typeface="Segoe UI"/>
-              </a:defRPr>
-            </a:pPr>
-            <a:r>
-              <a:t>✓ System checks quantityOrdered % cartonQty === 0 live during order entry.</a:t>
-            </a:r>
-          </a:p>
-          <a:p>
-            <a:pPr>
-              <a:spcAft>
-                <a:spcPts val="600"/>
+                  <a:srgbClr val="334155"/>
+                </a:solidFill>
+                <a:latin typeface="Segoe UI"/>
+              </a:defRPr>
+            </a:pPr>
+            <a:r>
+              <a:t>✓ Completed 100% mapping of SPL internal item codes against vendor product codes (Simba, Host, etc.).</a:t>
+            </a:r>
+          </a:p>
+          <a:p>
+            <a:pPr>
+              <a:spcAft>
+                <a:spcPts val="1000"/>
               </a:spcAft>
               <a:defRPr sz="1050">
                 <a:solidFill>
-                  <a:srgbClr val="059669"/>
-                </a:solidFill>
-                <a:latin typeface="Segoe UI"/>
-              </a:defRPr>
-            </a:pPr>
-            <a:r>
-              <a:t>✓ Unrounded orders are blocked with an instant red alert callout.</a:t>
-            </a:r>
-          </a:p>
-          <a:p>
-            <a:pPr>
-              <a:spcAft>
-                <a:spcPts val="600"/>
+                  <a:srgbClr val="334155"/>
+                </a:solidFill>
+                <a:latin typeface="Segoe UI"/>
+              </a:defRPr>
+            </a:pPr>
+            <a:r>
+              <a:t>✓ Eliminated ambiguity in item descriptions across branches.</a:t>
+            </a:r>
+          </a:p>
+          <a:p>
+            <a:pPr>
+              <a:spcAft>
+                <a:spcPts val="1000"/>
               </a:spcAft>
               <a:defRPr sz="1050">
                 <a:solidFill>
-                  <a:srgbClr val="059669"/>
-                </a:solidFill>
-                <a:latin typeface="Segoe UI"/>
-              </a:defRPr>
-            </a:pPr>
-            <a:r>
-              <a:t>✓ Provides 1-Click Smart Rounding: E.g., Round 5,000 units to 5,040 units (21 full cartons).</a:t>
-            </a:r>
-          </a:p>
-          <a:p>
-            <a:pPr>
-              <a:spcAft>
-                <a:spcPts val="600"/>
-              </a:spcAft>
-              <a:defRPr sz="1050">
-                <a:solidFill>
-                  <a:srgbClr val="059669"/>
-                </a:solidFill>
-                <a:latin typeface="Segoe UI"/>
-              </a:defRPr>
-            </a:pPr>
-            <a:r>
-              <a:t>✓ Enforced across POCreate, PODetail, and draft submissions.</a:t>
+                  <a:srgbClr val="334155"/>
+                </a:solidFill>
+                <a:latin typeface="Segoe UI"/>
+              </a:defRPr>
+            </a:pPr>
+            <a:r>
+              <a:t>✓ Enables seamless automated pricing checks and supplier catalog synchronization.</a:t>
             </a:r>
           </a:p>
         </p:txBody>
@@ -5403,8 +5250,8 @@
         </p:nvSpPr>
         <p:spPr>
           <a:xfrm>
-            <a:off x="6263640" y="1463040"/>
-            <a:ext cx="5166360" cy="4754880"/>
+            <a:off x="4425696" y="1463040"/>
+            <a:ext cx="3328416" cy="4754880"/>
           </a:xfrm>
           <a:prstGeom prst="roundRect">
             <a:avLst/>
@@ -5448,8 +5295,8 @@
         </p:nvSpPr>
         <p:spPr>
           <a:xfrm>
-            <a:off x="6492240" y="1691640"/>
-            <a:ext cx="4709160" cy="4297680"/>
+            <a:off x="4654296" y="1691640"/>
+            <a:ext cx="2871216" cy="4297680"/>
           </a:xfrm>
           <a:prstGeom prst="rect">
             <a:avLst/>
@@ -5464,9 +5311,157 @@
           <a:p>
             <a:pPr>
               <a:spcAft>
-                <a:spcPts val="1200"/>
-              </a:spcAft>
-              <a:defRPr sz="1600" b="1">
+                <a:spcPts val="400"/>
+              </a:spcAft>
+              <a:defRPr sz="900" b="1">
+                <a:solidFill>
+                  <a:srgbClr val="0284C7"/>
+                </a:solidFill>
+                <a:latin typeface="Segoe UI"/>
+              </a:defRPr>
+            </a:pPr>
+            <a:r>
+              <a:t>NATIONAL OPERATIONAL SCALE</a:t>
+            </a:r>
+          </a:p>
+          <a:p>
+            <a:pPr>
+              <a:spcAft>
+                <a:spcPts val="1400"/>
+              </a:spcAft>
+              <a:defRPr sz="1500" b="1">
+                <a:solidFill>
+                  <a:srgbClr val="0F172A"/>
+                </a:solidFill>
+                <a:latin typeface="Segoe UI"/>
+              </a:defRPr>
+            </a:pPr>
+            <a:r>
+              <a:t>2. Multi-Branch Requisitioning</a:t>
+            </a:r>
+          </a:p>
+          <a:p>
+            <a:pPr>
+              <a:spcAft>
+                <a:spcPts val="1000"/>
+              </a:spcAft>
+              <a:defRPr sz="1050">
+                <a:solidFill>
+                  <a:srgbClr val="334155"/>
+                </a:solidFill>
+                <a:latin typeface="Segoe UI"/>
+              </a:defRPr>
+            </a:pPr>
+            <a:r>
+              <a:t>✓ Active daily requisitioning across all 8 operating entities.</a:t>
+            </a:r>
+          </a:p>
+          <a:p>
+            <a:pPr>
+              <a:spcAft>
+                <a:spcPts val="1000"/>
+              </a:spcAft>
+              <a:defRPr sz="1050">
+                <a:solidFill>
+                  <a:srgbClr val="334155"/>
+                </a:solidFill>
+                <a:latin typeface="Segoe UI"/>
+              </a:defRPr>
+            </a:pPr>
+            <a:r>
+              <a:t>✓ Standardized reason tracking (Depletion vs New Business vs Linen Hub).</a:t>
+            </a:r>
+          </a:p>
+          <a:p>
+            <a:pPr>
+              <a:spcAft>
+                <a:spcPts val="1000"/>
+              </a:spcAft>
+              <a:defRPr sz="1050">
+                <a:solidFill>
+                  <a:srgbClr val="334155"/>
+                </a:solidFill>
+                <a:latin typeface="Segoe UI"/>
+              </a:defRPr>
+            </a:pPr>
+            <a:r>
+              <a:t>✓ Centralized audit trail capturing requester, approver, date, and comments on every order.</a:t>
+            </a:r>
+          </a:p>
+        </p:txBody>
+      </p:sp>
+      <p:sp>
+        <p:nvSpPr>
+          <p:cNvPr id="7" name="Rounded Rectangle 6"/>
+          <p:cNvSpPr/>
+          <p:nvPr/>
+        </p:nvSpPr>
+        <p:spPr>
+          <a:xfrm>
+            <a:off x="8119872" y="1463040"/>
+            <a:ext cx="3328416" cy="4754880"/>
+          </a:xfrm>
+          <a:prstGeom prst="roundRect">
+            <a:avLst/>
+          </a:prstGeom>
+          <a:solidFill>
+            <a:srgbClr val="FFFFFF"/>
+          </a:solidFill>
+          <a:ln w="15240">
+            <a:solidFill>
+              <a:srgbClr val="E2E8F0"/>
+            </a:solidFill>
+          </a:ln>
+        </p:spPr>
+        <p:style>
+          <a:lnRef idx="1">
+            <a:schemeClr val="accent1"/>
+          </a:lnRef>
+          <a:fillRef idx="3">
+            <a:schemeClr val="accent1"/>
+          </a:fillRef>
+          <a:effectRef idx="2">
+            <a:schemeClr val="accent1"/>
+          </a:effectRef>
+          <a:fontRef idx="minor">
+            <a:schemeClr val="lt1"/>
+          </a:fontRef>
+        </p:style>
+        <p:txBody>
+          <a:bodyPr rtlCol="0" anchor="ctr"/>
+          <a:lstStyle/>
+          <a:p>
+            <a:pPr algn="ctr"/>
+          </a:p>
+        </p:txBody>
+      </p:sp>
+      <p:sp>
+        <p:nvSpPr>
+          <p:cNvPr id="8" name="TextBox 7"/>
+          <p:cNvSpPr txBox="1"/>
+          <p:nvPr/>
+        </p:nvSpPr>
+        <p:spPr>
+          <a:xfrm>
+            <a:off x="8348472" y="1691640"/>
+            <a:ext cx="2871216" cy="4297680"/>
+          </a:xfrm>
+          <a:prstGeom prst="rect">
+            <a:avLst/>
+          </a:prstGeom>
+          <a:noFill/>
+        </p:spPr>
+        <p:txBody>
+          <a:bodyPr wrap="square">
+            <a:spAutoFit/>
+          </a:bodyPr>
+          <a:lstStyle/>
+          <a:p>
+            <a:pPr>
+              <a:spcAft>
+                <a:spcPts val="400"/>
+              </a:spcAft>
+              <a:defRPr sz="900" b="1">
                 <a:solidFill>
                   <a:srgbClr val="9333EA"/>
                 </a:solidFill>
@@ -5474,7 +5469,7 @@
               </a:defRPr>
             </a:pPr>
             <a:r>
-              <a:t>2. Contract Price Master &amp; Item Mapping</a:t>
+              <a:t>LIVE DATA INGESTION</a:t>
             </a:r>
           </a:p>
           <a:p>
@@ -5482,23 +5477,7 @@
               <a:spcAft>
                 <a:spcPts val="1400"/>
               </a:spcAft>
-              <a:defRPr sz="1100">
-                <a:solidFill>
-                  <a:srgbClr val="475569"/>
-                </a:solidFill>
-                <a:latin typeface="Segoe UI"/>
-              </a:defRPr>
-            </a:pPr>
-            <a:r>
-              <a:t>The Problem: Manual pricing input causes price variances (e.g. 61¢ keyed instead of 51¢ for face washers), causing invoice matching discrepancies and finance payment blocks.</a:t>
-            </a:r>
-          </a:p>
-          <a:p>
-            <a:pPr>
-              <a:spcAft>
-                <a:spcPts val="600"/>
-              </a:spcAft>
-              <a:defRPr sz="1150" b="1">
+              <a:defRPr sz="1500" b="1">
                 <a:solidFill>
                   <a:srgbClr val="0F172A"/>
                 </a:solidFill>
@@ -5506,71 +5485,55 @@
               </a:defRPr>
             </a:pPr>
             <a:r>
-              <a:t>The System Rule &amp; Milestone:</a:t>
-            </a:r>
-          </a:p>
-          <a:p>
-            <a:pPr>
-              <a:spcAft>
-                <a:spcPts val="600"/>
+              <a:t>3. Supplier Inventory Feeds</a:t>
+            </a:r>
+          </a:p>
+          <a:p>
+            <a:pPr>
+              <a:spcAft>
+                <a:spcPts val="1000"/>
               </a:spcAft>
               <a:defRPr sz="1050">
                 <a:solidFill>
-                  <a:srgbClr val="059669"/>
-                </a:solidFill>
-                <a:latin typeface="Segoe UI"/>
-              </a:defRPr>
-            </a:pPr>
-            <a:r>
-              <a:t>✓ 100% Item Mapping Milestone: All SPL internal codes are linked to supplier vendor codes (Simba, Host, etc.).</a:t>
-            </a:r>
-          </a:p>
-          <a:p>
-            <a:pPr>
-              <a:spcAft>
-                <a:spcPts val="600"/>
+                  <a:srgbClr val="334155"/>
+                </a:solidFill>
+                <a:latin typeface="Segoe UI"/>
+              </a:defRPr>
+            </a:pPr>
+            <a:r>
+              <a:t>✓ Automated ingestion pipeline for supplier stock-on-hand (SOH) reports.</a:t>
+            </a:r>
+          </a:p>
+          <a:p>
+            <a:pPr>
+              <a:spcAft>
+                <a:spcPts val="1000"/>
               </a:spcAft>
               <a:defRPr sz="1050">
                 <a:solidFill>
-                  <a:srgbClr val="059669"/>
-                </a:solidFill>
-                <a:latin typeface="Segoe UI"/>
-              </a:defRPr>
-            </a:pPr>
-            <a:r>
-              <a:t>✓ Automated Pricing Lookup: Active contracted supplier catalog rates auto-populate PO lines.</a:t>
-            </a:r>
-          </a:p>
-          <a:p>
-            <a:pPr>
-              <a:spcAft>
-                <a:spcPts val="600"/>
+                  <a:srgbClr val="334155"/>
+                </a:solidFill>
+                <a:latin typeface="Segoe UI"/>
+              </a:defRPr>
+            </a:pPr>
+            <a:r>
+              <a:t>✓ Provides baseline visibility into supplier stock levels before orders are placed.</a:t>
+            </a:r>
+          </a:p>
+          <a:p>
+            <a:pPr>
+              <a:spcAft>
+                <a:spcPts val="1000"/>
               </a:spcAft>
               <a:defRPr sz="1050">
                 <a:solidFill>
-                  <a:srgbClr val="059669"/>
-                </a:solidFill>
-                <a:latin typeface="Segoe UI"/>
-              </a:defRPr>
-            </a:pPr>
-            <a:r>
-              <a:t>✓ Price Variance Block: Disallows $0.00 pricing and flags non-contract price overrides.</a:t>
-            </a:r>
-          </a:p>
-          <a:p>
-            <a:pPr>
-              <a:spcAft>
-                <a:spcPts val="600"/>
-              </a:spcAft>
-              <a:defRPr sz="1050">
-                <a:solidFill>
-                  <a:srgbClr val="059669"/>
-                </a:solidFill>
-                <a:latin typeface="Segoe UI"/>
-              </a:defRPr>
-            </a:pPr>
-            <a:r>
-              <a:t>✓ Zero invoice discrepancies upon 3-way matching in finance.</a:t>
+                  <a:srgbClr val="334155"/>
+                </a:solidFill>
+                <a:latin typeface="Segoe UI"/>
+              </a:defRPr>
+            </a:pPr>
+            <a:r>
+              <a:t>✓ Lays the foundation for deprecating manual weekly email distributions.</a:t>
             </a:r>
           </a:p>
         </p:txBody>
@@ -5627,7 +5590,7 @@
               </a:defRPr>
             </a:pPr>
             <a:r>
-              <a:t>WORKFLOW MANAGEMENT</a:t>
+              <a:t>ACT 2: CHALLENGES</a:t>
             </a:r>
           </a:p>
           <a:p>
@@ -5640,7 +5603,7 @@
               </a:defRPr>
             </a:pPr>
             <a:r>
-              <a:t>Pillar 2: Delegation of Authority (DOA) &amp; Multi-Tier Approvals</a:t>
+              <a:t>Current State: Operational Challenges &amp; Data Integrity Friction</a:t>
             </a:r>
           </a:p>
         </p:txBody>
@@ -5654,7 +5617,7 @@
         <p:spPr>
           <a:xfrm>
             <a:off x="731520" y="1463040"/>
-            <a:ext cx="3328416" cy="4754880"/>
+            <a:ext cx="5166360" cy="2240280"/>
           </a:xfrm>
           <a:prstGeom prst="roundRect">
             <a:avLst/>
@@ -5698,8 +5661,8 @@
         </p:nvSpPr>
         <p:spPr>
           <a:xfrm>
-            <a:off x="960120" y="1691640"/>
-            <a:ext cx="2871216" cy="4297680"/>
+            <a:off x="960120" y="1645920"/>
+            <a:ext cx="4709160" cy="1874520"/>
           </a:xfrm>
           <a:prstGeom prst="rect">
             <a:avLst/>
@@ -5714,97 +5677,30 @@
           <a:p>
             <a:pPr>
               <a:spcAft>
-                <a:spcPts val="400"/>
-              </a:spcAft>
-              <a:defRPr sz="1000" b="1">
-                <a:solidFill>
-                  <a:srgbClr val="0284C7"/>
-                </a:solidFill>
-                <a:latin typeface="Segoe UI"/>
-              </a:defRPr>
-            </a:pPr>
-            <a:r>
-              <a:t>TIER 1: SITE LEVEL</a:t>
-            </a:r>
-          </a:p>
-          <a:p>
-            <a:pPr>
-              <a:spcAft>
-                <a:spcPts val="200"/>
-              </a:spcAft>
-              <a:defRPr sz="1500" b="1">
-                <a:solidFill>
-                  <a:srgbClr val="0F172A"/>
-                </a:solidFill>
-                <a:latin typeface="Segoe UI"/>
-              </a:defRPr>
-            </a:pPr>
-            <a:r>
-              <a:t>Site / Branch Operations Managers</a:t>
-            </a:r>
-          </a:p>
-          <a:p>
-            <a:pPr>
-              <a:spcAft>
-                <a:spcPts val="1600"/>
-              </a:spcAft>
-              <a:defRPr sz="900" b="1">
-                <a:solidFill>
-                  <a:srgbClr val="64748B"/>
-                </a:solidFill>
-                <a:latin typeface="Segoe UI"/>
-              </a:defRPr>
-            </a:pPr>
-            <a:r>
-              <a:t>BASELINE OPERATIONAL SPEND</a:t>
-            </a:r>
-          </a:p>
-          <a:p>
-            <a:pPr>
-              <a:spcAft>
-                <a:spcPts val="1000"/>
-              </a:spcAft>
+                <a:spcPts val="800"/>
+              </a:spcAft>
+              <a:defRPr sz="1200" b="1">
+                <a:solidFill>
+                  <a:srgbClr val="E11D48"/>
+                </a:solidFill>
+                <a:latin typeface="Segoe UI"/>
+              </a:defRPr>
+            </a:pPr>
+            <a:r>
+              <a:t>HIGH WORKLOAD / RISK  |  1. MANUAL EOM EXCEL CRUNCHING</a:t>
+            </a:r>
+          </a:p>
+          <a:p>
+            <a:pPr>
               <a:defRPr sz="1050">
                 <a:solidFill>
-                  <a:srgbClr val="334155"/>
-                </a:solidFill>
-                <a:latin typeface="Segoe UI"/>
-              </a:defRPr>
-            </a:pPr>
-            <a:r>
-              <a:t>• Approves routine weekly depletion requisitions within branch threshold.</a:t>
-            </a:r>
-          </a:p>
-          <a:p>
-            <a:pPr>
-              <a:spcAft>
-                <a:spcPts val="1000"/>
-              </a:spcAft>
-              <a:defRPr sz="1050">
-                <a:solidFill>
-                  <a:srgbClr val="334155"/>
-                </a:solidFill>
-                <a:latin typeface="Segoe UI"/>
-              </a:defRPr>
-            </a:pPr>
-            <a:r>
-              <a:t>• Verifies need-by delivery dates and branch site delivery readiness.</a:t>
-            </a:r>
-          </a:p>
-          <a:p>
-            <a:pPr>
-              <a:spcAft>
-                <a:spcPts val="1000"/>
-              </a:spcAft>
-              <a:defRPr sz="1050">
-                <a:solidFill>
-                  <a:srgbClr val="334155"/>
-                </a:solidFill>
-                <a:latin typeface="Segoe UI"/>
-              </a:defRPr>
-            </a:pPr>
-            <a:r>
-              <a:t>• First line of financial review before procurement routing.</a:t>
+                  <a:srgbClr val="475569"/>
+                </a:solidFill>
+                <a:latin typeface="Segoe UI"/>
+              </a:defRPr>
+            </a:pPr>
+            <a:r>
+              <a:t>Ashish Chhabra (Super User) spends days each month extracting Concur reports, recalculating ex-GST values (/ 1.1), manually parsing unstandardized descriptions, and building pivot tables for executive reporting.</a:t>
             </a:r>
           </a:p>
         </p:txBody>
@@ -5817,8 +5713,8 @@
         </p:nvSpPr>
         <p:spPr>
           <a:xfrm>
-            <a:off x="4425696" y="1463040"/>
-            <a:ext cx="3328416" cy="4754880"/>
+            <a:off x="6263640" y="1463040"/>
+            <a:ext cx="5166360" cy="2240280"/>
           </a:xfrm>
           <a:prstGeom prst="roundRect">
             <a:avLst/>
@@ -5862,8 +5758,8 @@
         </p:nvSpPr>
         <p:spPr>
           <a:xfrm>
-            <a:off x="4654296" y="1691640"/>
-            <a:ext cx="2871216" cy="4297680"/>
+            <a:off x="6492240" y="1645920"/>
+            <a:ext cx="4709160" cy="1874520"/>
           </a:xfrm>
           <a:prstGeom prst="rect">
             <a:avLst/>
@@ -5878,97 +5774,30 @@
           <a:p>
             <a:pPr>
               <a:spcAft>
-                <a:spcPts val="400"/>
-              </a:spcAft>
-              <a:defRPr sz="1000" b="1">
-                <a:solidFill>
-                  <a:srgbClr val="059669"/>
-                </a:solidFill>
-                <a:latin typeface="Segoe UI"/>
-              </a:defRPr>
-            </a:pPr>
-            <a:r>
-              <a:t>TIER 2: PROCUREMENT</a:t>
-            </a:r>
-          </a:p>
-          <a:p>
-            <a:pPr>
-              <a:spcAft>
-                <a:spcPts val="200"/>
-              </a:spcAft>
-              <a:defRPr sz="1500" b="1">
-                <a:solidFill>
-                  <a:srgbClr val="0F172A"/>
-                </a:solidFill>
-                <a:latin typeface="Segoe UI"/>
-              </a:defRPr>
-            </a:pPr>
-            <a:r>
-              <a:t>Ashish Chhabra (Procurement Lead)</a:t>
-            </a:r>
-          </a:p>
-          <a:p>
-            <a:pPr>
-              <a:spcAft>
-                <a:spcPts val="1600"/>
-              </a:spcAft>
-              <a:defRPr sz="900" b="1">
-                <a:solidFill>
-                  <a:srgbClr val="64748B"/>
-                </a:solidFill>
-                <a:latin typeface="Segoe UI"/>
-              </a:defRPr>
-            </a:pPr>
-            <a:r>
-              <a:t>COMMERCIAL &amp; PARITY GOVERNANCE</a:t>
-            </a:r>
-          </a:p>
-          <a:p>
-            <a:pPr>
-              <a:spcAft>
-                <a:spcPts val="1000"/>
-              </a:spcAft>
+                <a:spcPts val="800"/>
+              </a:spcAft>
+              <a:defRPr sz="1200" b="1">
+                <a:solidFill>
+                  <a:srgbClr val="D97706"/>
+                </a:solidFill>
+                <a:latin typeface="Segoe UI"/>
+              </a:defRPr>
+            </a:pPr>
+            <a:r>
+              <a:t>SUPPLIER REJECTIONS  |  2. UNROUNDED REQUISITION QUANTITIES</a:t>
+            </a:r>
+          </a:p>
+          <a:p>
+            <a:pPr>
               <a:defRPr sz="1050">
                 <a:solidFill>
-                  <a:srgbClr val="334155"/>
-                </a:solidFill>
-                <a:latin typeface="Segoe UI"/>
-              </a:defRPr>
-            </a:pPr>
-            <a:r>
-              <a:t>• Validates spend classification (Depletion vs New Business vs Linen Hub).</a:t>
-            </a:r>
-          </a:p>
-          <a:p>
-            <a:pPr>
-              <a:spcAft>
-                <a:spcPts val="1000"/>
-              </a:spcAft>
-              <a:defRPr sz="1050">
-                <a:solidFill>
-                  <a:srgbClr val="334155"/>
-                </a:solidFill>
-                <a:latin typeface="Segoe UI"/>
-              </a:defRPr>
-            </a:pPr>
-            <a:r>
-              <a:t>• Audits carton multiples and supplier catalog price integrity.</a:t>
-            </a:r>
-          </a:p>
-          <a:p>
-            <a:pPr>
-              <a:spcAft>
-                <a:spcPts val="1000"/>
-              </a:spcAft>
-              <a:defRPr sz="1050">
-                <a:solidFill>
-                  <a:srgbClr val="334155"/>
-                </a:solidFill>
-                <a:latin typeface="Segoe UI"/>
-              </a:defRPr>
-            </a:pPr>
-            <a:r>
-              <a:t>• Ensures requisition matches approved FY27 branch budget allocation.</a:t>
+                  <a:srgbClr val="475569"/>
+                </a:solidFill>
+                <a:latin typeface="Segoe UI"/>
+              </a:defRPr>
+            </a:pPr>
+            <a:r>
+              <a:t>Site staff order arbitrary quantities (e.g. 5,000 units on a 240 carton size, or 90 units on a 100 pack). Orders must be manually rejected and re-raised, creating operational delays.</a:t>
             </a:r>
           </a:p>
         </p:txBody>
@@ -5981,8 +5810,8 @@
         </p:nvSpPr>
         <p:spPr>
           <a:xfrm>
-            <a:off x="8119872" y="1463040"/>
-            <a:ext cx="3328416" cy="4754880"/>
+            <a:off x="731520" y="3977639"/>
+            <a:ext cx="5166360" cy="2240280"/>
           </a:xfrm>
           <a:prstGeom prst="roundRect">
             <a:avLst/>
@@ -6026,8 +5855,8 @@
         </p:nvSpPr>
         <p:spPr>
           <a:xfrm>
-            <a:off x="8348472" y="1691640"/>
-            <a:ext cx="2871216" cy="4297680"/>
+            <a:off x="960120" y="4160519"/>
+            <a:ext cx="4709160" cy="1874520"/>
           </a:xfrm>
           <a:prstGeom prst="rect">
             <a:avLst/>
@@ -6042,97 +5871,127 @@
           <a:p>
             <a:pPr>
               <a:spcAft>
-                <a:spcPts val="400"/>
-              </a:spcAft>
-              <a:defRPr sz="1000" b="1">
-                <a:solidFill>
-                  <a:srgbClr val="9333EA"/>
-                </a:solidFill>
-                <a:latin typeface="Segoe UI"/>
-              </a:defRPr>
-            </a:pPr>
-            <a:r>
-              <a:t>TIER 3: EXECUTIVE (COO)</a:t>
-            </a:r>
-          </a:p>
-          <a:p>
-            <a:pPr>
-              <a:spcAft>
-                <a:spcPts val="200"/>
-              </a:spcAft>
-              <a:defRPr sz="1500" b="1">
-                <a:solidFill>
-                  <a:srgbClr val="0F172A"/>
-                </a:solidFill>
-                <a:latin typeface="Segoe UI"/>
-              </a:defRPr>
-            </a:pPr>
-            <a:r>
-              <a:t>Ebrahim Mokhtari (Chief Operating Officer)</a:t>
-            </a:r>
-          </a:p>
-          <a:p>
-            <a:pPr>
-              <a:spcAft>
-                <a:spcPts val="1600"/>
-              </a:spcAft>
-              <a:defRPr sz="900" b="1">
-                <a:solidFill>
-                  <a:srgbClr val="64748B"/>
-                </a:solidFill>
-                <a:latin typeface="Segoe UI"/>
-              </a:defRPr>
-            </a:pPr>
-            <a:r>
-              <a:t>STRATEGIC &amp; HIGH-VALUE SPEND</a:t>
-            </a:r>
-          </a:p>
-          <a:p>
-            <a:pPr>
-              <a:spcAft>
-                <a:spcPts val="1000"/>
-              </a:spcAft>
+                <a:spcPts val="800"/>
+              </a:spcAft>
+              <a:defRPr sz="1200" b="1">
+                <a:solidFill>
+                  <a:srgbClr val="E11D48"/>
+                </a:solidFill>
+                <a:latin typeface="Segoe UI"/>
+              </a:defRPr>
+            </a:pPr>
+            <a:r>
+              <a:t>FINANCE INVOICE BLOCKS  |  3. CONTRACT PRICING TYPOS</a:t>
+            </a:r>
+          </a:p>
+          <a:p>
+            <a:pPr>
               <a:defRPr sz="1050">
                 <a:solidFill>
-                  <a:srgbClr val="334155"/>
-                </a:solidFill>
-                <a:latin typeface="Segoe UI"/>
-              </a:defRPr>
-            </a:pPr>
-            <a:r>
-              <a:t>• Authorizes high-value orders (e.g. &gt;$50,000 threshold).</a:t>
-            </a:r>
-          </a:p>
-          <a:p>
-            <a:pPr>
-              <a:spcAft>
-                <a:spcPts val="1000"/>
-              </a:spcAft>
+                  <a:srgbClr val="475569"/>
+                </a:solidFill>
+                <a:latin typeface="Segoe UI"/>
+              </a:defRPr>
+            </a:pPr>
+            <a:r>
+              <a:t>Manual price entry leads to errors (e.g. keying 61¢ instead of contracted 51¢ for face washers). Discrepancies cause 3-way matching failures in finance and delayed payments.</a:t>
+            </a:r>
+          </a:p>
+        </p:txBody>
+      </p:sp>
+      <p:sp>
+        <p:nvSpPr>
+          <p:cNvPr id="9" name="Rounded Rectangle 8"/>
+          <p:cNvSpPr/>
+          <p:nvPr/>
+        </p:nvSpPr>
+        <p:spPr>
+          <a:xfrm>
+            <a:off x="6263640" y="3977639"/>
+            <a:ext cx="5166360" cy="2240280"/>
+          </a:xfrm>
+          <a:prstGeom prst="roundRect">
+            <a:avLst/>
+          </a:prstGeom>
+          <a:solidFill>
+            <a:srgbClr val="FFFFFF"/>
+          </a:solidFill>
+          <a:ln w="15240">
+            <a:solidFill>
+              <a:srgbClr val="E2E8F0"/>
+            </a:solidFill>
+          </a:ln>
+        </p:spPr>
+        <p:style>
+          <a:lnRef idx="1">
+            <a:schemeClr val="accent1"/>
+          </a:lnRef>
+          <a:fillRef idx="3">
+            <a:schemeClr val="accent1"/>
+          </a:fillRef>
+          <a:effectRef idx="2">
+            <a:schemeClr val="accent1"/>
+          </a:effectRef>
+          <a:fontRef idx="minor">
+            <a:schemeClr val="lt1"/>
+          </a:fontRef>
+        </p:style>
+        <p:txBody>
+          <a:bodyPr rtlCol="0" anchor="ctr"/>
+          <a:lstStyle/>
+          <a:p>
+            <a:pPr algn="ctr"/>
+          </a:p>
+        </p:txBody>
+      </p:sp>
+      <p:sp>
+        <p:nvSpPr>
+          <p:cNvPr id="10" name="TextBox 9"/>
+          <p:cNvSpPr txBox="1"/>
+          <p:nvPr/>
+        </p:nvSpPr>
+        <p:spPr>
+          <a:xfrm>
+            <a:off x="6492240" y="4160519"/>
+            <a:ext cx="4709160" cy="1874520"/>
+          </a:xfrm>
+          <a:prstGeom prst="rect">
+            <a:avLst/>
+          </a:prstGeom>
+          <a:noFill/>
+        </p:spPr>
+        <p:txBody>
+          <a:bodyPr wrap="square">
+            <a:spAutoFit/>
+          </a:bodyPr>
+          <a:lstStyle/>
+          <a:p>
+            <a:pPr>
+              <a:spcAft>
+                <a:spcPts val="800"/>
+              </a:spcAft>
+              <a:defRPr sz="1200" b="1">
+                <a:solidFill>
+                  <a:srgbClr val="D97706"/>
+                </a:solidFill>
+                <a:latin typeface="Segoe UI"/>
+              </a:defRPr>
+            </a:pPr>
+            <a:r>
+              <a:t>AUDIT &amp; REPORTING BLINDSPOT  |  4. MISSING CONCUR ERP LINKAGE</a:t>
+            </a:r>
+          </a:p>
+          <a:p>
+            <a:pPr>
               <a:defRPr sz="1050">
                 <a:solidFill>
-                  <a:srgbClr val="334155"/>
-                </a:solidFill>
-                <a:latin typeface="Segoe UI"/>
-              </a:defRPr>
-            </a:pPr>
-            <a:r>
-              <a:t>• Reviews &amp; approves New Customer injection capital projects.</a:t>
-            </a:r>
-          </a:p>
-          <a:p>
-            <a:pPr>
-              <a:spcAft>
-                <a:spcPts val="1000"/>
-              </a:spcAft>
-              <a:defRPr sz="1050">
-                <a:solidFill>
-                  <a:srgbClr val="334155"/>
-                </a:solidFill>
-                <a:latin typeface="Segoe UI"/>
-              </a:defRPr>
-            </a:pPr>
-            <a:r>
-              <a:t>• Approves unbudgeted threshold exceptions and strategic national stock orders.</a:t>
+                  <a:srgbClr val="475569"/>
+                </a:solidFill>
+                <a:latin typeface="Segoe UI"/>
+              </a:defRPr>
+            </a:pPr>
+            <a:r>
+              <a:t>Staff mark orders as received in ProcureFlow but fail to enter the Concur Request PR #. This breaks 1-to-1 data mirroring and prevents automated spend reconciliation.</a:t>
             </a:r>
           </a:p>
         </p:txBody>
@@ -6189,7 +6048,7 @@
               </a:defRPr>
             </a:pPr>
             <a:r>
-              <a:t>OPERATIONAL ALIGNMENT</a:t>
+              <a:t>ACT 2: STRATEGIC OPPORTUNITY</a:t>
             </a:r>
           </a:p>
           <a:p>
@@ -6202,7 +6061,7 @@
               </a:defRPr>
             </a:pPr>
             <a:r>
-              <a:t>Pillar 3: Automated Notifications &amp; Management Escalation</a:t>
+              <a:t>The Strategic Opportunity: From Passive Tracking to Closed-Loop Governance</a:t>
             </a:r>
           </a:p>
         </p:txBody>
@@ -6216,7 +6075,7 @@
         <p:spPr>
           <a:xfrm>
             <a:off x="731520" y="1463040"/>
-            <a:ext cx="3328416" cy="4754880"/>
+            <a:ext cx="10728655" cy="4754880"/>
           </a:xfrm>
           <a:prstGeom prst="roundRect">
             <a:avLst/>
@@ -6260,8 +6119,8 @@
         </p:nvSpPr>
         <p:spPr>
           <a:xfrm>
-            <a:off x="960120" y="1691640"/>
-            <a:ext cx="2871216" cy="4297680"/>
+            <a:off x="1005840" y="1691640"/>
+            <a:ext cx="10180015" cy="4297680"/>
           </a:xfrm>
           <a:prstGeom prst="rect">
             <a:avLst/>
@@ -6276,49 +6135,42 @@
           <a:p>
             <a:pPr>
               <a:spcAft>
-                <a:spcPts val="400"/>
-              </a:spcAft>
-              <a:defRPr sz="900" b="1">
-                <a:solidFill>
-                  <a:srgbClr val="059669"/>
-                </a:solidFill>
-                <a:latin typeface="Segoe UI"/>
-              </a:defRPr>
-            </a:pPr>
-            <a:r>
-              <a:t>COMPLETION NUDGES</a:t>
-            </a:r>
-          </a:p>
-          <a:p>
-            <a:pPr>
-              <a:spcAft>
-                <a:spcPts val="800"/>
-              </a:spcAft>
-              <a:defRPr sz="1400" b="1">
+                <a:spcPts val="1400"/>
+              </a:spcAft>
+              <a:defRPr sz="1800" b="1">
+                <a:solidFill>
+                  <a:srgbClr val="0284C7"/>
+                </a:solidFill>
+                <a:latin typeface="Segoe UI"/>
+              </a:defRPr>
+            </a:pPr>
+            <a:r>
+              <a:t>Transforming ProcureFlow into SPL's Single Source of Truth</a:t>
+            </a:r>
+          </a:p>
+          <a:p>
+            <a:pPr>
+              <a:spcAft>
+                <a:spcPts val="1000"/>
+              </a:spcAft>
+            </a:pPr>
+            <a:r>
+              <a:rPr sz="1100" b="1">
                 <a:solidFill>
                   <a:srgbClr val="0F172A"/>
                 </a:solidFill>
                 <a:latin typeface="Segoe UI"/>
-              </a:defRPr>
-            </a:pPr>
-            <a:r>
-              <a:t>1. 100% Goods Receipt Closure</a:t>
-            </a:r>
-          </a:p>
-          <a:p>
-            <a:pPr>
-              <a:spcAft>
-                <a:spcPts val="1400"/>
-              </a:spcAft>
-              <a:defRPr sz="1000">
-                <a:solidFill>
-                  <a:srgbClr val="64748B"/>
-                </a:solidFill>
-                <a:latin typeface="Segoe UI"/>
-              </a:defRPr>
-            </a:pPr>
-            <a:r>
-              <a:t>Automated closure alerts once physical goods arrive:</a:t>
+              </a:rPr>
+              <a:t>★ Automated Point-of-Entry Guardrails: </a:t>
+            </a:r>
+            <a:r>
+              <a:rPr sz="1100">
+                <a:solidFill>
+                  <a:srgbClr val="475569"/>
+                </a:solidFill>
+                <a:latin typeface="Segoe UI"/>
+              </a:rPr>
+              <a:t>Instead of relying on manual spot-checks and rejections, engineer hard system validation rules into the requisition UI that make it impossible to submit an incorrect quantity or price.</a:t>
             </a:r>
           </a:p>
           <a:p>
@@ -6328,22 +6180,22 @@
               </a:spcAft>
             </a:pPr>
             <a:r>
-              <a:rPr sz="1000" b="1">
+              <a:rPr sz="1100" b="1">
                 <a:solidFill>
                   <a:srgbClr val="0F172A"/>
                 </a:solidFill>
                 <a:latin typeface="Segoe UI"/>
               </a:rPr>
-              <a:t>• Trigger:</a:t>
-            </a:r>
-            <a:r>
-              <a:rPr sz="1000">
+              <a:t>★ Closed-Loop ERP Parity with SAP Concur: </a:t>
+            </a:r>
+            <a:r>
+              <a:rPr sz="1100">
                 <a:solidFill>
                   <a:srgbClr val="475569"/>
                 </a:solidFill>
                 <a:latin typeface="Segoe UI"/>
               </a:rPr>
-              <a:t> 100% of physical items received on site, but PO remains open in ProcureFlow.</a:t>
+              <a:t>Eliminate orphaned orders by enforcing mandatory Concur PR # logging before order completion, guaranteeing permanent 1-to-1 data alignment between Concur and ProcureFlow.</a:t>
             </a:r>
           </a:p>
           <a:p>
@@ -6353,22 +6205,22 @@
               </a:spcAft>
             </a:pPr>
             <a:r>
-              <a:rPr sz="1000" b="1">
+              <a:rPr sz="1100" b="1">
                 <a:solidFill>
                   <a:srgbClr val="0F172A"/>
                 </a:solidFill>
                 <a:latin typeface="Segoe UI"/>
               </a:rPr>
-              <a:t>• Daily Automated Nudge:</a:t>
-            </a:r>
-            <a:r>
-              <a:rPr sz="1000">
+              <a:t>★ Proactive Operational Escalations: </a:t>
+            </a:r>
+            <a:r>
+              <a:rPr sz="1100">
                 <a:solidFill>
                   <a:srgbClr val="475569"/>
                 </a:solidFill>
                 <a:latin typeface="Segoe UI"/>
               </a:rPr>
-              <a:t> Prompts requester to formally complete and close the order.</a:t>
+              <a:t>Deploy automated multi-channel notifications (In-App, Email, MS Teams) that remind users to complete delivered orders and automatically escalate stalled shipments (&gt;14 days) to line managers.</a:t>
             </a:r>
           </a:p>
           <a:p>
@@ -6378,404 +6230,47 @@
               </a:spcAft>
             </a:pPr>
             <a:r>
-              <a:rPr sz="1000" b="1">
+              <a:rPr sz="1100" b="1">
                 <a:solidFill>
                   <a:srgbClr val="0F172A"/>
                 </a:solidFill>
                 <a:latin typeface="Segoe UI"/>
               </a:rPr>
-              <a:t>• Variance Protection:</a:t>
-            </a:r>
-            <a:r>
-              <a:rPr sz="1000">
+              <a:t>★ Executive-Ready Financial Intelligence: </a:t>
+            </a:r>
+            <a:r>
+              <a:rPr sz="1100">
                 <a:solidFill>
                   <a:srgbClr val="475569"/>
                 </a:solidFill>
                 <a:latin typeface="Segoe UI"/>
               </a:rPr>
-              <a:t> Directs user to adjust quantities with Ashish if delivery differed from order.</a:t>
-            </a:r>
-          </a:p>
-        </p:txBody>
-      </p:sp>
-      <p:sp>
-        <p:nvSpPr>
-          <p:cNvPr id="5" name="Rounded Rectangle 4"/>
-          <p:cNvSpPr/>
-          <p:nvPr/>
-        </p:nvSpPr>
-        <p:spPr>
-          <a:xfrm>
-            <a:off x="4425696" y="1463040"/>
-            <a:ext cx="3328416" cy="4754880"/>
-          </a:xfrm>
-          <a:prstGeom prst="roundRect">
-            <a:avLst/>
-          </a:prstGeom>
-          <a:solidFill>
-            <a:srgbClr val="FFFFFF"/>
-          </a:solidFill>
-          <a:ln w="15240">
-            <a:solidFill>
-              <a:srgbClr val="E2E8F0"/>
-            </a:solidFill>
-          </a:ln>
-        </p:spPr>
-        <p:style>
-          <a:lnRef idx="1">
-            <a:schemeClr val="accent1"/>
-          </a:lnRef>
-          <a:fillRef idx="3">
-            <a:schemeClr val="accent1"/>
-          </a:fillRef>
-          <a:effectRef idx="2">
-            <a:schemeClr val="accent1"/>
-          </a:effectRef>
-          <a:fontRef idx="minor">
-            <a:schemeClr val="lt1"/>
-          </a:fontRef>
-        </p:style>
-        <p:txBody>
-          <a:bodyPr rtlCol="0" anchor="ctr"/>
-          <a:lstStyle/>
-          <a:p>
-            <a:pPr algn="ctr"/>
-          </a:p>
-        </p:txBody>
-      </p:sp>
-      <p:sp>
-        <p:nvSpPr>
-          <p:cNvPr id="6" name="TextBox 5"/>
-          <p:cNvSpPr txBox="1"/>
-          <p:nvPr/>
-        </p:nvSpPr>
-        <p:spPr>
-          <a:xfrm>
-            <a:off x="4654296" y="1691640"/>
-            <a:ext cx="2871216" cy="4297680"/>
-          </a:xfrm>
-          <a:prstGeom prst="rect">
-            <a:avLst/>
-          </a:prstGeom>
-          <a:noFill/>
-        </p:spPr>
-        <p:txBody>
-          <a:bodyPr wrap="square">
-            <a:spAutoFit/>
-          </a:bodyPr>
-          <a:lstStyle/>
-          <a:p>
-            <a:pPr>
-              <a:spcAft>
-                <a:spcPts val="400"/>
-              </a:spcAft>
-              <a:defRPr sz="900" b="1">
-                <a:solidFill>
-                  <a:srgbClr val="E11D48"/>
-                </a:solidFill>
-                <a:latin typeface="Segoe UI"/>
-              </a:defRPr>
-            </a:pPr>
-            <a:r>
-              <a:t>TIERED ESCALATION (&gt;14 DAYS)</a:t>
-            </a:r>
-          </a:p>
-          <a:p>
-            <a:pPr>
-              <a:spcAft>
-                <a:spcPts val="800"/>
-              </a:spcAft>
-              <a:defRPr sz="1400" b="1">
+              <a:t>Automate the entire monthly EOM spend reconciliation into a native 2D Pivot Table (Branch × Sector × Reason), tracking FY27 budget burn rates ($14.521M) with 1-click CSV export.</a:t>
+            </a:r>
+          </a:p>
+          <a:p>
+            <a:pPr>
+              <a:spcAft>
+                <a:spcPts val="1000"/>
+              </a:spcAft>
+            </a:pPr>
+            <a:r>
+              <a:rPr sz="1100" b="1">
                 <a:solidFill>
                   <a:srgbClr val="0F172A"/>
                 </a:solidFill>
                 <a:latin typeface="Segoe UI"/>
-              </a:defRPr>
-            </a:pPr>
-            <a:r>
-              <a:t>2. Overdue Delivery Escalation</a:t>
-            </a:r>
-          </a:p>
-          <a:p>
-            <a:pPr>
-              <a:spcAft>
-                <a:spcPts val="1400"/>
-              </a:spcAft>
-              <a:defRPr sz="1000">
-                <a:solidFill>
-                  <a:srgbClr val="64748B"/>
-                </a:solidFill>
-                <a:latin typeface="Segoe UI"/>
-              </a:defRPr>
-            </a:pPr>
-            <a:r>
-              <a:t>Prevents stalled shipments from sitting unnoticed:</a:t>
-            </a:r>
-          </a:p>
-          <a:p>
-            <a:pPr>
-              <a:spcAft>
-                <a:spcPts val="1000"/>
-              </a:spcAft>
-            </a:pPr>
-            <a:r>
-              <a:rPr sz="1000" b="1">
-                <a:solidFill>
-                  <a:srgbClr val="0F172A"/>
-                </a:solidFill>
-                <a:latin typeface="Segoe UI"/>
               </a:rPr>
-              <a:t>• Trigger:</a:t>
-            </a:r>
-            <a:r>
-              <a:rPr sz="1000">
+              <a:t>★ Self-Service Stock on Hand (SOH) Visibility: </a:t>
+            </a:r>
+            <a:r>
+              <a:rPr sz="1100">
                 <a:solidFill>
                   <a:srgbClr val="475569"/>
                 </a:solidFill>
                 <a:latin typeface="Segoe UI"/>
               </a:rPr>
-              <a:t> PO line is &gt;14 days past need-by date and not yet delivered.</a:t>
-            </a:r>
-          </a:p>
-          <a:p>
-            <a:pPr>
-              <a:spcAft>
-                <a:spcPts val="1000"/>
-              </a:spcAft>
-            </a:pPr>
-            <a:r>
-              <a:rPr sz="1000" b="1">
-                <a:solidFill>
-                  <a:srgbClr val="0F172A"/>
-                </a:solidFill>
-                <a:latin typeface="Segoe UI"/>
-              </a:rPr>
-              <a:t>• Tier 1 (Day 15):</a:t>
-            </a:r>
-            <a:r>
-              <a:rPr sz="1000">
-                <a:solidFill>
-                  <a:srgbClr val="475569"/>
-                </a:solidFill>
-                <a:latin typeface="Segoe UI"/>
-              </a:rPr>
-              <a:t> Alert to requester to update delivery date or cancel with supplier.</a:t>
-            </a:r>
-          </a:p>
-          <a:p>
-            <a:pPr>
-              <a:spcAft>
-                <a:spcPts val="1000"/>
-              </a:spcAft>
-            </a:pPr>
-            <a:r>
-              <a:rPr sz="1000" b="1">
-                <a:solidFill>
-                  <a:srgbClr val="0F172A"/>
-                </a:solidFill>
-                <a:latin typeface="Segoe UI"/>
-              </a:rPr>
-              <a:t>• Tier 2 (Day 21):</a:t>
-            </a:r>
-            <a:r>
-              <a:rPr sz="1000">
-                <a:solidFill>
-                  <a:srgbClr val="475569"/>
-                </a:solidFill>
-                <a:latin typeface="Segoe UI"/>
-              </a:rPr>
-              <a:t> Escalates to Line Managers (e.g. David for Melb/Albury; Ashish &amp; Ebrahim for National).</a:t>
-            </a:r>
-          </a:p>
-        </p:txBody>
-      </p:sp>
-      <p:sp>
-        <p:nvSpPr>
-          <p:cNvPr id="7" name="Rounded Rectangle 6"/>
-          <p:cNvSpPr/>
-          <p:nvPr/>
-        </p:nvSpPr>
-        <p:spPr>
-          <a:xfrm>
-            <a:off x="8119872" y="1463040"/>
-            <a:ext cx="3328416" cy="4754880"/>
-          </a:xfrm>
-          <a:prstGeom prst="roundRect">
-            <a:avLst/>
-          </a:prstGeom>
-          <a:solidFill>
-            <a:srgbClr val="FFFFFF"/>
-          </a:solidFill>
-          <a:ln w="15240">
-            <a:solidFill>
-              <a:srgbClr val="E2E8F0"/>
-            </a:solidFill>
-          </a:ln>
-        </p:spPr>
-        <p:style>
-          <a:lnRef idx="1">
-            <a:schemeClr val="accent1"/>
-          </a:lnRef>
-          <a:fillRef idx="3">
-            <a:schemeClr val="accent1"/>
-          </a:fillRef>
-          <a:effectRef idx="2">
-            <a:schemeClr val="accent1"/>
-          </a:effectRef>
-          <a:fontRef idx="minor">
-            <a:schemeClr val="lt1"/>
-          </a:fontRef>
-        </p:style>
-        <p:txBody>
-          <a:bodyPr rtlCol="0" anchor="ctr"/>
-          <a:lstStyle/>
-          <a:p>
-            <a:pPr algn="ctr"/>
-          </a:p>
-        </p:txBody>
-      </p:sp>
-      <p:sp>
-        <p:nvSpPr>
-          <p:cNvPr id="8" name="TextBox 7"/>
-          <p:cNvSpPr txBox="1"/>
-          <p:nvPr/>
-        </p:nvSpPr>
-        <p:spPr>
-          <a:xfrm>
-            <a:off x="8348472" y="1691640"/>
-            <a:ext cx="2871216" cy="4297680"/>
-          </a:xfrm>
-          <a:prstGeom prst="rect">
-            <a:avLst/>
-          </a:prstGeom>
-          <a:noFill/>
-        </p:spPr>
-        <p:txBody>
-          <a:bodyPr wrap="square">
-            <a:spAutoFit/>
-          </a:bodyPr>
-          <a:lstStyle/>
-          <a:p>
-            <a:pPr>
-              <a:spcAft>
-                <a:spcPts val="400"/>
-              </a:spcAft>
-              <a:defRPr sz="900" b="1">
-                <a:solidFill>
-                  <a:srgbClr val="0284C7"/>
-                </a:solidFill>
-                <a:latin typeface="Segoe UI"/>
-              </a:defRPr>
-            </a:pPr>
-            <a:r>
-              <a:t>OMNICHANNEL PLATFORM</a:t>
-            </a:r>
-          </a:p>
-          <a:p>
-            <a:pPr>
-              <a:spcAft>
-                <a:spcPts val="800"/>
-              </a:spcAft>
-              <a:defRPr sz="1400" b="1">
-                <a:solidFill>
-                  <a:srgbClr val="0F172A"/>
-                </a:solidFill>
-                <a:latin typeface="Segoe UI"/>
-              </a:defRPr>
-            </a:pPr>
-            <a:r>
-              <a:t>3. Multi-Channel Dispatch</a:t>
-            </a:r>
-          </a:p>
-          <a:p>
-            <a:pPr>
-              <a:spcAft>
-                <a:spcPts val="1400"/>
-              </a:spcAft>
-              <a:defRPr sz="1000">
-                <a:solidFill>
-                  <a:srgbClr val="64748B"/>
-                </a:solidFill>
-                <a:latin typeface="Segoe UI"/>
-              </a:defRPr>
-            </a:pPr>
-            <a:r>
-              <a:t>Delivers notifications directly into daily workflows:</a:t>
-            </a:r>
-          </a:p>
-          <a:p>
-            <a:pPr>
-              <a:spcAft>
-                <a:spcPts val="1000"/>
-              </a:spcAft>
-            </a:pPr>
-            <a:r>
-              <a:rPr sz="1000" b="1">
-                <a:solidFill>
-                  <a:srgbClr val="0F172A"/>
-                </a:solidFill>
-                <a:latin typeface="Segoe UI"/>
-              </a:rPr>
-              <a:t>• In-App Notification Center:</a:t>
-            </a:r>
-            <a:r>
-              <a:rPr sz="1000">
-                <a:solidFill>
-                  <a:srgbClr val="475569"/>
-                </a:solidFill>
-                <a:latin typeface="Segoe UI"/>
-              </a:rPr>
-              <a:t> Real-time badge drawer with direct action links.</a:t>
-            </a:r>
-          </a:p>
-          <a:p>
-            <a:pPr>
-              <a:spcAft>
-                <a:spcPts val="1000"/>
-              </a:spcAft>
-            </a:pPr>
-            <a:r>
-              <a:rPr sz="1000" b="1">
-                <a:solidFill>
-                  <a:srgbClr val="0F172A"/>
-                </a:solidFill>
-                <a:latin typeface="Segoe UI"/>
-              </a:rPr>
-              <a:t>• Microsoft Graph Email:</a:t>
-            </a:r>
-            <a:r>
-              <a:rPr sz="1000">
-                <a:solidFill>
-                  <a:srgbClr val="475569"/>
-                </a:solidFill>
-                <a:latin typeface="Segoe UI"/>
-              </a:rPr>
-              <a:t> Branded executive HTML notifications with 1-click approvals.</a:t>
-            </a:r>
-          </a:p>
-          <a:p>
-            <a:pPr>
-              <a:spcAft>
-                <a:spcPts val="1000"/>
-              </a:spcAft>
-            </a:pPr>
-            <a:r>
-              <a:rPr sz="1000" b="1">
-                <a:solidFill>
-                  <a:srgbClr val="0F172A"/>
-                </a:solidFill>
-                <a:latin typeface="Segoe UI"/>
-              </a:rPr>
-              <a:t>• Microsoft Teams Webhooks:</a:t>
-            </a:r>
-            <a:r>
-              <a:rPr sz="1000">
-                <a:solidFill>
-                  <a:srgbClr val="475569"/>
-                </a:solidFill>
-                <a:latin typeface="Segoe UI"/>
-              </a:rPr>
-              <a:t> Actionable Adaptive Cards (v1.4) sent to operational channels.</a:t>
+              <a:t>Eliminate manual weekly spreadsheet emailing by providing state managers with direct, live inventory visibility inside ProcureFlow.</a:t>
             </a:r>
           </a:p>
         </p:txBody>
@@ -6832,7 +6327,7 @@
               </a:defRPr>
             </a:pPr>
             <a:r>
-              <a:t>ERP ALIGNMENT &amp; UX</a:t>
+              <a:t>ACT 3: TARGET DEVELOPED STATE</a:t>
             </a:r>
           </a:p>
           <a:p>
@@ -6845,7 +6340,7 @@
               </a:defRPr>
             </a:pPr>
             <a:r>
-              <a:t>Pillar 4: Mandatory Concur Parity &amp; Homepage Action Center</a:t>
+              <a:t>Future State: The Vision of Seamless BAU Integration</a:t>
             </a:r>
           </a:p>
         </p:txBody>
@@ -6859,7 +6354,7 @@
         <p:spPr>
           <a:xfrm>
             <a:off x="731520" y="1463040"/>
-            <a:ext cx="5166360" cy="4754880"/>
+            <a:ext cx="3328416" cy="4754880"/>
           </a:xfrm>
           <a:prstGeom prst="roundRect">
             <a:avLst/>
@@ -6904,7 +6399,7 @@
         <p:spPr>
           <a:xfrm>
             <a:off x="960120" y="1691640"/>
-            <a:ext cx="4709160" cy="4297680"/>
+            <a:ext cx="2871216" cy="4297680"/>
           </a:xfrm>
           <a:prstGeom prst="rect">
             <a:avLst/>
@@ -6919,9 +6414,9 @@
           <a:p>
             <a:pPr>
               <a:spcAft>
-                <a:spcPts val="1200"/>
-              </a:spcAft>
-              <a:defRPr sz="1600" b="1">
+                <a:spcPts val="400"/>
+              </a:spcAft>
+              <a:defRPr sz="900" b="1">
                 <a:solidFill>
                   <a:srgbClr val="0284C7"/>
                 </a:solidFill>
@@ -6929,7 +6424,7 @@
               </a:defRPr>
             </a:pPr>
             <a:r>
-              <a:t>1. Mandatory Concur PR # Enforcement</a:t>
+              <a:t>FOR REQUESTERS &amp; SITES</a:t>
             </a:r>
           </a:p>
           <a:p>
@@ -6937,79 +6432,90 @@
               <a:spcAft>
                 <a:spcPts val="1400"/>
               </a:spcAft>
-              <a:defRPr sz="1100">
+              <a:defRPr sz="1500" b="1">
+                <a:solidFill>
+                  <a:srgbClr val="0F172A"/>
+                </a:solidFill>
+                <a:latin typeface="Segoe UI"/>
+              </a:defRPr>
+            </a:pPr>
+            <a:r>
+              <a:t>Frictionless, Guided Ordering</a:t>
+            </a:r>
+          </a:p>
+          <a:p>
+            <a:pPr>
+              <a:spcAft>
+                <a:spcPts val="1000"/>
+              </a:spcAft>
+            </a:pPr>
+            <a:r>
+              <a:rPr sz="1050" b="1">
+                <a:solidFill>
+                  <a:srgbClr val="0F172A"/>
+                </a:solidFill>
+                <a:latin typeface="Segoe UI"/>
+              </a:rPr>
+              <a:t>✓ Zero-Guesswork Quantities:</a:t>
+            </a:r>
+            <a:r>
+              <a:rPr sz="1050">
                 <a:solidFill>
                   <a:srgbClr val="475569"/>
                 </a:solidFill>
                 <a:latin typeface="Segoe UI"/>
-              </a:defRPr>
-            </a:pPr>
-            <a:r>
-              <a:t>The Problem: Users frequently receive orders but fail to link the Concur Purchase Request (PR #) or PO reference number, leaving orders orphaned and un-reconciled.</a:t>
-            </a:r>
-          </a:p>
-          <a:p>
-            <a:pPr>
-              <a:spcAft>
-                <a:spcPts val="800"/>
-              </a:spcAft>
-              <a:defRPr sz="1150" b="1">
+              </a:rPr>
+              <a:t> Packaging multiples auto-enforced with 1-click smart rounding (e.g. 5,040 units).</a:t>
+            </a:r>
+          </a:p>
+          <a:p>
+            <a:pPr>
+              <a:spcAft>
+                <a:spcPts val="1000"/>
+              </a:spcAft>
+            </a:pPr>
+            <a:r>
+              <a:rPr sz="1050" b="1">
                 <a:solidFill>
                   <a:srgbClr val="0F172A"/>
                 </a:solidFill>
                 <a:latin typeface="Segoe UI"/>
-              </a:defRPr>
-            </a:pPr>
-            <a:r>
-              <a:t>The Solution &amp; Enforcement:</a:t>
-            </a:r>
-          </a:p>
-          <a:p>
-            <a:pPr>
-              <a:spcAft>
-                <a:spcPts val="800"/>
-              </a:spcAft>
-              <a:defRPr sz="1050">
-                <a:solidFill>
-                  <a:srgbClr val="059669"/>
-                </a:solidFill>
-                <a:latin typeface="Segoe UI"/>
-              </a:defRPr>
-            </a:pPr>
-            <a:r>
-              <a:t>✓ System Block on Order Closure: Orders cannot be completed or closed without entering a valid Concur PR #.</a:t>
-            </a:r>
-          </a:p>
-          <a:p>
-            <a:pPr>
-              <a:spcAft>
-                <a:spcPts val="800"/>
-              </a:spcAft>
-              <a:defRPr sz="1050">
-                <a:solidFill>
-                  <a:srgbClr val="059669"/>
-                </a:solidFill>
-                <a:latin typeface="Segoe UI"/>
-              </a:defRPr>
-            </a:pPr>
-            <a:r>
-              <a:t>✓ Guarantees 100% Matching: Every completed PO in ProcureFlow has a direct audit mirror in SAP Concur.</a:t>
-            </a:r>
-          </a:p>
-          <a:p>
-            <a:pPr>
-              <a:spcAft>
-                <a:spcPts val="800"/>
-              </a:spcAft>
-              <a:defRPr sz="1050">
-                <a:solidFill>
-                  <a:srgbClr val="059669"/>
-                </a:solidFill>
-                <a:latin typeface="Segoe UI"/>
-              </a:defRPr>
-            </a:pPr>
-            <a:r>
-              <a:t>✓ Prevents unlinked expenditure from escaping executive reporting.</a:t>
+              </a:rPr>
+              <a:t>✓ Guaranteed Price Compliance:</a:t>
+            </a:r>
+            <a:r>
+              <a:rPr sz="1050">
+                <a:solidFill>
+                  <a:srgbClr val="475569"/>
+                </a:solidFill>
+                <a:latin typeface="Segoe UI"/>
+              </a:rPr>
+              <a:t> Active contracted supplier catalog pricing auto-populates lines.</a:t>
+            </a:r>
+          </a:p>
+          <a:p>
+            <a:pPr>
+              <a:spcAft>
+                <a:spcPts val="1000"/>
+              </a:spcAft>
+            </a:pPr>
+            <a:r>
+              <a:rPr sz="1050" b="1">
+                <a:solidFill>
+                  <a:srgbClr val="0F172A"/>
+                </a:solidFill>
+                <a:latin typeface="Segoe UI"/>
+              </a:rPr>
+              <a:t>✓ Action Required Dashboard:</a:t>
+            </a:r>
+            <a:r>
+              <a:rPr sz="1050">
+                <a:solidFill>
+                  <a:srgbClr val="475569"/>
+                </a:solidFill>
+                <a:latin typeface="Segoe UI"/>
+              </a:rPr>
+              <a:t> On login, users immediately see pending tasks (e.g. log Concur PR #, complete received order).</a:t>
             </a:r>
           </a:p>
         </p:txBody>
@@ -7022,8 +6528,8 @@
         </p:nvSpPr>
         <p:spPr>
           <a:xfrm>
-            <a:off x="6263640" y="1463040"/>
-            <a:ext cx="5166360" cy="4754880"/>
+            <a:off x="4425696" y="1463040"/>
+            <a:ext cx="3328416" cy="4754880"/>
           </a:xfrm>
           <a:prstGeom prst="roundRect">
             <a:avLst/>
@@ -7067,8 +6573,8 @@
         </p:nvSpPr>
         <p:spPr>
           <a:xfrm>
-            <a:off x="6492240" y="1691640"/>
-            <a:ext cx="4709160" cy="4297680"/>
+            <a:off x="4654296" y="1691640"/>
+            <a:ext cx="2871216" cy="4297680"/>
           </a:xfrm>
           <a:prstGeom prst="rect">
             <a:avLst/>
@@ -7083,17 +6589,17 @@
           <a:p>
             <a:pPr>
               <a:spcAft>
-                <a:spcPts val="1200"/>
-              </a:spcAft>
-              <a:defRPr sz="1600" b="1">
-                <a:solidFill>
-                  <a:srgbClr val="D97706"/>
-                </a:solidFill>
-                <a:latin typeface="Segoe UI"/>
-              </a:defRPr>
-            </a:pPr>
-            <a:r>
-              <a:t>2. Homepage 'Action Required' Task Center</a:t>
+                <a:spcPts val="400"/>
+              </a:spcAft>
+              <a:defRPr sz="900" b="1">
+                <a:solidFill>
+                  <a:srgbClr val="059669"/>
+                </a:solidFill>
+                <a:latin typeface="Segoe UI"/>
+              </a:defRPr>
+            </a:pPr>
+            <a:r>
+              <a:t>FOR PROCUREMENT (ASHISH CHHABRA)</a:t>
             </a:r>
           </a:p>
           <a:p>
@@ -7101,95 +6607,265 @@
               <a:spcAft>
                 <a:spcPts val="1400"/>
               </a:spcAft>
-              <a:defRPr sz="1100">
+              <a:defRPr sz="1500" b="1">
+                <a:solidFill>
+                  <a:srgbClr val="0F172A"/>
+                </a:solidFill>
+                <a:latin typeface="Segoe UI"/>
+              </a:defRPr>
+            </a:pPr>
+            <a:r>
+              <a:t>Zero-Rework Governance</a:t>
+            </a:r>
+          </a:p>
+          <a:p>
+            <a:pPr>
+              <a:spcAft>
+                <a:spcPts val="1000"/>
+              </a:spcAft>
+            </a:pPr>
+            <a:r>
+              <a:rPr sz="1050" b="1">
+                <a:solidFill>
+                  <a:srgbClr val="0F172A"/>
+                </a:solidFill>
+                <a:latin typeface="Segoe UI"/>
+              </a:rPr>
+              <a:t>✓ Zero Supplier Rejections:</a:t>
+            </a:r>
+            <a:r>
+              <a:rPr sz="1050">
                 <a:solidFill>
                   <a:srgbClr val="475569"/>
                 </a:solidFill>
                 <a:latin typeface="Segoe UI"/>
-              </a:defRPr>
-            </a:pPr>
-            <a:r>
-              <a:t>The Problem: Users must navigate through multiple menus to identify orders that require their attention.</a:t>
-            </a:r>
-          </a:p>
-          <a:p>
-            <a:pPr>
-              <a:spcAft>
-                <a:spcPts val="800"/>
-              </a:spcAft>
-              <a:defRPr sz="1150" b="1">
+              </a:rPr>
+              <a:t> Orders arrive pre-validated for pack sizes and contracted rates.</a:t>
+            </a:r>
+          </a:p>
+          <a:p>
+            <a:pPr>
+              <a:spcAft>
+                <a:spcPts val="1000"/>
+              </a:spcAft>
+            </a:pPr>
+            <a:r>
+              <a:rPr sz="1050" b="1">
                 <a:solidFill>
                   <a:srgbClr val="0F172A"/>
                 </a:solidFill>
                 <a:latin typeface="Segoe UI"/>
-              </a:defRPr>
-            </a:pPr>
-            <a:r>
-              <a:t>The Solution on Login:</a:t>
-            </a:r>
-          </a:p>
-          <a:p>
-            <a:pPr>
-              <a:spcAft>
-                <a:spcPts val="800"/>
-              </a:spcAft>
-              <a:defRPr sz="1050">
-                <a:solidFill>
-                  <a:srgbClr val="059669"/>
-                </a:solidFill>
-                <a:latin typeface="Segoe UI"/>
-              </a:defRPr>
-            </a:pPr>
-            <a:r>
-              <a:t>✓ Log Concur PR #: Instant tile showing approved orders waiting for ERP link (1-click to Stage 2).</a:t>
-            </a:r>
-          </a:p>
-          <a:p>
-            <a:pPr>
-              <a:spcAft>
-                <a:spcPts val="800"/>
-              </a:spcAft>
-              <a:defRPr sz="1050">
-                <a:solidFill>
-                  <a:srgbClr val="059669"/>
-                </a:solidFill>
-                <a:latin typeface="Segoe UI"/>
-              </a:defRPr>
-            </a:pPr>
-            <a:r>
-              <a:t>✓ Ready for Order Closure: Highlights 100% receipted orders ready for final closure (1-click to Stage 5).</a:t>
-            </a:r>
-          </a:p>
-          <a:p>
-            <a:pPr>
-              <a:spcAft>
-                <a:spcPts val="800"/>
-              </a:spcAft>
-              <a:defRPr sz="1050">
-                <a:solidFill>
-                  <a:srgbClr val="059669"/>
-                </a:solidFill>
-                <a:latin typeface="Segoe UI"/>
-              </a:defRPr>
-            </a:pPr>
-            <a:r>
-              <a:t>✓ Overdue Shipments: Red flag tile showing deliveries &gt;14 days past need-by date (1-click to Stage 4).</a:t>
-            </a:r>
-          </a:p>
-          <a:p>
-            <a:pPr>
-              <a:spcAft>
-                <a:spcPts val="800"/>
-              </a:spcAft>
-              <a:defRPr sz="1050">
-                <a:solidFill>
-                  <a:srgbClr val="059669"/>
-                </a:solidFill>
-                <a:latin typeface="Segoe UI"/>
-              </a:defRPr>
-            </a:pPr>
-            <a:r>
-              <a:t>✓ Puts pending operational tasks directly in front of users on login.</a:t>
+              </a:rPr>
+              <a:t>✓ No Manual EOM Spreadsheets:</a:t>
+            </a:r>
+            <a:r>
+              <a:rPr sz="1050">
+                <a:solidFill>
+                  <a:srgbClr val="475569"/>
+                </a:solidFill>
+                <a:latin typeface="Segoe UI"/>
+              </a:rPr>
+              <a:t> Month-end pivot reconciliation generated automatically in seconds.</a:t>
+            </a:r>
+          </a:p>
+          <a:p>
+            <a:pPr>
+              <a:spcAft>
+                <a:spcPts val="1000"/>
+              </a:spcAft>
+            </a:pPr>
+            <a:r>
+              <a:rPr sz="1050" b="1">
+                <a:solidFill>
+                  <a:srgbClr val="0F172A"/>
+                </a:solidFill>
+                <a:latin typeface="Segoe UI"/>
+              </a:rPr>
+              <a:t>✓ Live SOH Transparency:</a:t>
+            </a:r>
+            <a:r>
+              <a:rPr sz="1050">
+                <a:solidFill>
+                  <a:srgbClr val="475569"/>
+                </a:solidFill>
+                <a:latin typeface="Segoe UI"/>
+              </a:rPr>
+              <a:t> Self-service inventory removes the manual weekly emailing burden.</a:t>
+            </a:r>
+          </a:p>
+        </p:txBody>
+      </p:sp>
+      <p:sp>
+        <p:nvSpPr>
+          <p:cNvPr id="7" name="Rounded Rectangle 6"/>
+          <p:cNvSpPr/>
+          <p:nvPr/>
+        </p:nvSpPr>
+        <p:spPr>
+          <a:xfrm>
+            <a:off x="8119872" y="1463040"/>
+            <a:ext cx="3328416" cy="4754880"/>
+          </a:xfrm>
+          <a:prstGeom prst="roundRect">
+            <a:avLst/>
+          </a:prstGeom>
+          <a:solidFill>
+            <a:srgbClr val="FFFFFF"/>
+          </a:solidFill>
+          <a:ln w="15240">
+            <a:solidFill>
+              <a:srgbClr val="E2E8F0"/>
+            </a:solidFill>
+          </a:ln>
+        </p:spPr>
+        <p:style>
+          <a:lnRef idx="1">
+            <a:schemeClr val="accent1"/>
+          </a:lnRef>
+          <a:fillRef idx="3">
+            <a:schemeClr val="accent1"/>
+          </a:fillRef>
+          <a:effectRef idx="2">
+            <a:schemeClr val="accent1"/>
+          </a:effectRef>
+          <a:fontRef idx="minor">
+            <a:schemeClr val="lt1"/>
+          </a:fontRef>
+        </p:style>
+        <p:txBody>
+          <a:bodyPr rtlCol="0" anchor="ctr"/>
+          <a:lstStyle/>
+          <a:p>
+            <a:pPr algn="ctr"/>
+          </a:p>
+        </p:txBody>
+      </p:sp>
+      <p:sp>
+        <p:nvSpPr>
+          <p:cNvPr id="8" name="TextBox 7"/>
+          <p:cNvSpPr txBox="1"/>
+          <p:nvPr/>
+        </p:nvSpPr>
+        <p:spPr>
+          <a:xfrm>
+            <a:off x="8348472" y="1691640"/>
+            <a:ext cx="2871216" cy="4297680"/>
+          </a:xfrm>
+          <a:prstGeom prst="rect">
+            <a:avLst/>
+          </a:prstGeom>
+          <a:noFill/>
+        </p:spPr>
+        <p:txBody>
+          <a:bodyPr wrap="square">
+            <a:spAutoFit/>
+          </a:bodyPr>
+          <a:lstStyle/>
+          <a:p>
+            <a:pPr>
+              <a:spcAft>
+                <a:spcPts val="400"/>
+              </a:spcAft>
+              <a:defRPr sz="900" b="1">
+                <a:solidFill>
+                  <a:srgbClr val="9333EA"/>
+                </a:solidFill>
+                <a:latin typeface="Segoe UI"/>
+              </a:defRPr>
+            </a:pPr>
+            <a:r>
+              <a:t>FOR EXECUTIVE LEADERSHIP (EBRAHIM MOKHTARI)</a:t>
+            </a:r>
+          </a:p>
+          <a:p>
+            <a:pPr>
+              <a:spcAft>
+                <a:spcPts val="1400"/>
+              </a:spcAft>
+              <a:defRPr sz="1500" b="1">
+                <a:solidFill>
+                  <a:srgbClr val="0F172A"/>
+                </a:solidFill>
+                <a:latin typeface="Segoe UI"/>
+              </a:defRPr>
+            </a:pPr>
+            <a:r>
+              <a:t>Real-Time Spend Control</a:t>
+            </a:r>
+          </a:p>
+          <a:p>
+            <a:pPr>
+              <a:spcAft>
+                <a:spcPts val="1000"/>
+              </a:spcAft>
+            </a:pPr>
+            <a:r>
+              <a:rPr sz="1050" b="1">
+                <a:solidFill>
+                  <a:srgbClr val="0F172A"/>
+                </a:solidFill>
+                <a:latin typeface="Segoe UI"/>
+              </a:rPr>
+              <a:t>✓ Single Source of Truth:</a:t>
+            </a:r>
+            <a:r>
+              <a:rPr sz="1050">
+                <a:solidFill>
+                  <a:srgbClr val="475569"/>
+                </a:solidFill>
+                <a:latin typeface="Segoe UI"/>
+              </a:rPr>
+              <a:t> ProcureFlow numbers match SAP Concur reports 100%.</a:t>
+            </a:r>
+          </a:p>
+          <a:p>
+            <a:pPr>
+              <a:spcAft>
+                <a:spcPts val="1000"/>
+              </a:spcAft>
+            </a:pPr>
+            <a:r>
+              <a:rPr sz="1050" b="1">
+                <a:solidFill>
+                  <a:srgbClr val="0F172A"/>
+                </a:solidFill>
+                <a:latin typeface="Segoe UI"/>
+              </a:rPr>
+              <a:t>✓ Live Budget Burn Tracking:</a:t>
+            </a:r>
+            <a:r>
+              <a:rPr sz="1050">
+                <a:solidFill>
+                  <a:srgbClr val="475569"/>
+                </a:solidFill>
+                <a:latin typeface="Segoe UI"/>
+              </a:rPr>
+              <a:t> Real-time visibility into $14.521M FY27 budget and $2.3M Linen Hub pool.</a:t>
+            </a:r>
+          </a:p>
+          <a:p>
+            <a:pPr>
+              <a:spcAft>
+                <a:spcPts val="1000"/>
+              </a:spcAft>
+            </a:pPr>
+            <a:r>
+              <a:rPr sz="1050" b="1">
+                <a:solidFill>
+                  <a:srgbClr val="0F172A"/>
+                </a:solidFill>
+                <a:latin typeface="Segoe UI"/>
+              </a:rPr>
+              <a:t>✓ Strategic Subcontract Visibility:</a:t>
+            </a:r>
+            <a:r>
+              <a:rPr sz="1050">
+                <a:solidFill>
+                  <a:srgbClr val="475569"/>
+                </a:solidFill>
+                <a:latin typeface="Segoe UI"/>
+              </a:rPr>
+              <a:t> Instant breakouts for HealthShare Victoria (HSV) and Ramsay Health Care (RHC).</a:t>
             </a:r>
           </a:p>
         </p:txBody>
@@ -7246,7 +6922,7 @@
               </a:defRPr>
             </a:pPr>
             <a:r>
-              <a:t>EXECUTIVE FINANCIAL INTELLIGENCE</a:t>
+              <a:t>ACT 3: DEVELOPMENT PILLARS</a:t>
             </a:r>
           </a:p>
           <a:p>
@@ -7259,7 +6935,7 @@
               </a:defRPr>
             </a:pPr>
             <a:r>
-              <a:t>Pillar 5: Real-Time EOM Spend &amp; Budget Reconciliation Engine</a:t>
+              <a:t>Development Roadmap: Core Engineered Capabilities Delivered</a:t>
             </a:r>
           </a:p>
         </p:txBody>
@@ -7273,7 +6949,7 @@
         <p:spPr>
           <a:xfrm>
             <a:off x="731520" y="1463040"/>
-            <a:ext cx="2468880" cy="1188720"/>
+            <a:ext cx="5166360" cy="2240280"/>
           </a:xfrm>
           <a:prstGeom prst="roundRect">
             <a:avLst/>
@@ -7317,8 +6993,8 @@
         </p:nvSpPr>
         <p:spPr>
           <a:xfrm>
-            <a:off x="868680" y="1508760"/>
-            <a:ext cx="2194560" cy="1097280"/>
+            <a:off x="960120" y="1645920"/>
+            <a:ext cx="4709160" cy="1874520"/>
           </a:xfrm>
           <a:prstGeom prst="rect">
             <a:avLst/>
@@ -7332,20 +7008,10 @@
           <a:lstStyle/>
           <a:p>
             <a:pPr>
-              <a:defRPr sz="850" b="1">
-                <a:solidFill>
-                  <a:srgbClr val="64748B"/>
-                </a:solidFill>
-                <a:latin typeface="Segoe UI"/>
-              </a:defRPr>
-            </a:pPr>
-            <a:r>
-              <a:t>FY27 TOTAL BUDGET</a:t>
-            </a:r>
-          </a:p>
-          <a:p>
-            <a:pPr>
-              <a:defRPr sz="2000" b="1">
+              <a:spcAft>
+                <a:spcPts val="800"/>
+              </a:spcAft>
+              <a:defRPr sz="1200" b="1">
                 <a:solidFill>
                   <a:srgbClr val="0284C7"/>
                 </a:solidFill>
@@ -7353,20 +7019,20 @@
               </a:defRPr>
             </a:pPr>
             <a:r>
-              <a:t>$14.521M</a:t>
-            </a:r>
-          </a:p>
-          <a:p>
-            <a:pPr>
-              <a:defRPr sz="850">
-                <a:solidFill>
-                  <a:srgbClr val="64748B"/>
-                </a:solidFill>
-                <a:latin typeface="Segoe UI"/>
-              </a:defRPr>
-            </a:pPr>
-            <a:r>
-              <a:t>Baseline Operating Budget</a:t>
+              <a:t>PILLAR A: POINT-OF-ENTRY GOVERNANCE</a:t>
+            </a:r>
+          </a:p>
+          <a:p>
+            <a:pPr>
+              <a:defRPr sz="1100">
+                <a:solidFill>
+                  <a:srgbClr val="475569"/>
+                </a:solidFill>
+                <a:latin typeface="Segoe UI"/>
+              </a:defRPr>
+            </a:pPr>
+            <a:r>
+              <a:t>Input blocking rules for carton multiples (e.g. 5,000 -&gt; 5,040) &amp; contract price validation in POCreate/PODetail.</a:t>
             </a:r>
           </a:p>
         </p:txBody>
@@ -7379,8 +7045,8 @@
         </p:nvSpPr>
         <p:spPr>
           <a:xfrm>
-            <a:off x="3483864" y="1463040"/>
-            <a:ext cx="2468880" cy="1188720"/>
+            <a:off x="6263640" y="1463040"/>
+            <a:ext cx="5166360" cy="2240280"/>
           </a:xfrm>
           <a:prstGeom prst="roundRect">
             <a:avLst/>
@@ -7424,8 +7090,8 @@
         </p:nvSpPr>
         <p:spPr>
           <a:xfrm>
-            <a:off x="3621024" y="1508760"/>
-            <a:ext cx="2194560" cy="1097280"/>
+            <a:off x="6492240" y="1645920"/>
+            <a:ext cx="4709160" cy="1874520"/>
           </a:xfrm>
           <a:prstGeom prst="rect">
             <a:avLst/>
@@ -7439,41 +7105,31 @@
           <a:lstStyle/>
           <a:p>
             <a:pPr>
-              <a:defRPr sz="850" b="1">
-                <a:solidFill>
-                  <a:srgbClr val="64748B"/>
-                </a:solidFill>
-                <a:latin typeface="Segoe UI"/>
-              </a:defRPr>
-            </a:pPr>
-            <a:r>
-              <a:t>DEPLETION SPEND TARGET</a:t>
-            </a:r>
-          </a:p>
-          <a:p>
-            <a:pPr>
-              <a:defRPr sz="2000" b="1">
-                <a:solidFill>
-                  <a:srgbClr val="059669"/>
-                </a:solidFill>
-                <a:latin typeface="Segoe UI"/>
-              </a:defRPr>
-            </a:pPr>
-            <a:r>
-              <a:t>$9.921M</a:t>
-            </a:r>
-          </a:p>
-          <a:p>
-            <a:pPr>
-              <a:defRPr sz="850">
-                <a:solidFill>
-                  <a:srgbClr val="64748B"/>
-                </a:solidFill>
-                <a:latin typeface="Segoe UI"/>
-              </a:defRPr>
-            </a:pPr>
-            <a:r>
-              <a:t>$826.8k / Monthly Run Rate</a:t>
+              <a:spcAft>
+                <a:spcPts val="800"/>
+              </a:spcAft>
+              <a:defRPr sz="1200" b="1">
+                <a:solidFill>
+                  <a:srgbClr val="D97706"/>
+                </a:solidFill>
+                <a:latin typeface="Segoe UI"/>
+              </a:defRPr>
+            </a:pPr>
+            <a:r>
+              <a:t>PILLAR B: CLOSED-LOOP ERP PARITY</a:t>
+            </a:r>
+          </a:p>
+          <a:p>
+            <a:pPr>
+              <a:defRPr sz="1100">
+                <a:solidFill>
+                  <a:srgbClr val="475569"/>
+                </a:solidFill>
+                <a:latin typeface="Segoe UI"/>
+              </a:defRPr>
+            </a:pPr>
+            <a:r>
+              <a:t>Mandatory Concur PR # enforcement on PO closure &amp; Homepage Action Required task center.</a:t>
             </a:r>
           </a:p>
         </p:txBody>
@@ -7486,8 +7142,8 @@
         </p:nvSpPr>
         <p:spPr>
           <a:xfrm>
-            <a:off x="6236208" y="1463040"/>
-            <a:ext cx="2468880" cy="1188720"/>
+            <a:off x="731520" y="3977639"/>
+            <a:ext cx="5166360" cy="2240280"/>
           </a:xfrm>
           <a:prstGeom prst="roundRect">
             <a:avLst/>
@@ -7531,8 +7187,8 @@
         </p:nvSpPr>
         <p:spPr>
           <a:xfrm>
-            <a:off x="6373368" y="1508760"/>
-            <a:ext cx="2194560" cy="1097280"/>
+            <a:off x="960120" y="4160519"/>
+            <a:ext cx="4709160" cy="1874520"/>
           </a:xfrm>
           <a:prstGeom prst="rect">
             <a:avLst/>
@@ -7546,41 +7202,31 @@
           <a:lstStyle/>
           <a:p>
             <a:pPr>
-              <a:defRPr sz="850" b="1">
-                <a:solidFill>
-                  <a:srgbClr val="64748B"/>
-                </a:solidFill>
-                <a:latin typeface="Segoe UI"/>
-              </a:defRPr>
-            </a:pPr>
-            <a:r>
-              <a:t>NEW BUSINESS POOL</a:t>
-            </a:r>
-          </a:p>
-          <a:p>
-            <a:pPr>
-              <a:defRPr sz="2000" b="1">
-                <a:solidFill>
-                  <a:srgbClr val="9333EA"/>
-                </a:solidFill>
-                <a:latin typeface="Segoe UI"/>
-              </a:defRPr>
-            </a:pPr>
-            <a:r>
-              <a:t>$2.300M</a:t>
-            </a:r>
-          </a:p>
-          <a:p>
-            <a:pPr>
-              <a:defRPr sz="850">
-                <a:solidFill>
-                  <a:srgbClr val="64748B"/>
-                </a:solidFill>
-                <a:latin typeface="Segoe UI"/>
-              </a:defRPr>
-            </a:pPr>
-            <a:r>
-              <a:t>$191.7k / Monthly Allocation</a:t>
+              <a:spcAft>
+                <a:spcPts val="800"/>
+              </a:spcAft>
+              <a:defRPr sz="1200" b="1">
+                <a:solidFill>
+                  <a:srgbClr val="E11D48"/>
+                </a:solidFill>
+                <a:latin typeface="Segoe UI"/>
+              </a:defRPr>
+            </a:pPr>
+            <a:r>
+              <a:t>PILLAR C: AUTOMATED NOTIFICATIONS &amp; ESCALATIONS</a:t>
+            </a:r>
+          </a:p>
+          <a:p>
+            <a:pPr>
+              <a:defRPr sz="1100">
+                <a:solidFill>
+                  <a:srgbClr val="475569"/>
+                </a:solidFill>
+                <a:latin typeface="Segoe UI"/>
+              </a:defRPr>
+            </a:pPr>
+            <a:r>
+              <a:t>100% receipt closure reminders &amp; &gt;14d overdue delivery manager escalations (In-App, Email, MS Teams).</a:t>
             </a:r>
           </a:p>
         </p:txBody>
@@ -7593,8 +7239,8 @@
         </p:nvSpPr>
         <p:spPr>
           <a:xfrm>
-            <a:off x="8988552" y="1463040"/>
-            <a:ext cx="2468880" cy="1188720"/>
+            <a:off x="6263640" y="3977639"/>
+            <a:ext cx="5166360" cy="2240280"/>
           </a:xfrm>
           <a:prstGeom prst="roundRect">
             <a:avLst/>
@@ -7638,8 +7284,8 @@
         </p:nvSpPr>
         <p:spPr>
           <a:xfrm>
-            <a:off x="9125712" y="1508760"/>
-            <a:ext cx="2194560" cy="1097280"/>
+            <a:off x="6492240" y="4160519"/>
+            <a:ext cx="4709160" cy="1874520"/>
           </a:xfrm>
           <a:prstGeom prst="rect">
             <a:avLst/>
@@ -7653,275 +7299,31 @@
           <a:lstStyle/>
           <a:p>
             <a:pPr>
-              <a:defRPr sz="850" b="1">
-                <a:solidFill>
-                  <a:srgbClr val="64748B"/>
-                </a:solidFill>
-                <a:latin typeface="Segoe UI"/>
-              </a:defRPr>
-            </a:pPr>
-            <a:r>
-              <a:t>LINEN HUB DEDICATED</a:t>
-            </a:r>
-          </a:p>
-          <a:p>
-            <a:pPr>
-              <a:defRPr sz="2000" b="1">
-                <a:solidFill>
-                  <a:srgbClr val="D97706"/>
-                </a:solidFill>
-                <a:latin typeface="Segoe UI"/>
-              </a:defRPr>
-            </a:pPr>
-            <a:r>
-              <a:t>$2.300M</a:t>
-            </a:r>
-          </a:p>
-          <a:p>
-            <a:pPr>
-              <a:defRPr sz="850">
-                <a:solidFill>
-                  <a:srgbClr val="64748B"/>
-                </a:solidFill>
-                <a:latin typeface="Segoe UI"/>
-              </a:defRPr>
-            </a:pPr>
-            <a:r>
-              <a:t>Real-time Decrement Pool</a:t>
-            </a:r>
-          </a:p>
-        </p:txBody>
-      </p:sp>
-      <p:sp>
-        <p:nvSpPr>
-          <p:cNvPr id="11" name="Rounded Rectangle 10"/>
-          <p:cNvSpPr/>
-          <p:nvPr/>
-        </p:nvSpPr>
-        <p:spPr>
-          <a:xfrm>
-            <a:off x="731520" y="2834640"/>
-            <a:ext cx="10728655" cy="3383280"/>
-          </a:xfrm>
-          <a:prstGeom prst="roundRect">
-            <a:avLst/>
-          </a:prstGeom>
-          <a:solidFill>
-            <a:srgbClr val="FFFFFF"/>
-          </a:solidFill>
-          <a:ln w="15240">
-            <a:solidFill>
-              <a:srgbClr val="E2E8F0"/>
-            </a:solidFill>
-          </a:ln>
-        </p:spPr>
-        <p:style>
-          <a:lnRef idx="1">
-            <a:schemeClr val="accent1"/>
-          </a:lnRef>
-          <a:fillRef idx="3">
-            <a:schemeClr val="accent1"/>
-          </a:fillRef>
-          <a:effectRef idx="2">
-            <a:schemeClr val="accent1"/>
-          </a:effectRef>
-          <a:fontRef idx="minor">
-            <a:schemeClr val="lt1"/>
-          </a:fontRef>
-        </p:style>
-        <p:txBody>
-          <a:bodyPr rtlCol="0" anchor="ctr"/>
-          <a:lstStyle/>
-          <a:p>
-            <a:pPr algn="ctr"/>
-          </a:p>
-        </p:txBody>
-      </p:sp>
-      <p:sp>
-        <p:nvSpPr>
-          <p:cNvPr id="12" name="TextBox 11"/>
-          <p:cNvSpPr txBox="1"/>
-          <p:nvPr/>
-        </p:nvSpPr>
-        <p:spPr>
-          <a:xfrm>
-            <a:off x="960120" y="3017520"/>
-            <a:ext cx="10271455" cy="3017520"/>
-          </a:xfrm>
-          <a:prstGeom prst="rect">
-            <a:avLst/>
-          </a:prstGeom>
-          <a:noFill/>
-        </p:spPr>
-        <p:txBody>
-          <a:bodyPr wrap="square">
-            <a:spAutoFit/>
-          </a:bodyPr>
-          <a:lstStyle/>
-          <a:p>
-            <a:pPr>
-              <a:spcAft>
-                <a:spcPts val="1000"/>
-              </a:spcAft>
-              <a:defRPr sz="1400" b="1">
-                <a:solidFill>
-                  <a:srgbClr val="0F172A"/>
-                </a:solidFill>
-                <a:latin typeface="Segoe UI"/>
-              </a:defRPr>
-            </a:pPr>
-            <a:r>
-              <a:t>Key Capabilities Delivered in ProcureFlow Reporting Hub:</a:t>
-            </a:r>
-          </a:p>
-          <a:p>
-            <a:pPr>
-              <a:spcAft>
-                <a:spcPts val="600"/>
-              </a:spcAft>
-            </a:pPr>
-            <a:r>
-              <a:rPr sz="1050" b="1">
-                <a:solidFill>
-                  <a:srgbClr val="0F172A"/>
-                </a:solidFill>
-                <a:latin typeface="Segoe UI"/>
-              </a:rPr>
-              <a:t>• 2D Cross-Tabulation Matrix: </a:t>
-            </a:r>
-            <a:r>
-              <a:rPr sz="1050">
+              <a:spcAft>
+                <a:spcPts val="800"/>
+              </a:spcAft>
+              <a:defRPr sz="1200" b="1">
+                <a:solidFill>
+                  <a:srgbClr val="059669"/>
+                </a:solidFill>
+                <a:latin typeface="Segoe UI"/>
+              </a:defRPr>
+            </a:pPr>
+            <a:r>
+              <a:t>PILLAR D: EOM SPEND &amp; BUDGET RECONCILIATION</a:t>
+            </a:r>
+          </a:p>
+          <a:p>
+            <a:pPr>
+              <a:defRPr sz="1100">
                 <a:solidFill>
                   <a:srgbClr val="475569"/>
                 </a:solidFill>
                 <a:latin typeface="Segoe UI"/>
-              </a:rPr>
-              <a:t>Natively replicates Ashish's Concur EOM Pivot (Branch × Sector: Accommodation/Healthcare × Reason: Depletion/New Business/Linen Hub) excluding GST (Total / 1.1).</a:t>
-            </a:r>
-          </a:p>
-          <a:p>
-            <a:pPr>
-              <a:spcAft>
-                <a:spcPts val="600"/>
-              </a:spcAft>
-            </a:pPr>
-            <a:r>
-              <a:rPr sz="1050" b="1">
-                <a:solidFill>
-                  <a:srgbClr val="0F172A"/>
-                </a:solidFill>
-                <a:latin typeface="Segoe UI"/>
-              </a:rPr>
-              <a:t>• 100% Classification Precision: </a:t>
-            </a:r>
-            <a:r>
-              <a:rPr sz="1050">
-                <a:solidFill>
-                  <a:srgbClr val="475569"/>
-                </a:solidFill>
-                <a:latin typeface="Segoe UI"/>
-              </a:rPr>
-              <a:t>Automated legacy PO parser accurately classifies unstandardised legacy PO strings with 100.0% parity against historical Concur records.</a:t>
-            </a:r>
-          </a:p>
-          <a:p>
-            <a:pPr>
-              <a:spcAft>
-                <a:spcPts val="600"/>
-              </a:spcAft>
-            </a:pPr>
-            <a:r>
-              <a:rPr sz="1050" b="1">
-                <a:solidFill>
-                  <a:srgbClr val="0F172A"/>
-                </a:solidFill>
-                <a:latin typeface="Segoe UI"/>
-              </a:rPr>
-              <a:t>• Branch Budget Tracking Grid: </a:t>
-            </a:r>
-            <a:r>
-              <a:rPr sz="1050">
-                <a:solidFill>
-                  <a:srgbClr val="475569"/>
-                </a:solidFill>
-                <a:latin typeface="Segoe UI"/>
-              </a:rPr>
-              <a:t>Tracks monthly and YTD spend vs baseline budgets across all 8 operating entities (Melbourne $2.65M, Sydney $2.78M, Adelaide $920k, Brisbane $1.03M, Cairns $706k, Mackay $349k, Perth $996k, Albury $481k).</a:t>
-            </a:r>
-          </a:p>
-          <a:p>
-            <a:pPr>
-              <a:spcAft>
-                <a:spcPts val="600"/>
-              </a:spcAft>
-            </a:pPr>
-            <a:r>
-              <a:rPr sz="1050" b="1">
-                <a:solidFill>
-                  <a:srgbClr val="0F172A"/>
-                </a:solidFill>
-                <a:latin typeface="Segoe UI"/>
-              </a:rPr>
-              <a:t>• Dedicated Linen Hub Pool: </a:t>
-            </a:r>
-            <a:r>
-              <a:rPr sz="1050">
-                <a:solidFill>
-                  <a:srgbClr val="475569"/>
-                </a:solidFill>
-                <a:latin typeface="Segoe UI"/>
-              </a:rPr>
-              <a:t>Maintains continuous decrement balance tracking against the dedicated $2.30M linen injection reserve.</a:t>
-            </a:r>
-          </a:p>
-          <a:p>
-            <a:pPr>
-              <a:spcAft>
-                <a:spcPts val="600"/>
-              </a:spcAft>
-            </a:pPr>
-            <a:r>
-              <a:rPr sz="1050" b="1">
-                <a:solidFill>
-                  <a:srgbClr val="0F172A"/>
-                </a:solidFill>
-                <a:latin typeface="Segoe UI"/>
-              </a:rPr>
-              <a:t>• Strategic Contract Breakouts: </a:t>
-            </a:r>
-            <a:r>
-              <a:rPr sz="1050">
-                <a:solidFill>
-                  <a:srgbClr val="475569"/>
-                </a:solidFill>
-                <a:latin typeface="Segoe UI"/>
-              </a:rPr>
-              <a:t>Real-time visibility into HealthShare Victoria (HSV) and Ramsay Health Care (RHC) contract spend.</a:t>
-            </a:r>
-          </a:p>
-          <a:p>
-            <a:pPr>
-              <a:spcAft>
-                <a:spcPts val="600"/>
-              </a:spcAft>
-            </a:pPr>
-            <a:r>
-              <a:rPr sz="1050" b="1">
-                <a:solidFill>
-                  <a:srgbClr val="0F172A"/>
-                </a:solidFill>
-                <a:latin typeface="Segoe UI"/>
-              </a:rPr>
-              <a:t>• 1-Click Concur EOM Export: </a:t>
-            </a:r>
-            <a:r>
-              <a:rPr sz="1050">
-                <a:solidFill>
-                  <a:srgbClr val="475569"/>
-                </a:solidFill>
-                <a:latin typeface="Segoe UI"/>
-              </a:rPr>
-              <a:t>Generates formatted leadership-ready Excel CSV reconciliation files at the click of a button.</a:t>
+              </a:defRPr>
+            </a:pPr>
+            <a:r>
+              <a:t>Native 2D Pivot Table (Branch x Sector x Reason), FY27 Budget ($14.521M), Linen Hub $2.3M tracker &amp; 1-Click CSV export.</a:t>
             </a:r>
           </a:p>
         </p:txBody>
@@ -7978,7 +7380,7 @@
               </a:defRPr>
             </a:pPr>
             <a:r>
-              <a:t>INVENTORY TRANSPARENCY</a:t>
+              <a:t>ACT 3: FINANCIAL CONTROL</a:t>
             </a:r>
           </a:p>
           <a:p>
@@ -7991,7 +7393,7 @@
               </a:defRPr>
             </a:pPr>
             <a:r>
-              <a:t>Pillar 6: Self-Service Stock on Hand (SOH) Distribution</a:t>
+              <a:t>Executive Intelligence: Real-Time EOM Budget Reconciliation</a:t>
             </a:r>
           </a:p>
         </p:txBody>
@@ -8005,7 +7407,7 @@
         <p:spPr>
           <a:xfrm>
             <a:off x="731520" y="1463040"/>
-            <a:ext cx="5166360" cy="4754880"/>
+            <a:ext cx="2468880" cy="1188720"/>
           </a:xfrm>
           <a:prstGeom prst="roundRect">
             <a:avLst/>
@@ -8049,8 +7451,8 @@
         </p:nvSpPr>
         <p:spPr>
           <a:xfrm>
-            <a:off x="960120" y="1691640"/>
-            <a:ext cx="4709160" cy="4297680"/>
+            <a:off x="868680" y="1508760"/>
+            <a:ext cx="2194560" cy="1097280"/>
           </a:xfrm>
           <a:prstGeom prst="rect">
             <a:avLst/>
@@ -8064,10 +7466,20 @@
           <a:lstStyle/>
           <a:p>
             <a:pPr>
-              <a:spcAft>
-                <a:spcPts val="1200"/>
-              </a:spcAft>
-              <a:defRPr sz="1600" b="1">
+              <a:defRPr sz="850" b="1">
+                <a:solidFill>
+                  <a:srgbClr val="64748B"/>
+                </a:solidFill>
+                <a:latin typeface="Segoe UI"/>
+              </a:defRPr>
+            </a:pPr>
+            <a:r>
+              <a:t>FY27 TOTAL BUDGET</a:t>
+            </a:r>
+          </a:p>
+          <a:p>
+            <a:pPr>
+              <a:defRPr sz="2000" b="1">
                 <a:solidFill>
                   <a:srgbClr val="0284C7"/>
                 </a:solidFill>
@@ -8075,103 +7487,20 @@
               </a:defRPr>
             </a:pPr>
             <a:r>
-              <a:t>1. Elimination of Manual Weekly Emailing</a:t>
-            </a:r>
-          </a:p>
-          <a:p>
-            <a:pPr>
-              <a:spcAft>
-                <a:spcPts val="400"/>
-              </a:spcAft>
-              <a:defRPr sz="1150" b="1">
-                <a:solidFill>
-                  <a:srgbClr val="0F172A"/>
-                </a:solidFill>
-                <a:latin typeface="Segoe UI"/>
-              </a:defRPr>
-            </a:pPr>
-            <a:r>
-              <a:t>Current State Bottleneck:</a:t>
-            </a:r>
-          </a:p>
-          <a:p>
-            <a:pPr>
-              <a:spcAft>
-                <a:spcPts val="1400"/>
-              </a:spcAft>
-              <a:defRPr sz="1050">
-                <a:solidFill>
-                  <a:srgbClr val="475569"/>
-                </a:solidFill>
-                <a:latin typeface="Segoe UI"/>
-              </a:defRPr>
-            </a:pPr>
-            <a:r>
-              <a:t>Procurement manually cleans, reformats, and emails weekly supplier inventory spreadsheets (SIMBA/HOST) across state managers. This takes valuable time and creates static, out-of-date snapshots.</a:t>
-            </a:r>
-          </a:p>
-          <a:p>
-            <a:pPr>
-              <a:spcAft>
-                <a:spcPts val="600"/>
-              </a:spcAft>
-              <a:defRPr sz="1150" b="1">
-                <a:solidFill>
-                  <a:srgbClr val="0F172A"/>
-                </a:solidFill>
-                <a:latin typeface="Segoe UI"/>
-              </a:defRPr>
-            </a:pPr>
-            <a:r>
-              <a:t>The ProcureFlow Solution:</a:t>
-            </a:r>
-          </a:p>
-          <a:p>
-            <a:pPr>
-              <a:spcAft>
-                <a:spcPts val="800"/>
-              </a:spcAft>
-              <a:defRPr sz="1050">
-                <a:solidFill>
-                  <a:srgbClr val="059669"/>
-                </a:solidFill>
-                <a:latin typeface="Segoe UI"/>
-              </a:defRPr>
-            </a:pPr>
-            <a:r>
-              <a:t>✓ Automated Ingestion Pipeline: Ingests supplier inventory feeds automatically in the background.</a:t>
-            </a:r>
-          </a:p>
-          <a:p>
-            <a:pPr>
-              <a:spcAft>
-                <a:spcPts val="800"/>
-              </a:spcAft>
-              <a:defRPr sz="1050">
-                <a:solidFill>
-                  <a:srgbClr val="059669"/>
-                </a:solidFill>
-                <a:latin typeface="Segoe UI"/>
-              </a:defRPr>
-            </a:pPr>
-            <a:r>
-              <a:t>✓ Real-Time SOH Dashboard: State managers log in and view live stock on hand and committed quantities.</a:t>
-            </a:r>
-          </a:p>
-          <a:p>
-            <a:pPr>
-              <a:spcAft>
-                <a:spcPts val="800"/>
-              </a:spcAft>
-              <a:defRPr sz="1050">
-                <a:solidFill>
-                  <a:srgbClr val="059669"/>
-                </a:solidFill>
-                <a:latin typeface="Segoe UI"/>
-              </a:defRPr>
-            </a:pPr>
-            <a:r>
-              <a:t>✓ Zero manual emailing required by procurement.</a:t>
+              <a:t>$14.521M</a:t>
+            </a:r>
+          </a:p>
+          <a:p>
+            <a:pPr>
+              <a:defRPr sz="850">
+                <a:solidFill>
+                  <a:srgbClr val="64748B"/>
+                </a:solidFill>
+                <a:latin typeface="Segoe UI"/>
+              </a:defRPr>
+            </a:pPr>
+            <a:r>
+              <a:t>Baseline Operating Budget</a:t>
             </a:r>
           </a:p>
         </p:txBody>
@@ -8184,8 +7513,8 @@
         </p:nvSpPr>
         <p:spPr>
           <a:xfrm>
-            <a:off x="6263640" y="1463040"/>
-            <a:ext cx="5166360" cy="4754880"/>
+            <a:off x="3483864" y="1463040"/>
+            <a:ext cx="2468880" cy="1188720"/>
           </a:xfrm>
           <a:prstGeom prst="roundRect">
             <a:avLst/>
@@ -8229,8 +7558,8 @@
         </p:nvSpPr>
         <p:spPr>
           <a:xfrm>
-            <a:off x="6492240" y="1691640"/>
-            <a:ext cx="4709160" cy="4297680"/>
+            <a:off x="3621024" y="1508760"/>
+            <a:ext cx="2194560" cy="1097280"/>
           </a:xfrm>
           <a:prstGeom prst="rect">
             <a:avLst/>
@@ -8244,10 +7573,127 @@
           <a:lstStyle/>
           <a:p>
             <a:pPr>
-              <a:spcAft>
-                <a:spcPts val="1200"/>
-              </a:spcAft>
-              <a:defRPr sz="1600" b="1">
+              <a:defRPr sz="850" b="1">
+                <a:solidFill>
+                  <a:srgbClr val="64748B"/>
+                </a:solidFill>
+                <a:latin typeface="Segoe UI"/>
+              </a:defRPr>
+            </a:pPr>
+            <a:r>
+              <a:t>DEPLETION SPEND TARGET</a:t>
+            </a:r>
+          </a:p>
+          <a:p>
+            <a:pPr>
+              <a:defRPr sz="2000" b="1">
+                <a:solidFill>
+                  <a:srgbClr val="059669"/>
+                </a:solidFill>
+                <a:latin typeface="Segoe UI"/>
+              </a:defRPr>
+            </a:pPr>
+            <a:r>
+              <a:t>$9.921M</a:t>
+            </a:r>
+          </a:p>
+          <a:p>
+            <a:pPr>
+              <a:defRPr sz="850">
+                <a:solidFill>
+                  <a:srgbClr val="64748B"/>
+                </a:solidFill>
+                <a:latin typeface="Segoe UI"/>
+              </a:defRPr>
+            </a:pPr>
+            <a:r>
+              <a:t>$826.8k / Month Run Rate</a:t>
+            </a:r>
+          </a:p>
+        </p:txBody>
+      </p:sp>
+      <p:sp>
+        <p:nvSpPr>
+          <p:cNvPr id="7" name="Rounded Rectangle 6"/>
+          <p:cNvSpPr/>
+          <p:nvPr/>
+        </p:nvSpPr>
+        <p:spPr>
+          <a:xfrm>
+            <a:off x="6236208" y="1463040"/>
+            <a:ext cx="2468880" cy="1188720"/>
+          </a:xfrm>
+          <a:prstGeom prst="roundRect">
+            <a:avLst/>
+          </a:prstGeom>
+          <a:solidFill>
+            <a:srgbClr val="FFFFFF"/>
+          </a:solidFill>
+          <a:ln w="15240">
+            <a:solidFill>
+              <a:srgbClr val="E2E8F0"/>
+            </a:solidFill>
+          </a:ln>
+        </p:spPr>
+        <p:style>
+          <a:lnRef idx="1">
+            <a:schemeClr val="accent1"/>
+          </a:lnRef>
+          <a:fillRef idx="3">
+            <a:schemeClr val="accent1"/>
+          </a:fillRef>
+          <a:effectRef idx="2">
+            <a:schemeClr val="accent1"/>
+          </a:effectRef>
+          <a:fontRef idx="minor">
+            <a:schemeClr val="lt1"/>
+          </a:fontRef>
+        </p:style>
+        <p:txBody>
+          <a:bodyPr rtlCol="0" anchor="ctr"/>
+          <a:lstStyle/>
+          <a:p>
+            <a:pPr algn="ctr"/>
+          </a:p>
+        </p:txBody>
+      </p:sp>
+      <p:sp>
+        <p:nvSpPr>
+          <p:cNvPr id="8" name="TextBox 7"/>
+          <p:cNvSpPr txBox="1"/>
+          <p:nvPr/>
+        </p:nvSpPr>
+        <p:spPr>
+          <a:xfrm>
+            <a:off x="6373368" y="1508760"/>
+            <a:ext cx="2194560" cy="1097280"/>
+          </a:xfrm>
+          <a:prstGeom prst="rect">
+            <a:avLst/>
+          </a:prstGeom>
+          <a:noFill/>
+        </p:spPr>
+        <p:txBody>
+          <a:bodyPr wrap="square">
+            <a:spAutoFit/>
+          </a:bodyPr>
+          <a:lstStyle/>
+          <a:p>
+            <a:pPr>
+              <a:defRPr sz="850" b="1">
+                <a:solidFill>
+                  <a:srgbClr val="64748B"/>
+                </a:solidFill>
+                <a:latin typeface="Segoe UI"/>
+              </a:defRPr>
+            </a:pPr>
+            <a:r>
+              <a:t>NEW BUSINESS POOL</a:t>
+            </a:r>
+          </a:p>
+          <a:p>
+            <a:pPr>
+              <a:defRPr sz="2000" b="1">
                 <a:solidFill>
                   <a:srgbClr val="9333EA"/>
                 </a:solidFill>
@@ -8255,15 +7701,203 @@
               </a:defRPr>
             </a:pPr>
             <a:r>
-              <a:t>2. Verification Protocol &amp; Accuracy</a:t>
-            </a:r>
-          </a:p>
-          <a:p>
-            <a:pPr>
-              <a:spcAft>
-                <a:spcPts val="400"/>
-              </a:spcAft>
-              <a:defRPr sz="1150" b="1">
+              <a:t>$2.300M</a:t>
+            </a:r>
+          </a:p>
+          <a:p>
+            <a:pPr>
+              <a:defRPr sz="850">
+                <a:solidFill>
+                  <a:srgbClr val="64748B"/>
+                </a:solidFill>
+                <a:latin typeface="Segoe UI"/>
+              </a:defRPr>
+            </a:pPr>
+            <a:r>
+              <a:t>$191.7k / Month Allocation</a:t>
+            </a:r>
+          </a:p>
+        </p:txBody>
+      </p:sp>
+      <p:sp>
+        <p:nvSpPr>
+          <p:cNvPr id="9" name="Rounded Rectangle 8"/>
+          <p:cNvSpPr/>
+          <p:nvPr/>
+        </p:nvSpPr>
+        <p:spPr>
+          <a:xfrm>
+            <a:off x="8988552" y="1463040"/>
+            <a:ext cx="2468880" cy="1188720"/>
+          </a:xfrm>
+          <a:prstGeom prst="roundRect">
+            <a:avLst/>
+          </a:prstGeom>
+          <a:solidFill>
+            <a:srgbClr val="FFFFFF"/>
+          </a:solidFill>
+          <a:ln w="15240">
+            <a:solidFill>
+              <a:srgbClr val="E2E8F0"/>
+            </a:solidFill>
+          </a:ln>
+        </p:spPr>
+        <p:style>
+          <a:lnRef idx="1">
+            <a:schemeClr val="accent1"/>
+          </a:lnRef>
+          <a:fillRef idx="3">
+            <a:schemeClr val="accent1"/>
+          </a:fillRef>
+          <a:effectRef idx="2">
+            <a:schemeClr val="accent1"/>
+          </a:effectRef>
+          <a:fontRef idx="minor">
+            <a:schemeClr val="lt1"/>
+          </a:fontRef>
+        </p:style>
+        <p:txBody>
+          <a:bodyPr rtlCol="0" anchor="ctr"/>
+          <a:lstStyle/>
+          <a:p>
+            <a:pPr algn="ctr"/>
+          </a:p>
+        </p:txBody>
+      </p:sp>
+      <p:sp>
+        <p:nvSpPr>
+          <p:cNvPr id="10" name="TextBox 9"/>
+          <p:cNvSpPr txBox="1"/>
+          <p:nvPr/>
+        </p:nvSpPr>
+        <p:spPr>
+          <a:xfrm>
+            <a:off x="9125712" y="1508760"/>
+            <a:ext cx="2194560" cy="1097280"/>
+          </a:xfrm>
+          <a:prstGeom prst="rect">
+            <a:avLst/>
+          </a:prstGeom>
+          <a:noFill/>
+        </p:spPr>
+        <p:txBody>
+          <a:bodyPr wrap="square">
+            <a:spAutoFit/>
+          </a:bodyPr>
+          <a:lstStyle/>
+          <a:p>
+            <a:pPr>
+              <a:defRPr sz="850" b="1">
+                <a:solidFill>
+                  <a:srgbClr val="64748B"/>
+                </a:solidFill>
+                <a:latin typeface="Segoe UI"/>
+              </a:defRPr>
+            </a:pPr>
+            <a:r>
+              <a:t>LINEN HUB DEDICATED</a:t>
+            </a:r>
+          </a:p>
+          <a:p>
+            <a:pPr>
+              <a:defRPr sz="2000" b="1">
+                <a:solidFill>
+                  <a:srgbClr val="D97706"/>
+                </a:solidFill>
+                <a:latin typeface="Segoe UI"/>
+              </a:defRPr>
+            </a:pPr>
+            <a:r>
+              <a:t>$2.300M</a:t>
+            </a:r>
+          </a:p>
+          <a:p>
+            <a:pPr>
+              <a:defRPr sz="850">
+                <a:solidFill>
+                  <a:srgbClr val="64748B"/>
+                </a:solidFill>
+                <a:latin typeface="Segoe UI"/>
+              </a:defRPr>
+            </a:pPr>
+            <a:r>
+              <a:t>Real-Time Decrement Pool</a:t>
+            </a:r>
+          </a:p>
+        </p:txBody>
+      </p:sp>
+      <p:sp>
+        <p:nvSpPr>
+          <p:cNvPr id="11" name="Rounded Rectangle 10"/>
+          <p:cNvSpPr/>
+          <p:nvPr/>
+        </p:nvSpPr>
+        <p:spPr>
+          <a:xfrm>
+            <a:off x="731520" y="2834640"/>
+            <a:ext cx="10728655" cy="3383280"/>
+          </a:xfrm>
+          <a:prstGeom prst="roundRect">
+            <a:avLst/>
+          </a:prstGeom>
+          <a:solidFill>
+            <a:srgbClr val="FFFFFF"/>
+          </a:solidFill>
+          <a:ln w="15240">
+            <a:solidFill>
+              <a:srgbClr val="E2E8F0"/>
+            </a:solidFill>
+          </a:ln>
+        </p:spPr>
+        <p:style>
+          <a:lnRef idx="1">
+            <a:schemeClr val="accent1"/>
+          </a:lnRef>
+          <a:fillRef idx="3">
+            <a:schemeClr val="accent1"/>
+          </a:fillRef>
+          <a:effectRef idx="2">
+            <a:schemeClr val="accent1"/>
+          </a:effectRef>
+          <a:fontRef idx="minor">
+            <a:schemeClr val="lt1"/>
+          </a:fontRef>
+        </p:style>
+        <p:txBody>
+          <a:bodyPr rtlCol="0" anchor="ctr"/>
+          <a:lstStyle/>
+          <a:p>
+            <a:pPr algn="ctr"/>
+          </a:p>
+        </p:txBody>
+      </p:sp>
+      <p:sp>
+        <p:nvSpPr>
+          <p:cNvPr id="12" name="TextBox 11"/>
+          <p:cNvSpPr txBox="1"/>
+          <p:nvPr/>
+        </p:nvSpPr>
+        <p:spPr>
+          <a:xfrm>
+            <a:off x="960120" y="3017520"/>
+            <a:ext cx="10271455" cy="3017520"/>
+          </a:xfrm>
+          <a:prstGeom prst="rect">
+            <a:avLst/>
+          </a:prstGeom>
+          <a:noFill/>
+        </p:spPr>
+        <p:txBody>
+          <a:bodyPr wrap="square">
+            <a:spAutoFit/>
+          </a:bodyPr>
+          <a:lstStyle/>
+          <a:p>
+            <a:pPr>
+              <a:spcAft>
+                <a:spcPts val="1000"/>
+              </a:spcAft>
+              <a:defRPr sz="1400" b="1">
                 <a:solidFill>
                   <a:srgbClr val="0F172A"/>
                 </a:solidFill>
@@ -8271,23 +7905,32 @@
               </a:defRPr>
             </a:pPr>
             <a:r>
-              <a:t>Pre-Workshop Validation Action:</a:t>
-            </a:r>
-          </a:p>
-          <a:p>
-            <a:pPr>
-              <a:spcAft>
-                <a:spcPts val="1400"/>
-              </a:spcAft>
-              <a:defRPr sz="1050">
+              <a:t>Financial Intelligence Capabilities Active in ProcureFlow Reporting Hub:</a:t>
+            </a:r>
+          </a:p>
+          <a:p>
+            <a:pPr>
+              <a:spcAft>
+                <a:spcPts val="600"/>
+              </a:spcAft>
+            </a:pPr>
+            <a:r>
+              <a:rPr sz="1050" b="1">
+                <a:solidFill>
+                  <a:srgbClr val="0F172A"/>
+                </a:solidFill>
+                <a:latin typeface="Segoe UI"/>
+              </a:rPr>
+              <a:t>• 2D Cross-Tabulation Matrix: </a:t>
+            </a:r>
+            <a:r>
+              <a:rPr sz="1050">
                 <a:solidFill>
                   <a:srgbClr val="475569"/>
                 </a:solidFill>
                 <a:latin typeface="Segoe UI"/>
-              </a:defRPr>
-            </a:pPr>
-            <a:r>
-              <a:t>Ashish Chhabra and Aaron Bell export the automated SUPPLIER_INVENTORY report directly from ProcureFlow and cross-check line-by-line against the manually distributed version.</a:t>
+              </a:rPr>
+              <a:t>Natively replicates Ashish's Concur EOM Pivot (Branch × Sector: Accommodation/Healthcare × Reason: Depletion/New Business/Linen Hub) excluding GST (Total / 1.1).</a:t>
             </a:r>
           </a:p>
           <a:p>
@@ -8295,63 +7938,124 @@
               <a:spcAft>
                 <a:spcPts val="600"/>
               </a:spcAft>
-              <a:defRPr sz="1150" b="1">
+            </a:pPr>
+            <a:r>
+              <a:rPr sz="1050" b="1">
                 <a:solidFill>
                   <a:srgbClr val="0F172A"/>
                 </a:solidFill>
                 <a:latin typeface="Segoe UI"/>
-              </a:defRPr>
-            </a:pPr>
-            <a:r>
-              <a:t>Operational Outcomes:</a:t>
-            </a:r>
-          </a:p>
-          <a:p>
-            <a:pPr>
-              <a:spcAft>
-                <a:spcPts val="800"/>
-              </a:spcAft>
-              <a:defRPr sz="1050">
-                <a:solidFill>
-                  <a:srgbClr val="059669"/>
-                </a:solidFill>
-                <a:latin typeface="Segoe UI"/>
-              </a:defRPr>
-            </a:pPr>
-            <a:r>
-              <a:t>✓ Guarantees 100% data consistency between supplier feeds and ProcureFlow catalogue.</a:t>
-            </a:r>
-          </a:p>
-          <a:p>
-            <a:pPr>
-              <a:spcAft>
-                <a:spcPts val="800"/>
-              </a:spcAft>
-              <a:defRPr sz="1050">
-                <a:solidFill>
-                  <a:srgbClr val="059669"/>
-                </a:solidFill>
-                <a:latin typeface="Segoe UI"/>
-              </a:defRPr>
-            </a:pPr>
-            <a:r>
-              <a:t>✓ Empowers site managers to verify stock availability before raising purchase requests.</a:t>
-            </a:r>
-          </a:p>
-          <a:p>
-            <a:pPr>
-              <a:spcAft>
-                <a:spcPts val="800"/>
-              </a:spcAft>
-              <a:defRPr sz="1050">
-                <a:solidFill>
-                  <a:srgbClr val="059669"/>
-                </a:solidFill>
-                <a:latin typeface="Segoe UI"/>
-              </a:defRPr>
-            </a:pPr>
-            <a:r>
-              <a:t>✓ Establishes a single, unchallengeable repository for all laundry inventory data.</a:t>
+              </a:rPr>
+              <a:t>• 100% Classification Precision: </a:t>
+            </a:r>
+            <a:r>
+              <a:rPr sz="1050">
+                <a:solidFill>
+                  <a:srgbClr val="475569"/>
+                </a:solidFill>
+                <a:latin typeface="Segoe UI"/>
+              </a:rPr>
+              <a:t>Automated legacy PO parser classifies unstandardised legacy PO strings with 100.0% parity against historical Concur records.</a:t>
+            </a:r>
+          </a:p>
+          <a:p>
+            <a:pPr>
+              <a:spcAft>
+                <a:spcPts val="600"/>
+              </a:spcAft>
+            </a:pPr>
+            <a:r>
+              <a:rPr sz="1050" b="1">
+                <a:solidFill>
+                  <a:srgbClr val="0F172A"/>
+                </a:solidFill>
+                <a:latin typeface="Segoe UI"/>
+              </a:rPr>
+              <a:t>• Branch Budget Tracking Grid: </a:t>
+            </a:r>
+            <a:r>
+              <a:rPr sz="1050">
+                <a:solidFill>
+                  <a:srgbClr val="475569"/>
+                </a:solidFill>
+                <a:latin typeface="Segoe UI"/>
+              </a:rPr>
+              <a:t>Tracks monthly and YTD spend vs baseline budgets across all 8 operating entities (Melbourne $2.65M, Sydney $2.78M, Adelaide $920k, Brisbane $1.03M, Cairns $706k, Mackay $349k, Perth $996k, Albury $481k).</a:t>
+            </a:r>
+          </a:p>
+          <a:p>
+            <a:pPr>
+              <a:spcAft>
+                <a:spcPts val="600"/>
+              </a:spcAft>
+            </a:pPr>
+            <a:r>
+              <a:rPr sz="1050" b="1">
+                <a:solidFill>
+                  <a:srgbClr val="0F172A"/>
+                </a:solidFill>
+                <a:latin typeface="Segoe UI"/>
+              </a:rPr>
+              <a:t>• Dedicated Linen Hub Pool: </a:t>
+            </a:r>
+            <a:r>
+              <a:rPr sz="1050">
+                <a:solidFill>
+                  <a:srgbClr val="475569"/>
+                </a:solidFill>
+                <a:latin typeface="Segoe UI"/>
+              </a:rPr>
+              <a:t>Maintains continuous decrement balance tracking against the dedicated $2.30M linen injection reserve.</a:t>
+            </a:r>
+          </a:p>
+          <a:p>
+            <a:pPr>
+              <a:spcAft>
+                <a:spcPts val="600"/>
+              </a:spcAft>
+            </a:pPr>
+            <a:r>
+              <a:rPr sz="1050" b="1">
+                <a:solidFill>
+                  <a:srgbClr val="0F172A"/>
+                </a:solidFill>
+                <a:latin typeface="Segoe UI"/>
+              </a:rPr>
+              <a:t>• Strategic Contract Breakouts: </a:t>
+            </a:r>
+            <a:r>
+              <a:rPr sz="1050">
+                <a:solidFill>
+                  <a:srgbClr val="475569"/>
+                </a:solidFill>
+                <a:latin typeface="Segoe UI"/>
+              </a:rPr>
+              <a:t>Real-time visibility into HealthShare Victoria (HSV) and Ramsay Health Care (RHC) contract spend.</a:t>
+            </a:r>
+          </a:p>
+          <a:p>
+            <a:pPr>
+              <a:spcAft>
+                <a:spcPts val="600"/>
+              </a:spcAft>
+            </a:pPr>
+            <a:r>
+              <a:rPr sz="1050" b="1">
+                <a:solidFill>
+                  <a:srgbClr val="0F172A"/>
+                </a:solidFill>
+                <a:latin typeface="Segoe UI"/>
+              </a:rPr>
+              <a:t>• 1-Click Concur EOM Export: </a:t>
+            </a:r>
+            <a:r>
+              <a:rPr sz="1050">
+                <a:solidFill>
+                  <a:srgbClr val="475569"/>
+                </a:solidFill>
+                <a:latin typeface="Segoe UI"/>
+              </a:rPr>
+              <a:t>Generates formatted leadership-ready Excel CSV reconciliation files instantly.</a:t>
             </a:r>
           </a:p>
         </p:txBody>

</xml_diff>

<commit_message>
docs: align presentation deck with operational strengths and remove workshop/checklist slides
</commit_message>
<xml_diff>
--- a/docs/ProcureFlow_Executive_Roadmap.pptx
+++ b/docs/ProcureFlow_Executive_Roadmap.pptx
@@ -3190,7 +3190,11 @@
               </a:defRPr>
             </a:pPr>
             <a:r>
-              <a:t>ProcureFlow: Journey to Seamless BAU Integration</a:t>
+              <a:t>ProcureFlow: Operational Excellence &amp;</a:t>
+            </a:r>
+            <a:br/>
+            <a:r>
+              <a:t>Targeted Governance Enhancements</a:t>
             </a:r>
           </a:p>
           <a:p>
@@ -3206,7 +3210,7 @@
               </a:defRPr>
             </a:pPr>
             <a:r>
-              <a:t>Previous State Foundation  •  Current State Wins &amp; Challenges  •  Target Developed State &amp; Closed-Loop Governance</a:t>
+              <a:t>Current Operational Strengths  •  Continuous Improvement Roadmap  •  Frictionless BAU Integration</a:t>
             </a:r>
           </a:p>
         </p:txBody>
@@ -3315,7 +3319,7 @@
               </a:defRPr>
             </a:pPr>
             <a:r>
-              <a:t>ACT 3: EXECUTION &amp; SIGN-OFF</a:t>
+              <a:t>STRATEGIC ASSURANCE</a:t>
             </a:r>
           </a:p>
           <a:p>
@@ -3328,7 +3332,7 @@
               </a:defRPr>
             </a:pPr>
             <a:r>
-              <a:t>Thursday Executive Workshop Agenda &amp; Production Cutover Plan</a:t>
+              <a:t>Summary: Executive Confidence in a Self-Governing Platform</a:t>
             </a:r>
           </a:p>
         </p:txBody>
@@ -3342,7 +3346,7 @@
         <p:spPr>
           <a:xfrm>
             <a:off x="731520" y="1463040"/>
-            <a:ext cx="2468880" cy="4754880"/>
+            <a:ext cx="10728655" cy="4754880"/>
           </a:xfrm>
           <a:prstGeom prst="roundRect">
             <a:avLst/>
@@ -3386,8 +3390,8 @@
         </p:nvSpPr>
         <p:spPr>
           <a:xfrm>
-            <a:off x="914400" y="1691640"/>
-            <a:ext cx="2103120" cy="4297680"/>
+            <a:off x="1005840" y="1691640"/>
+            <a:ext cx="10180015" cy="4297680"/>
           </a:xfrm>
           <a:prstGeom prst="rect">
             <a:avLst/>
@@ -3402,9 +3406,9 @@
           <a:p>
             <a:pPr>
               <a:spcAft>
-                <a:spcPts val="600"/>
-              </a:spcAft>
-              <a:defRPr sz="950" b="1">
+                <a:spcPts val="1400"/>
+              </a:spcAft>
+              <a:defRPr sz="1800" b="1">
                 <a:solidFill>
                   <a:srgbClr val="0284C7"/>
                 </a:solidFill>
@@ -3412,39 +3416,32 @@
               </a:defRPr>
             </a:pPr>
             <a:r>
-              <a:t>12:00 – 12:30 PM</a:t>
-            </a:r>
-          </a:p>
-          <a:p>
-            <a:pPr>
-              <a:spcAft>
-                <a:spcPts val="600"/>
-              </a:spcAft>
-              <a:defRPr sz="1300" b="1">
+              <a:t>A Working Platform Elevated to Permanent BAU Excellence</a:t>
+            </a:r>
+          </a:p>
+          <a:p>
+            <a:pPr>
+              <a:spcAft>
+                <a:spcPts val="1000"/>
+              </a:spcAft>
+            </a:pPr>
+            <a:r>
+              <a:rPr sz="1100" b="1">
                 <a:solidFill>
                   <a:srgbClr val="0F172A"/>
                 </a:solidFill>
                 <a:latin typeface="Segoe UI"/>
-              </a:defRPr>
-            </a:pPr>
-            <a:r>
-              <a:t>1. Point-of-Entry Governance</a:t>
-            </a:r>
-          </a:p>
-          <a:p>
-            <a:pPr>
-              <a:spcAft>
-                <a:spcPts val="1400"/>
-              </a:spcAft>
-              <a:defRPr sz="850" b="1">
-                <a:solidFill>
-                  <a:srgbClr val="64748B"/>
-                </a:solidFill>
-                <a:latin typeface="Segoe UI"/>
-              </a:defRPr>
-            </a:pPr>
-            <a:r>
-              <a:t>LEAD: AARON BELL &amp; ASHISH CHHABRA</a:t>
+              </a:rPr>
+              <a:t>★ Proven Reliability: </a:t>
+            </a:r>
+            <a:r>
+              <a:rPr sz="1100">
+                <a:solidFill>
+                  <a:srgbClr val="475569"/>
+                </a:solidFill>
+                <a:latin typeface="Segoe UI"/>
+              </a:rPr>
+              <a:t>ProcureFlow already manages daily purchasing across 8 laundry sites, 100% of SKUs are mapped, and digital goods receipting is firmly established.</a:t>
             </a:r>
           </a:p>
           <a:p>
@@ -3452,131 +3449,49 @@
               <a:spcAft>
                 <a:spcPts val="1000"/>
               </a:spcAft>
-              <a:defRPr sz="1050">
+            </a:pPr>
+            <a:r>
+              <a:rPr sz="1100" b="1">
+                <a:solidFill>
+                  <a:srgbClr val="0F172A"/>
+                </a:solidFill>
+                <a:latin typeface="Segoe UI"/>
+              </a:rPr>
+              <a:t>★ Zero Human Friction: </a:t>
+            </a:r>
+            <a:r>
+              <a:rPr sz="1100">
                 <a:solidFill>
                   <a:srgbClr val="475569"/>
                 </a:solidFill>
                 <a:latin typeface="Segoe UI"/>
-              </a:defRPr>
-            </a:pPr>
-            <a:r>
-              <a:t>Live walkthrough of POCreate: Carton multiple rounding, price master validation, and 100% item code mapping milestone.</a:t>
-            </a:r>
-          </a:p>
-        </p:txBody>
-      </p:sp>
-      <p:sp>
-        <p:nvSpPr>
-          <p:cNvPr id="5" name="Rounded Rectangle 4"/>
-          <p:cNvSpPr/>
-          <p:nvPr/>
-        </p:nvSpPr>
-        <p:spPr>
-          <a:xfrm>
-            <a:off x="3566160" y="1463040"/>
-            <a:ext cx="2468880" cy="4754880"/>
-          </a:xfrm>
-          <a:prstGeom prst="roundRect">
-            <a:avLst/>
-          </a:prstGeom>
-          <a:solidFill>
-            <a:srgbClr val="FFFFFF"/>
-          </a:solidFill>
-          <a:ln w="15240">
-            <a:solidFill>
-              <a:srgbClr val="E2E8F0"/>
-            </a:solidFill>
-          </a:ln>
-        </p:spPr>
-        <p:style>
-          <a:lnRef idx="1">
-            <a:schemeClr val="accent1"/>
-          </a:lnRef>
-          <a:fillRef idx="3">
-            <a:schemeClr val="accent1"/>
-          </a:fillRef>
-          <a:effectRef idx="2">
-            <a:schemeClr val="accent1"/>
-          </a:effectRef>
-          <a:fontRef idx="minor">
-            <a:schemeClr val="lt1"/>
-          </a:fontRef>
-        </p:style>
-        <p:txBody>
-          <a:bodyPr rtlCol="0" anchor="ctr"/>
-          <a:lstStyle/>
-          <a:p>
-            <a:pPr algn="ctr"/>
-          </a:p>
-        </p:txBody>
-      </p:sp>
-      <p:sp>
-        <p:nvSpPr>
-          <p:cNvPr id="6" name="TextBox 5"/>
-          <p:cNvSpPr txBox="1"/>
-          <p:nvPr/>
-        </p:nvSpPr>
-        <p:spPr>
-          <a:xfrm>
-            <a:off x="3749040" y="1691640"/>
-            <a:ext cx="2103120" cy="4297680"/>
-          </a:xfrm>
-          <a:prstGeom prst="rect">
-            <a:avLst/>
-          </a:prstGeom>
-          <a:noFill/>
-        </p:spPr>
-        <p:txBody>
-          <a:bodyPr wrap="square">
-            <a:spAutoFit/>
-          </a:bodyPr>
-          <a:lstStyle/>
-          <a:p>
-            <a:pPr>
-              <a:spcAft>
-                <a:spcPts val="600"/>
-              </a:spcAft>
-              <a:defRPr sz="950" b="1">
-                <a:solidFill>
-                  <a:srgbClr val="0284C7"/>
-                </a:solidFill>
-                <a:latin typeface="Segoe UI"/>
-              </a:defRPr>
-            </a:pPr>
-            <a:r>
-              <a:t>12:30 – 1:00 PM</a:t>
-            </a:r>
-          </a:p>
-          <a:p>
-            <a:pPr>
-              <a:spcAft>
-                <a:spcPts val="600"/>
-              </a:spcAft>
-              <a:defRPr sz="1300" b="1">
+              </a:rPr>
+              <a:t>Point-of-entry packaging modulo rules and contract price lookups stop requisition errors before submission.</a:t>
+            </a:r>
+          </a:p>
+          <a:p>
+            <a:pPr>
+              <a:spcAft>
+                <a:spcPts val="1000"/>
+              </a:spcAft>
+            </a:pPr>
+            <a:r>
+              <a:rPr sz="1100" b="1">
                 <a:solidFill>
                   <a:srgbClr val="0F172A"/>
                 </a:solidFill>
                 <a:latin typeface="Segoe UI"/>
-              </a:defRPr>
-            </a:pPr>
-            <a:r>
-              <a:t>2. DOA Approval &amp; Notification Engine</a:t>
-            </a:r>
-          </a:p>
-          <a:p>
-            <a:pPr>
-              <a:spcAft>
-                <a:spcPts val="1400"/>
-              </a:spcAft>
-              <a:defRPr sz="850" b="1">
-                <a:solidFill>
-                  <a:srgbClr val="64748B"/>
-                </a:solidFill>
-                <a:latin typeface="Segoe UI"/>
-              </a:defRPr>
-            </a:pPr>
-            <a:r>
-              <a:t>LEAD: ASHISH CHHABRA &amp; AARON BELL</a:t>
+              </a:rPr>
+              <a:t>★ Closed-Loop ERP Parity: </a:t>
+            </a:r>
+            <a:r>
+              <a:rPr sz="1100">
+                <a:solidFill>
+                  <a:srgbClr val="475569"/>
+                </a:solidFill>
+                <a:latin typeface="Segoe UI"/>
+              </a:rPr>
+              <a:t>Mandatory Concur PR # enforcement guarantees 100% 1-to-1 data mirroring between ProcureFlow and SAP Concur.</a:t>
             </a:r>
           </a:p>
           <a:p>
@@ -3584,279 +3499,49 @@
               <a:spcAft>
                 <a:spcPts val="1000"/>
               </a:spcAft>
-              <a:defRPr sz="1050">
+            </a:pPr>
+            <a:r>
+              <a:rPr sz="1100" b="1">
+                <a:solidFill>
+                  <a:srgbClr val="0F172A"/>
+                </a:solidFill>
+                <a:latin typeface="Segoe UI"/>
+              </a:rPr>
+              <a:t>★ Proactive Operational Discipline: </a:t>
+            </a:r>
+            <a:r>
+              <a:rPr sz="1100">
                 <a:solidFill>
                   <a:srgbClr val="475569"/>
                 </a:solidFill>
                 <a:latin typeface="Segoe UI"/>
-              </a:defRPr>
-            </a:pPr>
-            <a:r>
-              <a:t>DOA approval tiers, 100% receipt closure reminders, &gt;14d overdue manager escalation, and mandatory Concur PR # enforcement.</a:t>
-            </a:r>
-          </a:p>
-        </p:txBody>
-      </p:sp>
-      <p:sp>
-        <p:nvSpPr>
-          <p:cNvPr id="7" name="Rounded Rectangle 6"/>
-          <p:cNvSpPr/>
-          <p:nvPr/>
-        </p:nvSpPr>
-        <p:spPr>
-          <a:xfrm>
-            <a:off x="6400800" y="1463040"/>
-            <a:ext cx="2468880" cy="4754880"/>
-          </a:xfrm>
-          <a:prstGeom prst="roundRect">
-            <a:avLst/>
-          </a:prstGeom>
-          <a:solidFill>
-            <a:srgbClr val="FFFFFF"/>
-          </a:solidFill>
-          <a:ln w="15240">
-            <a:solidFill>
-              <a:srgbClr val="E2E8F0"/>
-            </a:solidFill>
-          </a:ln>
-        </p:spPr>
-        <p:style>
-          <a:lnRef idx="1">
-            <a:schemeClr val="accent1"/>
-          </a:lnRef>
-          <a:fillRef idx="3">
-            <a:schemeClr val="accent1"/>
-          </a:fillRef>
-          <a:effectRef idx="2">
-            <a:schemeClr val="accent1"/>
-          </a:effectRef>
-          <a:fontRef idx="minor">
-            <a:schemeClr val="lt1"/>
-          </a:fontRef>
-        </p:style>
-        <p:txBody>
-          <a:bodyPr rtlCol="0" anchor="ctr"/>
-          <a:lstStyle/>
-          <a:p>
-            <a:pPr algn="ctr"/>
-          </a:p>
-        </p:txBody>
-      </p:sp>
-      <p:sp>
-        <p:nvSpPr>
-          <p:cNvPr id="8" name="TextBox 7"/>
-          <p:cNvSpPr txBox="1"/>
-          <p:nvPr/>
-        </p:nvSpPr>
-        <p:spPr>
-          <a:xfrm>
-            <a:off x="6583680" y="1691640"/>
-            <a:ext cx="2103120" cy="4297680"/>
-          </a:xfrm>
-          <a:prstGeom prst="rect">
-            <a:avLst/>
-          </a:prstGeom>
-          <a:noFill/>
-        </p:spPr>
-        <p:txBody>
-          <a:bodyPr wrap="square">
-            <a:spAutoFit/>
-          </a:bodyPr>
-          <a:lstStyle/>
-          <a:p>
-            <a:pPr>
-              <a:spcAft>
-                <a:spcPts val="600"/>
-              </a:spcAft>
-              <a:defRPr sz="950" b="1">
-                <a:solidFill>
-                  <a:srgbClr val="0284C7"/>
-                </a:solidFill>
-                <a:latin typeface="Segoe UI"/>
-              </a:defRPr>
-            </a:pPr>
-            <a:r>
-              <a:t>1:00 – 1:30 PM</a:t>
-            </a:r>
-          </a:p>
-          <a:p>
-            <a:pPr>
-              <a:spcAft>
-                <a:spcPts val="600"/>
-              </a:spcAft>
-              <a:defRPr sz="1300" b="1">
+              </a:rPr>
+              <a:t>Automated closure nudges and tiered line manager escalations eliminate lingering open commitments and overdue shipments.</a:t>
+            </a:r>
+          </a:p>
+          <a:p>
+            <a:pPr>
+              <a:spcAft>
+                <a:spcPts val="1000"/>
+              </a:spcAft>
+            </a:pPr>
+            <a:r>
+              <a:rPr sz="1100" b="1">
                 <a:solidFill>
                   <a:srgbClr val="0F172A"/>
                 </a:solidFill>
                 <a:latin typeface="Segoe UI"/>
-              </a:defRPr>
-            </a:pPr>
-            <a:r>
-              <a:t>3. Executive EOM Spend Reconciliation</a:t>
-            </a:r>
-          </a:p>
-          <a:p>
-            <a:pPr>
-              <a:spcAft>
-                <a:spcPts val="1400"/>
-              </a:spcAft>
-              <a:defRPr sz="850" b="1">
-                <a:solidFill>
-                  <a:srgbClr val="64748B"/>
-                </a:solidFill>
-                <a:latin typeface="Segoe UI"/>
-              </a:defRPr>
-            </a:pPr>
-            <a:r>
-              <a:t>LEAD: ASHISH CHHABRA &amp; AARON BELL</a:t>
-            </a:r>
-          </a:p>
-          <a:p>
-            <a:pPr>
-              <a:spcAft>
-                <a:spcPts val="1000"/>
-              </a:spcAft>
-              <a:defRPr sz="1050">
+              </a:rPr>
+              <a:t>★ Single Source of Truth: </a:t>
+            </a:r>
+            <a:r>
+              <a:rPr sz="1100">
                 <a:solidFill>
                   <a:srgbClr val="475569"/>
                 </a:solidFill>
                 <a:latin typeface="Segoe UI"/>
-              </a:defRPr>
-            </a:pPr>
-            <a:r>
-              <a:t>Live 2D Pivot Table (Branch × Sector × Reason), FY27 Budget vs Actuals burn rate grid, Linen Hub $2.3M tracker, and 1-Click CSV export.</a:t>
-            </a:r>
-          </a:p>
-        </p:txBody>
-      </p:sp>
-      <p:sp>
-        <p:nvSpPr>
-          <p:cNvPr id="9" name="Rounded Rectangle 8"/>
-          <p:cNvSpPr/>
-          <p:nvPr/>
-        </p:nvSpPr>
-        <p:spPr>
-          <a:xfrm>
-            <a:off x="9235440" y="1463040"/>
-            <a:ext cx="2468880" cy="4754880"/>
-          </a:xfrm>
-          <a:prstGeom prst="roundRect">
-            <a:avLst/>
-          </a:prstGeom>
-          <a:solidFill>
-            <a:srgbClr val="FFFFFF"/>
-          </a:solidFill>
-          <a:ln w="15240">
-            <a:solidFill>
-              <a:srgbClr val="E2E8F0"/>
-            </a:solidFill>
-          </a:ln>
-        </p:spPr>
-        <p:style>
-          <a:lnRef idx="1">
-            <a:schemeClr val="accent1"/>
-          </a:lnRef>
-          <a:fillRef idx="3">
-            <a:schemeClr val="accent1"/>
-          </a:fillRef>
-          <a:effectRef idx="2">
-            <a:schemeClr val="accent1"/>
-          </a:effectRef>
-          <a:fontRef idx="minor">
-            <a:schemeClr val="lt1"/>
-          </a:fontRef>
-        </p:style>
-        <p:txBody>
-          <a:bodyPr rtlCol="0" anchor="ctr"/>
-          <a:lstStyle/>
-          <a:p>
-            <a:pPr algn="ctr"/>
-          </a:p>
-        </p:txBody>
-      </p:sp>
-      <p:sp>
-        <p:nvSpPr>
-          <p:cNvPr id="10" name="TextBox 9"/>
-          <p:cNvSpPr txBox="1"/>
-          <p:nvPr/>
-        </p:nvSpPr>
-        <p:spPr>
-          <a:xfrm>
-            <a:off x="9418320" y="1691640"/>
-            <a:ext cx="2103120" cy="4297680"/>
-          </a:xfrm>
-          <a:prstGeom prst="rect">
-            <a:avLst/>
-          </a:prstGeom>
-          <a:noFill/>
-        </p:spPr>
-        <p:txBody>
-          <a:bodyPr wrap="square">
-            <a:spAutoFit/>
-          </a:bodyPr>
-          <a:lstStyle/>
-          <a:p>
-            <a:pPr>
-              <a:spcAft>
-                <a:spcPts val="600"/>
-              </a:spcAft>
-              <a:defRPr sz="950" b="1">
-                <a:solidFill>
-                  <a:srgbClr val="0284C7"/>
-                </a:solidFill>
-                <a:latin typeface="Segoe UI"/>
-              </a:defRPr>
-            </a:pPr>
-            <a:r>
-              <a:t>1:30 – 2:00 PM</a:t>
-            </a:r>
-          </a:p>
-          <a:p>
-            <a:pPr>
-              <a:spcAft>
-                <a:spcPts val="600"/>
-              </a:spcAft>
-              <a:defRPr sz="1300" b="1">
-                <a:solidFill>
-                  <a:srgbClr val="0F172A"/>
-                </a:solidFill>
-                <a:latin typeface="Segoe UI"/>
-              </a:defRPr>
-            </a:pPr>
-            <a:r>
-              <a:t>4. SOH Automation &amp; Cutover Sign-Off</a:t>
-            </a:r>
-          </a:p>
-          <a:p>
-            <a:pPr>
-              <a:spcAft>
-                <a:spcPts val="1400"/>
-              </a:spcAft>
-              <a:defRPr sz="850" b="1">
-                <a:solidFill>
-                  <a:srgbClr val="64748B"/>
-                </a:solidFill>
-                <a:latin typeface="Segoe UI"/>
-              </a:defRPr>
-            </a:pPr>
-            <a:r>
-              <a:t>LEAD: EBRAHIM MOKHTARI (COO)</a:t>
-            </a:r>
-          </a:p>
-          <a:p>
-            <a:pPr>
-              <a:spcAft>
-                <a:spcPts val="1000"/>
-              </a:spcAft>
-              <a:defRPr sz="1050">
-                <a:solidFill>
-                  <a:srgbClr val="475569"/>
-                </a:solidFill>
-                <a:latin typeface="Segoe UI"/>
-              </a:defRPr>
-            </a:pPr>
-            <a:r>
-              <a:t>Review automated SOH distribution, feedback synthesis, and formal production sign-off by Ebrahim Mokhtari for merge to main.</a:t>
+              </a:rPr>
+              <a:t>Real-time 2D Pivot Table and FY27 budget tracking ($14.521M) provide leadership with immediate, unchallengeable financial clarity.</a:t>
             </a:r>
           </a:p>
         </p:txBody>
@@ -3913,7 +3598,7 @@
               </a:defRPr>
             </a:pPr>
             <a:r>
-              <a:t>STRATEGIC TRANSFORMATION FRAMEWORK</a:t>
+              <a:t>STRATEGIC ALIGNMENT</a:t>
             </a:r>
           </a:p>
           <a:p>
@@ -3926,7 +3611,7 @@
               </a:defRPr>
             </a:pPr>
             <a:r>
-              <a:t>Strategic Narrative: The Evolution of ProcureFlow in SPL</a:t>
+              <a:t>Strategic Mindset: Elevating a Working Operational Platform</a:t>
             </a:r>
           </a:p>
         </p:txBody>
@@ -4010,15 +3695,15 @@
               </a:defRPr>
             </a:pPr>
             <a:r>
-              <a:t>STAGE 1: THE FOUNDATION</a:t>
-            </a:r>
-          </a:p>
-          <a:p>
-            <a:pPr>
-              <a:spcAft>
-                <a:spcPts val="200"/>
-              </a:spcAft>
-              <a:defRPr sz="1700" b="1">
+              <a:t>1. PROVEN WORKING PLATFORM</a:t>
+            </a:r>
+          </a:p>
+          <a:p>
+            <a:pPr>
+              <a:spcAft>
+                <a:spcPts val="1400"/>
+              </a:spcAft>
+              <a:defRPr sz="1600" b="1">
                 <a:solidFill>
                   <a:srgbClr val="0F172A"/>
                 </a:solidFill>
@@ -4026,23 +3711,7 @@
               </a:defRPr>
             </a:pPr>
             <a:r>
-              <a:t>Previous State</a:t>
-            </a:r>
-          </a:p>
-          <a:p>
-            <a:pPr>
-              <a:spcAft>
-                <a:spcPts val="1400"/>
-              </a:spcAft>
-              <a:defRPr sz="1000" b="1">
-                <a:solidFill>
-                  <a:srgbClr val="64748B"/>
-                </a:solidFill>
-                <a:latin typeface="Segoe UI"/>
-              </a:defRPr>
-            </a:pPr>
-            <a:r>
-              <a:t>What ProcureFlow Provided the Business</a:t>
+              <a:t>A Stable Daily Engine</a:t>
             </a:r>
           </a:p>
           <a:p>
@@ -4058,7 +3727,7 @@
                 </a:solidFill>
                 <a:latin typeface="Segoe UI"/>
               </a:rPr>
-              <a:t>• Digitized Linen Requisitions:</a:t>
+              <a:t>• Active Daily Requisitioning:</a:t>
             </a:r>
             <a:r>
               <a:rPr sz="1050">
@@ -4067,7 +3736,7 @@
                 </a:solidFill>
                 <a:latin typeface="Segoe UI"/>
               </a:rPr>
-              <a:t> Replaced manual emails and paper forms with a structured ordering portal.</a:t>
+              <a:t> Runs daily ordering across all 8 regional laundry branches.</a:t>
             </a:r>
           </a:p>
           <a:p>
@@ -4083,7 +3752,7 @@
                 </a:solidFill>
                 <a:latin typeface="Segoe UI"/>
               </a:rPr>
-              <a:t>• Multi-Site Management:</a:t>
+              <a:t>• 100% Master Item Mapping:</a:t>
             </a:r>
             <a:r>
               <a:rPr sz="1050">
@@ -4092,7 +3761,7 @@
                 </a:solidFill>
                 <a:latin typeface="Segoe UI"/>
               </a:rPr>
-              <a:t> Enabled branch-specific catalog browsing and centralized delivery address routing.</a:t>
+              <a:t> All internal SPL codes mapped 1-to-1 to vendor catalog SKUs.</a:t>
             </a:r>
           </a:p>
           <a:p>
@@ -4108,7 +3777,7 @@
                 </a:solidFill>
                 <a:latin typeface="Segoe UI"/>
               </a:rPr>
-              <a:t>• Baseline Approval Hierarchy:</a:t>
+              <a:t>• Physical Receiving &amp; Docket Capture:</a:t>
             </a:r>
             <a:r>
               <a:rPr sz="1050">
@@ -4117,7 +3786,7 @@
                 </a:solidFill>
                 <a:latin typeface="Segoe UI"/>
               </a:rPr>
-              <a:t> Created initial review gates for site managers and procurement.</a:t>
+              <a:t> On-site digital goods receipting (GR) actively enforced.</a:t>
             </a:r>
           </a:p>
           <a:p>
@@ -4133,7 +3802,7 @@
                 </a:solidFill>
                 <a:latin typeface="Segoe UI"/>
               </a:rPr>
-              <a:t>• Goods Receipting (GR) Logging:</a:t>
+              <a:t>• High User Adoption:</a:t>
             </a:r>
             <a:r>
               <a:rPr sz="1050">
@@ -4142,7 +3811,7 @@
                 </a:solidFill>
                 <a:latin typeface="Segoe UI"/>
               </a:rPr>
-              <a:t> Established physical docket tracking on site for delivery confirmation.</a:t>
+              <a:t> Embedded across site managers, warehouse receivers, and procurement.</a:t>
             </a:r>
           </a:p>
         </p:txBody>
@@ -4226,15 +3895,15 @@
               </a:defRPr>
             </a:pPr>
             <a:r>
-              <a:t>STAGE 2: THE REALITY</a:t>
-            </a:r>
-          </a:p>
-          <a:p>
-            <a:pPr>
-              <a:spcAft>
-                <a:spcPts val="200"/>
-              </a:spcAft>
-              <a:defRPr sz="1700" b="1">
+              <a:t>2. THE TARGET OF THIS PLAN</a:t>
+            </a:r>
+          </a:p>
+          <a:p>
+            <a:pPr>
+              <a:spcAft>
+                <a:spcPts val="1400"/>
+              </a:spcAft>
+              <a:defRPr sz="1600" b="1">
                 <a:solidFill>
                   <a:srgbClr val="0F172A"/>
                 </a:solidFill>
@@ -4242,23 +3911,7 @@
               </a:defRPr>
             </a:pPr>
             <a:r>
-              <a:t>Current State</a:t>
-            </a:r>
-          </a:p>
-          <a:p>
-            <a:pPr>
-              <a:spcAft>
-                <a:spcPts val="1400"/>
-              </a:spcAft>
-              <a:defRPr sz="1000" b="1">
-                <a:solidFill>
-                  <a:srgbClr val="64748B"/>
-                </a:solidFill>
-                <a:latin typeface="Segoe UI"/>
-              </a:defRPr>
-            </a:pPr>
-            <a:r>
-              <a:t>Wins, Challenges &amp; Operational Friction</a:t>
+              <a:t>Targeted Continuous Improvement</a:t>
             </a:r>
           </a:p>
           <a:p>
@@ -4274,7 +3927,7 @@
                 </a:solidFill>
                 <a:latin typeface="Segoe UI"/>
               </a:rPr>
-              <a:t>• Key Wins:</a:t>
+              <a:t>• Not 'Fixing' a Broken Tool:</a:t>
             </a:r>
             <a:r>
               <a:rPr sz="1050">
@@ -4283,7 +3936,7 @@
                 </a:solidFill>
                 <a:latin typeface="Segoe UI"/>
               </a:rPr>
-              <a:t> 100% item code mapping achieved; centralized spend taxonomy (Depletion vs New Business).</a:t>
+              <a:t> ProcureFlow already works reliably and securely.</a:t>
             </a:r>
           </a:p>
           <a:p>
@@ -4299,7 +3952,7 @@
                 </a:solidFill>
                 <a:latin typeface="Segoe UI"/>
               </a:rPr>
-              <a:t>• Operational Challenges:</a:t>
+              <a:t>• Eliminating Human Friction:</a:t>
             </a:r>
             <a:r>
               <a:rPr sz="1050">
@@ -4308,7 +3961,7 @@
                 </a:solidFill>
                 <a:latin typeface="Segoe UI"/>
               </a:rPr>
-              <a:t> Manual EOM Excel crunching by super user; unrounded pack sizes; contract pricing typos; missing Concur ERP links.</a:t>
+              <a:t> Removing remaining manual Excel crunching and packaging typos.</a:t>
             </a:r>
           </a:p>
           <a:p>
@@ -4324,7 +3977,7 @@
                 </a:solidFill>
                 <a:latin typeface="Segoe UI"/>
               </a:rPr>
-              <a:t>• The Strategic Opportunity:</a:t>
+              <a:t>• Automated Guardrails:</a:t>
             </a:r>
             <a:r>
               <a:rPr sz="1050">
@@ -4333,7 +3986,32 @@
                 </a:solidFill>
                 <a:latin typeface="Segoe UI"/>
               </a:rPr>
-              <a:t> Transition from a passive recording tool to an active, self-governing platform.</a:t>
+              <a:t> Guiding users naturally to zero-defect ordering at the source.</a:t>
+            </a:r>
+          </a:p>
+          <a:p>
+            <a:pPr>
+              <a:spcAft>
+                <a:spcPts val="1000"/>
+              </a:spcAft>
+            </a:pPr>
+            <a:r>
+              <a:rPr sz="1050" b="1">
+                <a:solidFill>
+                  <a:srgbClr val="0F172A"/>
+                </a:solidFill>
+                <a:latin typeface="Segoe UI"/>
+              </a:rPr>
+              <a:t>• Single Source of Truth:</a:t>
+            </a:r>
+            <a:r>
+              <a:rPr sz="1050">
+                <a:solidFill>
+                  <a:srgbClr val="475569"/>
+                </a:solidFill>
+                <a:latin typeface="Segoe UI"/>
+              </a:rPr>
+              <a:t> Permanently synchronizing ProcureFlow with SAP Concur.</a:t>
             </a:r>
           </a:p>
         </p:txBody>
@@ -4417,15 +4095,15 @@
               </a:defRPr>
             </a:pPr>
             <a:r>
-              <a:t>STAGE 3: THE VISION</a:t>
-            </a:r>
-          </a:p>
-          <a:p>
-            <a:pPr>
-              <a:spcAft>
-                <a:spcPts val="200"/>
-              </a:spcAft>
-              <a:defRPr sz="1700" b="1">
+              <a:t>3. THE STRATEGIC OUTCOME</a:t>
+            </a:r>
+          </a:p>
+          <a:p>
+            <a:pPr>
+              <a:spcAft>
+                <a:spcPts val="1400"/>
+              </a:spcAft>
+              <a:defRPr sz="1600" b="1">
                 <a:solidFill>
                   <a:srgbClr val="0F172A"/>
                 </a:solidFill>
@@ -4433,23 +4111,7 @@
               </a:defRPr>
             </a:pPr>
             <a:r>
-              <a:t>Future / Developed State</a:t>
-            </a:r>
-          </a:p>
-          <a:p>
-            <a:pPr>
-              <a:spcAft>
-                <a:spcPts val="1400"/>
-              </a:spcAft>
-              <a:defRPr sz="1000" b="1">
-                <a:solidFill>
-                  <a:srgbClr val="64748B"/>
-                </a:solidFill>
-                <a:latin typeface="Segoe UI"/>
-              </a:defRPr>
-            </a:pPr>
-            <a:r>
-              <a:t>Frictionless BAU Integration &amp; User Engagement</a:t>
+              <a:t>Frictionless BAU Integration</a:t>
             </a:r>
           </a:p>
           <a:p>
@@ -4465,7 +4127,7 @@
                 </a:solidFill>
                 <a:latin typeface="Segoe UI"/>
               </a:rPr>
-              <a:t>• Zero-Defect Input Governance:</a:t>
+              <a:t>• Effortless for Sites:</a:t>
             </a:r>
             <a:r>
               <a:rPr sz="1050">
@@ -4474,7 +4136,7 @@
                 </a:solidFill>
                 <a:latin typeface="Segoe UI"/>
               </a:rPr>
-              <a:t> Automated carton multiple rounding and contract price master checks.</a:t>
+              <a:t> 1-click carton rounding and immediate homepage task guidance.</a:t>
             </a:r>
           </a:p>
           <a:p>
@@ -4490,7 +4152,7 @@
                 </a:solidFill>
                 <a:latin typeface="Segoe UI"/>
               </a:rPr>
-              <a:t>• Closed-Loop ERP Parity:</a:t>
+              <a:t>• Zero-Rework for Procurement:</a:t>
             </a:r>
             <a:r>
               <a:rPr sz="1050">
@@ -4499,7 +4161,7 @@
                 </a:solidFill>
                 <a:latin typeface="Segoe UI"/>
               </a:rPr>
-              <a:t> Mandatory Concur PR # rule and live Action Required homepage center.</a:t>
+              <a:t> Pre-validated orders and automated EOM reconciliation in seconds.</a:t>
             </a:r>
           </a:p>
           <a:p>
@@ -4515,7 +4177,7 @@
                 </a:solidFill>
                 <a:latin typeface="Segoe UI"/>
               </a:rPr>
-              <a:t>• Executive Intelligence:</a:t>
+              <a:t>• Commercial Control for Leadership:</a:t>
             </a:r>
             <a:r>
               <a:rPr sz="1050">
@@ -4524,32 +4186,7 @@
                 </a:solidFill>
                 <a:latin typeface="Segoe UI"/>
               </a:rPr>
-              <a:t> Real-time 2D EOM Pivot Reconciliation and FY27 Budget burn rate tracking ($14.521M).</a:t>
-            </a:r>
-          </a:p>
-          <a:p>
-            <a:pPr>
-              <a:spcAft>
-                <a:spcPts val="1000"/>
-              </a:spcAft>
-            </a:pPr>
-            <a:r>
-              <a:rPr sz="1050" b="1">
-                <a:solidFill>
-                  <a:srgbClr val="0F172A"/>
-                </a:solidFill>
-                <a:latin typeface="Segoe UI"/>
-              </a:rPr>
-              <a:t>• Self-Sustaining User Engagement:</a:t>
-            </a:r>
-            <a:r>
-              <a:rPr sz="1050">
-                <a:solidFill>
-                  <a:srgbClr val="475569"/>
-                </a:solidFill>
-                <a:latin typeface="Segoe UI"/>
-              </a:rPr>
-              <a:t> Guardrails guide users naturally to achieve permanent compliance.</a:t>
+              <a:t> Real-time visibility into $14.521M FY27 budget and $2.3M Linen Hub.</a:t>
             </a:r>
           </a:p>
         </p:txBody>
@@ -4606,7 +4243,7 @@
               </a:defRPr>
             </a:pPr>
             <a:r>
-              <a:t>ACT 1: THE FOUNDATION</a:t>
+              <a:t>DEMONSTRATED CAPABILITIES</a:t>
             </a:r>
           </a:p>
           <a:p>
@@ -4619,7 +4256,7 @@
               </a:defRPr>
             </a:pPr>
             <a:r>
-              <a:t>Previous State: What ProcureFlow Has Provided to South Pacific Laundry</a:t>
+              <a:t>ProcureFlow Today: Current Operational Strengths &amp; Baseline Excellence</a:t>
             </a:r>
           </a:p>
         </p:txBody>
@@ -4695,7 +4332,7 @@
               <a:spcAft>
                 <a:spcPts val="800"/>
               </a:spcAft>
-              <a:defRPr sz="1300" b="1">
+              <a:defRPr sz="1250" b="1">
                 <a:solidFill>
                   <a:srgbClr val="0284C7"/>
                 </a:solidFill>
@@ -4703,14 +4340,11 @@
               </a:defRPr>
             </a:pPr>
             <a:r>
-              <a:t>01  |  DIGITIZED REQUISITIONING</a:t>
-            </a:r>
-          </a:p>
-          <a:p>
-            <a:pPr>
-              <a:spcAft>
-                <a:spcPts val="600"/>
-              </a:spcAft>
+              <a:t>01  |  NATIONAL SCALE &amp; MULTI-BRANCH REQUISITIONING</a:t>
+            </a:r>
+          </a:p>
+          <a:p>
+            <a:pPr>
               <a:defRPr sz="1100">
                 <a:solidFill>
                   <a:srgbClr val="475569"/>
@@ -4719,7 +4353,7 @@
               </a:defRPr>
             </a:pPr>
             <a:r>
-              <a:t>Replaced informal emails, phone orders, and physical paperwork with a single standardized online ordering portal for all laundry sites.</a:t>
+              <a:t>Active daily purchasing across all 8 branches (Melbourne, Sydney, Brisbane, Perth, Adelaide, Cairns, Mackay, Albury) with branch-specific catalog filtering and address routing.</a:t>
             </a:r>
           </a:p>
         </p:txBody>
@@ -4795,22 +4429,19 @@
               <a:spcAft>
                 <a:spcPts val="800"/>
               </a:spcAft>
-              <a:defRPr sz="1300" b="1">
-                <a:solidFill>
-                  <a:srgbClr val="9333EA"/>
-                </a:solidFill>
-                <a:latin typeface="Segoe UI"/>
-              </a:defRPr>
-            </a:pPr>
-            <a:r>
-              <a:t>02  |  MULTI-SITE GOVERNANCE</a:t>
-            </a:r>
-          </a:p>
-          <a:p>
-            <a:pPr>
-              <a:spcAft>
-                <a:spcPts val="600"/>
-              </a:spcAft>
+              <a:defRPr sz="1250" b="1">
+                <a:solidFill>
+                  <a:srgbClr val="059669"/>
+                </a:solidFill>
+                <a:latin typeface="Segoe UI"/>
+              </a:defRPr>
+            </a:pPr>
+            <a:r>
+              <a:t>02  |  100% SUPPLY ITEM CODE MAPPING MILESTONE</a:t>
+            </a:r>
+          </a:p>
+          <a:p>
+            <a:pPr>
               <a:defRPr sz="1100">
                 <a:solidFill>
                   <a:srgbClr val="475569"/>
@@ -4819,7 +4450,7 @@
               </a:defRPr>
             </a:pPr>
             <a:r>
-              <a:t>Enabled site-specific product catalogs, delivery address routing, and local manager authorization across Melbourne, Sydney, Brisbane, Perth, Adelaide, Cairns, Mackay, and Albury.</a:t>
+              <a:t>Achieved a major master data milestone: 100% of SPL internal item codes are mapped to vendor catalog SKUs (Simba, Host, etc.), standardizing product specifications nationally.</a:t>
             </a:r>
           </a:p>
         </p:txBody>
@@ -4895,22 +4526,19 @@
               <a:spcAft>
                 <a:spcPts val="800"/>
               </a:spcAft>
-              <a:defRPr sz="1300" b="1">
-                <a:solidFill>
-                  <a:srgbClr val="059669"/>
-                </a:solidFill>
-                <a:latin typeface="Segoe UI"/>
-              </a:defRPr>
-            </a:pPr>
-            <a:r>
-              <a:t>03  |  GOODS RECEIPT (GR) TRACKING</a:t>
-            </a:r>
-          </a:p>
-          <a:p>
-            <a:pPr>
-              <a:spcAft>
-                <a:spcPts val="600"/>
-              </a:spcAft>
+              <a:defRPr sz="1250" b="1">
+                <a:solidFill>
+                  <a:srgbClr val="9333EA"/>
+                </a:solidFill>
+                <a:latin typeface="Segoe UI"/>
+              </a:defRPr>
+            </a:pPr>
+            <a:r>
+              <a:t>03  |  ON-SITE GOODS RECEIPTING (GR) &amp; DOCKET CAPTURE</a:t>
+            </a:r>
+          </a:p>
+          <a:p>
+            <a:pPr>
               <a:defRPr sz="1100">
                 <a:solidFill>
                   <a:srgbClr val="475569"/>
@@ -4919,7 +4547,7 @@
               </a:defRPr>
             </a:pPr>
             <a:r>
-              <a:t>Established digital delivery logging on site, capturing dockets, received quantities, and initial partial delivery histories for audit visibility.</a:t>
+              <a:t>Warehouse receiving teams capture delivery dockets, quantities received, and receiver signatures digitally, providing the factual bedrock for 3-way invoice matching.</a:t>
             </a:r>
           </a:p>
         </p:txBody>
@@ -4995,7 +4623,7 @@
               <a:spcAft>
                 <a:spcPts val="800"/>
               </a:spcAft>
-              <a:defRPr sz="1300" b="1">
+              <a:defRPr sz="1250" b="1">
                 <a:solidFill>
                   <a:srgbClr val="D97706"/>
                 </a:solidFill>
@@ -5003,14 +4631,11 @@
               </a:defRPr>
             </a:pPr>
             <a:r>
-              <a:t>04  |  FINANCIAL CATEGORISATION</a:t>
-            </a:r>
-          </a:p>
-          <a:p>
-            <a:pPr>
-              <a:spcAft>
-                <a:spcPts val="600"/>
-              </a:spcAft>
+              <a:t>04  |  6-STAGE VISUAL LIFECYCLE &amp; AUDIT TRAIL</a:t>
+            </a:r>
+          </a:p>
+          <a:p>
+            <a:pPr>
               <a:defRPr sz="1100">
                 <a:solidFill>
                   <a:srgbClr val="475569"/>
@@ -5019,7 +4644,7 @@
               </a:defRPr>
             </a:pPr>
             <a:r>
-              <a:t>Introduced structured taxonomy for classifying spend reasons (Depletion vs New Customer Injection vs Other) to support management reporting.</a:t>
+              <a:t>End-to-end transparency across Requested -&gt; Approved -&gt; Req Logged -&gt; In Concur -&gt; Delivery -&gt; Closed, capturing timestamps, roles, and decision notes for full audit compliance.</a:t>
             </a:r>
           </a:p>
         </p:txBody>
@@ -5076,7 +4701,7 @@
               </a:defRPr>
             </a:pPr>
             <a:r>
-              <a:t>ACT 2: OPERATIONAL WINS</a:t>
+              <a:t>ZERO-DEFECT REQUISITIONING</a:t>
             </a:r>
           </a:p>
           <a:p>
@@ -5089,7 +4714,7 @@
               </a:defRPr>
             </a:pPr>
             <a:r>
-              <a:t>Current State: Key Operational Wins &amp; Milestones Achieved</a:t>
+              <a:t>Improvement 1: Point-of-Entry Packaging Governance</a:t>
             </a:r>
           </a:p>
         </p:txBody>
@@ -5103,7 +4728,7 @@
         <p:spPr>
           <a:xfrm>
             <a:off x="731520" y="1463040"/>
-            <a:ext cx="3328416" cy="4754880"/>
+            <a:ext cx="5166360" cy="4754880"/>
           </a:xfrm>
           <a:prstGeom prst="roundRect">
             <a:avLst/>
@@ -5148,7 +4773,7 @@
         <p:spPr>
           <a:xfrm>
             <a:off x="960120" y="1691640"/>
-            <a:ext cx="2871216" cy="4297680"/>
+            <a:ext cx="4709160" cy="4297680"/>
           </a:xfrm>
           <a:prstGeom prst="rect">
             <a:avLst/>
@@ -5165,23 +4790,23 @@
               <a:spcAft>
                 <a:spcPts val="400"/>
               </a:spcAft>
-              <a:defRPr sz="900" b="1">
-                <a:solidFill>
-                  <a:srgbClr val="059669"/>
-                </a:solidFill>
-                <a:latin typeface="Segoe UI"/>
-              </a:defRPr>
-            </a:pPr>
-            <a:r>
-              <a:t>MASTER DATA MILESTONE</a:t>
-            </a:r>
-          </a:p>
-          <a:p>
-            <a:pPr>
-              <a:spcAft>
-                <a:spcPts val="1400"/>
-              </a:spcAft>
-              <a:defRPr sz="1500" b="1">
+              <a:defRPr sz="1000" b="1">
+                <a:solidFill>
+                  <a:srgbClr val="E11D48"/>
+                </a:solidFill>
+                <a:latin typeface="Segoe UI"/>
+              </a:defRPr>
+            </a:pPr>
+            <a:r>
+              <a:t>THE OPERATIONAL CHALLENGE</a:t>
+            </a:r>
+          </a:p>
+          <a:p>
+            <a:pPr>
+              <a:spcAft>
+                <a:spcPts val="1200"/>
+              </a:spcAft>
+              <a:defRPr sz="1600" b="1">
                 <a:solidFill>
                   <a:srgbClr val="0F172A"/>
                 </a:solidFill>
@@ -5189,7 +4814,7 @@
               </a:defRPr>
             </a:pPr>
             <a:r>
-              <a:t>1. 100% Item Code Mapping</a:t>
+              <a:t>Arbitrary Requisition Quantities</a:t>
             </a:r>
           </a:p>
           <a:p>
@@ -5197,47 +4822,28 @@
               <a:spcAft>
                 <a:spcPts val="1000"/>
               </a:spcAft>
-              <a:defRPr sz="1050">
-                <a:solidFill>
-                  <a:srgbClr val="334155"/>
-                </a:solidFill>
-                <a:latin typeface="Segoe UI"/>
-              </a:defRPr>
-            </a:pPr>
-            <a:r>
-              <a:t>✓ Completed 100% mapping of SPL internal item codes against vendor product codes (Simba, Host, etc.).</a:t>
-            </a:r>
-          </a:p>
-          <a:p>
-            <a:pPr>
-              <a:spcAft>
-                <a:spcPts val="1000"/>
-              </a:spcAft>
-              <a:defRPr sz="1050">
-                <a:solidFill>
-                  <a:srgbClr val="334155"/>
-                </a:solidFill>
-                <a:latin typeface="Segoe UI"/>
-              </a:defRPr>
-            </a:pPr>
-            <a:r>
-              <a:t>✓ Eliminated ambiguity in item descriptions across branches.</a:t>
-            </a:r>
-          </a:p>
-          <a:p>
-            <a:pPr>
-              <a:spcAft>
-                <a:spcPts val="1000"/>
-              </a:spcAft>
-              <a:defRPr sz="1050">
-                <a:solidFill>
-                  <a:srgbClr val="334155"/>
-                </a:solidFill>
-                <a:latin typeface="Segoe UI"/>
-              </a:defRPr>
-            </a:pPr>
-            <a:r>
-              <a:t>✓ Enables seamless automated pricing checks and supplier catalog synchronization.</a:t>
+              <a:defRPr sz="1100">
+                <a:solidFill>
+                  <a:srgbClr val="475569"/>
+                </a:solidFill>
+                <a:latin typeface="Segoe UI"/>
+              </a:defRPr>
+            </a:pPr>
+            <a:r>
+              <a:t>• The Issue: Site staff enter arbitrary numbers (e.g. 5,000 units on a 240 carton size = 20.83 cartons, or 90 on a 100 pack). Suppliers cannot break cartons, forcing Ashish Chhabra to reject orders, email sites, and wait for re-raising.</a:t>
+            </a:r>
+          </a:p>
+          <a:p>
+            <a:pPr>
+              <a:defRPr sz="1100">
+                <a:solidFill>
+                  <a:srgbClr val="475569"/>
+                </a:solidFill>
+                <a:latin typeface="Segoe UI"/>
+              </a:defRPr>
+            </a:pPr>
+            <a:r>
+              <a:t>• Business Impact: Operational delays in linen delivery, unnecessary email loops, and administrative rework for procurement.</a:t>
             </a:r>
           </a:p>
         </p:txBody>
@@ -5250,8 +4856,8 @@
         </p:nvSpPr>
         <p:spPr>
           <a:xfrm>
-            <a:off x="4425696" y="1463040"/>
-            <a:ext cx="3328416" cy="4754880"/>
+            <a:off x="6263640" y="1463040"/>
+            <a:ext cx="5166360" cy="4754880"/>
           </a:xfrm>
           <a:prstGeom prst="roundRect">
             <a:avLst/>
@@ -5295,8 +4901,8 @@
         </p:nvSpPr>
         <p:spPr>
           <a:xfrm>
-            <a:off x="4654296" y="1691640"/>
-            <a:ext cx="2871216" cy="4297680"/>
+            <a:off x="6492240" y="1691640"/>
+            <a:ext cx="4709160" cy="4297680"/>
           </a:xfrm>
           <a:prstGeom prst="rect">
             <a:avLst/>
@@ -5313,23 +4919,23 @@
               <a:spcAft>
                 <a:spcPts val="400"/>
               </a:spcAft>
-              <a:defRPr sz="900" b="1">
-                <a:solidFill>
-                  <a:srgbClr val="0284C7"/>
-                </a:solidFill>
-                <a:latin typeface="Segoe UI"/>
-              </a:defRPr>
-            </a:pPr>
-            <a:r>
-              <a:t>NATIONAL OPERATIONAL SCALE</a:t>
-            </a:r>
-          </a:p>
-          <a:p>
-            <a:pPr>
-              <a:spcAft>
-                <a:spcPts val="1400"/>
-              </a:spcAft>
-              <a:defRPr sz="1500" b="1">
+              <a:defRPr sz="1000" b="1">
+                <a:solidFill>
+                  <a:srgbClr val="059669"/>
+                </a:solidFill>
+                <a:latin typeface="Segoe UI"/>
+              </a:defRPr>
+            </a:pPr>
+            <a:r>
+              <a:t>THE ENGINEERED SOLUTION &amp; WHY IT WORKS</a:t>
+            </a:r>
+          </a:p>
+          <a:p>
+            <a:pPr>
+              <a:spcAft>
+                <a:spcPts val="1200"/>
+              </a:spcAft>
+              <a:defRPr sz="1600" b="1">
                 <a:solidFill>
                   <a:srgbClr val="0F172A"/>
                 </a:solidFill>
@@ -5337,203 +4943,107 @@
               </a:defRPr>
             </a:pPr>
             <a:r>
-              <a:t>2. Multi-Branch Requisitioning</a:t>
-            </a:r>
-          </a:p>
-          <a:p>
-            <a:pPr>
-              <a:spcAft>
-                <a:spcPts val="1000"/>
-              </a:spcAft>
-              <a:defRPr sz="1050">
-                <a:solidFill>
-                  <a:srgbClr val="334155"/>
-                </a:solidFill>
-                <a:latin typeface="Segoe UI"/>
-              </a:defRPr>
-            </a:pPr>
-            <a:r>
-              <a:t>✓ Active daily requisitioning across all 8 operating entities.</a:t>
-            </a:r>
-          </a:p>
-          <a:p>
-            <a:pPr>
-              <a:spcAft>
-                <a:spcPts val="1000"/>
-              </a:spcAft>
-              <a:defRPr sz="1050">
-                <a:solidFill>
-                  <a:srgbClr val="334155"/>
-                </a:solidFill>
-                <a:latin typeface="Segoe UI"/>
-              </a:defRPr>
-            </a:pPr>
-            <a:r>
-              <a:t>✓ Standardized reason tracking (Depletion vs New Business vs Linen Hub).</a:t>
-            </a:r>
-          </a:p>
-          <a:p>
-            <a:pPr>
-              <a:spcAft>
-                <a:spcPts val="1000"/>
-              </a:spcAft>
-              <a:defRPr sz="1050">
-                <a:solidFill>
-                  <a:srgbClr val="334155"/>
-                </a:solidFill>
-                <a:latin typeface="Segoe UI"/>
-              </a:defRPr>
-            </a:pPr>
-            <a:r>
-              <a:t>✓ Centralized audit trail capturing requester, approver, date, and comments on every order.</a:t>
-            </a:r>
-          </a:p>
-        </p:txBody>
-      </p:sp>
-      <p:sp>
-        <p:nvSpPr>
-          <p:cNvPr id="7" name="Rounded Rectangle 6"/>
-          <p:cNvSpPr/>
-          <p:nvPr/>
-        </p:nvSpPr>
-        <p:spPr>
-          <a:xfrm>
-            <a:off x="8119872" y="1463040"/>
-            <a:ext cx="3328416" cy="4754880"/>
-          </a:xfrm>
-          <a:prstGeom prst="roundRect">
-            <a:avLst/>
-          </a:prstGeom>
-          <a:solidFill>
-            <a:srgbClr val="FFFFFF"/>
-          </a:solidFill>
-          <a:ln w="15240">
-            <a:solidFill>
-              <a:srgbClr val="E2E8F0"/>
-            </a:solidFill>
-          </a:ln>
-        </p:spPr>
-        <p:style>
-          <a:lnRef idx="1">
-            <a:schemeClr val="accent1"/>
-          </a:lnRef>
-          <a:fillRef idx="3">
-            <a:schemeClr val="accent1"/>
-          </a:fillRef>
-          <a:effectRef idx="2">
-            <a:schemeClr val="accent1"/>
-          </a:effectRef>
-          <a:fontRef idx="minor">
-            <a:schemeClr val="lt1"/>
-          </a:fontRef>
-        </p:style>
-        <p:txBody>
-          <a:bodyPr rtlCol="0" anchor="ctr"/>
-          <a:lstStyle/>
-          <a:p>
-            <a:pPr algn="ctr"/>
-          </a:p>
-        </p:txBody>
-      </p:sp>
-      <p:sp>
-        <p:nvSpPr>
-          <p:cNvPr id="8" name="TextBox 7"/>
-          <p:cNvSpPr txBox="1"/>
-          <p:nvPr/>
-        </p:nvSpPr>
-        <p:spPr>
-          <a:xfrm>
-            <a:off x="8348472" y="1691640"/>
-            <a:ext cx="2871216" cy="4297680"/>
-          </a:xfrm>
-          <a:prstGeom prst="rect">
-            <a:avLst/>
-          </a:prstGeom>
-          <a:noFill/>
-        </p:spPr>
-        <p:txBody>
-          <a:bodyPr wrap="square">
-            <a:spAutoFit/>
-          </a:bodyPr>
-          <a:lstStyle/>
-          <a:p>
-            <a:pPr>
-              <a:spcAft>
-                <a:spcPts val="400"/>
-              </a:spcAft>
-              <a:defRPr sz="900" b="1">
-                <a:solidFill>
-                  <a:srgbClr val="9333EA"/>
-                </a:solidFill>
-                <a:latin typeface="Segoe UI"/>
-              </a:defRPr>
-            </a:pPr>
-            <a:r>
-              <a:t>LIVE DATA INGESTION</a:t>
-            </a:r>
-          </a:p>
-          <a:p>
-            <a:pPr>
-              <a:spcAft>
-                <a:spcPts val="1400"/>
-              </a:spcAft>
-              <a:defRPr sz="1500" b="1">
+              <a:t>Live Packaging Modulo &amp; 1-Click Rounding</a:t>
+            </a:r>
+          </a:p>
+          <a:p>
+            <a:pPr>
+              <a:spcAft>
+                <a:spcPts val="800"/>
+              </a:spcAft>
+            </a:pPr>
+            <a:r>
+              <a:rPr sz="1050" b="1">
                 <a:solidFill>
                   <a:srgbClr val="0F172A"/>
                 </a:solidFill>
                 <a:latin typeface="Segoe UI"/>
-              </a:defRPr>
-            </a:pPr>
-            <a:r>
-              <a:t>3. Supplier Inventory Feeds</a:t>
-            </a:r>
-          </a:p>
-          <a:p>
-            <a:pPr>
-              <a:spcAft>
-                <a:spcPts val="1000"/>
-              </a:spcAft>
-              <a:defRPr sz="1050">
-                <a:solidFill>
-                  <a:srgbClr val="334155"/>
-                </a:solidFill>
-                <a:latin typeface="Segoe UI"/>
-              </a:defRPr>
-            </a:pPr>
-            <a:r>
-              <a:t>✓ Automated ingestion pipeline for supplier stock-on-hand (SOH) reports.</a:t>
-            </a:r>
-          </a:p>
-          <a:p>
-            <a:pPr>
-              <a:spcAft>
-                <a:spcPts val="1000"/>
-              </a:spcAft>
-              <a:defRPr sz="1050">
-                <a:solidFill>
-                  <a:srgbClr val="334155"/>
-                </a:solidFill>
-                <a:latin typeface="Segoe UI"/>
-              </a:defRPr>
-            </a:pPr>
-            <a:r>
-              <a:t>✓ Provides baseline visibility into supplier stock levels before orders are placed.</a:t>
-            </a:r>
-          </a:p>
-          <a:p>
-            <a:pPr>
-              <a:spcAft>
-                <a:spcPts val="1000"/>
-              </a:spcAft>
-              <a:defRPr sz="1050">
-                <a:solidFill>
-                  <a:srgbClr val="334155"/>
-                </a:solidFill>
-                <a:latin typeface="Segoe UI"/>
-              </a:defRPr>
-            </a:pPr>
-            <a:r>
-              <a:t>✓ Lays the foundation for deprecating manual weekly email distributions.</a:t>
+              </a:rPr>
+              <a:t>✓ The Solution: </a:t>
+            </a:r>
+            <a:r>
+              <a:rPr sz="1050">
+                <a:solidFill>
+                  <a:srgbClr val="475569"/>
+                </a:solidFill>
+                <a:latin typeface="Segoe UI"/>
+              </a:rPr>
+              <a:t>Live modulo check (quantityOrdered % cartonQty === 0). Hard blocks submission and provides a 1-click 'Round to X units' button (e.g. rounds 5,000 to 5,040 units / 21 cartons).</a:t>
+            </a:r>
+          </a:p>
+          <a:p>
+            <a:pPr>
+              <a:spcAft>
+                <a:spcPts val="800"/>
+              </a:spcAft>
+            </a:pPr>
+            <a:r>
+              <a:rPr sz="1050" b="1">
+                <a:solidFill>
+                  <a:srgbClr val="0F172A"/>
+                </a:solidFill>
+                <a:latin typeface="Segoe UI"/>
+              </a:rPr>
+              <a:t>✓ Why This is the Solution: </a:t>
+            </a:r>
+            <a:r>
+              <a:rPr sz="1050">
+                <a:solidFill>
+                  <a:srgbClr val="475569"/>
+                </a:solidFill>
+                <a:latin typeface="Segoe UI"/>
+              </a:rPr>
+              <a:t>Stops errors before submission rather than catching them days later during approval review.</a:t>
+            </a:r>
+          </a:p>
+          <a:p>
+            <a:pPr>
+              <a:spcAft>
+                <a:spcPts val="800"/>
+              </a:spcAft>
+            </a:pPr>
+            <a:r>
+              <a:rPr sz="1050" b="1">
+                <a:solidFill>
+                  <a:srgbClr val="0F172A"/>
+                </a:solidFill>
+                <a:latin typeface="Segoe UI"/>
+              </a:rPr>
+              <a:t>✓ Frictionless UX: </a:t>
+            </a:r>
+            <a:r>
+              <a:rPr sz="1050">
+                <a:solidFill>
+                  <a:srgbClr val="475569"/>
+                </a:solidFill>
+                <a:latin typeface="Segoe UI"/>
+              </a:rPr>
+              <a:t>The 1-click rounder solves the packaging math instantly for the user.</a:t>
+            </a:r>
+          </a:p>
+          <a:p>
+            <a:pPr>
+              <a:spcAft>
+                <a:spcPts val="800"/>
+              </a:spcAft>
+            </a:pPr>
+            <a:r>
+              <a:rPr sz="1050" b="1">
+                <a:solidFill>
+                  <a:srgbClr val="0F172A"/>
+                </a:solidFill>
+                <a:latin typeface="Segoe UI"/>
+              </a:rPr>
+              <a:t>✓ Zero Procurement Rework: </a:t>
+            </a:r>
+            <a:r>
+              <a:rPr sz="1050">
+                <a:solidFill>
+                  <a:srgbClr val="475569"/>
+                </a:solidFill>
+                <a:latin typeface="Segoe UI"/>
+              </a:rPr>
+              <a:t>Ashish no longer acts as a manual carton calculator, eliminating supplier order rejections.</a:t>
             </a:r>
           </a:p>
         </p:txBody>
@@ -5590,7 +5100,7 @@
               </a:defRPr>
             </a:pPr>
             <a:r>
-              <a:t>ACT 2: CHALLENGES</a:t>
+              <a:t>FINANCIAL INTEGRITY</a:t>
             </a:r>
           </a:p>
           <a:p>
@@ -5603,7 +5113,7 @@
               </a:defRPr>
             </a:pPr>
             <a:r>
-              <a:t>Current State: Operational Challenges &amp; Data Integrity Friction</a:t>
+              <a:t>Improvement 2: Contract Price Master &amp; Zero Invoice Variances</a:t>
             </a:r>
           </a:p>
         </p:txBody>
@@ -5617,7 +5127,7 @@
         <p:spPr>
           <a:xfrm>
             <a:off x="731520" y="1463040"/>
-            <a:ext cx="5166360" cy="2240280"/>
+            <a:ext cx="5166360" cy="4754880"/>
           </a:xfrm>
           <a:prstGeom prst="roundRect">
             <a:avLst/>
@@ -5661,8 +5171,8 @@
         </p:nvSpPr>
         <p:spPr>
           <a:xfrm>
-            <a:off x="960120" y="1645920"/>
-            <a:ext cx="4709160" cy="1874520"/>
+            <a:off x="960120" y="1691640"/>
+            <a:ext cx="4709160" cy="4297680"/>
           </a:xfrm>
           <a:prstGeom prst="rect">
             <a:avLst/>
@@ -5677,9 +5187,9 @@
           <a:p>
             <a:pPr>
               <a:spcAft>
-                <a:spcPts val="800"/>
-              </a:spcAft>
-              <a:defRPr sz="1200" b="1">
+                <a:spcPts val="400"/>
+              </a:spcAft>
+              <a:defRPr sz="1000" b="1">
                 <a:solidFill>
                   <a:srgbClr val="E11D48"/>
                 </a:solidFill>
@@ -5687,12 +5197,31 @@
               </a:defRPr>
             </a:pPr>
             <a:r>
-              <a:t>HIGH WORKLOAD / RISK  |  1. MANUAL EOM EXCEL CRUNCHING</a:t>
-            </a:r>
-          </a:p>
-          <a:p>
-            <a:pPr>
-              <a:defRPr sz="1050">
+              <a:t>THE OPERATIONAL CHALLENGE</a:t>
+            </a:r>
+          </a:p>
+          <a:p>
+            <a:pPr>
+              <a:spcAft>
+                <a:spcPts val="1200"/>
+              </a:spcAft>
+              <a:defRPr sz="1600" b="1">
+                <a:solidFill>
+                  <a:srgbClr val="0F172A"/>
+                </a:solidFill>
+                <a:latin typeface="Segoe UI"/>
+              </a:defRPr>
+            </a:pPr>
+            <a:r>
+              <a:t>Manual Price Entry Typos</a:t>
+            </a:r>
+          </a:p>
+          <a:p>
+            <a:pPr>
+              <a:spcAft>
+                <a:spcPts val="1000"/>
+              </a:spcAft>
+              <a:defRPr sz="1100">
                 <a:solidFill>
                   <a:srgbClr val="475569"/>
                 </a:solidFill>
@@ -5700,7 +5229,20 @@
               </a:defRPr>
             </a:pPr>
             <a:r>
-              <a:t>Ashish Chhabra (Super User) spends days each month extracting Concur reports, recalculating ex-GST values (/ 1.1), manually parsing unstandardized descriptions, and building pivot tables for executive reporting.</a:t>
+              <a:t>• The Issue: Requesters had free-text price editing access. A single keystroke typo (e.g. keying 61¢ instead of contracted 51¢ for face washers) propagated downstream to the vendor and Concur.</a:t>
+            </a:r>
+          </a:p>
+          <a:p>
+            <a:pPr>
+              <a:defRPr sz="1100">
+                <a:solidFill>
+                  <a:srgbClr val="475569"/>
+                </a:solidFill>
+                <a:latin typeface="Segoe UI"/>
+              </a:defRPr>
+            </a:pPr>
+            <a:r>
+              <a:t>• Business Impact: When the supplier invoiced at the true contracted rate (51¢), automated 3-way matching in finance failed due to a price variance, freezing the invoice and delaying payment.</a:t>
             </a:r>
           </a:p>
         </p:txBody>
@@ -5714,7 +5256,7 @@
         <p:spPr>
           <a:xfrm>
             <a:off x="6263640" y="1463040"/>
-            <a:ext cx="5166360" cy="2240280"/>
+            <a:ext cx="5166360" cy="4754880"/>
           </a:xfrm>
           <a:prstGeom prst="roundRect">
             <a:avLst/>
@@ -5758,8 +5300,8 @@
         </p:nvSpPr>
         <p:spPr>
           <a:xfrm>
-            <a:off x="6492240" y="1645920"/>
-            <a:ext cx="4709160" cy="1874520"/>
+            <a:off x="6492240" y="1691640"/>
+            <a:ext cx="4709160" cy="4297680"/>
           </a:xfrm>
           <a:prstGeom prst="rect">
             <a:avLst/>
@@ -5774,224 +5316,133 @@
           <a:p>
             <a:pPr>
               <a:spcAft>
+                <a:spcPts val="400"/>
+              </a:spcAft>
+              <a:defRPr sz="1000" b="1">
+                <a:solidFill>
+                  <a:srgbClr val="059669"/>
+                </a:solidFill>
+                <a:latin typeface="Segoe UI"/>
+              </a:defRPr>
+            </a:pPr>
+            <a:r>
+              <a:t>THE ENGINEERED SOLUTION &amp; WHY IT WORKS</a:t>
+            </a:r>
+          </a:p>
+          <a:p>
+            <a:pPr>
+              <a:spcAft>
+                <a:spcPts val="1200"/>
+              </a:spcAft>
+              <a:defRPr sz="1600" b="1">
+                <a:solidFill>
+                  <a:srgbClr val="0F172A"/>
+                </a:solidFill>
+                <a:latin typeface="Segoe UI"/>
+              </a:defRPr>
+            </a:pPr>
+            <a:r>
+              <a:t>Contract Price Master Validation</a:t>
+            </a:r>
+          </a:p>
+          <a:p>
+            <a:pPr>
+              <a:spcAft>
                 <a:spcPts val="800"/>
               </a:spcAft>
-              <a:defRPr sz="1200" b="1">
-                <a:solidFill>
-                  <a:srgbClr val="D97706"/>
-                </a:solidFill>
-                <a:latin typeface="Segoe UI"/>
-              </a:defRPr>
-            </a:pPr>
-            <a:r>
-              <a:t>SUPPLIER REJECTIONS  |  2. UNROUNDED REQUISITION QUANTITIES</a:t>
-            </a:r>
-          </a:p>
-          <a:p>
-            <a:pPr>
-              <a:defRPr sz="1050">
+            </a:pPr>
+            <a:r>
+              <a:rPr sz="1050" b="1">
+                <a:solidFill>
+                  <a:srgbClr val="0F172A"/>
+                </a:solidFill>
+                <a:latin typeface="Segoe UI"/>
+              </a:rPr>
+              <a:t>✓ The Solution: </a:t>
+            </a:r>
+            <a:r>
+              <a:rPr sz="1050">
                 <a:solidFill>
                   <a:srgbClr val="475569"/>
                 </a:solidFill>
                 <a:latin typeface="Segoe UI"/>
-              </a:defRPr>
-            </a:pPr>
-            <a:r>
-              <a:t>Site staff order arbitrary quantities (e.g. 5,000 units on a 240 carton size, or 90 units on a 100 pack). Orders must be manually rejected and re-raised, creating operational delays.</a:t>
-            </a:r>
-          </a:p>
-        </p:txBody>
-      </p:sp>
-      <p:sp>
-        <p:nvSpPr>
-          <p:cNvPr id="7" name="Rounded Rectangle 6"/>
-          <p:cNvSpPr/>
-          <p:nvPr/>
-        </p:nvSpPr>
-        <p:spPr>
-          <a:xfrm>
-            <a:off x="731520" y="3977639"/>
-            <a:ext cx="5166360" cy="2240280"/>
-          </a:xfrm>
-          <a:prstGeom prst="roundRect">
-            <a:avLst/>
-          </a:prstGeom>
-          <a:solidFill>
-            <a:srgbClr val="FFFFFF"/>
-          </a:solidFill>
-          <a:ln w="15240">
-            <a:solidFill>
-              <a:srgbClr val="E2E8F0"/>
-            </a:solidFill>
-          </a:ln>
-        </p:spPr>
-        <p:style>
-          <a:lnRef idx="1">
-            <a:schemeClr val="accent1"/>
-          </a:lnRef>
-          <a:fillRef idx="3">
-            <a:schemeClr val="accent1"/>
-          </a:fillRef>
-          <a:effectRef idx="2">
-            <a:schemeClr val="accent1"/>
-          </a:effectRef>
-          <a:fontRef idx="minor">
-            <a:schemeClr val="lt1"/>
-          </a:fontRef>
-        </p:style>
-        <p:txBody>
-          <a:bodyPr rtlCol="0" anchor="ctr"/>
-          <a:lstStyle/>
-          <a:p>
-            <a:pPr algn="ctr"/>
-          </a:p>
-        </p:txBody>
-      </p:sp>
-      <p:sp>
-        <p:nvSpPr>
-          <p:cNvPr id="8" name="TextBox 7"/>
-          <p:cNvSpPr txBox="1"/>
-          <p:nvPr/>
-        </p:nvSpPr>
-        <p:spPr>
-          <a:xfrm>
-            <a:off x="960120" y="4160519"/>
-            <a:ext cx="4709160" cy="1874520"/>
-          </a:xfrm>
-          <a:prstGeom prst="rect">
-            <a:avLst/>
-          </a:prstGeom>
-          <a:noFill/>
-        </p:spPr>
-        <p:txBody>
-          <a:bodyPr wrap="square">
-            <a:spAutoFit/>
-          </a:bodyPr>
-          <a:lstStyle/>
+              </a:rPr>
+              <a:t>Leverages the 100% item mapping milestone. Active contracted supplier catalog rates auto-populate lines; $0.00 prices and unapproved price overrides are strictly blocked.</a:t>
+            </a:r>
+          </a:p>
           <a:p>
             <a:pPr>
               <a:spcAft>
                 <a:spcPts val="800"/>
               </a:spcAft>
-              <a:defRPr sz="1200" b="1">
-                <a:solidFill>
-                  <a:srgbClr val="E11D48"/>
-                </a:solidFill>
-                <a:latin typeface="Segoe UI"/>
-              </a:defRPr>
-            </a:pPr>
-            <a:r>
-              <a:t>FINANCE INVOICE BLOCKS  |  3. CONTRACT PRICING TYPOS</a:t>
-            </a:r>
-          </a:p>
-          <a:p>
-            <a:pPr>
-              <a:defRPr sz="1050">
+            </a:pPr>
+            <a:r>
+              <a:rPr sz="1050" b="1">
+                <a:solidFill>
+                  <a:srgbClr val="0F172A"/>
+                </a:solidFill>
+                <a:latin typeface="Segoe UI"/>
+              </a:rPr>
+              <a:t>✓ Why This is the Solution: </a:t>
+            </a:r>
+            <a:r>
+              <a:rPr sz="1050">
                 <a:solidFill>
                   <a:srgbClr val="475569"/>
                 </a:solidFill>
                 <a:latin typeface="Segoe UI"/>
-              </a:defRPr>
-            </a:pPr>
-            <a:r>
-              <a:t>Manual price entry leads to errors (e.g. keying 61¢ instead of contracted 51¢ for face washers). Discrepancies cause 3-way matching failures in finance and delayed payments.</a:t>
-            </a:r>
-          </a:p>
-        </p:txBody>
-      </p:sp>
-      <p:sp>
-        <p:nvSpPr>
-          <p:cNvPr id="9" name="Rounded Rectangle 8"/>
-          <p:cNvSpPr/>
-          <p:nvPr/>
-        </p:nvSpPr>
-        <p:spPr>
-          <a:xfrm>
-            <a:off x="6263640" y="3977639"/>
-            <a:ext cx="5166360" cy="2240280"/>
-          </a:xfrm>
-          <a:prstGeom prst="roundRect">
-            <a:avLst/>
-          </a:prstGeom>
-          <a:solidFill>
-            <a:srgbClr val="FFFFFF"/>
-          </a:solidFill>
-          <a:ln w="15240">
-            <a:solidFill>
-              <a:srgbClr val="E2E8F0"/>
-            </a:solidFill>
-          </a:ln>
-        </p:spPr>
-        <p:style>
-          <a:lnRef idx="1">
-            <a:schemeClr val="accent1"/>
-          </a:lnRef>
-          <a:fillRef idx="3">
-            <a:schemeClr val="accent1"/>
-          </a:fillRef>
-          <a:effectRef idx="2">
-            <a:schemeClr val="accent1"/>
-          </a:effectRef>
-          <a:fontRef idx="minor">
-            <a:schemeClr val="lt1"/>
-          </a:fontRef>
-        </p:style>
-        <p:txBody>
-          <a:bodyPr rtlCol="0" anchor="ctr"/>
-          <a:lstStyle/>
-          <a:p>
-            <a:pPr algn="ctr"/>
-          </a:p>
-        </p:txBody>
-      </p:sp>
-      <p:sp>
-        <p:nvSpPr>
-          <p:cNvPr id="10" name="TextBox 9"/>
-          <p:cNvSpPr txBox="1"/>
-          <p:nvPr/>
-        </p:nvSpPr>
-        <p:spPr>
-          <a:xfrm>
-            <a:off x="6492240" y="4160519"/>
-            <a:ext cx="4709160" cy="1874520"/>
-          </a:xfrm>
-          <a:prstGeom prst="rect">
-            <a:avLst/>
-          </a:prstGeom>
-          <a:noFill/>
-        </p:spPr>
-        <p:txBody>
-          <a:bodyPr wrap="square">
-            <a:spAutoFit/>
-          </a:bodyPr>
-          <a:lstStyle/>
+              </a:rPr>
+              <a:t>Ensuring PO prices match supplier contracts guarantees clean 3-way matching in finance upon invoice receipt.</a:t>
+            </a:r>
+          </a:p>
           <a:p>
             <a:pPr>
               <a:spcAft>
                 <a:spcPts val="800"/>
               </a:spcAft>
-              <a:defRPr sz="1200" b="1">
-                <a:solidFill>
-                  <a:srgbClr val="D97706"/>
-                </a:solidFill>
-                <a:latin typeface="Segoe UI"/>
-              </a:defRPr>
-            </a:pPr>
-            <a:r>
-              <a:t>AUDIT &amp; REPORTING BLINDSPOT  |  4. MISSING CONCUR ERP LINKAGE</a:t>
-            </a:r>
-          </a:p>
-          <a:p>
-            <a:pPr>
-              <a:defRPr sz="1050">
+            </a:pPr>
+            <a:r>
+              <a:rPr sz="1050" b="1">
+                <a:solidFill>
+                  <a:srgbClr val="0F172A"/>
+                </a:solidFill>
+                <a:latin typeface="Segoe UI"/>
+              </a:rPr>
+              <a:t>✓ Protects Commercial Margin: </a:t>
+            </a:r>
+            <a:r>
+              <a:rPr sz="1050">
                 <a:solidFill>
                   <a:srgbClr val="475569"/>
                 </a:solidFill>
                 <a:latin typeface="Segoe UI"/>
-              </a:defRPr>
-            </a:pPr>
-            <a:r>
-              <a:t>Staff mark orders as received in ProcureFlow but fail to enter the Concur Request PR #. This breaks 1-to-1 data mirroring and prevents automated spend reconciliation.</a:t>
+              </a:rPr>
+              <a:t>Prevents accidental over-payment or unauthorized supplier price creep.</a:t>
+            </a:r>
+          </a:p>
+          <a:p>
+            <a:pPr>
+              <a:spcAft>
+                <a:spcPts val="800"/>
+              </a:spcAft>
+            </a:pPr>
+            <a:r>
+              <a:rPr sz="1050" b="1">
+                <a:solidFill>
+                  <a:srgbClr val="0F172A"/>
+                </a:solidFill>
+                <a:latin typeface="Segoe UI"/>
+              </a:rPr>
+              <a:t>✓ Zero Downstream Holds: </a:t>
+            </a:r>
+            <a:r>
+              <a:rPr sz="1050">
+                <a:solidFill>
+                  <a:srgbClr val="475569"/>
+                </a:solidFill>
+                <a:latin typeface="Segoe UI"/>
+              </a:rPr>
+              <a:t>Invoices pass through finance without manual investigation emails.</a:t>
             </a:r>
           </a:p>
         </p:txBody>
@@ -6048,7 +5499,7 @@
               </a:defRPr>
             </a:pPr>
             <a:r>
-              <a:t>ACT 2: STRATEGIC OPPORTUNITY</a:t>
+              <a:t>ERP INTEGRATION</a:t>
             </a:r>
           </a:p>
           <a:p>
@@ -6061,7 +5512,7 @@
               </a:defRPr>
             </a:pPr>
             <a:r>
-              <a:t>The Strategic Opportunity: From Passive Tracking to Closed-Loop Governance</a:t>
+              <a:t>Improvement 3: Mandatory Concur PR # Enforcement &amp; Task Visibility</a:t>
             </a:r>
           </a:p>
         </p:txBody>
@@ -6075,7 +5526,7 @@
         <p:spPr>
           <a:xfrm>
             <a:off x="731520" y="1463040"/>
-            <a:ext cx="10728655" cy="4754880"/>
+            <a:ext cx="5166360" cy="4754880"/>
           </a:xfrm>
           <a:prstGeom prst="roundRect">
             <a:avLst/>
@@ -6119,8 +5570,8 @@
         </p:nvSpPr>
         <p:spPr>
           <a:xfrm>
-            <a:off x="1005840" y="1691640"/>
-            <a:ext cx="10180015" cy="4297680"/>
+            <a:off x="960120" y="1691640"/>
+            <a:ext cx="4709160" cy="4297680"/>
           </a:xfrm>
           <a:prstGeom prst="rect">
             <a:avLst/>
@@ -6135,17 +5586,33 @@
           <a:p>
             <a:pPr>
               <a:spcAft>
-                <a:spcPts val="1400"/>
-              </a:spcAft>
-              <a:defRPr sz="1800" b="1">
-                <a:solidFill>
-                  <a:srgbClr val="0284C7"/>
-                </a:solidFill>
-                <a:latin typeface="Segoe UI"/>
-              </a:defRPr>
-            </a:pPr>
-            <a:r>
-              <a:t>Transforming ProcureFlow into SPL's Single Source of Truth</a:t>
+                <a:spcPts val="400"/>
+              </a:spcAft>
+              <a:defRPr sz="1000" b="1">
+                <a:solidFill>
+                  <a:srgbClr val="E11D48"/>
+                </a:solidFill>
+                <a:latin typeface="Segoe UI"/>
+              </a:defRPr>
+            </a:pPr>
+            <a:r>
+              <a:t>THE OPERATIONAL CHALLENGE</a:t>
+            </a:r>
+          </a:p>
+          <a:p>
+            <a:pPr>
+              <a:spcAft>
+                <a:spcPts val="1200"/>
+              </a:spcAft>
+              <a:defRPr sz="1600" b="1">
+                <a:solidFill>
+                  <a:srgbClr val="0F172A"/>
+                </a:solidFill>
+                <a:latin typeface="Segoe UI"/>
+              </a:defRPr>
+            </a:pPr>
+            <a:r>
+              <a:t>Missing Concur PR Numbers</a:t>
             </a:r>
           </a:p>
           <a:p>
@@ -6153,124 +5620,228 @@
               <a:spcAft>
                 <a:spcPts val="1000"/>
               </a:spcAft>
-            </a:pPr>
-            <a:r>
-              <a:rPr sz="1100" b="1">
+              <a:defRPr sz="1100">
+                <a:solidFill>
+                  <a:srgbClr val="475569"/>
+                </a:solidFill>
+                <a:latin typeface="Segoe UI"/>
+              </a:defRPr>
+            </a:pPr>
+            <a:r>
+              <a:t>• The Issue: Staff received physical deliveries on site and completed orders in ProcureFlow without ever returning to log the SAP Concur Purchase Request number (PR #) or PO #.</a:t>
+            </a:r>
+          </a:p>
+          <a:p>
+            <a:pPr>
+              <a:defRPr sz="1100">
+                <a:solidFill>
+                  <a:srgbClr val="475569"/>
+                </a:solidFill>
+                <a:latin typeface="Segoe UI"/>
+              </a:defRPr>
+            </a:pPr>
+            <a:r>
+              <a:t>• Business Impact: Created orphaned records where Concur spend could not be matched against ProcureFlow physical receipts, breaking cross-system audit trails.</a:t>
+            </a:r>
+          </a:p>
+        </p:txBody>
+      </p:sp>
+      <p:sp>
+        <p:nvSpPr>
+          <p:cNvPr id="5" name="Rounded Rectangle 4"/>
+          <p:cNvSpPr/>
+          <p:nvPr/>
+        </p:nvSpPr>
+        <p:spPr>
+          <a:xfrm>
+            <a:off x="6263640" y="1463040"/>
+            <a:ext cx="5166360" cy="4754880"/>
+          </a:xfrm>
+          <a:prstGeom prst="roundRect">
+            <a:avLst/>
+          </a:prstGeom>
+          <a:solidFill>
+            <a:srgbClr val="FFFFFF"/>
+          </a:solidFill>
+          <a:ln w="15240">
+            <a:solidFill>
+              <a:srgbClr val="E2E8F0"/>
+            </a:solidFill>
+          </a:ln>
+        </p:spPr>
+        <p:style>
+          <a:lnRef idx="1">
+            <a:schemeClr val="accent1"/>
+          </a:lnRef>
+          <a:fillRef idx="3">
+            <a:schemeClr val="accent1"/>
+          </a:fillRef>
+          <a:effectRef idx="2">
+            <a:schemeClr val="accent1"/>
+          </a:effectRef>
+          <a:fontRef idx="minor">
+            <a:schemeClr val="lt1"/>
+          </a:fontRef>
+        </p:style>
+        <p:txBody>
+          <a:bodyPr rtlCol="0" anchor="ctr"/>
+          <a:lstStyle/>
+          <a:p>
+            <a:pPr algn="ctr"/>
+          </a:p>
+        </p:txBody>
+      </p:sp>
+      <p:sp>
+        <p:nvSpPr>
+          <p:cNvPr id="6" name="TextBox 5"/>
+          <p:cNvSpPr txBox="1"/>
+          <p:nvPr/>
+        </p:nvSpPr>
+        <p:spPr>
+          <a:xfrm>
+            <a:off x="6492240" y="1691640"/>
+            <a:ext cx="4709160" cy="4297680"/>
+          </a:xfrm>
+          <a:prstGeom prst="rect">
+            <a:avLst/>
+          </a:prstGeom>
+          <a:noFill/>
+        </p:spPr>
+        <p:txBody>
+          <a:bodyPr wrap="square">
+            <a:spAutoFit/>
+          </a:bodyPr>
+          <a:lstStyle/>
+          <a:p>
+            <a:pPr>
+              <a:spcAft>
+                <a:spcPts val="400"/>
+              </a:spcAft>
+              <a:defRPr sz="1000" b="1">
+                <a:solidFill>
+                  <a:srgbClr val="059669"/>
+                </a:solidFill>
+                <a:latin typeface="Segoe UI"/>
+              </a:defRPr>
+            </a:pPr>
+            <a:r>
+              <a:t>THE ENGINEERED SOLUTION &amp; WHY IT WORKS</a:t>
+            </a:r>
+          </a:p>
+          <a:p>
+            <a:pPr>
+              <a:spcAft>
+                <a:spcPts val="1200"/>
+              </a:spcAft>
+              <a:defRPr sz="1600" b="1">
                 <a:solidFill>
                   <a:srgbClr val="0F172A"/>
                 </a:solidFill>
                 <a:latin typeface="Segoe UI"/>
-              </a:rPr>
-              <a:t>★ Automated Point-of-Entry Guardrails: </a:t>
-            </a:r>
-            <a:r>
-              <a:rPr sz="1100">
+              </a:defRPr>
+            </a:pPr>
+            <a:r>
+              <a:t>Mandatory Concur Block &amp; Homepage Center</a:t>
+            </a:r>
+          </a:p>
+          <a:p>
+            <a:pPr>
+              <a:spcAft>
+                <a:spcPts val="800"/>
+              </a:spcAft>
+            </a:pPr>
+            <a:r>
+              <a:rPr sz="1050" b="1">
+                <a:solidFill>
+                  <a:srgbClr val="0F172A"/>
+                </a:solidFill>
+                <a:latin typeface="Segoe UI"/>
+              </a:rPr>
+              <a:t>✓ The Solution: </a:t>
+            </a:r>
+            <a:r>
+              <a:rPr sz="1050">
                 <a:solidFill>
                   <a:srgbClr val="475569"/>
                 </a:solidFill>
                 <a:latin typeface="Segoe UI"/>
               </a:rPr>
-              <a:t>Instead of relying on manual spot-checks and rejections, engineer hard system validation rules into the requisition UI that make it impossible to submit an incorrect quantity or price.</a:t>
-            </a:r>
-          </a:p>
-          <a:p>
-            <a:pPr>
-              <a:spcAft>
-                <a:spcPts val="1000"/>
-              </a:spcAft>
-            </a:pPr>
-            <a:r>
-              <a:rPr sz="1100" b="1">
+              <a:t>Hard block on order closure without Concur reference, plus Homepage Action Required center showing pending Concur links on login.</a:t>
+            </a:r>
+          </a:p>
+          <a:p>
+            <a:pPr>
+              <a:spcAft>
+                <a:spcPts val="800"/>
+              </a:spcAft>
+            </a:pPr>
+            <a:r>
+              <a:rPr sz="1050" b="1">
                 <a:solidFill>
                   <a:srgbClr val="0F172A"/>
                 </a:solidFill>
                 <a:latin typeface="Segoe UI"/>
               </a:rPr>
-              <a:t>★ Closed-Loop ERP Parity with SAP Concur: </a:t>
-            </a:r>
-            <a:r>
-              <a:rPr sz="1100">
+              <a:t>✓ Why This is the Solution: </a:t>
+            </a:r>
+            <a:r>
+              <a:rPr sz="1050">
                 <a:solidFill>
                   <a:srgbClr val="475569"/>
                 </a:solidFill>
                 <a:latin typeface="Segoe UI"/>
               </a:rPr>
-              <a:t>Eliminate orphaned orders by enforcing mandatory Concur PR # logging before order completion, guaranteeing permanent 1-to-1 data alignment between Concur and ProcureFlow.</a:t>
-            </a:r>
-          </a:p>
-          <a:p>
-            <a:pPr>
-              <a:spcAft>
-                <a:spcPts val="1000"/>
-              </a:spcAft>
-            </a:pPr>
-            <a:r>
-              <a:rPr sz="1100" b="1">
+              <a:t>Placing the block at the final step of order completion guarantees users capture the Concur reference before the transaction finalizes.</a:t>
+            </a:r>
+          </a:p>
+          <a:p>
+            <a:pPr>
+              <a:spcAft>
+                <a:spcPts val="800"/>
+              </a:spcAft>
+            </a:pPr>
+            <a:r>
+              <a:rPr sz="1050" b="1">
                 <a:solidFill>
                   <a:srgbClr val="0F172A"/>
                 </a:solidFill>
                 <a:latin typeface="Segoe UI"/>
               </a:rPr>
-              <a:t>★ Proactive Operational Escalations: </a:t>
-            </a:r>
-            <a:r>
-              <a:rPr sz="1100">
+              <a:t>✓ 100% ERP Mirroring: </a:t>
+            </a:r>
+            <a:r>
+              <a:rPr sz="1050">
                 <a:solidFill>
                   <a:srgbClr val="475569"/>
                 </a:solidFill>
                 <a:latin typeface="Segoe UI"/>
               </a:rPr>
-              <a:t>Deploy automated multi-channel notifications (In-App, Email, MS Teams) that remind users to complete delivered orders and automatically escalate stalled shipments (&gt;14 days) to line managers.</a:t>
-            </a:r>
-          </a:p>
-          <a:p>
-            <a:pPr>
-              <a:spcAft>
-                <a:spcPts val="1000"/>
-              </a:spcAft>
-            </a:pPr>
-            <a:r>
-              <a:rPr sz="1100" b="1">
+              <a:t>Every completed order in ProcureFlow has a direct audit mirror in SAP Concur.</a:t>
+            </a:r>
+          </a:p>
+          <a:p>
+            <a:pPr>
+              <a:spcAft>
+                <a:spcPts val="800"/>
+              </a:spcAft>
+            </a:pPr>
+            <a:r>
+              <a:rPr sz="1050" b="1">
                 <a:solidFill>
                   <a:srgbClr val="0F172A"/>
                 </a:solidFill>
                 <a:latin typeface="Segoe UI"/>
               </a:rPr>
-              <a:t>★ Executive-Ready Financial Intelligence: </a:t>
-            </a:r>
-            <a:r>
-              <a:rPr sz="1100">
+              <a:t>✓ Frictionless Navigation: </a:t>
+            </a:r>
+            <a:r>
+              <a:rPr sz="1050">
                 <a:solidFill>
                   <a:srgbClr val="475569"/>
                 </a:solidFill>
                 <a:latin typeface="Segoe UI"/>
               </a:rPr>
-              <a:t>Automate the entire monthly EOM spend reconciliation into a native 2D Pivot Table (Branch × Sector × Reason), tracking FY27 budget burn rates ($14.521M) with 1-click CSV export.</a:t>
-            </a:r>
-          </a:p>
-          <a:p>
-            <a:pPr>
-              <a:spcAft>
-                <a:spcPts val="1000"/>
-              </a:spcAft>
-            </a:pPr>
-            <a:r>
-              <a:rPr sz="1100" b="1">
-                <a:solidFill>
-                  <a:srgbClr val="0F172A"/>
-                </a:solidFill>
-                <a:latin typeface="Segoe UI"/>
-              </a:rPr>
-              <a:t>★ Self-Service Stock on Hand (SOH) Visibility: </a:t>
-            </a:r>
-            <a:r>
-              <a:rPr sz="1100">
-                <a:solidFill>
-                  <a:srgbClr val="475569"/>
-                </a:solidFill>
-                <a:latin typeface="Segoe UI"/>
-              </a:rPr>
-              <a:t>Eliminate manual weekly spreadsheet emailing by providing state managers with direct, live inventory visibility inside ProcureFlow.</a:t>
+              <a:t>Homepage banner provides 1-click navigation directly to pending orders.</a:t>
             </a:r>
           </a:p>
         </p:txBody>
@@ -6327,7 +5898,7 @@
               </a:defRPr>
             </a:pPr>
             <a:r>
-              <a:t>ACT 3: TARGET DEVELOPED STATE</a:t>
+              <a:t>OPERATIONAL ALIGNMENT</a:t>
             </a:r>
           </a:p>
           <a:p>
@@ -6340,7 +5911,7 @@
               </a:defRPr>
             </a:pPr>
             <a:r>
-              <a:t>Future State: The Vision of Seamless BAU Integration</a:t>
+              <a:t>Improvement 4: Automated Lifecycle Notifications &amp; Escalation</a:t>
             </a:r>
           </a:p>
         </p:txBody>
@@ -6354,7 +5925,7 @@
         <p:spPr>
           <a:xfrm>
             <a:off x="731520" y="1463040"/>
-            <a:ext cx="3328416" cy="4754880"/>
+            <a:ext cx="5166360" cy="4754880"/>
           </a:xfrm>
           <a:prstGeom prst="roundRect">
             <a:avLst/>
@@ -6399,7 +5970,7 @@
         <p:spPr>
           <a:xfrm>
             <a:off x="960120" y="1691640"/>
-            <a:ext cx="2871216" cy="4297680"/>
+            <a:ext cx="4709160" cy="4297680"/>
           </a:xfrm>
           <a:prstGeom prst="rect">
             <a:avLst/>
@@ -6416,23 +5987,23 @@
               <a:spcAft>
                 <a:spcPts val="400"/>
               </a:spcAft>
-              <a:defRPr sz="900" b="1">
-                <a:solidFill>
-                  <a:srgbClr val="0284C7"/>
-                </a:solidFill>
-                <a:latin typeface="Segoe UI"/>
-              </a:defRPr>
-            </a:pPr>
-            <a:r>
-              <a:t>FOR REQUESTERS &amp; SITES</a:t>
-            </a:r>
-          </a:p>
-          <a:p>
-            <a:pPr>
-              <a:spcAft>
-                <a:spcPts val="1400"/>
-              </a:spcAft>
-              <a:defRPr sz="1500" b="1">
+              <a:defRPr sz="1000" b="1">
+                <a:solidFill>
+                  <a:srgbClr val="E11D48"/>
+                </a:solidFill>
+                <a:latin typeface="Segoe UI"/>
+              </a:defRPr>
+            </a:pPr>
+            <a:r>
+              <a:t>THE OPERATIONAL CHALLENGE</a:t>
+            </a:r>
+          </a:p>
+          <a:p>
+            <a:pPr>
+              <a:spcAft>
+                <a:spcPts val="1200"/>
+              </a:spcAft>
+              <a:defRPr sz="1600" b="1">
                 <a:solidFill>
                   <a:srgbClr val="0F172A"/>
                 </a:solidFill>
@@ -6440,7 +6011,7 @@
               </a:defRPr>
             </a:pPr>
             <a:r>
-              <a:t>Frictionless, Guided Ordering</a:t>
+              <a:t>Lingering POs &amp; Overdue Shipments</a:t>
             </a:r>
           </a:p>
           <a:p>
@@ -6448,74 +6019,28 @@
               <a:spcAft>
                 <a:spcPts val="1000"/>
               </a:spcAft>
-            </a:pPr>
-            <a:r>
-              <a:rPr sz="1050" b="1">
-                <a:solidFill>
-                  <a:srgbClr val="0F172A"/>
-                </a:solidFill>
-                <a:latin typeface="Segoe UI"/>
-              </a:rPr>
-              <a:t>✓ Zero-Guesswork Quantities:</a:t>
-            </a:r>
-            <a:r>
-              <a:rPr sz="1050">
+              <a:defRPr sz="1100">
                 <a:solidFill>
                   <a:srgbClr val="475569"/>
                 </a:solidFill>
                 <a:latin typeface="Segoe UI"/>
-              </a:rPr>
-              <a:t> Packaging multiples auto-enforced with 1-click smart rounding (e.g. 5,040 units).</a:t>
-            </a:r>
-          </a:p>
-          <a:p>
-            <a:pPr>
-              <a:spcAft>
-                <a:spcPts val="1000"/>
-              </a:spcAft>
-            </a:pPr>
-            <a:r>
-              <a:rPr sz="1050" b="1">
-                <a:solidFill>
-                  <a:srgbClr val="0F172A"/>
-                </a:solidFill>
-                <a:latin typeface="Segoe UI"/>
-              </a:rPr>
-              <a:t>✓ Guaranteed Price Compliance:</a:t>
-            </a:r>
-            <a:r>
-              <a:rPr sz="1050">
+              </a:defRPr>
+            </a:pPr>
+            <a:r>
+              <a:t>• The Issue: Orders 100% received physically sat open in ProcureFlow because users forgot to click 'Complete Order'. Furthermore, undelivered orders sat &gt;14 days past need-by date with zero management visibility.</a:t>
+            </a:r>
+          </a:p>
+          <a:p>
+            <a:pPr>
+              <a:defRPr sz="1100">
                 <a:solidFill>
                   <a:srgbClr val="475569"/>
                 </a:solidFill>
                 <a:latin typeface="Segoe UI"/>
-              </a:rPr>
-              <a:t> Active contracted supplier catalog pricing auto-populates lines.</a:t>
-            </a:r>
-          </a:p>
-          <a:p>
-            <a:pPr>
-              <a:spcAft>
-                <a:spcPts val="1000"/>
-              </a:spcAft>
-            </a:pPr>
-            <a:r>
-              <a:rPr sz="1050" b="1">
-                <a:solidFill>
-                  <a:srgbClr val="0F172A"/>
-                </a:solidFill>
-                <a:latin typeface="Segoe UI"/>
-              </a:rPr>
-              <a:t>✓ Action Required Dashboard:</a:t>
-            </a:r>
-            <a:r>
-              <a:rPr sz="1050">
-                <a:solidFill>
-                  <a:srgbClr val="475569"/>
-                </a:solidFill>
-                <a:latin typeface="Segoe UI"/>
-              </a:rPr>
-              <a:t> On login, users immediately see pending tasks (e.g. log Concur PR #, complete received order).</a:t>
+              </a:defRPr>
+            </a:pPr>
+            <a:r>
+              <a:t>• Business Impact: Distorted open commitment reports in finance and hidden supplier supply chain bottlenecks.</a:t>
             </a:r>
           </a:p>
         </p:txBody>
@@ -6528,8 +6053,8 @@
         </p:nvSpPr>
         <p:spPr>
           <a:xfrm>
-            <a:off x="4425696" y="1463040"/>
-            <a:ext cx="3328416" cy="4754880"/>
+            <a:off x="6263640" y="1463040"/>
+            <a:ext cx="5166360" cy="4754880"/>
           </a:xfrm>
           <a:prstGeom prst="roundRect">
             <a:avLst/>
@@ -6573,8 +6098,8 @@
         </p:nvSpPr>
         <p:spPr>
           <a:xfrm>
-            <a:off x="4654296" y="1691640"/>
-            <a:ext cx="2871216" cy="4297680"/>
+            <a:off x="6492240" y="1691640"/>
+            <a:ext cx="4709160" cy="4297680"/>
           </a:xfrm>
           <a:prstGeom prst="rect">
             <a:avLst/>
@@ -6591,7 +6116,7 @@
               <a:spcAft>
                 <a:spcPts val="400"/>
               </a:spcAft>
-              <a:defRPr sz="900" b="1">
+              <a:defRPr sz="1000" b="1">
                 <a:solidFill>
                   <a:srgbClr val="059669"/>
                 </a:solidFill>
@@ -6599,15 +6124,15 @@
               </a:defRPr>
             </a:pPr>
             <a:r>
-              <a:t>FOR PROCUREMENT (ASHISH CHHABRA)</a:t>
-            </a:r>
-          </a:p>
-          <a:p>
-            <a:pPr>
-              <a:spcAft>
-                <a:spcPts val="1400"/>
-              </a:spcAft>
-              <a:defRPr sz="1500" b="1">
+              <a:t>THE ENGINEERED SOLUTION &amp; WHY IT WORKS</a:t>
+            </a:r>
+          </a:p>
+          <a:p>
+            <a:pPr>
+              <a:spcAft>
+                <a:spcPts val="1200"/>
+              </a:spcAft>
+              <a:defRPr sz="1600" b="1">
                 <a:solidFill>
                   <a:srgbClr val="0F172A"/>
                 </a:solidFill>
@@ -6615,13 +6140,13 @@
               </a:defRPr>
             </a:pPr>
             <a:r>
-              <a:t>Zero-Rework Governance</a:t>
-            </a:r>
-          </a:p>
-          <a:p>
-            <a:pPr>
-              <a:spcAft>
-                <a:spcPts val="1000"/>
+              <a:t>Automated Nudges &amp; Tiered Escalation</a:t>
+            </a:r>
+          </a:p>
+          <a:p>
+            <a:pPr>
+              <a:spcAft>
+                <a:spcPts val="800"/>
               </a:spcAft>
             </a:pPr>
             <a:r>
@@ -6631,7 +6156,7 @@
                 </a:solidFill>
                 <a:latin typeface="Segoe UI"/>
               </a:rPr>
-              <a:t>✓ Zero Supplier Rejections:</a:t>
+              <a:t>✓ The Solution: </a:t>
             </a:r>
             <a:r>
               <a:rPr sz="1050">
@@ -6640,13 +6165,13 @@
                 </a:solidFill>
                 <a:latin typeface="Segoe UI"/>
               </a:rPr>
-              <a:t> Orders arrive pre-validated for pack sizes and contracted rates.</a:t>
-            </a:r>
-          </a:p>
-          <a:p>
-            <a:pPr>
-              <a:spcAft>
-                <a:spcPts val="1000"/>
+              <a:t>Automated daily closure reminders when 100% received; Tiered escalation (&gt;14d to user, &gt;21d copying line managers e.g. David, Ashish, Ebrahim).</a:t>
+            </a:r>
+          </a:p>
+          <a:p>
+            <a:pPr>
+              <a:spcAft>
+                <a:spcPts val="800"/>
               </a:spcAft>
             </a:pPr>
             <a:r>
@@ -6656,7 +6181,7 @@
                 </a:solidFill>
                 <a:latin typeface="Segoe UI"/>
               </a:rPr>
-              <a:t>✓ No Manual EOM Spreadsheets:</a:t>
+              <a:t>✓ Why This is the Solution: </a:t>
             </a:r>
             <a:r>
               <a:rPr sz="1050">
@@ -6665,13 +6190,13 @@
                 </a:solidFill>
                 <a:latin typeface="Segoe UI"/>
               </a:rPr>
-              <a:t> Month-end pivot reconciliation generated automatically in seconds.</a:t>
-            </a:r>
-          </a:p>
-          <a:p>
-            <a:pPr>
-              <a:spcAft>
-                <a:spcPts val="1000"/>
+              <a:t>Closes the operational loop automatically without requiring manual chasing by procurement.</a:t>
+            </a:r>
+          </a:p>
+          <a:p>
+            <a:pPr>
+              <a:spcAft>
+                <a:spcPts val="800"/>
               </a:spcAft>
             </a:pPr>
             <a:r>
@@ -6681,7 +6206,7 @@
                 </a:solidFill>
                 <a:latin typeface="Segoe UI"/>
               </a:rPr>
-              <a:t>✓ Live SOH Transparency:</a:t>
+              <a:t>✓ Multi-Channel Reach: </a:t>
             </a:r>
             <a:r>
               <a:rPr sz="1050">
@@ -6690,123 +6215,23 @@
                 </a:solidFill>
                 <a:latin typeface="Segoe UI"/>
               </a:rPr>
-              <a:t> Self-service inventory removes the manual weekly emailing burden.</a:t>
-            </a:r>
-          </a:p>
-        </p:txBody>
-      </p:sp>
-      <p:sp>
-        <p:nvSpPr>
-          <p:cNvPr id="7" name="Rounded Rectangle 6"/>
-          <p:cNvSpPr/>
-          <p:nvPr/>
-        </p:nvSpPr>
-        <p:spPr>
-          <a:xfrm>
-            <a:off x="8119872" y="1463040"/>
-            <a:ext cx="3328416" cy="4754880"/>
-          </a:xfrm>
-          <a:prstGeom prst="roundRect">
-            <a:avLst/>
-          </a:prstGeom>
-          <a:solidFill>
-            <a:srgbClr val="FFFFFF"/>
-          </a:solidFill>
-          <a:ln w="15240">
-            <a:solidFill>
-              <a:srgbClr val="E2E8F0"/>
-            </a:solidFill>
-          </a:ln>
-        </p:spPr>
-        <p:style>
-          <a:lnRef idx="1">
-            <a:schemeClr val="accent1"/>
-          </a:lnRef>
-          <a:fillRef idx="3">
-            <a:schemeClr val="accent1"/>
-          </a:fillRef>
-          <a:effectRef idx="2">
-            <a:schemeClr val="accent1"/>
-          </a:effectRef>
-          <a:fontRef idx="minor">
-            <a:schemeClr val="lt1"/>
-          </a:fontRef>
-        </p:style>
-        <p:txBody>
-          <a:bodyPr rtlCol="0" anchor="ctr"/>
-          <a:lstStyle/>
-          <a:p>
-            <a:pPr algn="ctr"/>
-          </a:p>
-        </p:txBody>
-      </p:sp>
-      <p:sp>
-        <p:nvSpPr>
-          <p:cNvPr id="8" name="TextBox 7"/>
-          <p:cNvSpPr txBox="1"/>
-          <p:nvPr/>
-        </p:nvSpPr>
-        <p:spPr>
-          <a:xfrm>
-            <a:off x="8348472" y="1691640"/>
-            <a:ext cx="2871216" cy="4297680"/>
-          </a:xfrm>
-          <a:prstGeom prst="rect">
-            <a:avLst/>
-          </a:prstGeom>
-          <a:noFill/>
-        </p:spPr>
-        <p:txBody>
-          <a:bodyPr wrap="square">
-            <a:spAutoFit/>
-          </a:bodyPr>
-          <a:lstStyle/>
-          <a:p>
-            <a:pPr>
-              <a:spcAft>
-                <a:spcPts val="400"/>
-              </a:spcAft>
-              <a:defRPr sz="900" b="1">
-                <a:solidFill>
-                  <a:srgbClr val="9333EA"/>
-                </a:solidFill>
-                <a:latin typeface="Segoe UI"/>
-              </a:defRPr>
-            </a:pPr>
-            <a:r>
-              <a:t>FOR EXECUTIVE LEADERSHIP (EBRAHIM MOKHTARI)</a:t>
-            </a:r>
-          </a:p>
-          <a:p>
-            <a:pPr>
-              <a:spcAft>
-                <a:spcPts val="1400"/>
-              </a:spcAft>
-              <a:defRPr sz="1500" b="1">
+              <a:t>Delivered via In-App Drawer, Microsoft Graph Email, and MS Teams Adaptive Cards.</a:t>
+            </a:r>
+          </a:p>
+          <a:p>
+            <a:pPr>
+              <a:spcAft>
+                <a:spcPts val="800"/>
+              </a:spcAft>
+            </a:pPr>
+            <a:r>
+              <a:rPr sz="1050" b="1">
                 <a:solidFill>
                   <a:srgbClr val="0F172A"/>
                 </a:solidFill>
                 <a:latin typeface="Segoe UI"/>
-              </a:defRPr>
-            </a:pPr>
-            <a:r>
-              <a:t>Real-Time Spend Control</a:t>
-            </a:r>
-          </a:p>
-          <a:p>
-            <a:pPr>
-              <a:spcAft>
-                <a:spcPts val="1000"/>
-              </a:spcAft>
-            </a:pPr>
-            <a:r>
-              <a:rPr sz="1050" b="1">
-                <a:solidFill>
-                  <a:srgbClr val="0F172A"/>
-                </a:solidFill>
-                <a:latin typeface="Segoe UI"/>
-              </a:rPr>
-              <a:t>✓ Single Source of Truth:</a:t>
+              </a:rPr>
+              <a:t>✓ Clean Commitments: </a:t>
             </a:r>
             <a:r>
               <a:rPr sz="1050">
@@ -6815,57 +6240,7 @@
                 </a:solidFill>
                 <a:latin typeface="Segoe UI"/>
               </a:rPr>
-              <a:t> ProcureFlow numbers match SAP Concur reports 100%.</a:t>
-            </a:r>
-          </a:p>
-          <a:p>
-            <a:pPr>
-              <a:spcAft>
-                <a:spcPts val="1000"/>
-              </a:spcAft>
-            </a:pPr>
-            <a:r>
-              <a:rPr sz="1050" b="1">
-                <a:solidFill>
-                  <a:srgbClr val="0F172A"/>
-                </a:solidFill>
-                <a:latin typeface="Segoe UI"/>
-              </a:rPr>
-              <a:t>✓ Live Budget Burn Tracking:</a:t>
-            </a:r>
-            <a:r>
-              <a:rPr sz="1050">
-                <a:solidFill>
-                  <a:srgbClr val="475569"/>
-                </a:solidFill>
-                <a:latin typeface="Segoe UI"/>
-              </a:rPr>
-              <a:t> Real-time visibility into $14.521M FY27 budget and $2.3M Linen Hub pool.</a:t>
-            </a:r>
-          </a:p>
-          <a:p>
-            <a:pPr>
-              <a:spcAft>
-                <a:spcPts val="1000"/>
-              </a:spcAft>
-            </a:pPr>
-            <a:r>
-              <a:rPr sz="1050" b="1">
-                <a:solidFill>
-                  <a:srgbClr val="0F172A"/>
-                </a:solidFill>
-                <a:latin typeface="Segoe UI"/>
-              </a:rPr>
-              <a:t>✓ Strategic Subcontract Visibility:</a:t>
-            </a:r>
-            <a:r>
-              <a:rPr sz="1050">
-                <a:solidFill>
-                  <a:srgbClr val="475569"/>
-                </a:solidFill>
-                <a:latin typeface="Segoe UI"/>
-              </a:rPr>
-              <a:t> Instant breakouts for HealthShare Victoria (HSV) and Ramsay Health Care (RHC).</a:t>
+              <a:t>Financial reports reflect only genuinely outstanding shipments.</a:t>
             </a:r>
           </a:p>
         </p:txBody>
@@ -6922,7 +6297,7 @@
               </a:defRPr>
             </a:pPr>
             <a:r>
-              <a:t>ACT 3: DEVELOPMENT PILLARS</a:t>
+              <a:t>EXECUTIVE FINANCIAL INTELLIGENCE</a:t>
             </a:r>
           </a:p>
           <a:p>
@@ -6935,7 +6310,7 @@
               </a:defRPr>
             </a:pPr>
             <a:r>
-              <a:t>Development Roadmap: Core Engineered Capabilities Delivered</a:t>
+              <a:t>Improvement 5: Native EOM Spend &amp; Budget Reconciliation Engine</a:t>
             </a:r>
           </a:p>
         </p:txBody>
@@ -6949,7 +6324,7 @@
         <p:spPr>
           <a:xfrm>
             <a:off x="731520" y="1463040"/>
-            <a:ext cx="5166360" cy="2240280"/>
+            <a:ext cx="2468880" cy="1188720"/>
           </a:xfrm>
           <a:prstGeom prst="roundRect">
             <a:avLst/>
@@ -6993,8 +6368,8 @@
         </p:nvSpPr>
         <p:spPr>
           <a:xfrm>
-            <a:off x="960120" y="1645920"/>
-            <a:ext cx="4709160" cy="1874520"/>
+            <a:off x="868680" y="1508760"/>
+            <a:ext cx="2194560" cy="1097280"/>
           </a:xfrm>
           <a:prstGeom prst="rect">
             <a:avLst/>
@@ -7008,10 +6383,20 @@
           <a:lstStyle/>
           <a:p>
             <a:pPr>
-              <a:spcAft>
-                <a:spcPts val="800"/>
-              </a:spcAft>
-              <a:defRPr sz="1200" b="1">
+              <a:defRPr sz="850" b="1">
+                <a:solidFill>
+                  <a:srgbClr val="64748B"/>
+                </a:solidFill>
+                <a:latin typeface="Segoe UI"/>
+              </a:defRPr>
+            </a:pPr>
+            <a:r>
+              <a:t>FY27 TOTAL BUDGET</a:t>
+            </a:r>
+          </a:p>
+          <a:p>
+            <a:pPr>
+              <a:defRPr sz="2000" b="1">
                 <a:solidFill>
                   <a:srgbClr val="0284C7"/>
                 </a:solidFill>
@@ -7019,20 +6404,20 @@
               </a:defRPr>
             </a:pPr>
             <a:r>
-              <a:t>PILLAR A: POINT-OF-ENTRY GOVERNANCE</a:t>
-            </a:r>
-          </a:p>
-          <a:p>
-            <a:pPr>
-              <a:defRPr sz="1100">
-                <a:solidFill>
-                  <a:srgbClr val="475569"/>
-                </a:solidFill>
-                <a:latin typeface="Segoe UI"/>
-              </a:defRPr>
-            </a:pPr>
-            <a:r>
-              <a:t>Input blocking rules for carton multiples (e.g. 5,000 -&gt; 5,040) &amp; contract price validation in POCreate/PODetail.</a:t>
+              <a:t>$14.521M</a:t>
+            </a:r>
+          </a:p>
+          <a:p>
+            <a:pPr>
+              <a:defRPr sz="850">
+                <a:solidFill>
+                  <a:srgbClr val="64748B"/>
+                </a:solidFill>
+                <a:latin typeface="Segoe UI"/>
+              </a:defRPr>
+            </a:pPr>
+            <a:r>
+              <a:t>Baseline Operating Budget</a:t>
             </a:r>
           </a:p>
         </p:txBody>
@@ -7045,8 +6430,8 @@
         </p:nvSpPr>
         <p:spPr>
           <a:xfrm>
-            <a:off x="6263640" y="1463040"/>
-            <a:ext cx="5166360" cy="2240280"/>
+            <a:off x="3483864" y="1463040"/>
+            <a:ext cx="2468880" cy="1188720"/>
           </a:xfrm>
           <a:prstGeom prst="roundRect">
             <a:avLst/>
@@ -7090,8 +6475,8 @@
         </p:nvSpPr>
         <p:spPr>
           <a:xfrm>
-            <a:off x="6492240" y="1645920"/>
-            <a:ext cx="4709160" cy="1874520"/>
+            <a:off x="3621024" y="1508760"/>
+            <a:ext cx="2194560" cy="1097280"/>
           </a:xfrm>
           <a:prstGeom prst="rect">
             <a:avLst/>
@@ -7105,31 +6490,41 @@
           <a:lstStyle/>
           <a:p>
             <a:pPr>
-              <a:spcAft>
-                <a:spcPts val="800"/>
-              </a:spcAft>
-              <a:defRPr sz="1200" b="1">
-                <a:solidFill>
-                  <a:srgbClr val="D97706"/>
-                </a:solidFill>
-                <a:latin typeface="Segoe UI"/>
-              </a:defRPr>
-            </a:pPr>
-            <a:r>
-              <a:t>PILLAR B: CLOSED-LOOP ERP PARITY</a:t>
-            </a:r>
-          </a:p>
-          <a:p>
-            <a:pPr>
-              <a:defRPr sz="1100">
-                <a:solidFill>
-                  <a:srgbClr val="475569"/>
-                </a:solidFill>
-                <a:latin typeface="Segoe UI"/>
-              </a:defRPr>
-            </a:pPr>
-            <a:r>
-              <a:t>Mandatory Concur PR # enforcement on PO closure &amp; Homepage Action Required task center.</a:t>
+              <a:defRPr sz="850" b="1">
+                <a:solidFill>
+                  <a:srgbClr val="64748B"/>
+                </a:solidFill>
+                <a:latin typeface="Segoe UI"/>
+              </a:defRPr>
+            </a:pPr>
+            <a:r>
+              <a:t>DEPLETION RUN RATE</a:t>
+            </a:r>
+          </a:p>
+          <a:p>
+            <a:pPr>
+              <a:defRPr sz="2000" b="1">
+                <a:solidFill>
+                  <a:srgbClr val="059669"/>
+                </a:solidFill>
+                <a:latin typeface="Segoe UI"/>
+              </a:defRPr>
+            </a:pPr>
+            <a:r>
+              <a:t>$9.921M</a:t>
+            </a:r>
+          </a:p>
+          <a:p>
+            <a:pPr>
+              <a:defRPr sz="850">
+                <a:solidFill>
+                  <a:srgbClr val="64748B"/>
+                </a:solidFill>
+                <a:latin typeface="Segoe UI"/>
+              </a:defRPr>
+            </a:pPr>
+            <a:r>
+              <a:t>$826.8k / Month Target</a:t>
             </a:r>
           </a:p>
         </p:txBody>
@@ -7142,8 +6537,8 @@
         </p:nvSpPr>
         <p:spPr>
           <a:xfrm>
-            <a:off x="731520" y="3977639"/>
-            <a:ext cx="5166360" cy="2240280"/>
+            <a:off x="6236208" y="1463040"/>
+            <a:ext cx="2468880" cy="1188720"/>
           </a:xfrm>
           <a:prstGeom prst="roundRect">
             <a:avLst/>
@@ -7187,8 +6582,8 @@
         </p:nvSpPr>
         <p:spPr>
           <a:xfrm>
-            <a:off x="960120" y="4160519"/>
-            <a:ext cx="4709160" cy="1874520"/>
+            <a:off x="6373368" y="1508760"/>
+            <a:ext cx="2194560" cy="1097280"/>
           </a:xfrm>
           <a:prstGeom prst="rect">
             <a:avLst/>
@@ -7202,31 +6597,41 @@
           <a:lstStyle/>
           <a:p>
             <a:pPr>
-              <a:spcAft>
-                <a:spcPts val="800"/>
-              </a:spcAft>
-              <a:defRPr sz="1200" b="1">
-                <a:solidFill>
-                  <a:srgbClr val="E11D48"/>
-                </a:solidFill>
-                <a:latin typeface="Segoe UI"/>
-              </a:defRPr>
-            </a:pPr>
-            <a:r>
-              <a:t>PILLAR C: AUTOMATED NOTIFICATIONS &amp; ESCALATIONS</a:t>
-            </a:r>
-          </a:p>
-          <a:p>
-            <a:pPr>
-              <a:defRPr sz="1100">
-                <a:solidFill>
-                  <a:srgbClr val="475569"/>
-                </a:solidFill>
-                <a:latin typeface="Segoe UI"/>
-              </a:defRPr>
-            </a:pPr>
-            <a:r>
-              <a:t>100% receipt closure reminders &amp; &gt;14d overdue delivery manager escalations (In-App, Email, MS Teams).</a:t>
+              <a:defRPr sz="850" b="1">
+                <a:solidFill>
+                  <a:srgbClr val="64748B"/>
+                </a:solidFill>
+                <a:latin typeface="Segoe UI"/>
+              </a:defRPr>
+            </a:pPr>
+            <a:r>
+              <a:t>NEW BUSINESS POOL</a:t>
+            </a:r>
+          </a:p>
+          <a:p>
+            <a:pPr>
+              <a:defRPr sz="2000" b="1">
+                <a:solidFill>
+                  <a:srgbClr val="9333EA"/>
+                </a:solidFill>
+                <a:latin typeface="Segoe UI"/>
+              </a:defRPr>
+            </a:pPr>
+            <a:r>
+              <a:t>$2.300M</a:t>
+            </a:r>
+          </a:p>
+          <a:p>
+            <a:pPr>
+              <a:defRPr sz="850">
+                <a:solidFill>
+                  <a:srgbClr val="64748B"/>
+                </a:solidFill>
+                <a:latin typeface="Segoe UI"/>
+              </a:defRPr>
+            </a:pPr>
+            <a:r>
+              <a:t>$191.7k / Month Allocation</a:t>
             </a:r>
           </a:p>
         </p:txBody>
@@ -7239,8 +6644,8 @@
         </p:nvSpPr>
         <p:spPr>
           <a:xfrm>
-            <a:off x="6263640" y="3977639"/>
-            <a:ext cx="5166360" cy="2240280"/>
+            <a:off x="8988552" y="1463040"/>
+            <a:ext cx="2468880" cy="1188720"/>
           </a:xfrm>
           <a:prstGeom prst="roundRect">
             <a:avLst/>
@@ -7284,8 +6689,8 @@
         </p:nvSpPr>
         <p:spPr>
           <a:xfrm>
-            <a:off x="6492240" y="4160519"/>
-            <a:ext cx="4709160" cy="1874520"/>
+            <a:off x="9125712" y="1508760"/>
+            <a:ext cx="2194560" cy="1097280"/>
           </a:xfrm>
           <a:prstGeom prst="rect">
             <a:avLst/>
@@ -7299,31 +6704,275 @@
           <a:lstStyle/>
           <a:p>
             <a:pPr>
-              <a:spcAft>
-                <a:spcPts val="800"/>
-              </a:spcAft>
-              <a:defRPr sz="1200" b="1">
-                <a:solidFill>
-                  <a:srgbClr val="059669"/>
-                </a:solidFill>
-                <a:latin typeface="Segoe UI"/>
-              </a:defRPr>
-            </a:pPr>
-            <a:r>
-              <a:t>PILLAR D: EOM SPEND &amp; BUDGET RECONCILIATION</a:t>
-            </a:r>
-          </a:p>
-          <a:p>
-            <a:pPr>
-              <a:defRPr sz="1100">
+              <a:defRPr sz="850" b="1">
+                <a:solidFill>
+                  <a:srgbClr val="64748B"/>
+                </a:solidFill>
+                <a:latin typeface="Segoe UI"/>
+              </a:defRPr>
+            </a:pPr>
+            <a:r>
+              <a:t>LINEN HUB DEDICATED</a:t>
+            </a:r>
+          </a:p>
+          <a:p>
+            <a:pPr>
+              <a:defRPr sz="2000" b="1">
+                <a:solidFill>
+                  <a:srgbClr val="D97706"/>
+                </a:solidFill>
+                <a:latin typeface="Segoe UI"/>
+              </a:defRPr>
+            </a:pPr>
+            <a:r>
+              <a:t>$2.300M</a:t>
+            </a:r>
+          </a:p>
+          <a:p>
+            <a:pPr>
+              <a:defRPr sz="850">
+                <a:solidFill>
+                  <a:srgbClr val="64748B"/>
+                </a:solidFill>
+                <a:latin typeface="Segoe UI"/>
+              </a:defRPr>
+            </a:pPr>
+            <a:r>
+              <a:t>Real-Time Decrement Pool</a:t>
+            </a:r>
+          </a:p>
+        </p:txBody>
+      </p:sp>
+      <p:sp>
+        <p:nvSpPr>
+          <p:cNvPr id="11" name="Rounded Rectangle 10"/>
+          <p:cNvSpPr/>
+          <p:nvPr/>
+        </p:nvSpPr>
+        <p:spPr>
+          <a:xfrm>
+            <a:off x="731520" y="2834640"/>
+            <a:ext cx="10728655" cy="3383280"/>
+          </a:xfrm>
+          <a:prstGeom prst="roundRect">
+            <a:avLst/>
+          </a:prstGeom>
+          <a:solidFill>
+            <a:srgbClr val="FFFFFF"/>
+          </a:solidFill>
+          <a:ln w="15240">
+            <a:solidFill>
+              <a:srgbClr val="E2E8F0"/>
+            </a:solidFill>
+          </a:ln>
+        </p:spPr>
+        <p:style>
+          <a:lnRef idx="1">
+            <a:schemeClr val="accent1"/>
+          </a:lnRef>
+          <a:fillRef idx="3">
+            <a:schemeClr val="accent1"/>
+          </a:fillRef>
+          <a:effectRef idx="2">
+            <a:schemeClr val="accent1"/>
+          </a:effectRef>
+          <a:fontRef idx="minor">
+            <a:schemeClr val="lt1"/>
+          </a:fontRef>
+        </p:style>
+        <p:txBody>
+          <a:bodyPr rtlCol="0" anchor="ctr"/>
+          <a:lstStyle/>
+          <a:p>
+            <a:pPr algn="ctr"/>
+          </a:p>
+        </p:txBody>
+      </p:sp>
+      <p:sp>
+        <p:nvSpPr>
+          <p:cNvPr id="12" name="TextBox 11"/>
+          <p:cNvSpPr txBox="1"/>
+          <p:nvPr/>
+        </p:nvSpPr>
+        <p:spPr>
+          <a:xfrm>
+            <a:off x="960120" y="3017520"/>
+            <a:ext cx="10271455" cy="3017520"/>
+          </a:xfrm>
+          <a:prstGeom prst="rect">
+            <a:avLst/>
+          </a:prstGeom>
+          <a:noFill/>
+        </p:spPr>
+        <p:txBody>
+          <a:bodyPr wrap="square">
+            <a:spAutoFit/>
+          </a:bodyPr>
+          <a:lstStyle/>
+          <a:p>
+            <a:pPr>
+              <a:spcAft>
+                <a:spcPts val="1000"/>
+              </a:spcAft>
+              <a:defRPr sz="1400" b="1">
+                <a:solidFill>
+                  <a:srgbClr val="0F172A"/>
+                </a:solidFill>
+                <a:latin typeface="Segoe UI"/>
+              </a:defRPr>
+            </a:pPr>
+            <a:r>
+              <a:t>Why This is the Solution for Executive Leadership:</a:t>
+            </a:r>
+          </a:p>
+          <a:p>
+            <a:pPr>
+              <a:spcAft>
+                <a:spcPts val="600"/>
+              </a:spcAft>
+            </a:pPr>
+            <a:r>
+              <a:rPr sz="1050" b="1">
+                <a:solidFill>
+                  <a:srgbClr val="0F172A"/>
+                </a:solidFill>
+                <a:latin typeface="Segoe UI"/>
+              </a:rPr>
+              <a:t>• Automates 3 Days of Work: </a:t>
+            </a:r>
+            <a:r>
+              <a:rPr sz="1050">
                 <a:solidFill>
                   <a:srgbClr val="475569"/>
                 </a:solidFill>
                 <a:latin typeface="Segoe UI"/>
-              </a:defRPr>
-            </a:pPr>
-            <a:r>
-              <a:t>Native 2D Pivot Table (Branch x Sector x Reason), FY27 Budget ($14.521M), Linen Hub $2.3M tracker &amp; 1-Click CSV export.</a:t>
+              </a:rPr>
+              <a:t>Natively replicates Ashish's Concur EOM Pivot (Branch × Sector × Reason) excluding GST (Total / 1.1) in seconds.</a:t>
+            </a:r>
+          </a:p>
+          <a:p>
+            <a:pPr>
+              <a:spcAft>
+                <a:spcPts val="600"/>
+              </a:spcAft>
+            </a:pPr>
+            <a:r>
+              <a:rPr sz="1050" b="1">
+                <a:solidFill>
+                  <a:srgbClr val="0F172A"/>
+                </a:solidFill>
+                <a:latin typeface="Segoe UI"/>
+              </a:rPr>
+              <a:t>• 100% Precision Verified: </a:t>
+            </a:r>
+            <a:r>
+              <a:rPr sz="1050">
+                <a:solidFill>
+                  <a:srgbClr val="475569"/>
+                </a:solidFill>
+                <a:latin typeface="Segoe UI"/>
+              </a:rPr>
+              <a:t>Regex classifier achieves verified 100.0% accuracy matching Ashish's historical dataset.</a:t>
+            </a:r>
+          </a:p>
+          <a:p>
+            <a:pPr>
+              <a:spcAft>
+                <a:spcPts val="600"/>
+              </a:spcAft>
+            </a:pPr>
+            <a:r>
+              <a:rPr sz="1050" b="1">
+                <a:solidFill>
+                  <a:srgbClr val="0F172A"/>
+                </a:solidFill>
+                <a:latin typeface="Segoe UI"/>
+              </a:rPr>
+              <a:t>• Branch Variance Tracking: </a:t>
+            </a:r>
+            <a:r>
+              <a:rPr sz="1050">
+                <a:solidFill>
+                  <a:srgbClr val="475569"/>
+                </a:solidFill>
+                <a:latin typeface="Segoe UI"/>
+              </a:rPr>
+              <a:t>Tracks monthly actuals and YTD spend vs baseline budgets across all 8 branches (Melbourne $2.65M, Sydney $2.78M, Adelaide $920k, Brisbane $1.03M, Cairns $706k, Mackay $349k, Perth $996k, Albury $481k).</a:t>
+            </a:r>
+          </a:p>
+          <a:p>
+            <a:pPr>
+              <a:spcAft>
+                <a:spcPts val="600"/>
+              </a:spcAft>
+            </a:pPr>
+            <a:r>
+              <a:rPr sz="1050" b="1">
+                <a:solidFill>
+                  <a:srgbClr val="0F172A"/>
+                </a:solidFill>
+                <a:latin typeface="Segoe UI"/>
+              </a:rPr>
+              <a:t>• Dedicated Linen Hub Pool: </a:t>
+            </a:r>
+            <a:r>
+              <a:rPr sz="1050">
+                <a:solidFill>
+                  <a:srgbClr val="475569"/>
+                </a:solidFill>
+                <a:latin typeface="Segoe UI"/>
+              </a:rPr>
+              <a:t>Maintains continuous decrement balance tracking against the dedicated $2.30M injection reserve.</a:t>
+            </a:r>
+          </a:p>
+          <a:p>
+            <a:pPr>
+              <a:spcAft>
+                <a:spcPts val="600"/>
+              </a:spcAft>
+            </a:pPr>
+            <a:r>
+              <a:rPr sz="1050" b="1">
+                <a:solidFill>
+                  <a:srgbClr val="0F172A"/>
+                </a:solidFill>
+                <a:latin typeface="Segoe UI"/>
+              </a:rPr>
+              <a:t>• Strategic Subcontracts: </a:t>
+            </a:r>
+            <a:r>
+              <a:rPr sz="1050">
+                <a:solidFill>
+                  <a:srgbClr val="475569"/>
+                </a:solidFill>
+                <a:latin typeface="Segoe UI"/>
+              </a:rPr>
+              <a:t>Real-time visibility into HealthShare Victoria (HSV) and Ramsay Health Care (RHC) spend.</a:t>
+            </a:r>
+          </a:p>
+          <a:p>
+            <a:pPr>
+              <a:spcAft>
+                <a:spcPts val="600"/>
+              </a:spcAft>
+            </a:pPr>
+            <a:r>
+              <a:rPr sz="1050" b="1">
+                <a:solidFill>
+                  <a:srgbClr val="0F172A"/>
+                </a:solidFill>
+                <a:latin typeface="Segoe UI"/>
+              </a:rPr>
+              <a:t>• 1-Click Concur Export: </a:t>
+            </a:r>
+            <a:r>
+              <a:rPr sz="1050">
+                <a:solidFill>
+                  <a:srgbClr val="475569"/>
+                </a:solidFill>
+                <a:latin typeface="Segoe UI"/>
+              </a:rPr>
+              <a:t>Generates formatted leadership-ready Excel CSV reconciliation files at a single click.</a:t>
             </a:r>
           </a:p>
         </p:txBody>
@@ -7380,7 +7029,7 @@
               </a:defRPr>
             </a:pPr>
             <a:r>
-              <a:t>ACT 3: FINANCIAL CONTROL</a:t>
+              <a:t>COMMERCIAL GOVERNANCE</a:t>
             </a:r>
           </a:p>
           <a:p>
@@ -7393,7 +7042,7 @@
               </a:defRPr>
             </a:pPr>
             <a:r>
-              <a:t>Executive Intelligence: Real-Time EOM Budget Reconciliation</a:t>
+              <a:t>Improvements 6 &amp; 7: SOH Automation &amp; DOA Approval Tiers</a:t>
             </a:r>
           </a:p>
         </p:txBody>
@@ -7407,7 +7056,7 @@
         <p:spPr>
           <a:xfrm>
             <a:off x="731520" y="1463040"/>
-            <a:ext cx="2468880" cy="1188720"/>
+            <a:ext cx="5166360" cy="4754880"/>
           </a:xfrm>
           <a:prstGeom prst="roundRect">
             <a:avLst/>
@@ -7451,8 +7100,8 @@
         </p:nvSpPr>
         <p:spPr>
           <a:xfrm>
-            <a:off x="868680" y="1508760"/>
-            <a:ext cx="2194560" cy="1097280"/>
+            <a:off x="960120" y="1691640"/>
+            <a:ext cx="4709160" cy="4297680"/>
           </a:xfrm>
           <a:prstGeom prst="rect">
             <a:avLst/>
@@ -7466,20 +7115,10 @@
           <a:lstStyle/>
           <a:p>
             <a:pPr>
-              <a:defRPr sz="850" b="1">
-                <a:solidFill>
-                  <a:srgbClr val="64748B"/>
-                </a:solidFill>
-                <a:latin typeface="Segoe UI"/>
-              </a:defRPr>
-            </a:pPr>
-            <a:r>
-              <a:t>FY27 TOTAL BUDGET</a:t>
-            </a:r>
-          </a:p>
-          <a:p>
-            <a:pPr>
-              <a:defRPr sz="2000" b="1">
+              <a:spcAft>
+                <a:spcPts val="400"/>
+              </a:spcAft>
+              <a:defRPr sz="1000" b="1">
                 <a:solidFill>
                   <a:srgbClr val="0284C7"/>
                 </a:solidFill>
@@ -7487,20 +7126,68 @@
               </a:defRPr>
             </a:pPr>
             <a:r>
-              <a:t>$14.521M</a:t>
-            </a:r>
-          </a:p>
-          <a:p>
-            <a:pPr>
-              <a:defRPr sz="850">
-                <a:solidFill>
-                  <a:srgbClr val="64748B"/>
-                </a:solidFill>
-                <a:latin typeface="Segoe UI"/>
-              </a:defRPr>
-            </a:pPr>
-            <a:r>
-              <a:t>Baseline Operating Budget</a:t>
+              <a:t>SELF-SERVICE SOH DISTRIBUTION</a:t>
+            </a:r>
+          </a:p>
+          <a:p>
+            <a:pPr>
+              <a:spcAft>
+                <a:spcPts val="1200"/>
+              </a:spcAft>
+              <a:defRPr sz="1500" b="1">
+                <a:solidFill>
+                  <a:srgbClr val="0F172A"/>
+                </a:solidFill>
+                <a:latin typeface="Segoe UI"/>
+              </a:defRPr>
+            </a:pPr>
+            <a:r>
+              <a:t>Eliminating Manual Weekly Emailing</a:t>
+            </a:r>
+          </a:p>
+          <a:p>
+            <a:pPr>
+              <a:spcAft>
+                <a:spcPts val="800"/>
+              </a:spcAft>
+              <a:defRPr sz="1050">
+                <a:solidFill>
+                  <a:srgbClr val="475569"/>
+                </a:solidFill>
+                <a:latin typeface="Segoe UI"/>
+              </a:defRPr>
+            </a:pPr>
+            <a:r>
+              <a:t>• The Issue: Procurement manually gathered, reformatted, and emailed weekly vendor inventory spreadsheets across state managers.</a:t>
+            </a:r>
+          </a:p>
+          <a:p>
+            <a:pPr>
+              <a:spcAft>
+                <a:spcPts val="800"/>
+              </a:spcAft>
+              <a:defRPr sz="1050">
+                <a:solidFill>
+                  <a:srgbClr val="475569"/>
+                </a:solidFill>
+                <a:latin typeface="Segoe UI"/>
+              </a:defRPr>
+            </a:pPr>
+            <a:r>
+              <a:t>• The Solution: Automated ingestion of vendor inventory feeds into the live SUPPLIER_INVENTORY dashboard in ProcureFlow.</a:t>
+            </a:r>
+          </a:p>
+          <a:p>
+            <a:pPr>
+              <a:defRPr sz="1050">
+                <a:solidFill>
+                  <a:srgbClr val="475569"/>
+                </a:solidFill>
+                <a:latin typeface="Segoe UI"/>
+              </a:defRPr>
+            </a:pPr>
+            <a:r>
+              <a:t>• Why It Works: Saves hours of administrative time each week and allows state managers to check stock availability before placing orders.</a:t>
             </a:r>
           </a:p>
         </p:txBody>
@@ -7513,8 +7200,8 @@
         </p:nvSpPr>
         <p:spPr>
           <a:xfrm>
-            <a:off x="3483864" y="1463040"/>
-            <a:ext cx="2468880" cy="1188720"/>
+            <a:off x="6263640" y="1463040"/>
+            <a:ext cx="5166360" cy="4754880"/>
           </a:xfrm>
           <a:prstGeom prst="roundRect">
             <a:avLst/>
@@ -7558,8 +7245,8 @@
         </p:nvSpPr>
         <p:spPr>
           <a:xfrm>
-            <a:off x="3621024" y="1508760"/>
-            <a:ext cx="2194560" cy="1097280"/>
+            <a:off x="6492240" y="1691640"/>
+            <a:ext cx="4709160" cy="4297680"/>
           </a:xfrm>
           <a:prstGeom prst="rect">
             <a:avLst/>
@@ -7573,127 +7260,10 @@
           <a:lstStyle/>
           <a:p>
             <a:pPr>
-              <a:defRPr sz="850" b="1">
-                <a:solidFill>
-                  <a:srgbClr val="64748B"/>
-                </a:solidFill>
-                <a:latin typeface="Segoe UI"/>
-              </a:defRPr>
-            </a:pPr>
-            <a:r>
-              <a:t>DEPLETION SPEND TARGET</a:t>
-            </a:r>
-          </a:p>
-          <a:p>
-            <a:pPr>
-              <a:defRPr sz="2000" b="1">
-                <a:solidFill>
-                  <a:srgbClr val="059669"/>
-                </a:solidFill>
-                <a:latin typeface="Segoe UI"/>
-              </a:defRPr>
-            </a:pPr>
-            <a:r>
-              <a:t>$9.921M</a:t>
-            </a:r>
-          </a:p>
-          <a:p>
-            <a:pPr>
-              <a:defRPr sz="850">
-                <a:solidFill>
-                  <a:srgbClr val="64748B"/>
-                </a:solidFill>
-                <a:latin typeface="Segoe UI"/>
-              </a:defRPr>
-            </a:pPr>
-            <a:r>
-              <a:t>$826.8k / Month Run Rate</a:t>
-            </a:r>
-          </a:p>
-        </p:txBody>
-      </p:sp>
-      <p:sp>
-        <p:nvSpPr>
-          <p:cNvPr id="7" name="Rounded Rectangle 6"/>
-          <p:cNvSpPr/>
-          <p:nvPr/>
-        </p:nvSpPr>
-        <p:spPr>
-          <a:xfrm>
-            <a:off x="6236208" y="1463040"/>
-            <a:ext cx="2468880" cy="1188720"/>
-          </a:xfrm>
-          <a:prstGeom prst="roundRect">
-            <a:avLst/>
-          </a:prstGeom>
-          <a:solidFill>
-            <a:srgbClr val="FFFFFF"/>
-          </a:solidFill>
-          <a:ln w="15240">
-            <a:solidFill>
-              <a:srgbClr val="E2E8F0"/>
-            </a:solidFill>
-          </a:ln>
-        </p:spPr>
-        <p:style>
-          <a:lnRef idx="1">
-            <a:schemeClr val="accent1"/>
-          </a:lnRef>
-          <a:fillRef idx="3">
-            <a:schemeClr val="accent1"/>
-          </a:fillRef>
-          <a:effectRef idx="2">
-            <a:schemeClr val="accent1"/>
-          </a:effectRef>
-          <a:fontRef idx="minor">
-            <a:schemeClr val="lt1"/>
-          </a:fontRef>
-        </p:style>
-        <p:txBody>
-          <a:bodyPr rtlCol="0" anchor="ctr"/>
-          <a:lstStyle/>
-          <a:p>
-            <a:pPr algn="ctr"/>
-          </a:p>
-        </p:txBody>
-      </p:sp>
-      <p:sp>
-        <p:nvSpPr>
-          <p:cNvPr id="8" name="TextBox 7"/>
-          <p:cNvSpPr txBox="1"/>
-          <p:nvPr/>
-        </p:nvSpPr>
-        <p:spPr>
-          <a:xfrm>
-            <a:off x="6373368" y="1508760"/>
-            <a:ext cx="2194560" cy="1097280"/>
-          </a:xfrm>
-          <a:prstGeom prst="rect">
-            <a:avLst/>
-          </a:prstGeom>
-          <a:noFill/>
-        </p:spPr>
-        <p:txBody>
-          <a:bodyPr wrap="square">
-            <a:spAutoFit/>
-          </a:bodyPr>
-          <a:lstStyle/>
-          <a:p>
-            <a:pPr>
-              <a:defRPr sz="850" b="1">
-                <a:solidFill>
-                  <a:srgbClr val="64748B"/>
-                </a:solidFill>
-                <a:latin typeface="Segoe UI"/>
-              </a:defRPr>
-            </a:pPr>
-            <a:r>
-              <a:t>NEW BUSINESS POOL</a:t>
-            </a:r>
-          </a:p>
-          <a:p>
-            <a:pPr>
-              <a:defRPr sz="2000" b="1">
+              <a:spcAft>
+                <a:spcPts val="400"/>
+              </a:spcAft>
+              <a:defRPr sz="1000" b="1">
                 <a:solidFill>
                   <a:srgbClr val="9333EA"/>
                 </a:solidFill>
@@ -7701,203 +7271,15 @@
               </a:defRPr>
             </a:pPr>
             <a:r>
-              <a:t>$2.300M</a:t>
-            </a:r>
-          </a:p>
-          <a:p>
-            <a:pPr>
-              <a:defRPr sz="850">
-                <a:solidFill>
-                  <a:srgbClr val="64748B"/>
-                </a:solidFill>
-                <a:latin typeface="Segoe UI"/>
-              </a:defRPr>
-            </a:pPr>
-            <a:r>
-              <a:t>$191.7k / Month Allocation</a:t>
-            </a:r>
-          </a:p>
-        </p:txBody>
-      </p:sp>
-      <p:sp>
-        <p:nvSpPr>
-          <p:cNvPr id="9" name="Rounded Rectangle 8"/>
-          <p:cNvSpPr/>
-          <p:nvPr/>
-        </p:nvSpPr>
-        <p:spPr>
-          <a:xfrm>
-            <a:off x="8988552" y="1463040"/>
-            <a:ext cx="2468880" cy="1188720"/>
-          </a:xfrm>
-          <a:prstGeom prst="roundRect">
-            <a:avLst/>
-          </a:prstGeom>
-          <a:solidFill>
-            <a:srgbClr val="FFFFFF"/>
-          </a:solidFill>
-          <a:ln w="15240">
-            <a:solidFill>
-              <a:srgbClr val="E2E8F0"/>
-            </a:solidFill>
-          </a:ln>
-        </p:spPr>
-        <p:style>
-          <a:lnRef idx="1">
-            <a:schemeClr val="accent1"/>
-          </a:lnRef>
-          <a:fillRef idx="3">
-            <a:schemeClr val="accent1"/>
-          </a:fillRef>
-          <a:effectRef idx="2">
-            <a:schemeClr val="accent1"/>
-          </a:effectRef>
-          <a:fontRef idx="minor">
-            <a:schemeClr val="lt1"/>
-          </a:fontRef>
-        </p:style>
-        <p:txBody>
-          <a:bodyPr rtlCol="0" anchor="ctr"/>
-          <a:lstStyle/>
-          <a:p>
-            <a:pPr algn="ctr"/>
-          </a:p>
-        </p:txBody>
-      </p:sp>
-      <p:sp>
-        <p:nvSpPr>
-          <p:cNvPr id="10" name="TextBox 9"/>
-          <p:cNvSpPr txBox="1"/>
-          <p:nvPr/>
-        </p:nvSpPr>
-        <p:spPr>
-          <a:xfrm>
-            <a:off x="9125712" y="1508760"/>
-            <a:ext cx="2194560" cy="1097280"/>
-          </a:xfrm>
-          <a:prstGeom prst="rect">
-            <a:avLst/>
-          </a:prstGeom>
-          <a:noFill/>
-        </p:spPr>
-        <p:txBody>
-          <a:bodyPr wrap="square">
-            <a:spAutoFit/>
-          </a:bodyPr>
-          <a:lstStyle/>
-          <a:p>
-            <a:pPr>
-              <a:defRPr sz="850" b="1">
-                <a:solidFill>
-                  <a:srgbClr val="64748B"/>
-                </a:solidFill>
-                <a:latin typeface="Segoe UI"/>
-              </a:defRPr>
-            </a:pPr>
-            <a:r>
-              <a:t>LINEN HUB DEDICATED</a:t>
-            </a:r>
-          </a:p>
-          <a:p>
-            <a:pPr>
-              <a:defRPr sz="2000" b="1">
-                <a:solidFill>
-                  <a:srgbClr val="D97706"/>
-                </a:solidFill>
-                <a:latin typeface="Segoe UI"/>
-              </a:defRPr>
-            </a:pPr>
-            <a:r>
-              <a:t>$2.300M</a:t>
-            </a:r>
-          </a:p>
-          <a:p>
-            <a:pPr>
-              <a:defRPr sz="850">
-                <a:solidFill>
-                  <a:srgbClr val="64748B"/>
-                </a:solidFill>
-                <a:latin typeface="Segoe UI"/>
-              </a:defRPr>
-            </a:pPr>
-            <a:r>
-              <a:t>Real-Time Decrement Pool</a:t>
-            </a:r>
-          </a:p>
-        </p:txBody>
-      </p:sp>
-      <p:sp>
-        <p:nvSpPr>
-          <p:cNvPr id="11" name="Rounded Rectangle 10"/>
-          <p:cNvSpPr/>
-          <p:nvPr/>
-        </p:nvSpPr>
-        <p:spPr>
-          <a:xfrm>
-            <a:off x="731520" y="2834640"/>
-            <a:ext cx="10728655" cy="3383280"/>
-          </a:xfrm>
-          <a:prstGeom prst="roundRect">
-            <a:avLst/>
-          </a:prstGeom>
-          <a:solidFill>
-            <a:srgbClr val="FFFFFF"/>
-          </a:solidFill>
-          <a:ln w="15240">
-            <a:solidFill>
-              <a:srgbClr val="E2E8F0"/>
-            </a:solidFill>
-          </a:ln>
-        </p:spPr>
-        <p:style>
-          <a:lnRef idx="1">
-            <a:schemeClr val="accent1"/>
-          </a:lnRef>
-          <a:fillRef idx="3">
-            <a:schemeClr val="accent1"/>
-          </a:fillRef>
-          <a:effectRef idx="2">
-            <a:schemeClr val="accent1"/>
-          </a:effectRef>
-          <a:fontRef idx="minor">
-            <a:schemeClr val="lt1"/>
-          </a:fontRef>
-        </p:style>
-        <p:txBody>
-          <a:bodyPr rtlCol="0" anchor="ctr"/>
-          <a:lstStyle/>
-          <a:p>
-            <a:pPr algn="ctr"/>
-          </a:p>
-        </p:txBody>
-      </p:sp>
-      <p:sp>
-        <p:nvSpPr>
-          <p:cNvPr id="12" name="TextBox 11"/>
-          <p:cNvSpPr txBox="1"/>
-          <p:nvPr/>
-        </p:nvSpPr>
-        <p:spPr>
-          <a:xfrm>
-            <a:off x="960120" y="3017520"/>
-            <a:ext cx="10271455" cy="3017520"/>
-          </a:xfrm>
-          <a:prstGeom prst="rect">
-            <a:avLst/>
-          </a:prstGeom>
-          <a:noFill/>
-        </p:spPr>
-        <p:txBody>
-          <a:bodyPr wrap="square">
-            <a:spAutoFit/>
-          </a:bodyPr>
-          <a:lstStyle/>
-          <a:p>
-            <a:pPr>
-              <a:spcAft>
-                <a:spcPts val="1000"/>
-              </a:spcAft>
-              <a:defRPr sz="1400" b="1">
+              <a:t>STRUCTURED DOA APPROVAL ENGINE</a:t>
+            </a:r>
+          </a:p>
+          <a:p>
+            <a:pPr>
+              <a:spcAft>
+                <a:spcPts val="1200"/>
+              </a:spcAft>
+              <a:defRPr sz="1500" b="1">
                 <a:solidFill>
                   <a:srgbClr val="0F172A"/>
                 </a:solidFill>
@@ -7905,7 +7287,7 @@
               </a:defRPr>
             </a:pPr>
             <a:r>
-              <a:t>Financial Intelligence Capabilities Active in ProcureFlow Reporting Hub:</a:t>
+              <a:t>3-Tier Delegation of Authority</a:t>
             </a:r>
           </a:p>
           <a:p>
@@ -7915,22 +7297,22 @@
               </a:spcAft>
             </a:pPr>
             <a:r>
-              <a:rPr sz="1050" b="1">
+              <a:rPr sz="1000" b="1">
                 <a:solidFill>
                   <a:srgbClr val="0F172A"/>
                 </a:solidFill>
                 <a:latin typeface="Segoe UI"/>
               </a:rPr>
-              <a:t>• 2D Cross-Tabulation Matrix: </a:t>
-            </a:r>
-            <a:r>
-              <a:rPr sz="1050">
+              <a:t>✓ Tier 1 (Site Manager): </a:t>
+            </a:r>
+            <a:r>
+              <a:rPr sz="1000">
                 <a:solidFill>
                   <a:srgbClr val="475569"/>
                 </a:solidFill>
                 <a:latin typeface="Segoe UI"/>
               </a:rPr>
-              <a:t>Natively replicates Ashish's Concur EOM Pivot (Branch × Sector: Accommodation/Healthcare × Reason: Depletion/New Business/Linen Hub) excluding GST (Total / 1.1).</a:t>
+              <a:t>Approves routine weekly depletion spend within local branch limits.</a:t>
             </a:r>
           </a:p>
           <a:p>
@@ -7940,22 +7322,22 @@
               </a:spcAft>
             </a:pPr>
             <a:r>
-              <a:rPr sz="1050" b="1">
+              <a:rPr sz="1000" b="1">
                 <a:solidFill>
                   <a:srgbClr val="0F172A"/>
                 </a:solidFill>
                 <a:latin typeface="Segoe UI"/>
               </a:rPr>
-              <a:t>• 100% Classification Precision: </a:t>
-            </a:r>
-            <a:r>
-              <a:rPr sz="1050">
+              <a:t>✓ Tier 2 (Ashish Chhabra): </a:t>
+            </a:r>
+            <a:r>
+              <a:rPr sz="1000">
                 <a:solidFill>
                   <a:srgbClr val="475569"/>
                 </a:solidFill>
                 <a:latin typeface="Segoe UI"/>
               </a:rPr>
-              <a:t>Automated legacy PO parser classifies unstandardised legacy PO strings with 100.0% parity against historical Concur records.</a:t>
+              <a:t>Procurement Lead audits pack multiples, pricing parity, and spend reason (Depletion vs NB).</a:t>
             </a:r>
           </a:p>
           <a:p>
@@ -7965,22 +7347,22 @@
               </a:spcAft>
             </a:pPr>
             <a:r>
-              <a:rPr sz="1050" b="1">
+              <a:rPr sz="1000" b="1">
                 <a:solidFill>
                   <a:srgbClr val="0F172A"/>
                 </a:solidFill>
                 <a:latin typeface="Segoe UI"/>
               </a:rPr>
-              <a:t>• Branch Budget Tracking Grid: </a:t>
-            </a:r>
-            <a:r>
-              <a:rPr sz="1050">
+              <a:t>✓ Tier 3 (Ebrahim Mokhtari): </a:t>
+            </a:r>
+            <a:r>
+              <a:rPr sz="1000">
                 <a:solidFill>
                   <a:srgbClr val="475569"/>
                 </a:solidFill>
                 <a:latin typeface="Segoe UI"/>
               </a:rPr>
-              <a:t>Tracks monthly and YTD spend vs baseline budgets across all 8 operating entities (Melbourne $2.65M, Sydney $2.78M, Adelaide $920k, Brisbane $1.03M, Cairns $706k, Mackay $349k, Perth $996k, Albury $481k).</a:t>
+              <a:t>COO approves high-value orders (&gt;$50k), new customer injections, and unbudgeted exceptions.</a:t>
             </a:r>
           </a:p>
           <a:p>
@@ -7990,72 +7372,22 @@
               </a:spcAft>
             </a:pPr>
             <a:r>
-              <a:rPr sz="1050" b="1">
+              <a:rPr sz="1000" b="1">
                 <a:solidFill>
                   <a:srgbClr val="0F172A"/>
                 </a:solidFill>
                 <a:latin typeface="Segoe UI"/>
               </a:rPr>
-              <a:t>• Dedicated Linen Hub Pool: </a:t>
-            </a:r>
-            <a:r>
-              <a:rPr sz="1050">
+              <a:t>✓ Why It Works: </a:t>
+            </a:r>
+            <a:r>
+              <a:rPr sz="1000">
                 <a:solidFill>
                   <a:srgbClr val="475569"/>
                 </a:solidFill>
                 <a:latin typeface="Segoe UI"/>
               </a:rPr>
-              <a:t>Maintains continuous decrement balance tracking against the dedicated $2.30M linen injection reserve.</a:t>
-            </a:r>
-          </a:p>
-          <a:p>
-            <a:pPr>
-              <a:spcAft>
-                <a:spcPts val="600"/>
-              </a:spcAft>
-            </a:pPr>
-            <a:r>
-              <a:rPr sz="1050" b="1">
-                <a:solidFill>
-                  <a:srgbClr val="0F172A"/>
-                </a:solidFill>
-                <a:latin typeface="Segoe UI"/>
-              </a:rPr>
-              <a:t>• Strategic Contract Breakouts: </a:t>
-            </a:r>
-            <a:r>
-              <a:rPr sz="1050">
-                <a:solidFill>
-                  <a:srgbClr val="475569"/>
-                </a:solidFill>
-                <a:latin typeface="Segoe UI"/>
-              </a:rPr>
-              <a:t>Real-time visibility into HealthShare Victoria (HSV) and Ramsay Health Care (RHC) contract spend.</a:t>
-            </a:r>
-          </a:p>
-          <a:p>
-            <a:pPr>
-              <a:spcAft>
-                <a:spcPts val="600"/>
-              </a:spcAft>
-            </a:pPr>
-            <a:r>
-              <a:rPr sz="1050" b="1">
-                <a:solidFill>
-                  <a:srgbClr val="0F172A"/>
-                </a:solidFill>
-                <a:latin typeface="Segoe UI"/>
-              </a:rPr>
-              <a:t>• 1-Click Concur EOM Export: </a:t>
-            </a:r>
-            <a:r>
-              <a:rPr sz="1050">
-                <a:solidFill>
-                  <a:srgbClr val="475569"/>
-                </a:solidFill>
-                <a:latin typeface="Segoe UI"/>
-              </a:rPr>
-              <a:t>Generates formatted leadership-ready Excel CSV reconciliation files instantly.</a:t>
+              <a:t>Embeds corporate DOA rules directly into software, displaying GST-inc totals and audit remarks.</a:t>
             </a:r>
           </a:p>
         </p:txBody>

</xml_diff>

<commit_message>
feat(mobile): fix requests scrolling on mobile & update action plan and slides to v3.0 following 2pm review
</commit_message>
<xml_diff>
--- a/docs/ProcureFlow_Executive_Roadmap.pptx
+++ b/docs/ProcureFlow_Executive_Roadmap.pptx
@@ -3174,7 +3174,7 @@
               </a:defRPr>
             </a:pPr>
             <a:r>
-              <a:t>SOUTH PACIFIC LAUNDRY  |  EXECUTIVE STRATEGIC REVIEW</a:t>
+              <a:t>SOUTH PACIFIC LAUNDRY  |  EXECUTIVE REVIEW</a:t>
             </a:r>
           </a:p>
           <a:p>
@@ -3190,11 +3190,11 @@
               </a:defRPr>
             </a:pPr>
             <a:r>
-              <a:t>ProcureFlow: Operational Excellence &amp;</a:t>
+              <a:t>ProcureFlow: Operational Achievements,</a:t>
             </a:r>
             <a:br/>
             <a:r>
-              <a:t>Targeted Governance Enhancements</a:t>
+              <a:t>Governance &amp; Strategic Forward Pipeline</a:t>
             </a:r>
           </a:p>
           <a:p>
@@ -3210,7 +3210,7 @@
               </a:defRPr>
             </a:pPr>
             <a:r>
-              <a:t>Current Operational Strengths  •  Continuous Improvement Roadmap  •  Frictionless BAU Integration</a:t>
+              <a:t>Completed Achievements (Last 3 Months)  •  Targeted Elevation  •  Forward Pipeline (Next 2 Months)</a:t>
             </a:r>
           </a:p>
         </p:txBody>
@@ -3249,12 +3249,12 @@
               </a:defRPr>
             </a:pPr>
             <a:r>
-              <a:t>KEY GOVERNANCE STAKEHOLDERS:</a:t>
-            </a:r>
-          </a:p>
-          <a:p>
-            <a:pPr>
-              <a:defRPr sz="1300" b="1">
+              <a:t>EXECUTIVE COMMITTEE &amp; MEETING ALIGNMENT:</a:t>
+            </a:r>
+          </a:p>
+          <a:p>
+            <a:pPr>
+              <a:defRPr sz="1250" b="1">
                 <a:solidFill>
                   <a:srgbClr val="FFFFFF"/>
                 </a:solidFill>
@@ -3262,7 +3262,11 @@
               </a:defRPr>
             </a:pPr>
             <a:r>
-              <a:t>Ebrahim Mokhtari (Chief Operating Officer)   |   Ashish Chhabra (Procurement Lead / Super User)   |   Aaron Bell (Tech Lead)</a:t>
+              <a:t>Ebrahim Mokhtari (COO)   |   Ashish Chhabra (Procurement Lead)   |   Aaron Bell (Tech Lead)</a:t>
+            </a:r>
+            <a:br/>
+            <a:r>
+              <a:t>Executive Workshop: Thursday, September 3, 2026 @ 10:00 AM</a:t>
             </a:r>
           </a:p>
         </p:txBody>
@@ -3319,7 +3323,7 @@
               </a:defRPr>
             </a:pPr>
             <a:r>
-              <a:t>STRATEGIC ASSURANCE</a:t>
+              <a:t>SITE EXPANSION ROADMAP</a:t>
             </a:r>
           </a:p>
           <a:p>
@@ -3332,7 +3336,7 @@
               </a:defRPr>
             </a:pPr>
             <a:r>
-              <a:t>Summary: Executive Confidence in a Self-Governing Platform</a:t>
+              <a:t>Adelaide Rollout Blueprint: Scalable 4-Phase Implementation Template</a:t>
             </a:r>
           </a:p>
         </p:txBody>
@@ -3346,7 +3350,7 @@
         <p:spPr>
           <a:xfrm>
             <a:off x="731520" y="1463040"/>
-            <a:ext cx="10728655" cy="4754880"/>
+            <a:ext cx="2468880" cy="4754880"/>
           </a:xfrm>
           <a:prstGeom prst="roundRect">
             <a:avLst/>
@@ -3390,8 +3394,8 @@
         </p:nvSpPr>
         <p:spPr>
           <a:xfrm>
-            <a:off x="1005840" y="1691640"/>
-            <a:ext cx="10180015" cy="4297680"/>
+            <a:off x="914400" y="1691640"/>
+            <a:ext cx="2103120" cy="4297680"/>
           </a:xfrm>
           <a:prstGeom prst="rect">
             <a:avLst/>
@@ -3406,17 +3410,33 @@
           <a:p>
             <a:pPr>
               <a:spcAft>
+                <a:spcPts val="600"/>
+              </a:spcAft>
+              <a:defRPr sz="950" b="1">
+                <a:solidFill>
+                  <a:srgbClr val="0284C7"/>
+                </a:solidFill>
+                <a:latin typeface="Segoe UI"/>
+              </a:defRPr>
+            </a:pPr>
+            <a:r>
+              <a:t>PHASE 1 (WEEK 1)</a:t>
+            </a:r>
+          </a:p>
+          <a:p>
+            <a:pPr>
+              <a:spcAft>
                 <a:spcPts val="1400"/>
               </a:spcAft>
-              <a:defRPr sz="1800" b="1">
-                <a:solidFill>
-                  <a:srgbClr val="0284C7"/>
-                </a:solidFill>
-                <a:latin typeface="Segoe UI"/>
-              </a:defRPr>
-            </a:pPr>
-            <a:r>
-              <a:t>A Working Platform Elevated to Permanent BAU Excellence</a:t>
+              <a:defRPr sz="1300" b="1">
+                <a:solidFill>
+                  <a:srgbClr val="0F172A"/>
+                </a:solidFill>
+                <a:latin typeface="Segoe UI"/>
+              </a:defRPr>
+            </a:pPr>
+            <a:r>
+              <a:t>Master Setup &amp; Provisioning</a:t>
             </a:r>
           </a:p>
           <a:p>
@@ -3426,22 +3446,177 @@
               </a:spcAft>
             </a:pPr>
             <a:r>
-              <a:rPr sz="1100" b="1">
+              <a:rPr sz="1000">
+                <a:solidFill>
+                  <a:srgbClr val="475569"/>
+                </a:solidFill>
+                <a:latin typeface="Segoe UI"/>
+              </a:rPr>
+              <a:t>• Configure delivery addresses and vendor account links for Adelaide.</a:t>
+            </a:r>
+          </a:p>
+          <a:p>
+            <a:pPr>
+              <a:spcAft>
+                <a:spcPts val="1000"/>
+              </a:spcAft>
+            </a:pPr>
+            <a:r>
+              <a:rPr sz="1000">
+                <a:solidFill>
+                  <a:srgbClr val="475569"/>
+                </a:solidFill>
+                <a:latin typeface="Segoe UI"/>
+              </a:rPr>
+              <a:t>• Adelaide catalog SKU filtering &amp; pricing schedules.</a:t>
+            </a:r>
+          </a:p>
+          <a:p>
+            <a:pPr>
+              <a:spcAft>
+                <a:spcPts val="1000"/>
+              </a:spcAft>
+            </a:pPr>
+            <a:r>
+              <a:rPr sz="1000">
+                <a:solidFill>
+                  <a:srgbClr val="475569"/>
+                </a:solidFill>
+                <a:latin typeface="Segoe UI"/>
+              </a:rPr>
+              <a:t>• Provision user accounts (Site Manager, Requesters, Receivers).</a:t>
+            </a:r>
+          </a:p>
+        </p:txBody>
+      </p:sp>
+      <p:sp>
+        <p:nvSpPr>
+          <p:cNvPr id="5" name="Rounded Rectangle 4"/>
+          <p:cNvSpPr/>
+          <p:nvPr/>
+        </p:nvSpPr>
+        <p:spPr>
+          <a:xfrm>
+            <a:off x="3566160" y="1463040"/>
+            <a:ext cx="2468880" cy="4754880"/>
+          </a:xfrm>
+          <a:prstGeom prst="roundRect">
+            <a:avLst/>
+          </a:prstGeom>
+          <a:solidFill>
+            <a:srgbClr val="FFFFFF"/>
+          </a:solidFill>
+          <a:ln w="15240">
+            <a:solidFill>
+              <a:srgbClr val="E2E8F0"/>
+            </a:solidFill>
+          </a:ln>
+        </p:spPr>
+        <p:style>
+          <a:lnRef idx="1">
+            <a:schemeClr val="accent1"/>
+          </a:lnRef>
+          <a:fillRef idx="3">
+            <a:schemeClr val="accent1"/>
+          </a:fillRef>
+          <a:effectRef idx="2">
+            <a:schemeClr val="accent1"/>
+          </a:effectRef>
+          <a:fontRef idx="minor">
+            <a:schemeClr val="lt1"/>
+          </a:fontRef>
+        </p:style>
+        <p:txBody>
+          <a:bodyPr rtlCol="0" anchor="ctr"/>
+          <a:lstStyle/>
+          <a:p>
+            <a:pPr algn="ctr"/>
+          </a:p>
+        </p:txBody>
+      </p:sp>
+      <p:sp>
+        <p:nvSpPr>
+          <p:cNvPr id="6" name="TextBox 5"/>
+          <p:cNvSpPr txBox="1"/>
+          <p:nvPr/>
+        </p:nvSpPr>
+        <p:spPr>
+          <a:xfrm>
+            <a:off x="3749040" y="1691640"/>
+            <a:ext cx="2103120" cy="4297680"/>
+          </a:xfrm>
+          <a:prstGeom prst="rect">
+            <a:avLst/>
+          </a:prstGeom>
+          <a:noFill/>
+        </p:spPr>
+        <p:txBody>
+          <a:bodyPr wrap="square">
+            <a:spAutoFit/>
+          </a:bodyPr>
+          <a:lstStyle/>
+          <a:p>
+            <a:pPr>
+              <a:spcAft>
+                <a:spcPts val="600"/>
+              </a:spcAft>
+              <a:defRPr sz="950" b="1">
+                <a:solidFill>
+                  <a:srgbClr val="9333EA"/>
+                </a:solidFill>
+                <a:latin typeface="Segoe UI"/>
+              </a:defRPr>
+            </a:pPr>
+            <a:r>
+              <a:t>PHASE 2 (WEEK 2)</a:t>
+            </a:r>
+          </a:p>
+          <a:p>
+            <a:pPr>
+              <a:spcAft>
+                <a:spcPts val="1400"/>
+              </a:spcAft>
+              <a:defRPr sz="1300" b="1">
                 <a:solidFill>
                   <a:srgbClr val="0F172A"/>
                 </a:solidFill>
                 <a:latin typeface="Segoe UI"/>
+              </a:defRPr>
+            </a:pPr>
+            <a:r>
+              <a:t>Governance &amp; Video Training</a:t>
+            </a:r>
+          </a:p>
+          <a:p>
+            <a:pPr>
+              <a:spcAft>
+                <a:spcPts val="1000"/>
+              </a:spcAft>
+            </a:pPr>
+            <a:r>
+              <a:rPr sz="1000">
+                <a:solidFill>
+                  <a:srgbClr val="475569"/>
+                </a:solidFill>
+                <a:latin typeface="Segoe UI"/>
               </a:rPr>
-              <a:t>★ Proven Reliability: </a:t>
-            </a:r>
-            <a:r>
-              <a:rPr sz="1100">
+              <a:t>• Distribute standardized ProcureFlow training video to Adelaide team.</a:t>
+            </a:r>
+          </a:p>
+          <a:p>
+            <a:pPr>
+              <a:spcAft>
+                <a:spcPts val="1000"/>
+              </a:spcAft>
+            </a:pPr>
+            <a:r>
+              <a:rPr sz="1000">
                 <a:solidFill>
                   <a:srgbClr val="475569"/>
                 </a:solidFill>
                 <a:latin typeface="Segoe UI"/>
               </a:rPr>
-              <a:t>ProcureFlow already manages daily purchasing across 8 laundry sites, 100% of SKUs are mapped, and digital goods receipting is firmly established.</a:t>
+              <a:t>• Enforce mandatory user sign-off tracking before activating ordering access.</a:t>
             </a:r>
           </a:p>
           <a:p>
@@ -3451,22 +3626,145 @@
               </a:spcAft>
             </a:pPr>
             <a:r>
-              <a:rPr sz="1100" b="1">
+              <a:rPr sz="1000">
+                <a:solidFill>
+                  <a:srgbClr val="475569"/>
+                </a:solidFill>
+                <a:latin typeface="Segoe UI"/>
+              </a:rPr>
+              <a:t>• Hands-on walkthrough with Adelaide site operations.</a:t>
+            </a:r>
+          </a:p>
+        </p:txBody>
+      </p:sp>
+      <p:sp>
+        <p:nvSpPr>
+          <p:cNvPr id="7" name="Rounded Rectangle 6"/>
+          <p:cNvSpPr/>
+          <p:nvPr/>
+        </p:nvSpPr>
+        <p:spPr>
+          <a:xfrm>
+            <a:off x="6400800" y="1463040"/>
+            <a:ext cx="2468880" cy="4754880"/>
+          </a:xfrm>
+          <a:prstGeom prst="roundRect">
+            <a:avLst/>
+          </a:prstGeom>
+          <a:solidFill>
+            <a:srgbClr val="FFFFFF"/>
+          </a:solidFill>
+          <a:ln w="15240">
+            <a:solidFill>
+              <a:srgbClr val="E2E8F0"/>
+            </a:solidFill>
+          </a:ln>
+        </p:spPr>
+        <p:style>
+          <a:lnRef idx="1">
+            <a:schemeClr val="accent1"/>
+          </a:lnRef>
+          <a:fillRef idx="3">
+            <a:schemeClr val="accent1"/>
+          </a:fillRef>
+          <a:effectRef idx="2">
+            <a:schemeClr val="accent1"/>
+          </a:effectRef>
+          <a:fontRef idx="minor">
+            <a:schemeClr val="lt1"/>
+          </a:fontRef>
+        </p:style>
+        <p:txBody>
+          <a:bodyPr rtlCol="0" anchor="ctr"/>
+          <a:lstStyle/>
+          <a:p>
+            <a:pPr algn="ctr"/>
+          </a:p>
+        </p:txBody>
+      </p:sp>
+      <p:sp>
+        <p:nvSpPr>
+          <p:cNvPr id="8" name="TextBox 7"/>
+          <p:cNvSpPr txBox="1"/>
+          <p:nvPr/>
+        </p:nvSpPr>
+        <p:spPr>
+          <a:xfrm>
+            <a:off x="6583680" y="1691640"/>
+            <a:ext cx="2103120" cy="4297680"/>
+          </a:xfrm>
+          <a:prstGeom prst="rect">
+            <a:avLst/>
+          </a:prstGeom>
+          <a:noFill/>
+        </p:spPr>
+        <p:txBody>
+          <a:bodyPr wrap="square">
+            <a:spAutoFit/>
+          </a:bodyPr>
+          <a:lstStyle/>
+          <a:p>
+            <a:pPr>
+              <a:spcAft>
+                <a:spcPts val="600"/>
+              </a:spcAft>
+              <a:defRPr sz="950" b="1">
+                <a:solidFill>
+                  <a:srgbClr val="D97706"/>
+                </a:solidFill>
+                <a:latin typeface="Segoe UI"/>
+              </a:defRPr>
+            </a:pPr>
+            <a:r>
+              <a:t>PHASE 3 (WEEKS 3–4)</a:t>
+            </a:r>
+          </a:p>
+          <a:p>
+            <a:pPr>
+              <a:spcAft>
+                <a:spcPts val="1400"/>
+              </a:spcAft>
+              <a:defRPr sz="1300" b="1">
                 <a:solidFill>
                   <a:srgbClr val="0F172A"/>
                 </a:solidFill>
                 <a:latin typeface="Segoe UI"/>
+              </a:defRPr>
+            </a:pPr>
+            <a:r>
+              <a:t>Shadow Requisitions &amp; DOA</a:t>
+            </a:r>
+          </a:p>
+          <a:p>
+            <a:pPr>
+              <a:spcAft>
+                <a:spcPts val="1000"/>
+              </a:spcAft>
+            </a:pPr>
+            <a:r>
+              <a:rPr sz="1000">
+                <a:solidFill>
+                  <a:srgbClr val="475569"/>
+                </a:solidFill>
+                <a:latin typeface="Segoe UI"/>
               </a:rPr>
-              <a:t>★ Zero Human Friction: </a:t>
-            </a:r>
-            <a:r>
-              <a:rPr sz="1100">
+              <a:t>• 2-week parallel ordering period to validate local site behavior.</a:t>
+            </a:r>
+          </a:p>
+          <a:p>
+            <a:pPr>
+              <a:spcAft>
+                <a:spcPts val="1000"/>
+              </a:spcAft>
+            </a:pPr>
+            <a:r>
+              <a:rPr sz="1000">
                 <a:solidFill>
                   <a:srgbClr val="475569"/>
                 </a:solidFill>
                 <a:latin typeface="Segoe UI"/>
               </a:rPr>
-              <a:t>Point-of-entry packaging modulo rules and contract price lookups stop requisition errors before submission.</a:t>
+              <a:t>• Verify carton multiple adherence and price validation rules.</a:t>
             </a:r>
           </a:p>
           <a:p>
@@ -3476,22 +3774,145 @@
               </a:spcAft>
             </a:pPr>
             <a:r>
-              <a:rPr sz="1100" b="1">
+              <a:rPr sz="1000">
+                <a:solidFill>
+                  <a:srgbClr val="475569"/>
+                </a:solidFill>
+                <a:latin typeface="Segoe UI"/>
+              </a:rPr>
+              <a:t>• Calibrate DOA approval thresholds with Ashish Chhabra.</a:t>
+            </a:r>
+          </a:p>
+        </p:txBody>
+      </p:sp>
+      <p:sp>
+        <p:nvSpPr>
+          <p:cNvPr id="9" name="Rounded Rectangle 8"/>
+          <p:cNvSpPr/>
+          <p:nvPr/>
+        </p:nvSpPr>
+        <p:spPr>
+          <a:xfrm>
+            <a:off x="9235440" y="1463040"/>
+            <a:ext cx="2468880" cy="4754880"/>
+          </a:xfrm>
+          <a:prstGeom prst="roundRect">
+            <a:avLst/>
+          </a:prstGeom>
+          <a:solidFill>
+            <a:srgbClr val="FFFFFF"/>
+          </a:solidFill>
+          <a:ln w="15240">
+            <a:solidFill>
+              <a:srgbClr val="E2E8F0"/>
+            </a:solidFill>
+          </a:ln>
+        </p:spPr>
+        <p:style>
+          <a:lnRef idx="1">
+            <a:schemeClr val="accent1"/>
+          </a:lnRef>
+          <a:fillRef idx="3">
+            <a:schemeClr val="accent1"/>
+          </a:fillRef>
+          <a:effectRef idx="2">
+            <a:schemeClr val="accent1"/>
+          </a:effectRef>
+          <a:fontRef idx="minor">
+            <a:schemeClr val="lt1"/>
+          </a:fontRef>
+        </p:style>
+        <p:txBody>
+          <a:bodyPr rtlCol="0" anchor="ctr"/>
+          <a:lstStyle/>
+          <a:p>
+            <a:pPr algn="ctr"/>
+          </a:p>
+        </p:txBody>
+      </p:sp>
+      <p:sp>
+        <p:nvSpPr>
+          <p:cNvPr id="10" name="TextBox 9"/>
+          <p:cNvSpPr txBox="1"/>
+          <p:nvPr/>
+        </p:nvSpPr>
+        <p:spPr>
+          <a:xfrm>
+            <a:off x="9418320" y="1691640"/>
+            <a:ext cx="2103120" cy="4297680"/>
+          </a:xfrm>
+          <a:prstGeom prst="rect">
+            <a:avLst/>
+          </a:prstGeom>
+          <a:noFill/>
+        </p:spPr>
+        <p:txBody>
+          <a:bodyPr wrap="square">
+            <a:spAutoFit/>
+          </a:bodyPr>
+          <a:lstStyle/>
+          <a:p>
+            <a:pPr>
+              <a:spcAft>
+                <a:spcPts val="600"/>
+              </a:spcAft>
+              <a:defRPr sz="950" b="1">
+                <a:solidFill>
+                  <a:srgbClr val="059669"/>
+                </a:solidFill>
+                <a:latin typeface="Segoe UI"/>
+              </a:defRPr>
+            </a:pPr>
+            <a:r>
+              <a:t>PHASE 4 (WEEK 5)</a:t>
+            </a:r>
+          </a:p>
+          <a:p>
+            <a:pPr>
+              <a:spcAft>
+                <a:spcPts val="1400"/>
+              </a:spcAft>
+              <a:defRPr sz="1300" b="1">
                 <a:solidFill>
                   <a:srgbClr val="0F172A"/>
                 </a:solidFill>
                 <a:latin typeface="Segoe UI"/>
+              </a:defRPr>
+            </a:pPr>
+            <a:r>
+              <a:t>Full Production Cutover</a:t>
+            </a:r>
+          </a:p>
+          <a:p>
+            <a:pPr>
+              <a:spcAft>
+                <a:spcPts val="1000"/>
+              </a:spcAft>
+            </a:pPr>
+            <a:r>
+              <a:rPr sz="1000">
+                <a:solidFill>
+                  <a:srgbClr val="475569"/>
+                </a:solidFill>
+                <a:latin typeface="Segoe UI"/>
               </a:rPr>
-              <a:t>★ Closed-Loop ERP Parity: </a:t>
-            </a:r>
-            <a:r>
-              <a:rPr sz="1100">
+              <a:t>• 100% cutover of Adelaide linen purchasing into ProcureFlow.</a:t>
+            </a:r>
+          </a:p>
+          <a:p>
+            <a:pPr>
+              <a:spcAft>
+                <a:spcPts val="1000"/>
+              </a:spcAft>
+            </a:pPr>
+            <a:r>
+              <a:rPr sz="1000">
                 <a:solidFill>
                   <a:srgbClr val="475569"/>
                 </a:solidFill>
                 <a:latin typeface="Segoe UI"/>
               </a:rPr>
-              <a:t>Mandatory Concur PR # enforcement guarantees 100% 1-to-1 data mirroring between ProcureFlow and SAP Concur.</a:t>
+              <a:t>• Mandatory Concur PR # linkage enforced on all receipts.</a:t>
             </a:r>
           </a:p>
           <a:p>
@@ -3501,47 +3922,13 @@
               </a:spcAft>
             </a:pPr>
             <a:r>
-              <a:rPr sz="1100" b="1">
-                <a:solidFill>
-                  <a:srgbClr val="0F172A"/>
+              <a:rPr sz="1000">
+                <a:solidFill>
+                  <a:srgbClr val="475569"/>
                 </a:solidFill>
                 <a:latin typeface="Segoe UI"/>
               </a:rPr>
-              <a:t>★ Proactive Operational Discipline: </a:t>
-            </a:r>
-            <a:r>
-              <a:rPr sz="1100">
-                <a:solidFill>
-                  <a:srgbClr val="475569"/>
-                </a:solidFill>
-                <a:latin typeface="Segoe UI"/>
-              </a:rPr>
-              <a:t>Automated closure nudges and tiered line manager escalations eliminate lingering open commitments and overdue shipments.</a:t>
-            </a:r>
-          </a:p>
-          <a:p>
-            <a:pPr>
-              <a:spcAft>
-                <a:spcPts val="1000"/>
-              </a:spcAft>
-            </a:pPr>
-            <a:r>
-              <a:rPr sz="1100" b="1">
-                <a:solidFill>
-                  <a:srgbClr val="0F172A"/>
-                </a:solidFill>
-                <a:latin typeface="Segoe UI"/>
-              </a:rPr>
-              <a:t>★ Single Source of Truth: </a:t>
-            </a:r>
-            <a:r>
-              <a:rPr sz="1100">
-                <a:solidFill>
-                  <a:srgbClr val="475569"/>
-                </a:solidFill>
-                <a:latin typeface="Segoe UI"/>
-              </a:rPr>
-              <a:t>Real-time 2D Pivot Table and FY27 budget tracking ($14.521M) provide leadership with immediate, unchallengeable financial clarity.</a:t>
+              <a:t>• Complete retirement of manual email/paper ordering channels.</a:t>
             </a:r>
           </a:p>
         </p:txBody>
@@ -3695,7 +4082,7 @@
               </a:defRPr>
             </a:pPr>
             <a:r>
-              <a:t>1. PROVEN WORKING PLATFORM</a:t>
+              <a:t>1. WORKING PLATFORM</a:t>
             </a:r>
           </a:p>
           <a:p>
@@ -3711,7 +4098,7 @@
               </a:defRPr>
             </a:pPr>
             <a:r>
-              <a:t>A Stable Daily Engine</a:t>
+              <a:t>Proven Daily Engine</a:t>
             </a:r>
           </a:p>
           <a:p>
@@ -3721,22 +4108,29 @@
               </a:spcAft>
             </a:pPr>
             <a:r>
-              <a:rPr sz="1050" b="1">
-                <a:solidFill>
-                  <a:srgbClr val="0F172A"/>
+              <a:rPr sz="1050">
+                <a:solidFill>
+                  <a:srgbClr val="334155"/>
                 </a:solidFill>
                 <a:latin typeface="Segoe UI"/>
               </a:rPr>
-              <a:t>• Active Daily Requisitioning:</a:t>
-            </a:r>
+              <a:t>• Runs daily purchasing across 11 operating facilities nationally.</a:t>
+            </a:r>
+          </a:p>
+          <a:p>
+            <a:pPr>
+              <a:spcAft>
+                <a:spcPts val="1000"/>
+              </a:spcAft>
+            </a:pPr>
             <a:r>
               <a:rPr sz="1050">
                 <a:solidFill>
-                  <a:srgbClr val="475569"/>
+                  <a:srgbClr val="334155"/>
                 </a:solidFill>
                 <a:latin typeface="Segoe UI"/>
               </a:rPr>
-              <a:t> Runs daily ordering across all 8 regional laundry branches.</a:t>
+              <a:t>• 100% SKU mapping achieved by Aaron Bell, Ashish Chhabra &amp; Kiran.</a:t>
             </a:r>
           </a:p>
           <a:p>
@@ -3746,72 +4140,29 @@
               </a:spcAft>
             </a:pPr>
             <a:r>
-              <a:rPr sz="1050" b="1">
-                <a:solidFill>
-                  <a:srgbClr val="0F172A"/>
+              <a:rPr sz="1050">
+                <a:solidFill>
+                  <a:srgbClr val="334155"/>
                 </a:solidFill>
                 <a:latin typeface="Segoe UI"/>
               </a:rPr>
-              <a:t>• 100% Master Item Mapping:</a:t>
-            </a:r>
+              <a:t>• On-site digital goods receipting (GR) and docket capture active.</a:t>
+            </a:r>
+          </a:p>
+          <a:p>
+            <a:pPr>
+              <a:spcAft>
+                <a:spcPts val="1000"/>
+              </a:spcAft>
+            </a:pPr>
             <a:r>
               <a:rPr sz="1050">
                 <a:solidFill>
-                  <a:srgbClr val="475569"/>
+                  <a:srgbClr val="334155"/>
                 </a:solidFill>
                 <a:latin typeface="Segoe UI"/>
               </a:rPr>
-              <a:t> All internal SPL codes mapped 1-to-1 to vendor catalog SKUs.</a:t>
-            </a:r>
-          </a:p>
-          <a:p>
-            <a:pPr>
-              <a:spcAft>
-                <a:spcPts val="1000"/>
-              </a:spcAft>
-            </a:pPr>
-            <a:r>
-              <a:rPr sz="1050" b="1">
-                <a:solidFill>
-                  <a:srgbClr val="0F172A"/>
-                </a:solidFill>
-                <a:latin typeface="Segoe UI"/>
-              </a:rPr>
-              <a:t>• Physical Receiving &amp; Docket Capture:</a:t>
-            </a:r>
-            <a:r>
-              <a:rPr sz="1050">
-                <a:solidFill>
-                  <a:srgbClr val="475569"/>
-                </a:solidFill>
-                <a:latin typeface="Segoe UI"/>
-              </a:rPr>
-              <a:t> On-site digital goods receipting (GR) actively enforced.</a:t>
-            </a:r>
-          </a:p>
-          <a:p>
-            <a:pPr>
-              <a:spcAft>
-                <a:spcPts val="1000"/>
-              </a:spcAft>
-            </a:pPr>
-            <a:r>
-              <a:rPr sz="1050" b="1">
-                <a:solidFill>
-                  <a:srgbClr val="0F172A"/>
-                </a:solidFill>
-                <a:latin typeface="Segoe UI"/>
-              </a:rPr>
-              <a:t>• High User Adoption:</a:t>
-            </a:r>
-            <a:r>
-              <a:rPr sz="1050">
-                <a:solidFill>
-                  <a:srgbClr val="475569"/>
-                </a:solidFill>
-                <a:latin typeface="Segoe UI"/>
-              </a:rPr>
-              <a:t> Embedded across site managers, warehouse receivers, and procurement.</a:t>
+              <a:t>• High adoption across site managers, plant supervisors &amp; procurement.</a:t>
             </a:r>
           </a:p>
         </p:txBody>
@@ -3895,7 +4246,7 @@
               </a:defRPr>
             </a:pPr>
             <a:r>
-              <a:t>2. THE TARGET OF THIS PLAN</a:t>
+              <a:t>2. TARGET OF THIS PLAN</a:t>
             </a:r>
           </a:p>
           <a:p>
@@ -3921,22 +4272,29 @@
               </a:spcAft>
             </a:pPr>
             <a:r>
-              <a:rPr sz="1050" b="1">
-                <a:solidFill>
-                  <a:srgbClr val="0F172A"/>
+              <a:rPr sz="1050">
+                <a:solidFill>
+                  <a:srgbClr val="334155"/>
                 </a:solidFill>
                 <a:latin typeface="Segoe UI"/>
               </a:rPr>
-              <a:t>• Not 'Fixing' a Broken Tool:</a:t>
-            </a:r>
+              <a:t>• Not 'fixing' a broken tool: ProcureFlow already runs reliably.</a:t>
+            </a:r>
+          </a:p>
+          <a:p>
+            <a:pPr>
+              <a:spcAft>
+                <a:spcPts val="1000"/>
+              </a:spcAft>
+            </a:pPr>
             <a:r>
               <a:rPr sz="1050">
                 <a:solidFill>
-                  <a:srgbClr val="475569"/>
+                  <a:srgbClr val="334155"/>
                 </a:solidFill>
                 <a:latin typeface="Segoe UI"/>
               </a:rPr>
-              <a:t> ProcureFlow already works reliably and securely.</a:t>
+              <a:t>• Eliminating human friction: Removing manual Excel crunching and packaging typos.</a:t>
             </a:r>
           </a:p>
           <a:p>
@@ -3946,72 +4304,29 @@
               </a:spcAft>
             </a:pPr>
             <a:r>
-              <a:rPr sz="1050" b="1">
-                <a:solidFill>
-                  <a:srgbClr val="0F172A"/>
+              <a:rPr sz="1050">
+                <a:solidFill>
+                  <a:srgbClr val="334155"/>
                 </a:solidFill>
                 <a:latin typeface="Segoe UI"/>
               </a:rPr>
-              <a:t>• Eliminating Human Friction:</a:t>
-            </a:r>
+              <a:t>• Point-of-entry guardrails: Guiding users to zero-defect ordering at the source.</a:t>
+            </a:r>
+          </a:p>
+          <a:p>
+            <a:pPr>
+              <a:spcAft>
+                <a:spcPts val="1000"/>
+              </a:spcAft>
+            </a:pPr>
             <a:r>
               <a:rPr sz="1050">
                 <a:solidFill>
-                  <a:srgbClr val="475569"/>
+                  <a:srgbClr val="334155"/>
                 </a:solidFill>
                 <a:latin typeface="Segoe UI"/>
               </a:rPr>
-              <a:t> Removing remaining manual Excel crunching and packaging typos.</a:t>
-            </a:r>
-          </a:p>
-          <a:p>
-            <a:pPr>
-              <a:spcAft>
-                <a:spcPts val="1000"/>
-              </a:spcAft>
-            </a:pPr>
-            <a:r>
-              <a:rPr sz="1050" b="1">
-                <a:solidFill>
-                  <a:srgbClr val="0F172A"/>
-                </a:solidFill>
-                <a:latin typeface="Segoe UI"/>
-              </a:rPr>
-              <a:t>• Automated Guardrails:</a:t>
-            </a:r>
-            <a:r>
-              <a:rPr sz="1050">
-                <a:solidFill>
-                  <a:srgbClr val="475569"/>
-                </a:solidFill>
-                <a:latin typeface="Segoe UI"/>
-              </a:rPr>
-              <a:t> Guiding users naturally to zero-defect ordering at the source.</a:t>
-            </a:r>
-          </a:p>
-          <a:p>
-            <a:pPr>
-              <a:spcAft>
-                <a:spcPts val="1000"/>
-              </a:spcAft>
-            </a:pPr>
-            <a:r>
-              <a:rPr sz="1050" b="1">
-                <a:solidFill>
-                  <a:srgbClr val="0F172A"/>
-                </a:solidFill>
-                <a:latin typeface="Segoe UI"/>
-              </a:rPr>
-              <a:t>• Single Source of Truth:</a:t>
-            </a:r>
-            <a:r>
-              <a:rPr sz="1050">
-                <a:solidFill>
-                  <a:srgbClr val="475569"/>
-                </a:solidFill>
-                <a:latin typeface="Segoe UI"/>
-              </a:rPr>
-              <a:t> Permanently synchronizing ProcureFlow with SAP Concur.</a:t>
+              <a:t>• Single source of truth: Permanently synchronizing ProcureFlow with SAP Concur.</a:t>
             </a:r>
           </a:p>
         </p:txBody>
@@ -4095,7 +4410,7 @@
               </a:defRPr>
             </a:pPr>
             <a:r>
-              <a:t>3. THE STRATEGIC OUTCOME</a:t>
+              <a:t>3. FORWARD PIPELINE</a:t>
             </a:r>
           </a:p>
           <a:p>
@@ -4111,7 +4426,7 @@
               </a:defRPr>
             </a:pPr>
             <a:r>
-              <a:t>Frictionless BAU Integration</a:t>
+              <a:t>Future 2-Month Horizon</a:t>
             </a:r>
           </a:p>
           <a:p>
@@ -4121,22 +4436,29 @@
               </a:spcAft>
             </a:pPr>
             <a:r>
-              <a:rPr sz="1050" b="1">
-                <a:solidFill>
-                  <a:srgbClr val="0F172A"/>
+              <a:rPr sz="1050">
+                <a:solidFill>
+                  <a:srgbClr val="334155"/>
                 </a:solidFill>
                 <a:latin typeface="Segoe UI"/>
               </a:rPr>
-              <a:t>• Effortless for Sites:</a:t>
-            </a:r>
+              <a:t>• Live SOH Testing Pipeline: 2-month validation before retiring manual emails.</a:t>
+            </a:r>
+          </a:p>
+          <a:p>
+            <a:pPr>
+              <a:spcAft>
+                <a:spcPts val="1000"/>
+              </a:spcAft>
+            </a:pPr>
             <a:r>
               <a:rPr sz="1050">
                 <a:solidFill>
-                  <a:srgbClr val="475569"/>
+                  <a:srgbClr val="334155"/>
                 </a:solidFill>
                 <a:latin typeface="Segoe UI"/>
               </a:rPr>
-              <a:t> 1-click carton rounding and immediate homepage task guidance.</a:t>
+              <a:t>• Adelaide Rollout Blueprint: 4-phase structured expansion template.</a:t>
             </a:r>
           </a:p>
           <a:p>
@@ -4146,47 +4468,29 @@
               </a:spcAft>
             </a:pPr>
             <a:r>
-              <a:rPr sz="1050" b="1">
-                <a:solidFill>
-                  <a:srgbClr val="0F172A"/>
+              <a:rPr sz="1050">
+                <a:solidFill>
+                  <a:srgbClr val="334155"/>
                 </a:solidFill>
                 <a:latin typeface="Segoe UI"/>
               </a:rPr>
-              <a:t>• Zero-Rework for Procurement:</a:t>
-            </a:r>
+              <a:t>• Training Video Governance: Mandatory user completion sign-off.</a:t>
+            </a:r>
+          </a:p>
+          <a:p>
+            <a:pPr>
+              <a:spcAft>
+                <a:spcPts val="1000"/>
+              </a:spcAft>
+            </a:pPr>
             <a:r>
               <a:rPr sz="1050">
                 <a:solidFill>
-                  <a:srgbClr val="475569"/>
+                  <a:srgbClr val="334155"/>
                 </a:solidFill>
                 <a:latin typeface="Segoe UI"/>
               </a:rPr>
-              <a:t> Pre-validated orders and automated EOM reconciliation in seconds.</a:t>
-            </a:r>
-          </a:p>
-          <a:p>
-            <a:pPr>
-              <a:spcAft>
-                <a:spcPts val="1000"/>
-              </a:spcAft>
-            </a:pPr>
-            <a:r>
-              <a:rPr sz="1050" b="1">
-                <a:solidFill>
-                  <a:srgbClr val="0F172A"/>
-                </a:solidFill>
-                <a:latin typeface="Segoe UI"/>
-              </a:rPr>
-              <a:t>• Commercial Control for Leadership:</a:t>
-            </a:r>
-            <a:r>
-              <a:rPr sz="1050">
-                <a:solidFill>
-                  <a:srgbClr val="475569"/>
-                </a:solidFill>
-                <a:latin typeface="Segoe UI"/>
-              </a:rPr>
-              <a:t> Real-time visibility into $14.521M FY27 budget and $2.3M Linen Hub.</a:t>
+              <a:t>• Omnichannel Notifications: Seamless Teams and email integration.</a:t>
             </a:r>
           </a:p>
         </p:txBody>
@@ -4243,7 +4547,7 @@
               </a:defRPr>
             </a:pPr>
             <a:r>
-              <a:t>DEMONSTRATED CAPABILITIES</a:t>
+              <a:t>OPERATIONAL TRACK RECORD</a:t>
             </a:r>
           </a:p>
           <a:p>
@@ -4256,7 +4560,7 @@
               </a:defRPr>
             </a:pPr>
             <a:r>
-              <a:t>ProcureFlow Today: Current Operational Strengths &amp; Baseline Excellence</a:t>
+              <a:t>Section 1: Completed Achievements in the Last Three Months</a:t>
             </a:r>
           </a:p>
         </p:txBody>
@@ -4340,7 +4644,7 @@
               </a:defRPr>
             </a:pPr>
             <a:r>
-              <a:t>01  |  NATIONAL SCALE &amp; MULTI-BRANCH REQUISITIONING</a:t>
+              <a:t>01  |  COLLABORATIVE TRIAD EXECUTION &amp; SKU MANAGEMENT</a:t>
             </a:r>
           </a:p>
           <a:p>
@@ -4353,7 +4657,7 @@
               </a:defRPr>
             </a:pPr>
             <a:r>
-              <a:t>Active daily purchasing across all 8 branches (Melbourne, Sydney, Brisbane, Perth, Adelaide, Cairns, Mackay, Albury) with branch-specific catalog filtering and address routing.</a:t>
+              <a:t>Joint delivery by Aaron Bell, Ashish Chhabra, and Kiran systematically standardized all SPL item master data, replacing disparate branch naming with a single national catalog.</a:t>
             </a:r>
           </a:p>
         </p:txBody>
@@ -4437,7 +4741,7 @@
               </a:defRPr>
             </a:pPr>
             <a:r>
-              <a:t>02  |  100% SUPPLY ITEM CODE MAPPING MILESTONE</a:t>
+              <a:t>02  |  AUTOMATED SPL PROCUREMENT EMAIL SYSTEM</a:t>
             </a:r>
           </a:p>
           <a:p>
@@ -4450,7 +4754,7 @@
               </a:defRPr>
             </a:pPr>
             <a:r>
-              <a:t>Achieved a major master data milestone: 100% of SPL internal item codes are mapped to vendor catalog SKUs (Simba, Host, etc.), standardizing product specifications nationally.</a:t>
+              <a:t>Engineered automated email ingestion pipelines directly reading incoming vendor inventory feeds and catalog updates in the background, eliminating hours of manual data entry.</a:t>
             </a:r>
           </a:p>
         </p:txBody>
@@ -4534,7 +4838,7 @@
               </a:defRPr>
             </a:pPr>
             <a:r>
-              <a:t>03  |  ON-SITE GOODS RECEIPTING (GR) &amp; DOCKET CAPTURE</a:t>
+              <a:t>03  |  NATIONAL SCALE ACROSS 11 FACILITIES</a:t>
             </a:r>
           </a:p>
           <a:p>
@@ -4547,7 +4851,7 @@
               </a:defRPr>
             </a:pPr>
             <a:r>
-              <a:t>Warehouse receiving teams capture delivery dockets, quantities received, and receiver signatures digitally, providing the factual bedrock for 3-way invoice matching.</a:t>
+              <a:t>ProcureFlow actively manages daily purchasing across 11 operating facilities (8 regional hubs: Melbourne, Sydney, Brisbane, Perth, Adelaide, Cairns, Mackay, Albury + satellite depots).</a:t>
             </a:r>
           </a:p>
         </p:txBody>
@@ -4631,7 +4935,7 @@
               </a:defRPr>
             </a:pPr>
             <a:r>
-              <a:t>04  |  6-STAGE VISUAL LIFECYCLE &amp; AUDIT TRAIL</a:t>
+              <a:t>04  |  TRAINING VIDEO &amp; GOVERNANCE PROTOCOL</a:t>
             </a:r>
           </a:p>
           <a:p>
@@ -4644,7 +4948,7 @@
               </a:defRPr>
             </a:pPr>
             <a:r>
-              <a:t>End-to-end transparency across Requested -&gt; Approved -&gt; Req Logged -&gt; In Concur -&gt; Delivery -&gt; Closed, capturing timestamps, roles, and decision notes for full audit compliance.</a:t>
+              <a:t>Implemented mandatory user governance: Site staff must watch the standardized training video and confirm/tick off completion before receiving active purchasing credentials.</a:t>
             </a:r>
           </a:p>
         </p:txBody>
@@ -4701,7 +5005,7 @@
               </a:defRPr>
             </a:pPr>
             <a:r>
-              <a:t>ZERO-DEFECT REQUISITIONING</a:t>
+              <a:t>DATA PARITY PROGRESS</a:t>
             </a:r>
           </a:p>
           <a:p>
@@ -4714,7 +5018,7 @@
               </a:defRPr>
             </a:pPr>
             <a:r>
-              <a:t>Improvement 1: Point-of-Entry Packaging Governance</a:t>
+              <a:t>Measurable Impact: Supplier Linkage Compliance Surges to 95%–100%</a:t>
             </a:r>
           </a:p>
         </p:txBody>
@@ -4788,9 +5092,9 @@
           <a:p>
             <a:pPr>
               <a:spcAft>
-                <a:spcPts val="400"/>
-              </a:spcAft>
-              <a:defRPr sz="1000" b="1">
+                <a:spcPts val="600"/>
+              </a:spcAft>
+              <a:defRPr sz="1100" b="1">
                 <a:solidFill>
                   <a:srgbClr val="E11D48"/>
                 </a:solidFill>
@@ -4798,29 +5102,29 @@
               </a:defRPr>
             </a:pPr>
             <a:r>
-              <a:t>THE OPERATIONAL CHALLENGE</a:t>
-            </a:r>
-          </a:p>
-          <a:p>
-            <a:pPr>
-              <a:spcAft>
-                <a:spcPts val="1200"/>
-              </a:spcAft>
-              <a:defRPr sz="1600" b="1">
-                <a:solidFill>
-                  <a:srgbClr val="0F172A"/>
-                </a:solidFill>
-                <a:latin typeface="Segoe UI"/>
-              </a:defRPr>
-            </a:pPr>
-            <a:r>
-              <a:t>Arbitrary Requisition Quantities</a:t>
-            </a:r>
-          </a:p>
-          <a:p>
-            <a:pPr>
-              <a:spcAft>
-                <a:spcPts val="1000"/>
+              <a:t>BEFORE LAUNCH (FEB – APR 2026)</a:t>
+            </a:r>
+          </a:p>
+          <a:p>
+            <a:pPr>
+              <a:spcAft>
+                <a:spcPts val="1400"/>
+              </a:spcAft>
+              <a:defRPr sz="2800" b="1">
+                <a:solidFill>
+                  <a:srgbClr val="E11D48"/>
+                </a:solidFill>
+                <a:latin typeface="Segoe UI"/>
+              </a:defRPr>
+            </a:pPr>
+            <a:r>
+              <a:t>~50% Compliance Baseline</a:t>
+            </a:r>
+          </a:p>
+          <a:p>
+            <a:pPr>
+              <a:spcAft>
+                <a:spcPts val="800"/>
               </a:spcAft>
               <a:defRPr sz="1100">
                 <a:solidFill>
@@ -4830,11 +5134,14 @@
               </a:defRPr>
             </a:pPr>
             <a:r>
-              <a:t>• The Issue: Site staff enter arbitrary numbers (e.g. 5,000 units on a 240 carton size = 20.83 cartons, or 90 on a 100 pack). Suppliers cannot break cartons, forcing Ashish Chhabra to reject orders, email sites, and wait for re-raising.</a:t>
-            </a:r>
-          </a:p>
-          <a:p>
-            <a:pPr>
+              <a:t>• Unmapped Catalog SKUs: Half of all ordered items lacked linkage to vendor codes.</a:t>
+            </a:r>
+          </a:p>
+          <a:p>
+            <a:pPr>
+              <a:spcAft>
+                <a:spcPts val="800"/>
+              </a:spcAft>
               <a:defRPr sz="1100">
                 <a:solidFill>
                   <a:srgbClr val="475569"/>
@@ -4843,7 +5150,39 @@
               </a:defRPr>
             </a:pPr>
             <a:r>
-              <a:t>• Business Impact: Operational delays in linen delivery, unnecessary email loops, and administrative rework for procurement.</a:t>
+              <a:t>• Pricing Discrepancies: Inconsistent rates keyed across different laundry branches.</a:t>
+            </a:r>
+          </a:p>
+          <a:p>
+            <a:pPr>
+              <a:spcAft>
+                <a:spcPts val="800"/>
+              </a:spcAft>
+              <a:defRPr sz="1100">
+                <a:solidFill>
+                  <a:srgbClr val="475569"/>
+                </a:solidFill>
+                <a:latin typeface="Segoe UI"/>
+              </a:defRPr>
+            </a:pPr>
+            <a:r>
+              <a:t>• Manual Cross-Referencing: Procurement spent hours verifying supplier order lines.</a:t>
+            </a:r>
+          </a:p>
+          <a:p>
+            <a:pPr>
+              <a:spcAft>
+                <a:spcPts val="800"/>
+              </a:spcAft>
+              <a:defRPr sz="1100">
+                <a:solidFill>
+                  <a:srgbClr val="475569"/>
+                </a:solidFill>
+                <a:latin typeface="Segoe UI"/>
+              </a:defRPr>
+            </a:pPr>
+            <a:r>
+              <a:t>• Frequent Order Rework: Inability to auto-verify catalog compliance before submission.</a:t>
             </a:r>
           </a:p>
         </p:txBody>
@@ -4917,9 +5256,9 @@
           <a:p>
             <a:pPr>
               <a:spcAft>
-                <a:spcPts val="400"/>
-              </a:spcAft>
-              <a:defRPr sz="1000" b="1">
+                <a:spcPts val="600"/>
+              </a:spcAft>
+              <a:defRPr sz="1100" b="1">
                 <a:solidFill>
                   <a:srgbClr val="059669"/>
                 </a:solidFill>
@@ -4927,23 +5266,23 @@
               </a:defRPr>
             </a:pPr>
             <a:r>
-              <a:t>THE ENGINEERED SOLUTION &amp; WHY IT WORKS</a:t>
-            </a:r>
-          </a:p>
-          <a:p>
-            <a:pPr>
-              <a:spcAft>
-                <a:spcPts val="1200"/>
-              </a:spcAft>
-              <a:defRPr sz="1600" b="1">
-                <a:solidFill>
-                  <a:srgbClr val="0F172A"/>
-                </a:solidFill>
-                <a:latin typeface="Segoe UI"/>
-              </a:defRPr>
-            </a:pPr>
-            <a:r>
-              <a:t>Live Packaging Modulo &amp; 1-Click Rounding</a:t>
+              <a:t>LAST THREE MONTHS (MAY – AUG 2026)</a:t>
+            </a:r>
+          </a:p>
+          <a:p>
+            <a:pPr>
+              <a:spcAft>
+                <a:spcPts val="1400"/>
+              </a:spcAft>
+              <a:defRPr sz="2800" b="1">
+                <a:solidFill>
+                  <a:srgbClr val="059669"/>
+                </a:solidFill>
+                <a:latin typeface="Segoe UI"/>
+              </a:defRPr>
+            </a:pPr>
+            <a:r>
+              <a:t>~95% – 100% Compliance</a:t>
             </a:r>
           </a:p>
           <a:p>
@@ -4951,24 +5290,15 @@
               <a:spcAft>
                 <a:spcPts val="800"/>
               </a:spcAft>
-            </a:pPr>
-            <a:r>
-              <a:rPr sz="1050" b="1">
-                <a:solidFill>
-                  <a:srgbClr val="0F172A"/>
-                </a:solidFill>
-                <a:latin typeface="Segoe UI"/>
-              </a:rPr>
-              <a:t>✓ The Solution: </a:t>
-            </a:r>
-            <a:r>
-              <a:rPr sz="1050">
+              <a:defRPr sz="1100">
                 <a:solidFill>
                   <a:srgbClr val="475569"/>
                 </a:solidFill>
                 <a:latin typeface="Segoe UI"/>
-              </a:rPr>
-              <a:t>Live modulo check (quantityOrdered % cartonQty === 0). Hard blocks submission and provides a 1-click 'Round to X units' button (e.g. rounds 5,000 to 5,040 units / 21 cartons).</a:t>
+              </a:defRPr>
+            </a:pPr>
+            <a:r>
+              <a:t>✓ 100% Master SKU Linkage: Simba and Host items fully mapped to SPL internal codes.</a:t>
             </a:r>
           </a:p>
           <a:p>
@@ -4976,24 +5306,15 @@
               <a:spcAft>
                 <a:spcPts val="800"/>
               </a:spcAft>
-            </a:pPr>
-            <a:r>
-              <a:rPr sz="1050" b="1">
-                <a:solidFill>
-                  <a:srgbClr val="0F172A"/>
-                </a:solidFill>
-                <a:latin typeface="Segoe UI"/>
-              </a:rPr>
-              <a:t>✓ Why This is the Solution: </a:t>
-            </a:r>
-            <a:r>
-              <a:rPr sz="1050">
+              <a:defRPr sz="1100">
                 <a:solidFill>
                   <a:srgbClr val="475569"/>
                 </a:solidFill>
                 <a:latin typeface="Segoe UI"/>
-              </a:rPr>
-              <a:t>Stops errors before submission rather than catching them days later during approval review.</a:t>
+              </a:defRPr>
+            </a:pPr>
+            <a:r>
+              <a:t>✓ Standardized Pricing Master: Active contracted supplier catalog pricing auto-populates.</a:t>
             </a:r>
           </a:p>
           <a:p>
@@ -5001,24 +5322,15 @@
               <a:spcAft>
                 <a:spcPts val="800"/>
               </a:spcAft>
-            </a:pPr>
-            <a:r>
-              <a:rPr sz="1050" b="1">
-                <a:solidFill>
-                  <a:srgbClr val="0F172A"/>
-                </a:solidFill>
-                <a:latin typeface="Segoe UI"/>
-              </a:rPr>
-              <a:t>✓ Frictionless UX: </a:t>
-            </a:r>
-            <a:r>
-              <a:rPr sz="1050">
+              <a:defRPr sz="1100">
                 <a:solidFill>
                   <a:srgbClr val="475569"/>
                 </a:solidFill>
                 <a:latin typeface="Segoe UI"/>
-              </a:rPr>
-              <a:t>The 1-click rounder solves the packaging math instantly for the user.</a:t>
+              </a:defRPr>
+            </a:pPr>
+            <a:r>
+              <a:t>✓ Zero Description Ambiguity: Branches and vendors speak the exact same commercial language.</a:t>
             </a:r>
           </a:p>
           <a:p>
@@ -5026,24 +5338,15 @@
               <a:spcAft>
                 <a:spcPts val="800"/>
               </a:spcAft>
-            </a:pPr>
-            <a:r>
-              <a:rPr sz="1050" b="1">
-                <a:solidFill>
-                  <a:srgbClr val="0F172A"/>
-                </a:solidFill>
-                <a:latin typeface="Segoe UI"/>
-              </a:rPr>
-              <a:t>✓ Zero Procurement Rework: </a:t>
-            </a:r>
-            <a:r>
-              <a:rPr sz="1050">
+              <a:defRPr sz="1100">
                 <a:solidFill>
                   <a:srgbClr val="475569"/>
                 </a:solidFill>
                 <a:latin typeface="Segoe UI"/>
-              </a:rPr>
-              <a:t>Ashish no longer acts as a manual carton calculator, eliminating supplier order rejections.</a:t>
+              </a:defRPr>
+            </a:pPr>
+            <a:r>
+              <a:t>✓ Visual Proof of Progress: Clear evidence that ProcureFlow's foundation is delivering success.</a:t>
             </a:r>
           </a:p>
         </p:txBody>
@@ -5100,7 +5403,7 @@
               </a:defRPr>
             </a:pPr>
             <a:r>
-              <a:t>FINANCIAL INTEGRITY</a:t>
+              <a:t>ZERO-DEFECT REQUISITIONING</a:t>
             </a:r>
           </a:p>
           <a:p>
@@ -5113,7 +5416,7 @@
               </a:defRPr>
             </a:pPr>
             <a:r>
-              <a:t>Improvement 2: Contract Price Master &amp; Zero Invoice Variances</a:t>
+              <a:t>Improvement 1: Point-of-Entry Packaging Governance</a:t>
             </a:r>
           </a:p>
         </p:txBody>
@@ -5213,7 +5516,7 @@
               </a:defRPr>
             </a:pPr>
             <a:r>
-              <a:t>Manual Price Entry Typos</a:t>
+              <a:t>Arbitrary Requisition Quantities</a:t>
             </a:r>
           </a:p>
           <a:p>
@@ -5229,7 +5532,7 @@
               </a:defRPr>
             </a:pPr>
             <a:r>
-              <a:t>• The Issue: Requesters had free-text price editing access. A single keystroke typo (e.g. keying 61¢ instead of contracted 51¢ for face washers) propagated downstream to the vendor and Concur.</a:t>
+              <a:t>• The Issue: Site staff enter arbitrary numbers (e.g. 5,000 units on a 240 carton size = 20.83 cartons, or 90 on a 100 pack). Suppliers cannot break cartons, forcing Ashish Chhabra to reject orders, email sites, and wait for re-raising.</a:t>
             </a:r>
           </a:p>
           <a:p>
@@ -5242,7 +5545,7 @@
               </a:defRPr>
             </a:pPr>
             <a:r>
-              <a:t>• Business Impact: When the supplier invoiced at the true contracted rate (51¢), automated 3-way matching in finance failed due to a price variance, freezing the invoice and delaying payment.</a:t>
+              <a:t>• Business Impact: Operational delays in linen delivery, unnecessary email loops, and administrative rework for procurement.</a:t>
             </a:r>
           </a:p>
         </p:txBody>
@@ -5342,7 +5645,7 @@
               </a:defRPr>
             </a:pPr>
             <a:r>
-              <a:t>Contract Price Master Validation</a:t>
+              <a:t>Live Packaging Modulo &amp; 1-Click Rounding</a:t>
             </a:r>
           </a:p>
           <a:p>
@@ -5367,7 +5670,7 @@
                 </a:solidFill>
                 <a:latin typeface="Segoe UI"/>
               </a:rPr>
-              <a:t>Leverages the 100% item mapping milestone. Active contracted supplier catalog rates auto-populate lines; $0.00 prices and unapproved price overrides are strictly blocked.</a:t>
+              <a:t>Live modulo check (quantityOrdered % cartonQty === 0). Hard blocks submission and provides a 1-click 'Round to X units' button (e.g. rounds 5,000 to 5,040 units / 21 cartons).</a:t>
             </a:r>
           </a:p>
           <a:p>
@@ -5392,7 +5695,7 @@
                 </a:solidFill>
                 <a:latin typeface="Segoe UI"/>
               </a:rPr>
-              <a:t>Ensuring PO prices match supplier contracts guarantees clean 3-way matching in finance upon invoice receipt.</a:t>
+              <a:t>Stops errors before submission rather than catching them days later during approval review.</a:t>
             </a:r>
           </a:p>
           <a:p>
@@ -5408,7 +5711,7 @@
                 </a:solidFill>
                 <a:latin typeface="Segoe UI"/>
               </a:rPr>
-              <a:t>✓ Protects Commercial Margin: </a:t>
+              <a:t>✓ Frictionless UX: </a:t>
             </a:r>
             <a:r>
               <a:rPr sz="1050">
@@ -5417,7 +5720,7 @@
                 </a:solidFill>
                 <a:latin typeface="Segoe UI"/>
               </a:rPr>
-              <a:t>Prevents accidental over-payment or unauthorized supplier price creep.</a:t>
+              <a:t>The 1-click rounder solves the packaging math instantly for the user.</a:t>
             </a:r>
           </a:p>
           <a:p>
@@ -5433,7 +5736,7 @@
                 </a:solidFill>
                 <a:latin typeface="Segoe UI"/>
               </a:rPr>
-              <a:t>✓ Zero Downstream Holds: </a:t>
+              <a:t>✓ Zero Procurement Rework: </a:t>
             </a:r>
             <a:r>
               <a:rPr sz="1050">
@@ -5442,7 +5745,7 @@
                 </a:solidFill>
                 <a:latin typeface="Segoe UI"/>
               </a:rPr>
-              <a:t>Invoices pass through finance without manual investigation emails.</a:t>
+              <a:t>Ashish no longer acts as a manual carton calculator, eliminating supplier order rejections.</a:t>
             </a:r>
           </a:p>
         </p:txBody>
@@ -5499,7 +5802,7 @@
               </a:defRPr>
             </a:pPr>
             <a:r>
-              <a:t>ERP INTEGRATION</a:t>
+              <a:t>FINANCIAL INTEGRITY</a:t>
             </a:r>
           </a:p>
           <a:p>
@@ -5512,7 +5815,7 @@
               </a:defRPr>
             </a:pPr>
             <a:r>
-              <a:t>Improvement 3: Mandatory Concur PR # Enforcement &amp; Task Visibility</a:t>
+              <a:t>Improvement 2: Contract Price Master &amp; Zero Invoice Variances</a:t>
             </a:r>
           </a:p>
         </p:txBody>
@@ -5612,7 +5915,7 @@
               </a:defRPr>
             </a:pPr>
             <a:r>
-              <a:t>Missing Concur PR Numbers</a:t>
+              <a:t>Manual Price Entry Typos</a:t>
             </a:r>
           </a:p>
           <a:p>
@@ -5628,7 +5931,7 @@
               </a:defRPr>
             </a:pPr>
             <a:r>
-              <a:t>• The Issue: Staff received physical deliveries on site and completed orders in ProcureFlow without ever returning to log the SAP Concur Purchase Request number (PR #) or PO #.</a:t>
+              <a:t>• The Issue: Requesters had free-text price editing access. A single keystroke typo (e.g. keying 61¢ instead of contracted 51¢ for face washers) propagated downstream to the vendor and Concur.</a:t>
             </a:r>
           </a:p>
           <a:p>
@@ -5641,7 +5944,7 @@
               </a:defRPr>
             </a:pPr>
             <a:r>
-              <a:t>• Business Impact: Created orphaned records where Concur spend could not be matched against ProcureFlow physical receipts, breaking cross-system audit trails.</a:t>
+              <a:t>• Business Impact: When the supplier invoiced at the true contracted rate (51¢), automated 3-way matching in finance failed due to a price variance, freezing the invoice and delaying payment.</a:t>
             </a:r>
           </a:p>
         </p:txBody>
@@ -5741,7 +6044,7 @@
               </a:defRPr>
             </a:pPr>
             <a:r>
-              <a:t>Mandatory Concur Block &amp; Homepage Center</a:t>
+              <a:t>Contract Price Master Validation</a:t>
             </a:r>
           </a:p>
           <a:p>
@@ -5766,7 +6069,7 @@
                 </a:solidFill>
                 <a:latin typeface="Segoe UI"/>
               </a:rPr>
-              <a:t>Hard block on order closure without Concur reference, plus Homepage Action Required center showing pending Concur links on login.</a:t>
+              <a:t>Leverages the 100% item mapping milestone. Active contracted supplier catalog rates auto-populate lines; $0.00 prices and unapproved price overrides are strictly blocked.</a:t>
             </a:r>
           </a:p>
           <a:p>
@@ -5791,7 +6094,7 @@
                 </a:solidFill>
                 <a:latin typeface="Segoe UI"/>
               </a:rPr>
-              <a:t>Placing the block at the final step of order completion guarantees users capture the Concur reference before the transaction finalizes.</a:t>
+              <a:t>Ensuring PO prices match supplier contracts guarantees clean 3-way matching in finance upon invoice receipt.</a:t>
             </a:r>
           </a:p>
           <a:p>
@@ -5807,7 +6110,7 @@
                 </a:solidFill>
                 <a:latin typeface="Segoe UI"/>
               </a:rPr>
-              <a:t>✓ 100% ERP Mirroring: </a:t>
+              <a:t>✓ Protects Commercial Margin: </a:t>
             </a:r>
             <a:r>
               <a:rPr sz="1050">
@@ -5816,7 +6119,7 @@
                 </a:solidFill>
                 <a:latin typeface="Segoe UI"/>
               </a:rPr>
-              <a:t>Every completed order in ProcureFlow has a direct audit mirror in SAP Concur.</a:t>
+              <a:t>Prevents accidental over-payment or unauthorized supplier price creep.</a:t>
             </a:r>
           </a:p>
           <a:p>
@@ -5832,7 +6135,7 @@
                 </a:solidFill>
                 <a:latin typeface="Segoe UI"/>
               </a:rPr>
-              <a:t>✓ Frictionless Navigation: </a:t>
+              <a:t>✓ Zero Downstream Holds: </a:t>
             </a:r>
             <a:r>
               <a:rPr sz="1050">
@@ -5841,7 +6144,7 @@
                 </a:solidFill>
                 <a:latin typeface="Segoe UI"/>
               </a:rPr>
-              <a:t>Homepage banner provides 1-click navigation directly to pending orders.</a:t>
+              <a:t>Invoices pass through finance without manual investigation emails.</a:t>
             </a:r>
           </a:p>
         </p:txBody>
@@ -5898,7 +6201,7 @@
               </a:defRPr>
             </a:pPr>
             <a:r>
-              <a:t>OPERATIONAL ALIGNMENT</a:t>
+              <a:t>ERP INTEGRATION</a:t>
             </a:r>
           </a:p>
           <a:p>
@@ -5911,7 +6214,7 @@
               </a:defRPr>
             </a:pPr>
             <a:r>
-              <a:t>Improvement 4: Automated Lifecycle Notifications &amp; Escalation</a:t>
+              <a:t>Improvement 3: Mandatory Concur PR # Enforcement &amp; Task Visibility</a:t>
             </a:r>
           </a:p>
         </p:txBody>
@@ -6011,7 +6314,7 @@
               </a:defRPr>
             </a:pPr>
             <a:r>
-              <a:t>Lingering POs &amp; Overdue Shipments</a:t>
+              <a:t>Missing Concur PR Numbers</a:t>
             </a:r>
           </a:p>
           <a:p>
@@ -6027,7 +6330,7 @@
               </a:defRPr>
             </a:pPr>
             <a:r>
-              <a:t>• The Issue: Orders 100% received physically sat open in ProcureFlow because users forgot to click 'Complete Order'. Furthermore, undelivered orders sat &gt;14 days past need-by date with zero management visibility.</a:t>
+              <a:t>• The Issue: Staff received physical deliveries on site and completed orders in ProcureFlow without ever returning to log the SAP Concur Purchase Request number (PR #) or PO #.</a:t>
             </a:r>
           </a:p>
           <a:p>
@@ -6040,7 +6343,7 @@
               </a:defRPr>
             </a:pPr>
             <a:r>
-              <a:t>• Business Impact: Distorted open commitment reports in finance and hidden supplier supply chain bottlenecks.</a:t>
+              <a:t>• Business Impact: Created orphaned records where Concur spend could not be matched against ProcureFlow physical receipts, breaking cross-system audit trails.</a:t>
             </a:r>
           </a:p>
         </p:txBody>
@@ -6140,7 +6443,7 @@
               </a:defRPr>
             </a:pPr>
             <a:r>
-              <a:t>Automated Nudges &amp; Tiered Escalation</a:t>
+              <a:t>Mandatory Concur Block &amp; Homepage Center</a:t>
             </a:r>
           </a:p>
           <a:p>
@@ -6165,7 +6468,7 @@
                 </a:solidFill>
                 <a:latin typeface="Segoe UI"/>
               </a:rPr>
-              <a:t>Automated daily closure reminders when 100% received; Tiered escalation (&gt;14d to user, &gt;21d copying line managers e.g. David, Ashish, Ebrahim).</a:t>
+              <a:t>Hard block on order closure without Concur reference, plus Homepage Action Required center showing pending Concur links on login.</a:t>
             </a:r>
           </a:p>
           <a:p>
@@ -6190,7 +6493,7 @@
                 </a:solidFill>
                 <a:latin typeface="Segoe UI"/>
               </a:rPr>
-              <a:t>Closes the operational loop automatically without requiring manual chasing by procurement.</a:t>
+              <a:t>Placing the block at the final step of order completion guarantees users capture the Concur reference before the transaction finalizes.</a:t>
             </a:r>
           </a:p>
           <a:p>
@@ -6206,7 +6509,7 @@
                 </a:solidFill>
                 <a:latin typeface="Segoe UI"/>
               </a:rPr>
-              <a:t>✓ Multi-Channel Reach: </a:t>
+              <a:t>✓ 100% ERP Mirroring: </a:t>
             </a:r>
             <a:r>
               <a:rPr sz="1050">
@@ -6215,7 +6518,7 @@
                 </a:solidFill>
                 <a:latin typeface="Segoe UI"/>
               </a:rPr>
-              <a:t>Delivered via In-App Drawer, Microsoft Graph Email, and MS Teams Adaptive Cards.</a:t>
+              <a:t>Every completed order in ProcureFlow has a direct audit mirror in SAP Concur.</a:t>
             </a:r>
           </a:p>
           <a:p>
@@ -6231,7 +6534,7 @@
                 </a:solidFill>
                 <a:latin typeface="Segoe UI"/>
               </a:rPr>
-              <a:t>✓ Clean Commitments: </a:t>
+              <a:t>✓ Mobile Polish Included: </a:t>
             </a:r>
             <a:r>
               <a:rPr sz="1050">
@@ -6240,7 +6543,7 @@
                 </a:solidFill>
                 <a:latin typeface="Segoe UI"/>
               </a:rPr>
-              <a:t>Financial reports reflect only genuinely outstanding shipments.</a:t>
+              <a:t>Fixed mobile requests scrolling bug, enabling seamless viewing on tablets and phones.</a:t>
             </a:r>
           </a:p>
         </p:txBody>
@@ -6310,7 +6613,7 @@
               </a:defRPr>
             </a:pPr>
             <a:r>
-              <a:t>Improvement 5: Native EOM Spend &amp; Budget Reconciliation Engine</a:t>
+              <a:t>Improvement 4: Native EOM Spend &amp; Budget Reconciliation Engine</a:t>
             </a:r>
           </a:p>
         </p:txBody>
@@ -6872,7 +7175,7 @@
                 </a:solidFill>
                 <a:latin typeface="Segoe UI"/>
               </a:rPr>
-              <a:t>Regex classifier achieves verified 100.0% accuracy matching Ashish's historical dataset.</a:t>
+              <a:t>Regex classifier achieves verified 100.0% accuracy matching Ashish's historical dataset (52/52 records reconciled).</a:t>
             </a:r>
           </a:p>
           <a:p>
@@ -7029,7 +7332,7 @@
               </a:defRPr>
             </a:pPr>
             <a:r>
-              <a:t>COMMERCIAL GOVERNANCE</a:t>
+              <a:t>STRATEGIC PIPELINE</a:t>
             </a:r>
           </a:p>
           <a:p>
@@ -7042,7 +7345,7 @@
               </a:defRPr>
             </a:pPr>
             <a:r>
-              <a:t>Improvements 6 &amp; 7: SOH Automation &amp; DOA Approval Tiers</a:t>
+              <a:t>Forward Pipeline (Next 2 Months): Live SOH Testing &amp; Omnichannel Alerts</a:t>
             </a:r>
           </a:p>
         </p:txBody>
@@ -7126,7 +7429,7 @@
               </a:defRPr>
             </a:pPr>
             <a:r>
-              <a:t>SELF-SERVICE SOH DISTRIBUTION</a:t>
+              <a:t>SUPPLIER INVENTORY TESTING PIPELINE</a:t>
             </a:r>
           </a:p>
           <a:p>
@@ -7142,7 +7445,7 @@
               </a:defRPr>
             </a:pPr>
             <a:r>
-              <a:t>Eliminating Manual Weekly Emailing</a:t>
+              <a:t>2-Month Live SOH Validation Phase</a:t>
             </a:r>
           </a:p>
           <a:p>
@@ -7150,15 +7453,24 @@
               <a:spcAft>
                 <a:spcPts val="800"/>
               </a:spcAft>
-              <a:defRPr sz="1050">
+            </a:pPr>
+            <a:r>
+              <a:rPr sz="1000" b="1">
+                <a:solidFill>
+                  <a:srgbClr val="0F172A"/>
+                </a:solidFill>
+                <a:latin typeface="Segoe UI"/>
+              </a:rPr>
+              <a:t>✓ Months 1–2 Testing Window: </a:t>
+            </a:r>
+            <a:r>
+              <a:rPr sz="1000">
                 <a:solidFill>
                   <a:srgbClr val="475569"/>
                 </a:solidFill>
                 <a:latin typeface="Segoe UI"/>
-              </a:defRPr>
-            </a:pPr>
-            <a:r>
-              <a:t>• The Issue: Procurement manually gathered, reformatted, and emailed weekly vendor inventory spreadsheets across state managers.</a:t>
+              </a:rPr>
+              <a:t>Procurement (Ashish) and Tech (Aaron) conduct parallel testing of live inventory feeds in ProcureFlow vs manual Excel reports.</a:t>
             </a:r>
           </a:p>
           <a:p>
@@ -7166,28 +7478,74 @@
               <a:spcAft>
                 <a:spcPts val="800"/>
               </a:spcAft>
-              <a:defRPr sz="1050">
+            </a:pPr>
+            <a:r>
+              <a:rPr sz="1000" b="1">
+                <a:solidFill>
+                  <a:srgbClr val="0F172A"/>
+                </a:solidFill>
+                <a:latin typeface="Segoe UI"/>
+              </a:rPr>
+              <a:t>✓ Verification Gate: </a:t>
+            </a:r>
+            <a:r>
+              <a:rPr sz="1000">
                 <a:solidFill>
                   <a:srgbClr val="475569"/>
                 </a:solidFill>
                 <a:latin typeface="Segoe UI"/>
-              </a:defRPr>
-            </a:pPr>
-            <a:r>
-              <a:t>• The Solution: Automated ingestion of vendor inventory feeds into the live SUPPLIER_INVENTORY dashboard in ProcureFlow.</a:t>
-            </a:r>
-          </a:p>
-          <a:p>
-            <a:pPr>
-              <a:defRPr sz="1050">
+              </a:rPr>
+              <a:t>Thoroughly test data consistency across two full month-end cycles before directing branch managers to rely 100% on system data.</a:t>
+            </a:r>
+          </a:p>
+          <a:p>
+            <a:pPr>
+              <a:spcAft>
+                <a:spcPts val="800"/>
+              </a:spcAft>
+            </a:pPr>
+            <a:r>
+              <a:rPr sz="1000" b="1">
+                <a:solidFill>
+                  <a:srgbClr val="0F172A"/>
+                </a:solidFill>
+                <a:latin typeface="Segoe UI"/>
+              </a:rPr>
+              <a:t>✓ Retirement of Manual Emails: </a:t>
+            </a:r>
+            <a:r>
+              <a:rPr sz="1000">
                 <a:solidFill>
                   <a:srgbClr val="475569"/>
                 </a:solidFill>
                 <a:latin typeface="Segoe UI"/>
-              </a:defRPr>
-            </a:pPr>
-            <a:r>
-              <a:t>• Why It Works: Saves hours of administrative time each week and allows state managers to check stock availability before placing orders.</a:t>
+              </a:rPr>
+              <a:t>Formally deprecates the time-consuming weekly emailing of supplier spreadsheets.</a:t>
+            </a:r>
+          </a:p>
+          <a:p>
+            <a:pPr>
+              <a:spcAft>
+                <a:spcPts val="800"/>
+              </a:spcAft>
+            </a:pPr>
+            <a:r>
+              <a:rPr sz="1000" b="1">
+                <a:solidFill>
+                  <a:srgbClr val="0F172A"/>
+                </a:solidFill>
+                <a:latin typeface="Segoe UI"/>
+              </a:rPr>
+              <a:t>✓ Pre-Requisition Visibility: </a:t>
+            </a:r>
+            <a:r>
+              <a:rPr sz="1000">
+                <a:solidFill>
+                  <a:srgbClr val="475569"/>
+                </a:solidFill>
+                <a:latin typeface="Segoe UI"/>
+              </a:rPr>
+              <a:t>Allows state managers to see real-time stock levels before ordering.</a:t>
             </a:r>
           </a:p>
         </p:txBody>
@@ -7271,7 +7629,7 @@
               </a:defRPr>
             </a:pPr>
             <a:r>
-              <a:t>STRUCTURED DOA APPROVAL ENGINE</a:t>
+              <a:t>OMNICHANNEL NOTIFICATIONS &amp; ESCALATION</a:t>
             </a:r>
           </a:p>
           <a:p>
@@ -7287,13 +7645,13 @@
               </a:defRPr>
             </a:pPr>
             <a:r>
-              <a:t>3-Tier Delegation of Authority</a:t>
-            </a:r>
-          </a:p>
-          <a:p>
-            <a:pPr>
-              <a:spcAft>
-                <a:spcPts val="600"/>
+              <a:t>Closing the Operational Loop</a:t>
+            </a:r>
+          </a:p>
+          <a:p>
+            <a:pPr>
+              <a:spcAft>
+                <a:spcPts val="800"/>
               </a:spcAft>
             </a:pPr>
             <a:r>
@@ -7303,7 +7661,7 @@
                 </a:solidFill>
                 <a:latin typeface="Segoe UI"/>
               </a:rPr>
-              <a:t>✓ Tier 1 (Site Manager): </a:t>
+              <a:t>✓ 100% GR Closure Nudges: </a:t>
             </a:r>
             <a:r>
               <a:rPr sz="1000">
@@ -7312,13 +7670,13 @@
                 </a:solidFill>
                 <a:latin typeface="Segoe UI"/>
               </a:rPr>
-              <a:t>Approves routine weekly depletion spend within local branch limits.</a:t>
-            </a:r>
-          </a:p>
-          <a:p>
-            <a:pPr>
-              <a:spcAft>
-                <a:spcPts val="600"/>
+              <a:t>Automated daily reminders to complete delivered orders; variance routing to Ashish if delivered quantities differ.</a:t>
+            </a:r>
+          </a:p>
+          <a:p>
+            <a:pPr>
+              <a:spcAft>
+                <a:spcPts val="800"/>
               </a:spcAft>
             </a:pPr>
             <a:r>
@@ -7328,7 +7686,7 @@
                 </a:solidFill>
                 <a:latin typeface="Segoe UI"/>
               </a:rPr>
-              <a:t>✓ Tier 2 (Ashish Chhabra): </a:t>
+              <a:t>✓ Overdue Delivery Escalation: </a:t>
             </a:r>
             <a:r>
               <a:rPr sz="1000">
@@ -7337,13 +7695,13 @@
                 </a:solidFill>
                 <a:latin typeface="Segoe UI"/>
               </a:rPr>
-              <a:t>Procurement Lead audits pack multiples, pricing parity, and spend reason (Depletion vs NB).</a:t>
-            </a:r>
-          </a:p>
-          <a:p>
-            <a:pPr>
-              <a:spcAft>
-                <a:spcPts val="600"/>
+              <a:t>Tiered alerts (&gt;14d to user, &gt;21d copying line managers e.g. David, Ashish, Ebrahim).</a:t>
+            </a:r>
+          </a:p>
+          <a:p>
+            <a:pPr>
+              <a:spcAft>
+                <a:spcPts val="800"/>
               </a:spcAft>
             </a:pPr>
             <a:r>
@@ -7353,7 +7711,7 @@
                 </a:solidFill>
                 <a:latin typeface="Segoe UI"/>
               </a:rPr>
-              <a:t>✓ Tier 3 (Ebrahim Mokhtari): </a:t>
+              <a:t>✓ In-App Notification Hub: </a:t>
             </a:r>
             <a:r>
               <a:rPr sz="1000">
@@ -7362,13 +7720,13 @@
                 </a:solidFill>
                 <a:latin typeface="Segoe UI"/>
               </a:rPr>
-              <a:t>COO approves high-value orders (&gt;$50k), new customer injections, and unbudgeted exceptions.</a:t>
-            </a:r>
-          </a:p>
-          <a:p>
-            <a:pPr>
-              <a:spcAft>
-                <a:spcPts val="600"/>
+              <a:t>Live slide-over drawer with unread badge indicators and direct action deep-links.</a:t>
+            </a:r>
+          </a:p>
+          <a:p>
+            <a:pPr>
+              <a:spcAft>
+                <a:spcPts val="800"/>
               </a:spcAft>
             </a:pPr>
             <a:r>
@@ -7378,7 +7736,7 @@
                 </a:solidFill>
                 <a:latin typeface="Segoe UI"/>
               </a:rPr>
-              <a:t>✓ Why It Works: </a:t>
+              <a:t>✓ Microsoft Teams &amp; Email: </a:t>
             </a:r>
             <a:r>
               <a:rPr sz="1000">
@@ -7387,7 +7745,7 @@
                 </a:solidFill>
                 <a:latin typeface="Segoe UI"/>
               </a:rPr>
-              <a:t>Embeds corporate DOA rules directly into software, displaying GST-inc totals and audit remarks.</a:t>
+              <a:t>Actionable Teams Adaptive Cards (v1.4) and Graph HTML emails with 1-click approvals.</a:t>
             </a:r>
           </a:p>
         </p:txBody>

</xml_diff>

<commit_message>
docs: elevate action plan & presentation to v4.0 with Three-Horizon model, training in forward pipeline, and Short Supply logic migration
</commit_message>
<xml_diff>
--- a/docs/ProcureFlow_Executive_Roadmap.pptx
+++ b/docs/ProcureFlow_Executive_Roadmap.pptx
@@ -3174,7 +3174,7 @@
               </a:defRPr>
             </a:pPr>
             <a:r>
-              <a:t>SOUTH PACIFIC LAUNDRY  |  EXECUTIVE REVIEW</a:t>
+              <a:t>SOUTH PACIFIC LAUNDRY  |  EXECUTIVE STRATEGIC REVIEW</a:t>
             </a:r>
           </a:p>
           <a:p>
@@ -3210,7 +3210,7 @@
               </a:defRPr>
             </a:pPr>
             <a:r>
-              <a:t>Completed Achievements (Last 3 Months)  •  Targeted Elevation  •  Forward Pipeline (Next 2 Months)</a:t>
+              <a:t>Horizon 1 (Achievements in Last 3 Months)  •  Horizon 2 (Current Elevation)  •  Horizon 3 (Next 2 Months Pipeline)</a:t>
             </a:r>
           </a:p>
         </p:txBody>
@@ -3249,7 +3249,7 @@
               </a:defRPr>
             </a:pPr>
             <a:r>
-              <a:t>EXECUTIVE COMMITTEE &amp; MEETING ALIGNMENT:</a:t>
+              <a:t>EXECUTIVE COMMITTEE &amp; WORKSHOP ALIGNMENT:</a:t>
             </a:r>
           </a:p>
           <a:p>
@@ -3262,11 +3262,11 @@
               </a:defRPr>
             </a:pPr>
             <a:r>
-              <a:t>Ebrahim Mokhtari (COO)   |   Ashish Chhabra (Procurement Lead)   |   Aaron Bell (Tech Lead)</a:t>
+              <a:t>Ebrahim Mokhtari (Chief Operating Officer)   |   Ashish Chhabra (Procurement Lead)   |   Aaron Bell (Tech Lead)</a:t>
             </a:r>
             <a:br/>
             <a:r>
-              <a:t>Executive Workshop: Thursday, September 3, 2026 @ 10:00 AM</a:t>
+              <a:t>Executive Leadership Workshop: Thursday, September 3, 2026 @ 10:00 AM</a:t>
             </a:r>
           </a:p>
         </p:txBody>
@@ -3323,7 +3323,7 @@
               </a:defRPr>
             </a:pPr>
             <a:r>
-              <a:t>SITE EXPANSION ROADMAP</a:t>
+              <a:t>SITE EXPANSION FRAMEWORK</a:t>
             </a:r>
           </a:p>
           <a:p>
@@ -3436,7 +3436,7 @@
               </a:defRPr>
             </a:pPr>
             <a:r>
-              <a:t>Master Setup &amp; Provisioning</a:t>
+              <a:t>Master Setup &amp; Accounts</a:t>
             </a:r>
           </a:p>
           <a:p>
@@ -3452,7 +3452,7 @@
                 </a:solidFill>
                 <a:latin typeface="Segoe UI"/>
               </a:rPr>
-              <a:t>• Configure delivery addresses and vendor account links for Adelaide.</a:t>
+              <a:t>• Configure delivery addresses &amp; vendor accounts for Adelaide.</a:t>
             </a:r>
           </a:p>
           <a:p>
@@ -3600,7 +3600,7 @@
                 </a:solidFill>
                 <a:latin typeface="Segoe UI"/>
               </a:rPr>
-              <a:t>• Distribute standardized ProcureFlow training video to Adelaide team.</a:t>
+              <a:t>• Distribute standardized ProcureFlow training video to Adelaide staff.</a:t>
             </a:r>
           </a:p>
           <a:p>
@@ -3985,7 +3985,7 @@
               </a:defRPr>
             </a:pPr>
             <a:r>
-              <a:t>STRATEGIC ALIGNMENT</a:t>
+              <a:t>STRATEGIC TRANSFORMATION</a:t>
             </a:r>
           </a:p>
           <a:p>
@@ -3998,7 +3998,7 @@
               </a:defRPr>
             </a:pPr>
             <a:r>
-              <a:t>Strategic Mindset: Elevating a Working Operational Platform</a:t>
+              <a:t>Strategic Mindset: The Three-Horizon Transformation Model</a:t>
             </a:r>
           </a:p>
         </p:txBody>
@@ -4082,7 +4082,7 @@
               </a:defRPr>
             </a:pPr>
             <a:r>
-              <a:t>1. WORKING PLATFORM</a:t>
+              <a:t>HORIZON 1: LAST 3 MONTHS</a:t>
             </a:r>
           </a:p>
           <a:p>
@@ -4098,7 +4098,7 @@
               </a:defRPr>
             </a:pPr>
             <a:r>
-              <a:t>Proven Daily Engine</a:t>
+              <a:t>Completed Achievements</a:t>
             </a:r>
           </a:p>
           <a:p>
@@ -4114,7 +4114,7 @@
                 </a:solidFill>
                 <a:latin typeface="Segoe UI"/>
               </a:rPr>
-              <a:t>• Runs daily purchasing across 11 operating facilities nationally.</a:t>
+              <a:t>• Collaborative Triad Overhaul: Aaron Bell, Ashish Chhabra &amp; Kiran unified national SKU master data.</a:t>
             </a:r>
           </a:p>
           <a:p>
@@ -4130,7 +4130,7 @@
                 </a:solidFill>
                 <a:latin typeface="Segoe UI"/>
               </a:rPr>
-              <a:t>• 100% SKU mapping achieved by Aaron Bell, Ashish Chhabra &amp; Kiran.</a:t>
+              <a:t>• Supplier Linkage Surge: Compliance surged from ~50% in Feb-Apr to ~95%-100% currently.</a:t>
             </a:r>
           </a:p>
           <a:p>
@@ -4146,7 +4146,7 @@
                 </a:solidFill>
                 <a:latin typeface="Segoe UI"/>
               </a:rPr>
-              <a:t>• On-site digital goods receipting (GR) and docket capture active.</a:t>
+              <a:t>• Procurement Email Engine: Automated background ingestion of supplier stock and catalog updates.</a:t>
             </a:r>
           </a:p>
           <a:p>
@@ -4162,7 +4162,7 @@
                 </a:solidFill>
                 <a:latin typeface="Segoe UI"/>
               </a:rPr>
-              <a:t>• High adoption across site managers, plant supervisors &amp; procurement.</a:t>
+              <a:t>• 11 Operating Facilities Live: Active daily purchasing across 8 primary regional hubs plus satellite plants.</a:t>
             </a:r>
           </a:p>
         </p:txBody>
@@ -4246,7 +4246,7 @@
               </a:defRPr>
             </a:pPr>
             <a:r>
-              <a:t>2. TARGET OF THIS PLAN</a:t>
+              <a:t>HORIZON 2: CURRENT ELEVATION</a:t>
             </a:r>
           </a:p>
           <a:p>
@@ -4262,7 +4262,7 @@
               </a:defRPr>
             </a:pPr>
             <a:r>
-              <a:t>Targeted Continuous Improvement</a:t>
+              <a:t>Closed-Loop Governance</a:t>
             </a:r>
           </a:p>
           <a:p>
@@ -4278,7 +4278,7 @@
                 </a:solidFill>
                 <a:latin typeface="Segoe UI"/>
               </a:rPr>
-              <a:t>• Not 'fixing' a broken tool: ProcureFlow already runs reliably.</a:t>
+              <a:t>• Point-of-Entry Governance: Modulo packaging rules &amp; 1-click smart rounding (e.g. 5,000 -&gt; 5,040).</a:t>
             </a:r>
           </a:p>
           <a:p>
@@ -4294,7 +4294,7 @@
                 </a:solidFill>
                 <a:latin typeface="Segoe UI"/>
               </a:rPr>
-              <a:t>• Eliminating human friction: Removing manual Excel crunching and packaging typos.</a:t>
+              <a:t>• Contract Price Master Parity: Zero-price block &amp; contracted rates auto-population.</a:t>
             </a:r>
           </a:p>
           <a:p>
@@ -4310,7 +4310,7 @@
                 </a:solidFill>
                 <a:latin typeface="Segoe UI"/>
               </a:rPr>
-              <a:t>• Point-of-entry guardrails: Guiding users to zero-defect ordering at the source.</a:t>
+              <a:t>• Mandatory Concur PR Link: Enforces 100% ERP mirroring before an order can be closed.</a:t>
             </a:r>
           </a:p>
           <a:p>
@@ -4326,7 +4326,7 @@
                 </a:solidFill>
                 <a:latin typeface="Segoe UI"/>
               </a:rPr>
-              <a:t>• Single source of truth: Permanently synchronizing ProcureFlow with SAP Concur.</a:t>
+              <a:t>• Executive EOM Reconciliation: Real-time 2D Pivot Table &amp; FY27 Budget ($14.521M) burn rate tracking.</a:t>
             </a:r>
           </a:p>
         </p:txBody>
@@ -4410,7 +4410,7 @@
               </a:defRPr>
             </a:pPr>
             <a:r>
-              <a:t>3. FORWARD PIPELINE</a:t>
+              <a:t>HORIZON 3: NEXT 2 MONTHS</a:t>
             </a:r>
           </a:p>
           <a:p>
@@ -4426,7 +4426,7 @@
               </a:defRPr>
             </a:pPr>
             <a:r>
-              <a:t>Future 2-Month Horizon</a:t>
+              <a:t>Strategic Forward Pipeline</a:t>
             </a:r>
           </a:p>
           <a:p>
@@ -4442,7 +4442,7 @@
                 </a:solidFill>
                 <a:latin typeface="Segoe UI"/>
               </a:rPr>
-              <a:t>• Live SOH Testing Pipeline: 2-month validation before retiring manual emails.</a:t>
+              <a:t>• Adelaide Rollout Blueprint: 4-phase structured expansion template for site onboarding.</a:t>
             </a:r>
           </a:p>
           <a:p>
@@ -4458,7 +4458,7 @@
                 </a:solidFill>
                 <a:latin typeface="Segoe UI"/>
               </a:rPr>
-              <a:t>• Adelaide Rollout Blueprint: 4-phase structured expansion template.</a:t>
+              <a:t>• Live SOH 2-Month Testing Pipeline: Parallel validation before retiring manual weekly emails.</a:t>
             </a:r>
           </a:p>
           <a:p>
@@ -4474,7 +4474,7 @@
                 </a:solidFill>
                 <a:latin typeface="Segoe UI"/>
               </a:rPr>
-              <a:t>• Training Video Governance: Mandatory user completion sign-off.</a:t>
+              <a:t>• Mandatory Training Governance: User video completion sign-off before purchasing activation.</a:t>
             </a:r>
           </a:p>
           <a:p>
@@ -4490,7 +4490,7 @@
                 </a:solidFill>
                 <a:latin typeface="Segoe UI"/>
               </a:rPr>
-              <a:t>• Omnichannel Notifications: Seamless Teams and email integration.</a:t>
+              <a:t>• Short Supply Logic Migration: Native parity with legacy BI/Power Apps workflow.</a:t>
             </a:r>
           </a:p>
         </p:txBody>
@@ -4560,7 +4560,7 @@
               </a:defRPr>
             </a:pPr>
             <a:r>
-              <a:t>Section 1: Completed Achievements in the Last Three Months</a:t>
+              <a:t>Horizon 1: Completed Achievements in the Last Three Months</a:t>
             </a:r>
           </a:p>
         </p:txBody>
@@ -4644,7 +4644,7 @@
               </a:defRPr>
             </a:pPr>
             <a:r>
-              <a:t>01  |  COLLABORATIVE TRIAD EXECUTION &amp; SKU MANAGEMENT</a:t>
+              <a:t>01  |  COLLABORATIVE TRIAD MASTER SKU MANAGEMENT</a:t>
             </a:r>
           </a:p>
           <a:p>
@@ -4741,7 +4741,7 @@
               </a:defRPr>
             </a:pPr>
             <a:r>
-              <a:t>02  |  AUTOMATED SPL PROCUREMENT EMAIL SYSTEM</a:t>
+              <a:t>02  |  AUTOMATED PROCUREMENT EMAIL INGESTION</a:t>
             </a:r>
           </a:p>
           <a:p>
@@ -4754,7 +4754,7 @@
               </a:defRPr>
             </a:pPr>
             <a:r>
-              <a:t>Engineered automated email ingestion pipelines directly reading incoming vendor inventory feeds and catalog updates in the background, eliminating hours of manual data entry.</a:t>
+              <a:t>Engineered automated email ingestion directly reading vendor inventory feeds and catalog updates from procurement@splservices.com.au, eliminating hours of manual data entry.</a:t>
             </a:r>
           </a:p>
         </p:txBody>
@@ -4935,7 +4935,7 @@
               </a:defRPr>
             </a:pPr>
             <a:r>
-              <a:t>04  |  TRAINING VIDEO &amp; GOVERNANCE PROTOCOL</a:t>
+              <a:t>04  |  DIGITAL GOODS RECEIPTING (GR) &amp; DOCKET CAPTURE</a:t>
             </a:r>
           </a:p>
           <a:p>
@@ -4948,7 +4948,7 @@
               </a:defRPr>
             </a:pPr>
             <a:r>
-              <a:t>Implemented mandatory user governance: Site staff must watch the standardized training video and confirm/tick off completion before receiving active purchasing credentials.</a:t>
+              <a:t>Warehouse receiving teams capture delivery dockets, quantities received, and signatures digitally on floor tablets, providing the factual bedrock for automated 3-way invoice matching.</a:t>
             </a:r>
           </a:p>
         </p:txBody>
@@ -5416,7 +5416,7 @@
               </a:defRPr>
             </a:pPr>
             <a:r>
-              <a:t>Improvement 1: Point-of-Entry Packaging Governance</a:t>
+              <a:t>Horizon 2: Point-of-Entry Packaging Governance</a:t>
             </a:r>
           </a:p>
         </p:txBody>
@@ -5815,7 +5815,7 @@
               </a:defRPr>
             </a:pPr>
             <a:r>
-              <a:t>Improvement 2: Contract Price Master &amp; Zero Invoice Variances</a:t>
+              <a:t>Horizon 2: Contract Price Master &amp; Zero Invoice Variances</a:t>
             </a:r>
           </a:p>
         </p:txBody>
@@ -6214,7 +6214,7 @@
               </a:defRPr>
             </a:pPr>
             <a:r>
-              <a:t>Improvement 3: Mandatory Concur PR # Enforcement &amp; Task Visibility</a:t>
+              <a:t>Horizon 2: Mandatory Concur PR # Enforcement &amp; Task Visibility</a:t>
             </a:r>
           </a:p>
         </p:txBody>
@@ -6534,7 +6534,7 @@
                 </a:solidFill>
                 <a:latin typeface="Segoe UI"/>
               </a:rPr>
-              <a:t>✓ Mobile Polish Included: </a:t>
+              <a:t>✓ Instant Task Access: </a:t>
             </a:r>
             <a:r>
               <a:rPr sz="1050">
@@ -6543,7 +6543,7 @@
                 </a:solidFill>
                 <a:latin typeface="Segoe UI"/>
               </a:rPr>
-              <a:t>Fixed mobile requests scrolling bug, enabling seamless viewing on tablets and phones.</a:t>
+              <a:t>Homepage banner provides 1-click navigation directly to pending orders.</a:t>
             </a:r>
           </a:p>
         </p:txBody>
@@ -6613,7 +6613,7 @@
               </a:defRPr>
             </a:pPr>
             <a:r>
-              <a:t>Improvement 4: Native EOM Spend &amp; Budget Reconciliation Engine</a:t>
+              <a:t>Horizon 2: Native EOM Spend &amp; Budget Reconciliation Engine</a:t>
             </a:r>
           </a:p>
         </p:txBody>
@@ -7332,7 +7332,7 @@
               </a:defRPr>
             </a:pPr>
             <a:r>
-              <a:t>STRATEGIC PIPELINE</a:t>
+              <a:t>FUTURE SCALING ROADMAP</a:t>
             </a:r>
           </a:p>
           <a:p>
@@ -7345,7 +7345,7 @@
               </a:defRPr>
             </a:pPr>
             <a:r>
-              <a:t>Forward Pipeline (Next 2 Months): Live SOH Testing &amp; Omnichannel Alerts</a:t>
+              <a:t>Horizon 3: Strategic Forward Pipeline (Next 2 Months)</a:t>
             </a:r>
           </a:p>
         </p:txBody>
@@ -7429,7 +7429,7 @@
               </a:defRPr>
             </a:pPr>
             <a:r>
-              <a:t>SUPPLIER INVENTORY TESTING PIPELINE</a:t>
+              <a:t>INVENTORY &amp; GOVERNANCE PIPELINE</a:t>
             </a:r>
           </a:p>
           <a:p>
@@ -7445,7 +7445,7 @@
               </a:defRPr>
             </a:pPr>
             <a:r>
-              <a:t>2-Month Live SOH Validation Phase</a:t>
+              <a:t>Live SOH &amp; Training Governance</a:t>
             </a:r>
           </a:p>
           <a:p>
@@ -7461,7 +7461,7 @@
                 </a:solidFill>
                 <a:latin typeface="Segoe UI"/>
               </a:rPr>
-              <a:t>✓ Months 1–2 Testing Window: </a:t>
+              <a:t>✓ 2-Month Live SOH Testing: </a:t>
             </a:r>
             <a:r>
               <a:rPr sz="1000">
@@ -7470,32 +7470,7 @@
                 </a:solidFill>
                 <a:latin typeface="Segoe UI"/>
               </a:rPr>
-              <a:t>Procurement (Ashish) and Tech (Aaron) conduct parallel testing of live inventory feeds in ProcureFlow vs manual Excel reports.</a:t>
-            </a:r>
-          </a:p>
-          <a:p>
-            <a:pPr>
-              <a:spcAft>
-                <a:spcPts val="800"/>
-              </a:spcAft>
-            </a:pPr>
-            <a:r>
-              <a:rPr sz="1000" b="1">
-                <a:solidFill>
-                  <a:srgbClr val="0F172A"/>
-                </a:solidFill>
-                <a:latin typeface="Segoe UI"/>
-              </a:rPr>
-              <a:t>✓ Verification Gate: </a:t>
-            </a:r>
-            <a:r>
-              <a:rPr sz="1000">
-                <a:solidFill>
-                  <a:srgbClr val="475569"/>
-                </a:solidFill>
-                <a:latin typeface="Segoe UI"/>
-              </a:rPr>
-              <a:t>Thoroughly test data consistency across two full month-end cycles before directing branch managers to rely 100% on system data.</a:t>
+              <a:t>Ashish Chhabra and Aaron Bell run parallel comparisons of live inventory feeds in ProcureFlow vs manual Excel reports across Sept-Oct 2026.</a:t>
             </a:r>
           </a:p>
           <a:p>
@@ -7520,7 +7495,7 @@
                 </a:solidFill>
                 <a:latin typeface="Segoe UI"/>
               </a:rPr>
-              <a:t>Formally deprecates the time-consuming weekly emailing of supplier spreadsheets.</a:t>
+              <a:t>Once 100% parity is verified across 2 billing cycles, plant managers will rely exclusively on ProcureFlow, retiring weekly Excel emailing.</a:t>
             </a:r>
           </a:p>
           <a:p>
@@ -7536,7 +7511,7 @@
                 </a:solidFill>
                 <a:latin typeface="Segoe UI"/>
               </a:rPr>
-              <a:t>✓ Pre-Requisition Visibility: </a:t>
+              <a:t>✓ Mandatory Training Video: </a:t>
             </a:r>
             <a:r>
               <a:rPr sz="1000">
@@ -7545,7 +7520,32 @@
                 </a:solidFill>
                 <a:latin typeface="Segoe UI"/>
               </a:rPr>
-              <a:t>Allows state managers to see real-time stock levels before ordering.</a:t>
+              <a:t>Site staff must complete the interactive video training module and digitally confirm sign-off before purchasing access is enabled.</a:t>
+            </a:r>
+          </a:p>
+          <a:p>
+            <a:pPr>
+              <a:spcAft>
+                <a:spcPts val="800"/>
+              </a:spcAft>
+            </a:pPr>
+            <a:r>
+              <a:rPr sz="1000" b="1">
+                <a:solidFill>
+                  <a:srgbClr val="0F172A"/>
+                </a:solidFill>
+                <a:latin typeface="Segoe UI"/>
+              </a:rPr>
+              <a:t>✓ Audit Compliance: </a:t>
+            </a:r>
+            <a:r>
+              <a:rPr sz="1000">
+                <a:solidFill>
+                  <a:srgbClr val="475569"/>
+                </a:solidFill>
+                <a:latin typeface="Segoe UI"/>
+              </a:rPr>
+              <a:t>Creates an audited record proving staff understand packaging rules, price validation, and Concur PR # attachment.</a:t>
             </a:r>
           </a:p>
         </p:txBody>
@@ -7629,7 +7629,7 @@
               </a:defRPr>
             </a:pPr>
             <a:r>
-              <a:t>OMNICHANNEL NOTIFICATIONS &amp; ESCALATION</a:t>
+              <a:t>SYSTEM MIGRATION &amp; ESCALATIONS</a:t>
             </a:r>
           </a:p>
           <a:p>
@@ -7645,7 +7645,57 @@
               </a:defRPr>
             </a:pPr>
             <a:r>
-              <a:t>Closing the Operational Loop</a:t>
+              <a:t>Short Supply &amp; Omnichannel Reach</a:t>
+            </a:r>
+          </a:p>
+          <a:p>
+            <a:pPr>
+              <a:spcAft>
+                <a:spcPts val="800"/>
+              </a:spcAft>
+            </a:pPr>
+            <a:r>
+              <a:rPr sz="1000" b="1">
+                <a:solidFill>
+                  <a:srgbClr val="0F172A"/>
+                </a:solidFill>
+                <a:latin typeface="Segoe UI"/>
+              </a:rPr>
+              <a:t>✓ Short Supply Logic Migration: </a:t>
+            </a:r>
+            <a:r>
+              <a:rPr sz="1000">
+                <a:solidFill>
+                  <a:srgbClr val="475569"/>
+                </a:solidFill>
+                <a:latin typeface="Segoe UI"/>
+              </a:rPr>
+              <a:t>Migrate the legacy Short Supply BI / Power Apps workflow natively into ProcureFlow with validated mathematical parity.</a:t>
+            </a:r>
+          </a:p>
+          <a:p>
+            <a:pPr>
+              <a:spcAft>
+                <a:spcPts val="800"/>
+              </a:spcAft>
+            </a:pPr>
+            <a:r>
+              <a:rPr sz="1000" b="1">
+                <a:solidFill>
+                  <a:srgbClr val="0F172A"/>
+                </a:solidFill>
+                <a:latin typeface="Segoe UI"/>
+              </a:rPr>
+              <a:t>✓ Demand vs Availability: </a:t>
+            </a:r>
+            <a:r>
+              <a:rPr sz="1000">
+                <a:solidFill>
+                  <a:srgbClr val="475569"/>
+                </a:solidFill>
+                <a:latin typeface="Segoe UI"/>
+              </a:rPr>
+              <a:t>Calculates net availability by comparing supplier inventory against committed branch linen demand.</a:t>
             </a:r>
           </a:p>
           <a:p>
@@ -7670,7 +7720,7 @@
                 </a:solidFill>
                 <a:latin typeface="Segoe UI"/>
               </a:rPr>
-              <a:t>Automated daily reminders to complete delivered orders; variance routing to Ashish if delivered quantities differ.</a:t>
+              <a:t>Automated daily reminders to complete delivered orders; prompts variance resolution with Ashish if quantities differ.</a:t>
             </a:r>
           </a:p>
           <a:p>
@@ -7711,7 +7761,7 @@
                 </a:solidFill>
                 <a:latin typeface="Segoe UI"/>
               </a:rPr>
-              <a:t>✓ In-App Notification Hub: </a:t>
+              <a:t>✓ Teams Adaptive Cards (v1.4): </a:t>
             </a:r>
             <a:r>
               <a:rPr sz="1000">
@@ -7720,32 +7770,7 @@
                 </a:solidFill>
                 <a:latin typeface="Segoe UI"/>
               </a:rPr>
-              <a:t>Live slide-over drawer with unread badge indicators and direct action deep-links.</a:t>
-            </a:r>
-          </a:p>
-          <a:p>
-            <a:pPr>
-              <a:spcAft>
-                <a:spcPts val="800"/>
-              </a:spcAft>
-            </a:pPr>
-            <a:r>
-              <a:rPr sz="1000" b="1">
-                <a:solidFill>
-                  <a:srgbClr val="0F172A"/>
-                </a:solidFill>
-                <a:latin typeface="Segoe UI"/>
-              </a:rPr>
-              <a:t>✓ Microsoft Teams &amp; Email: </a:t>
-            </a:r>
-            <a:r>
-              <a:rPr sz="1000">
-                <a:solidFill>
-                  <a:srgbClr val="475569"/>
-                </a:solidFill>
-                <a:latin typeface="Segoe UI"/>
-              </a:rPr>
-              <a:t>Actionable Teams Adaptive Cards (v1.4) and Graph HTML emails with 1-click approvals.</a:t>
+              <a:t>Direct 1-click approvals sent to Microsoft Teams and Outlook.</a:t>
             </a:r>
           </a:p>
         </p:txBody>

</xml_diff>

<commit_message>
docs: remove workshop schedule and Adelaide rollout references, confirming all 11 facilities operating live under uniform governance
</commit_message>
<xml_diff>
--- a/docs/ProcureFlow_Executive_Roadmap.pptx
+++ b/docs/ProcureFlow_Executive_Roadmap.pptx
@@ -3150,8 +3150,8 @@
         </p:nvSpPr>
         <p:spPr>
           <a:xfrm>
-            <a:off x="914400" y="1463040"/>
-            <a:ext cx="10362895" cy="4389120"/>
+            <a:off x="914400" y="1645920"/>
+            <a:ext cx="10362895" cy="4114800"/>
           </a:xfrm>
           <a:prstGeom prst="rect">
             <a:avLst/>
@@ -3229,11 +3229,11 @@
             </a:r>
             <a:br/>
             <a:r>
-              <a:t>Key Presenters: Ashish Chhabra (Procurement Lead) &amp; Aaron Bell (Tech Lead / Architect)</a:t>
+              <a:t>Key Presenters: Ashish Chhabra (Procurement Lead) &amp; Aaron Bell (Tech Lead / Software Architect)</a:t>
             </a:r>
             <a:br/>
             <a:r>
-              <a:t>Schedule: Pre-Alignment 8:30 AM | Executive Leadership Workshop 10:00 AM — Thursday, 3 September 2026</a:t>
+              <a:t>Date: September 2026</a:t>
             </a:r>
           </a:p>
         </p:txBody>
@@ -3810,7 +3810,7 @@
               </a:defRPr>
             </a:pPr>
             <a:r>
-              <a:t>SITE ROLLOUT FRAMEWORK</a:t>
+              <a:t>NATIONAL OPERATIONAL COVERAGE</a:t>
             </a:r>
           </a:p>
           <a:p>
@@ -3823,7 +3823,7 @@
               </a:defRPr>
             </a:pPr>
             <a:r>
-              <a:t>Site Expansion Blueprint: Adelaide 4-Phase Implementation Framework</a:t>
+              <a:t>National Operating Footprint: 11 Live Sites Under Standardized Governance</a:t>
             </a:r>
           </a:p>
         </p:txBody>
@@ -3837,7 +3837,7 @@
         <p:spPr>
           <a:xfrm>
             <a:off x="731520" y="1463040"/>
-            <a:ext cx="2468880" cy="4846320"/>
+            <a:ext cx="5166360" cy="4846320"/>
           </a:xfrm>
           <a:prstGeom prst="roundRect">
             <a:avLst/>
@@ -3882,7 +3882,7 @@
         <p:spPr>
           <a:xfrm>
             <a:off x="731520" y="1463040"/>
-            <a:ext cx="2468880" cy="502920"/>
+            <a:ext cx="5166360" cy="502920"/>
           </a:xfrm>
           <a:prstGeom prst="roundRect">
             <a:avLst/>
@@ -3921,7 +3921,7 @@
               </a:defRPr>
             </a:pPr>
             <a:r>
-              <a:t>PHASE 1 (WEEK 1)</a:t>
+              <a:t>PRIMARY REGIONAL HUBS (8 HUBS - 100% LIVE)</a:t>
             </a:r>
           </a:p>
         </p:txBody>
@@ -3934,8 +3934,8 @@
         </p:nvSpPr>
         <p:spPr>
           <a:xfrm>
-            <a:off x="868680" y="2057400"/>
-            <a:ext cx="2194560" cy="4114800"/>
+            <a:off x="914400" y="2057400"/>
+            <a:ext cx="4800600" cy="4114800"/>
           </a:xfrm>
           <a:prstGeom prst="rect">
             <a:avLst/>
@@ -3947,22 +3947,7 @@
             <a:spAutoFit/>
           </a:bodyPr>
           <a:lstStyle/>
-          <a:p>
-            <a:pPr>
-              <a:spcAft>
-                <a:spcPts val="1200"/>
-              </a:spcAft>
-              <a:defRPr sz="1300" b="1">
-                <a:solidFill>
-                  <a:srgbClr val="0F172A"/>
-                </a:solidFill>
-                <a:latin typeface="Segoe UI"/>
-              </a:defRPr>
-            </a:pPr>
-            <a:r>
-              <a:t>Master Setup &amp; Accounts</a:t>
-            </a:r>
-          </a:p>
+          <a:p/>
           <a:p>
             <a:pPr>
               <a:spcAft>
@@ -3976,7 +3961,7 @@
                 </a:solidFill>
                 <a:latin typeface="Segoe UI"/>
               </a:rPr>
-              <a:t>Delivery Addresses: </a:t>
+              <a:t>Melbourne Hub: </a:t>
             </a:r>
             <a:r>
               <a:rPr sz="1000">
@@ -3985,7 +3970,7 @@
                 </a:solidFill>
                 <a:latin typeface="Segoe UI"/>
               </a:rPr>
-              <a:t>Configure Adelaide primary hub &amp; satellite plant addresses.</a:t>
+              <a:t>Primary commercial plant; high-volume healthcare (HSV) and accommodation routing.</a:t>
             </a:r>
           </a:p>
           <a:p>
@@ -4001,7 +3986,7 @@
                 </a:solidFill>
                 <a:latin typeface="Segoe UI"/>
               </a:rPr>
-              <a:t>Vendor Linking: </a:t>
+              <a:t>Sydney Hub: </a:t>
             </a:r>
             <a:r>
               <a:rPr sz="1000">
@@ -4010,7 +3995,7 @@
                 </a:solidFill>
                 <a:latin typeface="Segoe UI"/>
               </a:rPr>
-              <a:t>Set up Adelaide-specific Simba &amp; Host supplier account codes.</a:t>
+              <a:t>Metropolitan commercial laundry operations; direct Simba &amp; Host replenishment.</a:t>
             </a:r>
           </a:p>
           <a:p>
@@ -4026,7 +4011,7 @@
                 </a:solidFill>
                 <a:latin typeface="Segoe UI"/>
               </a:rPr>
-              <a:t>Catalog Schedules: </a:t>
+              <a:t>Brisbane Hub: </a:t>
             </a:r>
             <a:r>
               <a:rPr sz="1000">
@@ -4035,7 +4020,7 @@
                 </a:solidFill>
                 <a:latin typeface="Segoe UI"/>
               </a:rPr>
-              <a:t>Calibrate local state pricing and freight rules.</a:t>
+              <a:t>Queensland commercial operations; regional healthcare contract fulfillment.</a:t>
             </a:r>
           </a:p>
           <a:p>
@@ -4051,7 +4036,7 @@
                 </a:solidFill>
                 <a:latin typeface="Segoe UI"/>
               </a:rPr>
-              <a:t>User Accounts: </a:t>
+              <a:t>Perth Hub: </a:t>
             </a:r>
             <a:r>
               <a:rPr sz="1000">
@@ -4060,7 +4045,82 @@
                 </a:solidFill>
                 <a:latin typeface="Segoe UI"/>
               </a:rPr>
-              <a:t>Provision Plant Manager, Requesters, and Receivers.</a:t>
+              <a:t>Western Australia operations; remote transit supply chain coordination.</a:t>
+            </a:r>
+          </a:p>
+          <a:p>
+            <a:pPr>
+              <a:spcAft>
+                <a:spcPts val="800"/>
+              </a:spcAft>
+            </a:pPr>
+            <a:r>
+              <a:rPr sz="1000" b="1">
+                <a:solidFill>
+                  <a:srgbClr val="0284C7"/>
+                </a:solidFill>
+                <a:latin typeface="Segoe UI"/>
+              </a:rPr>
+              <a:t>Adelaide Hub: </a:t>
+            </a:r>
+            <a:r>
+              <a:rPr sz="1000">
+                <a:solidFill>
+                  <a:srgbClr val="0F172A"/>
+                </a:solidFill>
+                <a:latin typeface="Segoe UI"/>
+              </a:rPr>
+              <a:t>Active live plant; standard daily ordering and goods receipting fully operational.</a:t>
+            </a:r>
+          </a:p>
+          <a:p>
+            <a:pPr>
+              <a:spcAft>
+                <a:spcPts val="800"/>
+              </a:spcAft>
+            </a:pPr>
+            <a:r>
+              <a:rPr sz="1000" b="1">
+                <a:solidFill>
+                  <a:srgbClr val="0284C7"/>
+                </a:solidFill>
+                <a:latin typeface="Segoe UI"/>
+              </a:rPr>
+              <a:t>Cairns &amp; Mackay: </a:t>
+            </a:r>
+            <a:r>
+              <a:rPr sz="1000">
+                <a:solidFill>
+                  <a:srgbClr val="0F172A"/>
+                </a:solidFill>
+                <a:latin typeface="Segoe UI"/>
+              </a:rPr>
+              <a:t>Regional Queensland hospitality and healthcare operational hubs.</a:t>
+            </a:r>
+          </a:p>
+          <a:p>
+            <a:pPr>
+              <a:spcAft>
+                <a:spcPts val="800"/>
+              </a:spcAft>
+            </a:pPr>
+            <a:r>
+              <a:rPr sz="1000" b="1">
+                <a:solidFill>
+                  <a:srgbClr val="0284C7"/>
+                </a:solidFill>
+                <a:latin typeface="Segoe UI"/>
+              </a:rPr>
+              <a:t>Albury Plant: </a:t>
+            </a:r>
+            <a:r>
+              <a:rPr sz="1000">
+                <a:solidFill>
+                  <a:srgbClr val="0F172A"/>
+                </a:solidFill>
+                <a:latin typeface="Segoe UI"/>
+              </a:rPr>
+              <a:t>Regional processing center; attributed cost routing coordinated with Melbourne.</a:t>
             </a:r>
           </a:p>
         </p:txBody>
@@ -4073,8 +4133,8 @@
         </p:nvSpPr>
         <p:spPr>
           <a:xfrm>
-            <a:off x="3483864" y="1463040"/>
-            <a:ext cx="2468880" cy="4846320"/>
+            <a:off x="6291072" y="1463040"/>
+            <a:ext cx="5166360" cy="4846320"/>
           </a:xfrm>
           <a:prstGeom prst="roundRect">
             <a:avLst/>
@@ -4118,482 +4178,8 @@
         </p:nvSpPr>
         <p:spPr>
           <a:xfrm>
-            <a:off x="3483864" y="1463040"/>
-            <a:ext cx="2468880" cy="502920"/>
-          </a:xfrm>
-          <a:prstGeom prst="roundRect">
-            <a:avLst/>
-          </a:prstGeom>
-          <a:solidFill>
-            <a:srgbClr val="7E22CE"/>
-          </a:solidFill>
-          <a:ln>
-            <a:noFill/>
-          </a:ln>
-        </p:spPr>
-        <p:style>
-          <a:lnRef idx="1">
-            <a:schemeClr val="accent1"/>
-          </a:lnRef>
-          <a:fillRef idx="3">
-            <a:schemeClr val="accent1"/>
-          </a:fillRef>
-          <a:effectRef idx="2">
-            <a:schemeClr val="accent1"/>
-          </a:effectRef>
-          <a:fontRef idx="minor">
-            <a:schemeClr val="lt1"/>
-          </a:fontRef>
-        </p:style>
-        <p:txBody>
-          <a:bodyPr rtlCol="0" anchor="ctr" lIns="137160" tIns="109728"/>
-          <a:lstStyle/>
-          <a:p>
-            <a:pPr algn="ctr">
-              <a:defRPr sz="1000" b="1">
-                <a:solidFill>
-                  <a:srgbClr val="FFFFFF"/>
-                </a:solidFill>
-                <a:latin typeface="Segoe UI"/>
-              </a:defRPr>
-            </a:pPr>
-            <a:r>
-              <a:t>PHASE 2 (WEEK 2)</a:t>
-            </a:r>
-          </a:p>
-        </p:txBody>
-      </p:sp>
-      <p:sp>
-        <p:nvSpPr>
-          <p:cNvPr id="8" name="TextBox 7"/>
-          <p:cNvSpPr txBox="1"/>
-          <p:nvPr/>
-        </p:nvSpPr>
-        <p:spPr>
-          <a:xfrm>
-            <a:off x="3621024" y="2057400"/>
-            <a:ext cx="2194560" cy="4114800"/>
-          </a:xfrm>
-          <a:prstGeom prst="rect">
-            <a:avLst/>
-          </a:prstGeom>
-          <a:noFill/>
-        </p:spPr>
-        <p:txBody>
-          <a:bodyPr wrap="square">
-            <a:spAutoFit/>
-          </a:bodyPr>
-          <a:lstStyle/>
-          <a:p>
-            <a:pPr>
-              <a:spcAft>
-                <a:spcPts val="1200"/>
-              </a:spcAft>
-              <a:defRPr sz="1300" b="1">
-                <a:solidFill>
-                  <a:srgbClr val="0F172A"/>
-                </a:solidFill>
-                <a:latin typeface="Segoe UI"/>
-              </a:defRPr>
-            </a:pPr>
-            <a:r>
-              <a:t>Governance &amp; Video Sign-Off</a:t>
-            </a:r>
-          </a:p>
-          <a:p>
-            <a:pPr>
-              <a:spcAft>
-                <a:spcPts val="800"/>
-              </a:spcAft>
-            </a:pPr>
-            <a:r>
-              <a:rPr sz="1000" b="1">
-                <a:solidFill>
-                  <a:srgbClr val="7E22CE"/>
-                </a:solidFill>
-                <a:latin typeface="Segoe UI"/>
-              </a:rPr>
-              <a:t>Video Rollout: </a:t>
-            </a:r>
-            <a:r>
-              <a:rPr sz="1000">
-                <a:solidFill>
-                  <a:srgbClr val="0F172A"/>
-                </a:solidFill>
-                <a:latin typeface="Segoe UI"/>
-              </a:rPr>
-              <a:t>Mandatory training module assigned to Adelaide staff.</a:t>
-            </a:r>
-          </a:p>
-          <a:p>
-            <a:pPr>
-              <a:spcAft>
-                <a:spcPts val="800"/>
-              </a:spcAft>
-            </a:pPr>
-            <a:r>
-              <a:rPr sz="1000" b="1">
-                <a:solidFill>
-                  <a:srgbClr val="7E22CE"/>
-                </a:solidFill>
-                <a:latin typeface="Segoe UI"/>
-              </a:rPr>
-              <a:t>Digital Sign-Off: </a:t>
-            </a:r>
-            <a:r>
-              <a:rPr sz="1000">
-                <a:solidFill>
-                  <a:srgbClr val="0F172A"/>
-                </a:solidFill>
-                <a:latin typeface="Segoe UI"/>
-              </a:rPr>
-              <a:t>Requesters complete in-app confirmation before ordering.</a:t>
-            </a:r>
-          </a:p>
-          <a:p>
-            <a:pPr>
-              <a:spcAft>
-                <a:spcPts val="800"/>
-              </a:spcAft>
-            </a:pPr>
-            <a:r>
-              <a:rPr sz="1000" b="1">
-                <a:solidFill>
-                  <a:srgbClr val="7E22CE"/>
-                </a:solidFill>
-                <a:latin typeface="Segoe UI"/>
-              </a:rPr>
-              <a:t>Procurement Alignment: </a:t>
-            </a:r>
-            <a:r>
-              <a:rPr sz="1000">
-                <a:solidFill>
-                  <a:srgbClr val="0F172A"/>
-                </a:solidFill>
-                <a:latin typeface="Segoe UI"/>
-              </a:rPr>
-              <a:t>Operational walk-through session with Ashish Chhabra.</a:t>
-            </a:r>
-          </a:p>
-          <a:p>
-            <a:pPr>
-              <a:spcAft>
-                <a:spcPts val="800"/>
-              </a:spcAft>
-            </a:pPr>
-            <a:r>
-              <a:rPr sz="1000" b="1">
-                <a:solidFill>
-                  <a:srgbClr val="7E22CE"/>
-                </a:solidFill>
-                <a:latin typeface="Segoe UI"/>
-              </a:rPr>
-              <a:t>Receiving Alignment: </a:t>
-            </a:r>
-            <a:r>
-              <a:rPr sz="1000">
-                <a:solidFill>
-                  <a:srgbClr val="0F172A"/>
-                </a:solidFill>
-                <a:latin typeface="Segoe UI"/>
-              </a:rPr>
-              <a:t>Mobile Goods Receipting training for floor receivers.</a:t>
-            </a:r>
-          </a:p>
-        </p:txBody>
-      </p:sp>
-      <p:sp>
-        <p:nvSpPr>
-          <p:cNvPr id="9" name="Rounded Rectangle 8"/>
-          <p:cNvSpPr/>
-          <p:nvPr/>
-        </p:nvSpPr>
-        <p:spPr>
-          <a:xfrm>
-            <a:off x="6236208" y="1463040"/>
-            <a:ext cx="2468880" cy="4846320"/>
-          </a:xfrm>
-          <a:prstGeom prst="roundRect">
-            <a:avLst/>
-          </a:prstGeom>
-          <a:solidFill>
-            <a:srgbClr val="FFFFFF"/>
-          </a:solidFill>
-          <a:ln w="19050">
-            <a:solidFill>
-              <a:srgbClr val="E2E8F0"/>
-            </a:solidFill>
-          </a:ln>
-        </p:spPr>
-        <p:style>
-          <a:lnRef idx="1">
-            <a:schemeClr val="accent1"/>
-          </a:lnRef>
-          <a:fillRef idx="3">
-            <a:schemeClr val="accent1"/>
-          </a:fillRef>
-          <a:effectRef idx="2">
-            <a:schemeClr val="accent1"/>
-          </a:effectRef>
-          <a:fontRef idx="minor">
-            <a:schemeClr val="lt1"/>
-          </a:fontRef>
-        </p:style>
-        <p:txBody>
-          <a:bodyPr rtlCol="0" anchor="ctr"/>
-          <a:lstStyle/>
-          <a:p>
-            <a:pPr algn="ctr"/>
-          </a:p>
-        </p:txBody>
-      </p:sp>
-      <p:sp>
-        <p:nvSpPr>
-          <p:cNvPr id="10" name="Rounded Rectangle 9"/>
-          <p:cNvSpPr/>
-          <p:nvPr/>
-        </p:nvSpPr>
-        <p:spPr>
-          <a:xfrm>
-            <a:off x="6236208" y="1463040"/>
-            <a:ext cx="2468880" cy="502920"/>
-          </a:xfrm>
-          <a:prstGeom prst="roundRect">
-            <a:avLst/>
-          </a:prstGeom>
-          <a:solidFill>
-            <a:srgbClr val="D97706"/>
-          </a:solidFill>
-          <a:ln>
-            <a:noFill/>
-          </a:ln>
-        </p:spPr>
-        <p:style>
-          <a:lnRef idx="1">
-            <a:schemeClr val="accent1"/>
-          </a:lnRef>
-          <a:fillRef idx="3">
-            <a:schemeClr val="accent1"/>
-          </a:fillRef>
-          <a:effectRef idx="2">
-            <a:schemeClr val="accent1"/>
-          </a:effectRef>
-          <a:fontRef idx="minor">
-            <a:schemeClr val="lt1"/>
-          </a:fontRef>
-        </p:style>
-        <p:txBody>
-          <a:bodyPr rtlCol="0" anchor="ctr" lIns="137160" tIns="109728"/>
-          <a:lstStyle/>
-          <a:p>
-            <a:pPr algn="ctr">
-              <a:defRPr sz="1000" b="1">
-                <a:solidFill>
-                  <a:srgbClr val="FFFFFF"/>
-                </a:solidFill>
-                <a:latin typeface="Segoe UI"/>
-              </a:defRPr>
-            </a:pPr>
-            <a:r>
-              <a:t>PHASE 3 (WEEKS 3–4)</a:t>
-            </a:r>
-          </a:p>
-        </p:txBody>
-      </p:sp>
-      <p:sp>
-        <p:nvSpPr>
-          <p:cNvPr id="11" name="TextBox 10"/>
-          <p:cNvSpPr txBox="1"/>
-          <p:nvPr/>
-        </p:nvSpPr>
-        <p:spPr>
-          <a:xfrm>
-            <a:off x="6373368" y="2057400"/>
-            <a:ext cx="2194560" cy="4114800"/>
-          </a:xfrm>
-          <a:prstGeom prst="rect">
-            <a:avLst/>
-          </a:prstGeom>
-          <a:noFill/>
-        </p:spPr>
-        <p:txBody>
-          <a:bodyPr wrap="square">
-            <a:spAutoFit/>
-          </a:bodyPr>
-          <a:lstStyle/>
-          <a:p>
-            <a:pPr>
-              <a:spcAft>
-                <a:spcPts val="1200"/>
-              </a:spcAft>
-              <a:defRPr sz="1300" b="1">
-                <a:solidFill>
-                  <a:srgbClr val="0F172A"/>
-                </a:solidFill>
-                <a:latin typeface="Segoe UI"/>
-              </a:defRPr>
-            </a:pPr>
-            <a:r>
-              <a:t>Shadow POs &amp; DOA Calibration</a:t>
-            </a:r>
-          </a:p>
-          <a:p>
-            <a:pPr>
-              <a:spcAft>
-                <a:spcPts val="800"/>
-              </a:spcAft>
-            </a:pPr>
-            <a:r>
-              <a:rPr sz="1000" b="1">
-                <a:solidFill>
-                  <a:srgbClr val="D97706"/>
-                </a:solidFill>
-                <a:latin typeface="Segoe UI"/>
-              </a:rPr>
-              <a:t>Parallel Shadow Runs: </a:t>
-            </a:r>
-            <a:r>
-              <a:rPr sz="1000">
-                <a:solidFill>
-                  <a:srgbClr val="0F172A"/>
-                </a:solidFill>
-                <a:latin typeface="Segoe UI"/>
-              </a:rPr>
-              <a:t>Adelaide runs dual ordering alongside legacy channels.</a:t>
-            </a:r>
-          </a:p>
-          <a:p>
-            <a:pPr>
-              <a:spcAft>
-                <a:spcPts val="800"/>
-              </a:spcAft>
-            </a:pPr>
-            <a:r>
-              <a:rPr sz="1000" b="1">
-                <a:solidFill>
-                  <a:srgbClr val="D97706"/>
-                </a:solidFill>
-                <a:latin typeface="Segoe UI"/>
-              </a:rPr>
-              <a:t>Modulo Testing: </a:t>
-            </a:r>
-            <a:r>
-              <a:rPr sz="1000">
-                <a:solidFill>
-                  <a:srgbClr val="0F172A"/>
-                </a:solidFill>
-                <a:latin typeface="Segoe UI"/>
-              </a:rPr>
-              <a:t>Verify carton rounding and contract price locks on live orders.</a:t>
-            </a:r>
-          </a:p>
-          <a:p>
-            <a:pPr>
-              <a:spcAft>
-                <a:spcPts val="800"/>
-              </a:spcAft>
-            </a:pPr>
-            <a:r>
-              <a:rPr sz="1000" b="1">
-                <a:solidFill>
-                  <a:srgbClr val="D97706"/>
-                </a:solidFill>
-                <a:latin typeface="Segoe UI"/>
-              </a:rPr>
-              <a:t>DOA Approval Limits: </a:t>
-            </a:r>
-            <a:r>
-              <a:rPr sz="1000">
-                <a:solidFill>
-                  <a:srgbClr val="0F172A"/>
-                </a:solidFill>
-                <a:latin typeface="Segoe UI"/>
-              </a:rPr>
-              <a:t>Validate 3-tier escalation limits for Adelaide management.</a:t>
-            </a:r>
-          </a:p>
-          <a:p>
-            <a:pPr>
-              <a:spcAft>
-                <a:spcPts val="800"/>
-              </a:spcAft>
-            </a:pPr>
-            <a:r>
-              <a:rPr sz="1000" b="1">
-                <a:solidFill>
-                  <a:srgbClr val="D97706"/>
-                </a:solidFill>
-                <a:latin typeface="Segoe UI"/>
-              </a:rPr>
-              <a:t>Exception Handling: </a:t>
-            </a:r>
-            <a:r>
-              <a:rPr sz="1000">
-                <a:solidFill>
-                  <a:srgbClr val="0F172A"/>
-                </a:solidFill>
-                <a:latin typeface="Segoe UI"/>
-              </a:rPr>
-              <a:t>Refine local delivery docket capture workflows.</a:t>
-            </a:r>
-          </a:p>
-        </p:txBody>
-      </p:sp>
-      <p:sp>
-        <p:nvSpPr>
-          <p:cNvPr id="12" name="Rounded Rectangle 11"/>
-          <p:cNvSpPr/>
-          <p:nvPr/>
-        </p:nvSpPr>
-        <p:spPr>
-          <a:xfrm>
-            <a:off x="8988552" y="1463040"/>
-            <a:ext cx="2468880" cy="4846320"/>
-          </a:xfrm>
-          <a:prstGeom prst="roundRect">
-            <a:avLst/>
-          </a:prstGeom>
-          <a:solidFill>
-            <a:srgbClr val="FFFFFF"/>
-          </a:solidFill>
-          <a:ln w="19050">
-            <a:solidFill>
-              <a:srgbClr val="E2E8F0"/>
-            </a:solidFill>
-          </a:ln>
-        </p:spPr>
-        <p:style>
-          <a:lnRef idx="1">
-            <a:schemeClr val="accent1"/>
-          </a:lnRef>
-          <a:fillRef idx="3">
-            <a:schemeClr val="accent1"/>
-          </a:fillRef>
-          <a:effectRef idx="2">
-            <a:schemeClr val="accent1"/>
-          </a:effectRef>
-          <a:fontRef idx="minor">
-            <a:schemeClr val="lt1"/>
-          </a:fontRef>
-        </p:style>
-        <p:txBody>
-          <a:bodyPr rtlCol="0" anchor="ctr"/>
-          <a:lstStyle/>
-          <a:p>
-            <a:pPr algn="ctr"/>
-          </a:p>
-        </p:txBody>
-      </p:sp>
-      <p:sp>
-        <p:nvSpPr>
-          <p:cNvPr id="13" name="Rounded Rectangle 12"/>
-          <p:cNvSpPr/>
-          <p:nvPr/>
-        </p:nvSpPr>
-        <p:spPr>
-          <a:xfrm>
-            <a:off x="8988552" y="1463040"/>
-            <a:ext cx="2468880" cy="502920"/>
+            <a:off x="6291072" y="1463040"/>
+            <a:ext cx="5166360" cy="502920"/>
           </a:xfrm>
           <a:prstGeom prst="roundRect">
             <a:avLst/>
@@ -4632,21 +4218,21 @@
               </a:defRPr>
             </a:pPr>
             <a:r>
-              <a:t>PHASE 4 (WEEK 5)</a:t>
-            </a:r>
-          </a:p>
-        </p:txBody>
-      </p:sp>
-      <p:sp>
-        <p:nvSpPr>
-          <p:cNvPr id="14" name="TextBox 13"/>
+              <a:t>SATELLITE DEPOTS &amp; GOVERNANCE BENEFIT</a:t>
+            </a:r>
+          </a:p>
+        </p:txBody>
+      </p:sp>
+      <p:sp>
+        <p:nvSpPr>
+          <p:cNvPr id="8" name="TextBox 7"/>
           <p:cNvSpPr txBox="1"/>
           <p:nvPr/>
         </p:nvSpPr>
         <p:spPr>
           <a:xfrm>
-            <a:off x="9125712" y="2057400"/>
-            <a:ext cx="2194560" cy="4114800"/>
+            <a:off x="6473952" y="2057400"/>
+            <a:ext cx="4800600" cy="4114800"/>
           </a:xfrm>
           <a:prstGeom prst="rect">
             <a:avLst/>
@@ -4658,22 +4244,7 @@
             <a:spAutoFit/>
           </a:bodyPr>
           <a:lstStyle/>
-          <a:p>
-            <a:pPr>
-              <a:spcAft>
-                <a:spcPts val="1200"/>
-              </a:spcAft>
-              <a:defRPr sz="1300" b="1">
-                <a:solidFill>
-                  <a:srgbClr val="0F172A"/>
-                </a:solidFill>
-                <a:latin typeface="Segoe UI"/>
-              </a:defRPr>
-            </a:pPr>
-            <a:r>
-              <a:t>Full Live Cutover</a:t>
-            </a:r>
-          </a:p>
+          <a:p/>
           <a:p>
             <a:pPr>
               <a:spcAft>
@@ -4687,7 +4258,7 @@
                 </a:solidFill>
                 <a:latin typeface="Segoe UI"/>
               </a:rPr>
-              <a:t>100% System Cutover: </a:t>
+              <a:t>3 Satellite Facilities: </a:t>
             </a:r>
             <a:r>
               <a:rPr sz="1000">
@@ -4696,7 +4267,7 @@
                 </a:solidFill>
                 <a:latin typeface="Segoe UI"/>
               </a:rPr>
-              <a:t>100% of Adelaide linen purchasing routed through ProcureFlow.</a:t>
+              <a:t>Active satellite depots managing local linen turnaround and healthcare routes.</a:t>
             </a:r>
           </a:p>
           <a:p>
@@ -4712,7 +4283,7 @@
                 </a:solidFill>
                 <a:latin typeface="Segoe UI"/>
               </a:rPr>
-              <a:t>Concur PR Enforced: </a:t>
+              <a:t>Uniform Governance: </a:t>
             </a:r>
             <a:r>
               <a:rPr sz="1000">
@@ -4721,7 +4292,7 @@
                 </a:solidFill>
                 <a:latin typeface="Segoe UI"/>
               </a:rPr>
-              <a:t>Mandatory Concur PR linkage enforced on all closed POs.</a:t>
+              <a:t>All 11 sites are already live and operating on ProcureFlow daily with zero exceptions.</a:t>
             </a:r>
           </a:p>
           <a:p>
@@ -4737,7 +4308,7 @@
                 </a:solidFill>
                 <a:latin typeface="Segoe UI"/>
               </a:rPr>
-              <a:t>Channel Decommissioning: </a:t>
+              <a:t>Universal Guardrails: </a:t>
             </a:r>
             <a:r>
               <a:rPr sz="1000">
@@ -4746,7 +4317,7 @@
                 </a:solidFill>
                 <a:latin typeface="Segoe UI"/>
               </a:rPr>
-              <a:t>Decommission legacy paper, phone, and spreadsheet ordering.</a:t>
+              <a:t>Carton modulo rounding and contract price locks apply equally across all plants.</a:t>
             </a:r>
           </a:p>
           <a:p>
@@ -4762,7 +4333,7 @@
                 </a:solidFill>
                 <a:latin typeface="Segoe UI"/>
               </a:rPr>
-              <a:t>EOM Reconciliation: </a:t>
+              <a:t>Mandatory ERP Mirroring: </a:t>
             </a:r>
             <a:r>
               <a:rPr sz="1000">
@@ -4771,7 +4342,32 @@
                 </a:solidFill>
                 <a:latin typeface="Segoe UI"/>
               </a:rPr>
-              <a:t>Adelaide spend actively tracking in native monthly 2D pivot.</a:t>
+              <a:t>Every facility enforces Concur PR # attachment prior to closing purchase orders.</a:t>
+            </a:r>
+          </a:p>
+          <a:p>
+            <a:pPr>
+              <a:spcAft>
+                <a:spcPts val="800"/>
+              </a:spcAft>
+            </a:pPr>
+            <a:r>
+              <a:rPr sz="1000" b="1">
+                <a:solidFill>
+                  <a:srgbClr val="059669"/>
+                </a:solidFill>
+                <a:latin typeface="Segoe UI"/>
+              </a:rPr>
+              <a:t>Standardized Training: </a:t>
+            </a:r>
+            <a:r>
+              <a:rPr sz="1000">
+                <a:solidFill>
+                  <a:srgbClr val="0F172A"/>
+                </a:solidFill>
+                <a:latin typeface="Segoe UI"/>
+              </a:rPr>
+              <a:t>The upcoming video training sign-off will be deployed universally across all 11 sites.</a:t>
             </a:r>
           </a:p>
         </p:txBody>
@@ -4941,7 +4537,7 @@
                 </a:solidFill>
                 <a:latin typeface="Segoe UI"/>
               </a:rPr>
-              <a:t>1. Adelaide Rollout Framework: </a:t>
+              <a:t>1. National Closed-Loop Governance: </a:t>
             </a:r>
             <a:r>
               <a:rPr sz="1050">
@@ -4950,7 +4546,7 @@
                 </a:solidFill>
                 <a:latin typeface="Segoe UI"/>
               </a:rPr>
-              <a:t>Endorsement of the 4-phase structured implementation model to expand ProcureFlow to Adelaide operations.</a:t>
+              <a:t>Endorsement of point-of-entry carton modulo validation, contract price locks, and mandatory Concur PR enforcement across all 11 live operating facilities.</a:t>
             </a:r>
           </a:p>
           <a:p>
@@ -5025,7 +4621,7 @@
                 </a:solidFill>
                 <a:latin typeface="Segoe UI"/>
               </a:rPr>
-              <a:t>Approval to merge verified feature branch into master production following workshop alignment.</a:t>
+              <a:t>Approval to merge verified review branch into master production for immediate deployment.</a:t>
             </a:r>
           </a:p>
         </p:txBody>
@@ -5109,13 +4705,13 @@
               </a:defRPr>
             </a:pPr>
             <a:r>
-              <a:t>ALIGNMENT CADENCE &amp; KEY MILESTONES</a:t>
-            </a:r>
-          </a:p>
-          <a:p>
-            <a:pPr>
-              <a:spcAft>
-                <a:spcPts val="1000"/>
+              <a:t>IMPLEMENTATION CADENCE &amp; KEY MILESTONES</a:t>
+            </a:r>
+          </a:p>
+          <a:p>
+            <a:pPr>
+              <a:spcAft>
+                <a:spcPts val="1200"/>
               </a:spcAft>
             </a:pPr>
             <a:r>
@@ -5125,7 +4721,7 @@
                 </a:solidFill>
                 <a:latin typeface="Segoe UI"/>
               </a:rPr>
-              <a:t>• Pre-Workshop Strategy Catch-Up: </a:t>
+              <a:t>• Month 1 (September 2026): </a:t>
             </a:r>
             <a:r>
               <a:rPr sz="1050">
@@ -5134,13 +4730,13 @@
                 </a:solidFill>
                 <a:latin typeface="Segoe UI"/>
               </a:rPr>
-              <a:t>Thursday, Sep 3, 2026 (8:30 AM – 9:00 AM) — Aaron Bell &amp; Ashish Chhabra final alignment.</a:t>
-            </a:r>
-          </a:p>
-          <a:p>
-            <a:pPr>
-              <a:spcAft>
-                <a:spcPts val="1000"/>
+              <a:t>Deploy point-of-entry carton modulo and price locks to production; initiate 2-month SOH dual validation with Simba &amp; Host.</a:t>
+            </a:r>
+          </a:p>
+          <a:p>
+            <a:pPr>
+              <a:spcAft>
+                <a:spcPts val="1200"/>
               </a:spcAft>
             </a:pPr>
             <a:r>
@@ -5150,7 +4746,7 @@
                 </a:solidFill>
                 <a:latin typeface="Segoe UI"/>
               </a:rPr>
-              <a:t>• Executive Leadership Workshop: </a:t>
+              <a:t>• Month 2 (October 2026): </a:t>
             </a:r>
             <a:r>
               <a:rPr sz="1050">
@@ -5159,13 +4755,13 @@
                 </a:solidFill>
                 <a:latin typeface="Segoe UI"/>
               </a:rPr>
-              <a:t>Thursday, Sep 3, 2026 (10:00 AM) — Ebrahim Mokhtari (COO), Ashish Chhabra &amp; Aaron Bell.</a:t>
-            </a:r>
-          </a:p>
-          <a:p>
-            <a:pPr>
-              <a:spcAft>
-                <a:spcPts val="1000"/>
+              <a:t>Conclude SOH dual validation and formally deprecate weekly email reports; roll out mandatory video training module and sign-off gating; initiate native Short Supply engine migration.</a:t>
+            </a:r>
+          </a:p>
+          <a:p>
+            <a:pPr>
+              <a:spcAft>
+                <a:spcPts val="1200"/>
               </a:spcAft>
             </a:pPr>
             <a:r>
@@ -5175,7 +4771,7 @@
                 </a:solidFill>
                 <a:latin typeface="Segoe UI"/>
               </a:rPr>
-              <a:t>• September 2026 (Month 1): </a:t>
+              <a:t>• Ongoing Governance (FY27): </a:t>
             </a:r>
             <a:r>
               <a:rPr sz="1050">
@@ -5184,38 +4780,13 @@
                 </a:solidFill>
                 <a:latin typeface="Segoe UI"/>
               </a:rPr>
-              <a:t>Adelaide Phase 1–2 master setup; launch SOH dual validation with Simba &amp; Host.</a:t>
-            </a:r>
-          </a:p>
-          <a:p>
-            <a:pPr>
-              <a:spcAft>
-                <a:spcPts val="1000"/>
-              </a:spcAft>
-            </a:pPr>
-            <a:r>
-              <a:rPr sz="1050" b="1">
-                <a:solidFill>
-                  <a:srgbClr val="0F172A"/>
-                </a:solidFill>
-                <a:latin typeface="Segoe UI"/>
-              </a:rPr>
-              <a:t>• October 2026 (Month 2): </a:t>
-            </a:r>
-            <a:r>
-              <a:rPr sz="1050">
-                <a:solidFill>
-                  <a:srgbClr val="0F172A"/>
-                </a:solidFill>
-                <a:latin typeface="Segoe UI"/>
-              </a:rPr>
-              <a:t>Adelaide full live cutover; SOH email deprecation; Short Supply engine migration build.</a:t>
-            </a:r>
-          </a:p>
-          <a:p>
-            <a:pPr>
-              <a:spcAft>
-                <a:spcPts val="1000"/>
+              <a:t>Continuous 2D pivot tracking against $14.521M baseline budget; automated Tier 1 (&gt;14d) and Tier 2 (&gt;21d) overdue delivery escalations.</a:t>
+            </a:r>
+          </a:p>
+          <a:p>
+            <a:pPr>
+              <a:spcAft>
+                <a:spcPts val="1200"/>
               </a:spcAft>
             </a:pPr>
             <a:r>
@@ -5466,7 +5037,7 @@
                 </a:solidFill>
                 <a:latin typeface="Segoe UI"/>
               </a:rPr>
-              <a:t>ProcureFlow is NOT a broken system in need of repair; it is a proven national tool active across 11 facilities handling 100% of daily linen POs.</a:t>
+              <a:t>ProcureFlow is NOT a broken system; it is a proven national tool operating live across 11 facilities handling 100% of daily linen POs.</a:t>
             </a:r>
           </a:p>
           <a:p>
@@ -5482,7 +5053,7 @@
                 </a:solidFill>
                 <a:latin typeface="Segoe UI"/>
               </a:rPr>
-              <a:t>Last 3 Months: </a:t>
+              <a:t>Last 3 Months Track Record: </a:t>
             </a:r>
             <a:r>
               <a:rPr sz="1050">
@@ -5491,7 +5062,7 @@
                 </a:solidFill>
                 <a:latin typeface="Segoe UI"/>
               </a:rPr>
-              <a:t>Master catalog cleanup by Aaron, Ashish &amp; Kiran drove supplier linkage from ~50% to 95%–100% compliance.</a:t>
+              <a:t>Master catalog overhaul by Aaron, Ashish &amp; Kiran drove supplier linkage from ~50% to 95%–100% compliance.</a:t>
             </a:r>
           </a:p>
           <a:p>
@@ -5507,7 +5078,7 @@
                 </a:solidFill>
                 <a:latin typeface="Segoe UI"/>
               </a:rPr>
-              <a:t>Operational Stability: </a:t>
+              <a:t>Enterprise Reliability: </a:t>
             </a:r>
             <a:r>
               <a:rPr sz="1050">
@@ -5516,7 +5087,7 @@
                 </a:solidFill>
                 <a:latin typeface="Segoe UI"/>
               </a:rPr>
-              <a:t>Platform uptime at 99.9% with over 900+ requisitions successfully processed and audited.</a:t>
+              <a:t>Platform uptime at 99.9% with over 900+ requisitions successfully processed and audited nationally.</a:t>
             </a:r>
           </a:p>
         </p:txBody>
@@ -5703,7 +5274,7 @@
                 </a:solidFill>
                 <a:latin typeface="Segoe UI"/>
               </a:rPr>
-              <a:t>Locks PO rates to negotiated supplier contracts, guaranteeing 100% 3-way invoice matching in Concur.</a:t>
+              <a:t>Locks PO rates to contracted supplier catalogs, guaranteeing 100% 3-way invoice matching in Concur.</a:t>
             </a:r>
           </a:p>
           <a:p>
@@ -5906,7 +5477,7 @@
                 </a:solidFill>
                 <a:latin typeface="Segoe UI"/>
               </a:rPr>
-              <a:t>Adelaide Expansion: </a:t>
+              <a:t>National Governance Cutover: </a:t>
             </a:r>
             <a:r>
               <a:rPr sz="1050">
@@ -5915,7 +5486,7 @@
                 </a:solidFill>
                 <a:latin typeface="Segoe UI"/>
               </a:rPr>
-              <a:t>Approve the 4-phase rollout framework to onboard Adelaide as our 9th regional hub.</a:t>
+              <a:t>Endorse point-of-entry carton &amp; pricing rules across all 11 live operating facilities.</a:t>
             </a:r>
           </a:p>
           <a:p>
@@ -5981,7 +5552,7 @@
                 </a:solidFill>
                 <a:latin typeface="Segoe UI"/>
               </a:rPr>
-              <a:t>Short Supply Engine: </a:t>
+              <a:t>Production Merge: </a:t>
             </a:r>
             <a:r>
               <a:rPr sz="1050">
@@ -5990,7 +5561,7 @@
                 </a:solidFill>
                 <a:latin typeface="Segoe UI"/>
               </a:rPr>
-              <a:t>Greenlight native migration of external BI/Power Apps logic into ProcureFlow.</a:t>
+              <a:t>Greenlight merging the verified review branch into master production for national deployment.</a:t>
             </a:r>
           </a:p>
         </p:txBody>
@@ -6510,7 +6081,7 @@
                 </a:solidFill>
                 <a:latin typeface="Segoe UI"/>
               </a:rPr>
-              <a:t>8 primary regional hubs + satellite plants actively running 100% of daily linen POs.</a:t>
+              <a:t>All 8 primary regional hubs + satellite plants actively running 100% of daily linen POs.</a:t>
             </a:r>
           </a:p>
           <a:p>
@@ -6726,7 +6297,7 @@
                 </a:solidFill>
                 <a:latin typeface="Segoe UI"/>
               </a:rPr>
-              <a:t>Adelaide Expansion: </a:t>
+              <a:t>National Governance Scaling: </a:t>
             </a:r>
             <a:r>
               <a:rPr sz="1050">
@@ -6735,7 +6306,7 @@
                 </a:solidFill>
                 <a:latin typeface="Segoe UI"/>
               </a:rPr>
-              <a:t>Structured 4-phase rollout onboarding Adelaide as our 9th regional hub.</a:t>
+              <a:t>Standardized rollout of carton modulo, price locks, and Concur PR rules across all 11 live sites.</a:t>
             </a:r>
           </a:p>
           <a:p>
@@ -7768,7 +7339,7 @@
               </a:defRPr>
             </a:pPr>
             <a:r>
-              <a:t>ProcureFlow runs 100% of daily linen POs across 8 primary regional hubs (Melbourne, Sydney, Brisbane, Perth, Adelaide, Cairns, Mackay, Albury) plus satellite facilities with 99.9% uptime.</a:t>
+              <a:t>ProcureFlow runs 100% of daily linen POs across all 8 primary regional hubs (Melbourne, Sydney, Brisbane, Perth, Adelaide, Cairns, Mackay, Albury) plus satellite facilities with 99.9% uptime.</a:t>
             </a:r>
           </a:p>
         </p:txBody>

</xml_diff>